<commit_message>
feat(showcase): incorporate native slide transitions into all 12 showcase slides
</commit_message>
<xml_diff>
--- a/hokkyss_showcase_deck.pptx
+++ b/hokkyss_showcase_deck.pptx
@@ -2772,7 +2772,7 @@
     <p:bg>
       <p:bgPr>
         <a:solidFill>
-          <a:srgbClr val="0F172A"/>
+          <a:srgbClr val="0B1120"/>
         </a:solidFill>
         <a:effectLst/>
       </p:bgPr>
@@ -3126,6 +3126,9 @@
   <p:clrMapOvr>
     <a:masterClrMapping/>
   </p:clrMapOvr>
+  <p:transition spd="fast">
+    <p:fade thruBlk="1"/>
+  </p:transition>
 </p:sld>
 </file>
 
@@ -3519,6 +3522,9 @@
   <p:clrMapOvr>
     <a:masterClrMapping/>
   </p:clrMapOvr>
+  <p:transition spd="fast">
+    <p:blinds dir="horz"/>
+  </p:transition>
 </p:sld>
 </file>
 
@@ -3528,7 +3534,7 @@
     <p:bg>
       <p:bgPr>
         <a:solidFill>
-          <a:srgbClr val="0F172A"/>
+          <a:srgbClr val="FFFFFF"/>
         </a:solidFill>
         <a:effectLst/>
       </p:bgPr>
@@ -3912,6 +3918,9 @@
   <p:clrMapOvr>
     <a:masterClrMapping/>
   </p:clrMapOvr>
+  <p:transition spd="fast">
+    <p:checker dir="vert"/>
+  </p:transition>
 </p:sld>
 </file>
 
@@ -3921,7 +3930,7 @@
     <p:bg>
       <p:bgPr>
         <a:solidFill>
-          <a:srgbClr val="F8FAFC"/>
+          <a:srgbClr val="0F172A"/>
         </a:solidFill>
         <a:effectLst/>
       </p:bgPr>
@@ -4914,6 +4923,9 @@
   <p:clrMapOvr>
     <a:masterClrMapping/>
   </p:clrMapOvr>
+  <p:transition spd="med">
+    <p:zoom dir="in"/>
+  </p:transition>
 </p:sld>
 </file>
 
@@ -5435,6 +5447,9 @@
   <p:clrMapOvr>
     <a:masterClrMapping/>
   </p:clrMapOvr>
+  <p:transition spd="fast">
+    <p:wipe dir="r"/>
+  </p:transition>
 </p:sld>
 </file>
 
@@ -6326,10 +6341,419 @@
   <p:clrMapOvr>
     <a:masterClrMapping/>
   </p:clrMapOvr>
+  <p:transition spd="med">
+    <p:push dir="u"/>
+  </p:transition>
 </p:sld>
 </file>
 
 <file path=ppt/slides/slide4.xml><?xml version="1.0" encoding="utf-8"?>
+<p:sld xmlns:a="http://schemas.openxmlformats.org/drawingml/2006/main" xmlns:r="http://schemas.openxmlformats.org/officeDocument/2006/relationships" xmlns:p="http://schemas.openxmlformats.org/presentationml/2006/main">
+  <p:cSld>
+    <p:bg>
+      <p:bgPr>
+        <a:solidFill>
+          <a:srgbClr val="F8FAFC"/>
+        </a:solidFill>
+        <a:effectLst/>
+      </p:bgPr>
+    </p:bg>
+    <p:spTree>
+      <p:nvGrpSpPr>
+        <p:cNvPr id="1" name=""/>
+        <p:cNvGrpSpPr/>
+        <p:nvPr/>
+      </p:nvGrpSpPr>
+      <p:grpSpPr>
+        <a:xfrm>
+          <a:off x="0" y="0"/>
+          <a:ext cx="0" cy="0"/>
+          <a:chOff x="0" y="0"/>
+          <a:chExt cx="0" cy="0"/>
+        </a:xfrm>
+      </p:grpSpPr>
+      <p:sp>
+        <p:nvSpPr>
+          <p:cNvPr id="2" name="Text Box 1"/>
+          <p:cNvSpPr/>
+          <p:nvPr/>
+        </p:nvSpPr>
+        <p:spPr>
+          <a:xfrm>
+            <a:off x="914400" y="731520"/>
+            <a:ext cx="10360152" cy="548640"/>
+          </a:xfrm>
+          <a:prstGeom prst="rect">
+            <a:avLst/>
+          </a:prstGeom>
+        </p:spPr>
+        <p:txBody>
+          <a:bodyPr anchor="t"/>
+          <a:lstStyle/>
+          <a:p>
+            <a:pPr algn="l"/>
+            <a:r>
+              <a:rPr b="1" sz="2400">
+                <a:solidFill>
+                  <a:srgbClr val="38BDF8"/>
+                </a:solidFill>
+                <a:latin typeface="+mj-lt"/>
+                <a:cs typeface="+mj-lt"/>
+              </a:rPr>
+              <a:t>Type-Safe Nominal Units &amp; Coordinate System</a:t>
+            </a:r>
+          </a:p>
+        </p:txBody>
+      </p:sp>
+      <p:sp>
+        <p:nvSpPr>
+          <p:cNvPr id="3" name="Text Box 2"/>
+          <p:cNvSpPr/>
+          <p:nvPr/>
+        </p:nvSpPr>
+        <p:spPr>
+          <a:xfrm>
+            <a:off x="914400" y="1463040"/>
+            <a:ext cx="10360152" cy="4114800"/>
+          </a:xfrm>
+          <a:prstGeom prst="rect">
+            <a:avLst/>
+          </a:prstGeom>
+        </p:spPr>
+        <p:txBody>
+          <a:bodyPr anchor="t"/>
+          <a:lstStyle/>
+          <a:p>
+            <a:pPr algn="l" lvl="0"/>
+            <a:r>
+              <a:rPr sz="1200">
+                <a:solidFill>
+                  <a:srgbClr val="E2E8F0"/>
+                </a:solidFill>
+                <a:latin typeface="+mn-lt"/>
+                <a:cs typeface="+mn-lt"/>
+              </a:rPr>
+              <a:t>1. Nominal Units &amp; Compile-Time Safety</a:t>
+            </a:r>
+          </a:p>
+          <a:p>
+            <a:pPr algn="l" lvl="1"/>
+            <a:r>
+              <a:rPr sz="1200">
+                <a:solidFill>
+                  <a:srgbClr val="E2E8F0"/>
+                </a:solidFill>
+                <a:latin typeface="+mn-lt"/>
+                <a:cs typeface="+mn-lt"/>
+              </a:rPr>
+              <a:t>1.1 Zero-runtime-overhead branded types for dimensional coordinates</a:t>
+            </a:r>
+          </a:p>
+          <a:p>
+            <a:pPr algn="l" lvl="2"/>
+            <a:r>
+              <a:rPr sz="1200">
+                <a:solidFill>
+                  <a:srgbClr val="E2E8F0"/>
+                </a:solidFill>
+                <a:latin typeface="+mn-lt"/>
+                <a:cs typeface="+mn-lt"/>
+              </a:rPr>
+              <a:t>1.1.1 English Metric Units (EMU): </a:t>
+            </a:r>
+            <a:r>
+              <a:rPr b="1" sz="1200">
+                <a:solidFill>
+                  <a:srgbClr val="38BDF8"/>
+                </a:solidFill>
+                <a:latin typeface="+mn-lt"/>
+                <a:cs typeface="+mn-lt"/>
+              </a:rPr>
+              <a:t>1 inch = 914,400 EMU</a:t>
+            </a:r>
+            <a:r>
+              <a:rPr sz="1200">
+                <a:solidFill>
+                  <a:srgbClr val="E2E8F0"/>
+                </a:solidFill>
+                <a:latin typeface="+mn-lt"/>
+                <a:cs typeface="+mn-lt"/>
+              </a:rPr>
+              <a:t> — </a:t>
+            </a:r>
+            <a:r>
+              <a:rPr b="1" sz="1200">
+                <a:solidFill>
+                  <a:srgbClr val="10B981"/>
+                </a:solidFill>
+                <a:latin typeface="+mn-lt"/>
+                <a:cs typeface="+mn-lt"/>
+              </a:rPr>
+              <a:t>1 pt = 12,700 EMU</a:t>
+            </a:r>
+          </a:p>
+          <a:p>
+            <a:pPr algn="l" lvl="2"/>
+            <a:r>
+              <a:rPr sz="1200">
+                <a:solidFill>
+                  <a:srgbClr val="E2E8F0"/>
+                </a:solidFill>
+                <a:latin typeface="+mn-lt"/>
+                <a:cs typeface="+mn-lt"/>
+              </a:rPr>
+              <a:t>1.1.2 Rotational Angles: </a:t>
+            </a:r>
+            <a:r>
+              <a:rPr b="1" sz="1200">
+                <a:solidFill>
+                  <a:srgbClr val="F59E0B"/>
+                </a:solidFill>
+                <a:latin typeface="+mn-lt"/>
+                <a:cs typeface="+mn-lt"/>
+              </a:rPr>
+              <a:t>degrees(θ)</a:t>
+            </a:r>
+            <a:r>
+              <a:rPr sz="1200">
+                <a:solidFill>
+                  <a:srgbClr val="E2E8F0"/>
+                </a:solidFill>
+                <a:latin typeface="+mn-lt"/>
+                <a:cs typeface="+mn-lt"/>
+              </a:rPr>
+              <a:t> compiles to </a:t>
+            </a:r>
+            <a:r>
+              <a:rPr b="1" sz="1200">
+                <a:solidFill>
+                  <a:srgbClr val="F59E0B"/>
+                </a:solidFill>
+                <a:latin typeface="+mn-lt"/>
+                <a:cs typeface="+mn-lt"/>
+              </a:rPr>
+              <a:t>θ × 60,000 EmuDegrees</a:t>
+            </a:r>
+          </a:p>
+          <a:p>
+            <a:pPr algn="l" lvl="2"/>
+            <a:r>
+              <a:rPr sz="1200">
+                <a:solidFill>
+                  <a:srgbClr val="E2E8F0"/>
+                </a:solidFill>
+                <a:latin typeface="+mn-lt"/>
+                <a:cs typeface="+mn-lt"/>
+              </a:rPr>
+              <a:t>1.1.3 Maximum memory ceiling: </a:t>
+            </a:r>
+            <a:r>
+              <a:rPr b="1" sz="1200">
+                <a:solidFill>
+                  <a:srgbClr val="F59E0B"/>
+                </a:solidFill>
+                <a:latin typeface="+mn-lt"/>
+                <a:cs typeface="+mn-lt"/>
+              </a:rPr>
+              <a:t>2</a:t>
+            </a:r>
+            <a:r>
+              <a:rPr b="1" baseline="30000" sz="1200">
+                <a:solidFill>
+                  <a:srgbClr val="F59E0B"/>
+                </a:solidFill>
+                <a:latin typeface="+mn-lt"/>
+                <a:cs typeface="+mn-lt"/>
+              </a:rPr>
+              <a:t>32</a:t>
+            </a:r>
+            <a:r>
+              <a:rPr sz="1200">
+                <a:solidFill>
+                  <a:srgbClr val="E2E8F0"/>
+                </a:solidFill>
+                <a:latin typeface="+mn-lt"/>
+                <a:cs typeface="+mn-lt"/>
+              </a:rPr>
+              <a:t> bytes (4 GB buffer limit)</a:t>
+            </a:r>
+          </a:p>
+          <a:p>
+            <a:pPr algn="l" lvl="0"/>
+            <a:r>
+              <a:rPr sz="1200">
+                <a:solidFill>
+                  <a:srgbClr val="E2E8F0"/>
+                </a:solidFill>
+                <a:latin typeface="+mn-lt"/>
+                <a:cs typeface="+mn-lt"/>
+              </a:rPr>
+              <a:t>2. High-Performance Text Run Modifiers</a:t>
+            </a:r>
+          </a:p>
+          <a:p>
+            <a:pPr algn="l" lvl="1"/>
+            <a:r>
+              <a:rPr sz="1200">
+                <a:solidFill>
+                  <a:srgbClr val="E2E8F0"/>
+                </a:solidFill>
+                <a:latin typeface="+mn-lt"/>
+                <a:cs typeface="+mn-lt"/>
+              </a:rPr>
+              <a:t>2.1 Rich inline text runs with mixed typographic styles</a:t>
+            </a:r>
+          </a:p>
+          <a:p>
+            <a:pPr algn="l" lvl="2"/>
+            <a:r>
+              <a:rPr sz="1200">
+                <a:solidFill>
+                  <a:srgbClr val="E2E8F0"/>
+                </a:solidFill>
+                <a:latin typeface="+mn-lt"/>
+                <a:cs typeface="+mn-lt"/>
+              </a:rPr>
+              <a:t>Formatting: </a:t>
+            </a:r>
+            <a:r>
+              <a:rPr b="1" sz="1200">
+                <a:solidFill>
+                  <a:srgbClr val="E2E8F0"/>
+                </a:solidFill>
+                <a:latin typeface="+mn-lt"/>
+                <a:cs typeface="+mn-lt"/>
+              </a:rPr>
+              <a:t>Bold</a:t>
+            </a:r>
+            <a:r>
+              <a:rPr sz="1200">
+                <a:solidFill>
+                  <a:srgbClr val="E2E8F0"/>
+                </a:solidFill>
+                <a:latin typeface="+mn-lt"/>
+                <a:cs typeface="+mn-lt"/>
+              </a:rPr>
+              <a:t> | </a:t>
+            </a:r>
+            <a:r>
+              <a:rPr i="1" sz="1200">
+                <a:solidFill>
+                  <a:srgbClr val="E2E8F0"/>
+                </a:solidFill>
+                <a:latin typeface="+mn-lt"/>
+                <a:cs typeface="+mn-lt"/>
+              </a:rPr>
+              <a:t>Italic</a:t>
+            </a:r>
+            <a:r>
+              <a:rPr sz="1200">
+                <a:solidFill>
+                  <a:srgbClr val="E2E8F0"/>
+                </a:solidFill>
+                <a:latin typeface="+mn-lt"/>
+                <a:cs typeface="+mn-lt"/>
+              </a:rPr>
+              <a:t> | </a:t>
+            </a:r>
+            <a:r>
+              <a:rPr u="sng" sz="1200">
+                <a:solidFill>
+                  <a:srgbClr val="E2E8F0"/>
+                </a:solidFill>
+                <a:latin typeface="+mn-lt"/>
+                <a:cs typeface="+mn-lt"/>
+              </a:rPr>
+              <a:t>Underlined</a:t>
+            </a:r>
+            <a:r>
+              <a:rPr sz="1200">
+                <a:solidFill>
+                  <a:srgbClr val="E2E8F0"/>
+                </a:solidFill>
+                <a:latin typeface="+mn-lt"/>
+                <a:cs typeface="+mn-lt"/>
+              </a:rPr>
+              <a:t> | </a:t>
+            </a:r>
+            <a:r>
+              <a:rPr strike="sngStrike" sz="1200">
+                <a:solidFill>
+                  <a:srgbClr val="E2E8F0"/>
+                </a:solidFill>
+                <a:latin typeface="+mn-lt"/>
+                <a:cs typeface="+mn-lt"/>
+              </a:rPr>
+              <a:t>Strikethrough</a:t>
+            </a:r>
+            <a:r>
+              <a:rPr sz="1200">
+                <a:solidFill>
+                  <a:srgbClr val="E2E8F0"/>
+                </a:solidFill>
+                <a:latin typeface="+mn-lt"/>
+                <a:cs typeface="+mn-lt"/>
+              </a:rPr>
+              <a:t> | </a:t>
+            </a:r>
+            <a:r>
+              <a:rPr b="1" sz="1200">
+                <a:solidFill>
+                  <a:srgbClr val="6366F1"/>
+                </a:solidFill>
+                <a:latin typeface="+mn-lt"/>
+                <a:cs typeface="+mn-lt"/>
+              </a:rPr>
+              <a:t>Colored #6366F1</a:t>
+            </a:r>
+          </a:p>
+        </p:txBody>
+      </p:sp>
+      <p:sp>
+        <p:nvSpPr>
+          <p:cNvPr id="4" name="Text Box 3"/>
+          <p:cNvSpPr/>
+          <p:nvPr/>
+        </p:nvSpPr>
+        <p:spPr>
+          <a:xfrm>
+            <a:off x="731520" y="6510528"/>
+            <a:ext cx="10725912" cy="228600"/>
+          </a:xfrm>
+          <a:prstGeom prst="rect">
+            <a:avLst/>
+          </a:prstGeom>
+        </p:spPr>
+        <p:txBody>
+          <a:bodyPr anchor="t"/>
+          <a:lstStyle/>
+          <a:p>
+            <a:pPr algn="ctr"/>
+            <a:r>
+              <a:rPr i="1" sz="800">
+                <a:solidFill>
+                  <a:srgbClr val="64748B"/>
+                </a:solidFill>
+                <a:latin typeface="+mn-lt"/>
+                <a:cs typeface="+mn-lt"/>
+              </a:rPr>
+              <a:t>* Disclaimer: All benchmark metrics, performance figures, and simulated architectures in this deck are synthetic demonstration values generated solely to showcase the authoring, formatting, and rendering capabilities of @hokkyss/pptx.</a:t>
+            </a:r>
+          </a:p>
+        </p:txBody>
+      </p:sp>
+    </p:spTree>
+  </p:cSld>
+  <p:clrMapOvr>
+    <a:masterClrMapping/>
+  </p:clrMapOvr>
+  <p:transition spd="fast">
+    <p:split dir="in"/>
+  </p:transition>
+</p:sld>
+</file>
+
+<file path=ppt/slides/slide5.xml><?xml version="1.0" encoding="utf-8"?>
 <p:sld xmlns:a="http://schemas.openxmlformats.org/drawingml/2006/main" xmlns:r="http://schemas.openxmlformats.org/officeDocument/2006/relationships" xmlns:p="http://schemas.openxmlformats.org/presentationml/2006/main">
   <p:cSld>
     <p:bg>
@@ -6377,12 +6801,12 @@
             <a:r>
               <a:rPr b="1" sz="2400">
                 <a:solidFill>
-                  <a:srgbClr val="38BDF8"/>
+                  <a:srgbClr val="0F172A"/>
                 </a:solidFill>
                 <a:latin typeface="+mj-lt"/>
                 <a:cs typeface="+mj-lt"/>
               </a:rPr>
-              <a:t>Type-Safe Nominal Units &amp; Coordinate System</a:t>
+              <a:t>Three-Tier Decoupled Platform Architecture</a:t>
             </a:r>
           </a:p>
         </p:txBody>
@@ -6395,8 +6819,8 @@
         </p:nvSpPr>
         <p:spPr>
           <a:xfrm>
-            <a:off x="914400" y="1463040"/>
-            <a:ext cx="10360152" cy="4114800"/>
+            <a:off x="914400" y="1280160"/>
+            <a:ext cx="10360152" cy="365760"/>
           </a:xfrm>
           <a:prstGeom prst="rect">
             <a:avLst/>
@@ -6406,294 +6830,536 @@
           <a:bodyPr anchor="t"/>
           <a:lstStyle/>
           <a:p>
+            <a:pPr algn="l"/>
+            <a:r>
+              <a:rPr sz="1400">
+                <a:solidFill>
+                  <a:srgbClr val="64748B"/>
+                </a:solidFill>
+                <a:latin typeface="+mn-lt"/>
+                <a:cs typeface="+mn-lt"/>
+              </a:rPr>
+              <a:t>Ingress routing, stateless isolate compilation, and distributed object persistence</a:t>
+            </a:r>
+          </a:p>
+        </p:txBody>
+      </p:sp>
+      <p:sp>
+        <p:nvSpPr>
+          <p:cNvPr id="4" name="roundRect 3"/>
+          <p:cNvSpPr/>
+          <p:nvPr/>
+        </p:nvSpPr>
+        <p:spPr>
+          <a:xfrm>
+            <a:off x="914400" y="1828800"/>
+            <a:ext cx="3291840" cy="4114800"/>
+          </a:xfrm>
+          <a:prstGeom prst="roundRect">
+            <a:avLst/>
+          </a:prstGeom>
+          <a:solidFill>
+            <a:srgbClr val="FFFFFF"/>
+          </a:solidFill>
+          <a:ln w="13716">
+            <a:solidFill>
+              <a:srgbClr val="E2E8F0"/>
+            </a:solidFill>
+          </a:ln>
+          <a:effectLst>
+            <a:outerShdw blurRad="137160" dist="45720" dir="5400000">
+              <a:srgbClr val="0F172A">
+                <a:alpha val="12000"/>
+              </a:srgbClr>
+            </a:outerShdw>
+          </a:effectLst>
+        </p:spPr>
+        <p:txBody>
+          <a:bodyPr/>
+          <a:lstStyle/>
+          <a:p>
+            <a:endParaRPr/>
+          </a:p>
+        </p:txBody>
+      </p:sp>
+      <p:sp>
+        <p:nvSpPr>
+          <p:cNvPr id="5" name="roundRect 4"/>
+          <p:cNvSpPr/>
+          <p:nvPr/>
+        </p:nvSpPr>
+        <p:spPr>
+          <a:xfrm>
+            <a:off x="1188720" y="2103120"/>
+            <a:ext cx="1828800" cy="320040"/>
+          </a:xfrm>
+          <a:prstGeom prst="roundRect">
+            <a:avLst/>
+          </a:prstGeom>
+          <a:solidFill>
+            <a:srgbClr val="F8FAFC"/>
+          </a:solidFill>
+          <a:ln w="9144">
+            <a:solidFill>
+              <a:srgbClr val="0284C7"/>
+            </a:solidFill>
+          </a:ln>
+        </p:spPr>
+        <p:txBody>
+          <a:bodyPr anchor="t"/>
+          <a:lstStyle/>
+          <a:p>
+            <a:pPr algn="ctr"/>
+            <a:r>
+              <a:rPr b="1" sz="900">
+                <a:solidFill>
+                  <a:srgbClr val="0284C7"/>
+                </a:solidFill>
+                <a:latin typeface="+mn-lt"/>
+                <a:cs typeface="+mn-lt"/>
+              </a:rPr>
+              <a:t>TIER 1 • INGRESS</a:t>
+            </a:r>
+          </a:p>
+        </p:txBody>
+      </p:sp>
+      <p:sp>
+        <p:nvSpPr>
+          <p:cNvPr id="6" name="Text Box 5"/>
+          <p:cNvSpPr/>
+          <p:nvPr/>
+        </p:nvSpPr>
+        <p:spPr>
+          <a:xfrm>
+            <a:off x="1188720" y="2560320"/>
+            <a:ext cx="2743200" cy="457200"/>
+          </a:xfrm>
+          <a:prstGeom prst="rect">
+            <a:avLst/>
+          </a:prstGeom>
+        </p:spPr>
+        <p:txBody>
+          <a:bodyPr anchor="t"/>
+          <a:lstStyle/>
+          <a:p>
+            <a:pPr algn="l"/>
+            <a:r>
+              <a:rPr b="1" sz="1600">
+                <a:solidFill>
+                  <a:srgbClr val="0F172A"/>
+                </a:solidFill>
+                <a:latin typeface="+mn-lt"/>
+                <a:cs typeface="+mn-lt"/>
+              </a:rPr>
+              <a:t>Global Edge Router</a:t>
+            </a:r>
+          </a:p>
+        </p:txBody>
+      </p:sp>
+      <p:sp>
+        <p:nvSpPr>
+          <p:cNvPr id="7" name="Text Box 6"/>
+          <p:cNvSpPr/>
+          <p:nvPr/>
+        </p:nvSpPr>
+        <p:spPr>
+          <a:xfrm>
+            <a:off x="1188720" y="3108960"/>
+            <a:ext cx="2743200" cy="2286000"/>
+          </a:xfrm>
+          <a:prstGeom prst="rect">
+            <a:avLst/>
+          </a:prstGeom>
+        </p:spPr>
+        <p:txBody>
+          <a:bodyPr anchor="t"/>
+          <a:lstStyle/>
+          <a:p>
             <a:pPr algn="l" lvl="0"/>
             <a:r>
-              <a:rPr sz="1200">
-                <a:solidFill>
-                  <a:srgbClr val="E2E8F0"/>
-                </a:solidFill>
-                <a:latin typeface="+mn-lt"/>
-                <a:cs typeface="+mn-lt"/>
-              </a:rPr>
-              <a:t>1. Nominal Units &amp; Compile-Time Safety</a:t>
-            </a:r>
-          </a:p>
-          <a:p>
-            <a:pPr algn="l" lvl="1"/>
-            <a:r>
-              <a:rPr sz="1200">
-                <a:solidFill>
-                  <a:srgbClr val="E2E8F0"/>
-                </a:solidFill>
-                <a:latin typeface="+mn-lt"/>
-                <a:cs typeface="+mn-lt"/>
-              </a:rPr>
-              <a:t>1.1 Zero-runtime-overhead branded types for dimensional coordinates</a:t>
-            </a:r>
-          </a:p>
-          <a:p>
-            <a:pPr algn="l" lvl="2"/>
-            <a:r>
-              <a:rPr sz="1200">
-                <a:solidFill>
-                  <a:srgbClr val="E2E8F0"/>
-                </a:solidFill>
-                <a:latin typeface="+mn-lt"/>
-                <a:cs typeface="+mn-lt"/>
-              </a:rPr>
-              <a:t>1.1.1 English Metric Units (EMU): </a:t>
-            </a:r>
-            <a:r>
-              <a:rPr b="1" sz="1200">
-                <a:solidFill>
-                  <a:srgbClr val="38BDF8"/>
-                </a:solidFill>
-                <a:latin typeface="+mn-lt"/>
-                <a:cs typeface="+mn-lt"/>
-              </a:rPr>
-              <a:t>1 inch = 914,400 EMU</a:t>
-            </a:r>
-            <a:r>
-              <a:rPr sz="1200">
-                <a:solidFill>
-                  <a:srgbClr val="E2E8F0"/>
-                </a:solidFill>
-                <a:latin typeface="+mn-lt"/>
-                <a:cs typeface="+mn-lt"/>
-              </a:rPr>
-              <a:t> — </a:t>
-            </a:r>
-            <a:r>
-              <a:rPr b="1" sz="1200">
+              <a:rPr sz="1100">
+                <a:solidFill>
+                  <a:srgbClr val="475569"/>
+                </a:solidFill>
+                <a:latin typeface="+mn-lt"/>
+                <a:cs typeface="+mn-lt"/>
+              </a:rPr>
+              <a:t>Anycast DNS routing (330+ locations)</a:t>
+            </a:r>
+          </a:p>
+          <a:p>
+            <a:pPr algn="l" lvl="0"/>
+            <a:r>
+              <a:rPr sz="1100">
+                <a:solidFill>
+                  <a:srgbClr val="475569"/>
+                </a:solidFill>
+                <a:latin typeface="+mn-lt"/>
+                <a:cs typeface="+mn-lt"/>
+              </a:rPr>
+              <a:t>TLS 1.3 0-RTT termination</a:t>
+            </a:r>
+          </a:p>
+          <a:p>
+            <a:pPr algn="l" lvl="0"/>
+            <a:r>
+              <a:rPr sz="1100">
+                <a:solidFill>
+                  <a:srgbClr val="475569"/>
+                </a:solidFill>
+                <a:latin typeface="+mn-lt"/>
+                <a:cs typeface="+mn-lt"/>
+              </a:rPr>
+              <a:t>DDoS protection &amp; Rate limiting</a:t>
+            </a:r>
+          </a:p>
+        </p:txBody>
+      </p:sp>
+      <p:sp>
+        <p:nvSpPr>
+          <p:cNvPr id="8" name="roundRect 7"/>
+          <p:cNvSpPr/>
+          <p:nvPr/>
+        </p:nvSpPr>
+        <p:spPr>
+          <a:xfrm>
+            <a:off x="4389120" y="1828800"/>
+            <a:ext cx="3291840" cy="4114800"/>
+          </a:xfrm>
+          <a:prstGeom prst="roundRect">
+            <a:avLst/>
+          </a:prstGeom>
+          <a:solidFill>
+            <a:srgbClr val="FFFFFF"/>
+          </a:solidFill>
+          <a:ln w="13716">
+            <a:solidFill>
+              <a:srgbClr val="E2E8F0"/>
+            </a:solidFill>
+          </a:ln>
+          <a:effectLst>
+            <a:outerShdw blurRad="137160" dist="45720" dir="5400000">
+              <a:srgbClr val="0F172A">
+                <a:alpha val="12000"/>
+              </a:srgbClr>
+            </a:outerShdw>
+          </a:effectLst>
+        </p:spPr>
+        <p:txBody>
+          <a:bodyPr/>
+          <a:lstStyle/>
+          <a:p>
+            <a:endParaRPr/>
+          </a:p>
+        </p:txBody>
+      </p:sp>
+      <p:sp>
+        <p:nvSpPr>
+          <p:cNvPr id="9" name="roundRect 8"/>
+          <p:cNvSpPr/>
+          <p:nvPr/>
+        </p:nvSpPr>
+        <p:spPr>
+          <a:xfrm>
+            <a:off x="4663440" y="2103120"/>
+            <a:ext cx="1828800" cy="320040"/>
+          </a:xfrm>
+          <a:prstGeom prst="roundRect">
+            <a:avLst/>
+          </a:prstGeom>
+          <a:solidFill>
+            <a:srgbClr val="F8FAFC"/>
+          </a:solidFill>
+          <a:ln w="9144">
+            <a:solidFill>
+              <a:srgbClr val="6366F1"/>
+            </a:solidFill>
+          </a:ln>
+        </p:spPr>
+        <p:txBody>
+          <a:bodyPr anchor="t"/>
+          <a:lstStyle/>
+          <a:p>
+            <a:pPr algn="ctr"/>
+            <a:r>
+              <a:rPr b="1" sz="900">
+                <a:solidFill>
+                  <a:srgbClr val="6366F1"/>
+                </a:solidFill>
+                <a:latin typeface="+mn-lt"/>
+                <a:cs typeface="+mn-lt"/>
+              </a:rPr>
+              <a:t>TIER 2 • COMPUTE</a:t>
+            </a:r>
+          </a:p>
+        </p:txBody>
+      </p:sp>
+      <p:sp>
+        <p:nvSpPr>
+          <p:cNvPr id="10" name="Text Box 9"/>
+          <p:cNvSpPr/>
+          <p:nvPr/>
+        </p:nvSpPr>
+        <p:spPr>
+          <a:xfrm>
+            <a:off x="4663440" y="2560320"/>
+            <a:ext cx="2743200" cy="457200"/>
+          </a:xfrm>
+          <a:prstGeom prst="rect">
+            <a:avLst/>
+          </a:prstGeom>
+        </p:spPr>
+        <p:txBody>
+          <a:bodyPr anchor="t"/>
+          <a:lstStyle/>
+          <a:p>
+            <a:pPr algn="l"/>
+            <a:r>
+              <a:rPr b="1" sz="1600">
+                <a:solidFill>
+                  <a:srgbClr val="0F172A"/>
+                </a:solidFill>
+                <a:latin typeface="+mn-lt"/>
+                <a:cs typeface="+mn-lt"/>
+              </a:rPr>
+              <a:t>Stateless Worker Fleet</a:t>
+            </a:r>
+          </a:p>
+        </p:txBody>
+      </p:sp>
+      <p:sp>
+        <p:nvSpPr>
+          <p:cNvPr id="11" name="Text Box 10"/>
+          <p:cNvSpPr/>
+          <p:nvPr/>
+        </p:nvSpPr>
+        <p:spPr>
+          <a:xfrm>
+            <a:off x="4663440" y="3108960"/>
+            <a:ext cx="2743200" cy="2286000"/>
+          </a:xfrm>
+          <a:prstGeom prst="rect">
+            <a:avLst/>
+          </a:prstGeom>
+        </p:spPr>
+        <p:txBody>
+          <a:bodyPr anchor="t"/>
+          <a:lstStyle/>
+          <a:p>
+            <a:pPr algn="l" lvl="0"/>
+            <a:r>
+              <a:rPr sz="1100">
+                <a:solidFill>
+                  <a:srgbClr val="475569"/>
+                </a:solidFill>
+                <a:latin typeface="+mn-lt"/>
+                <a:cs typeface="+mn-lt"/>
+              </a:rPr>
+              <a:t>V8 Isolate sandboxed execution</a:t>
+            </a:r>
+          </a:p>
+          <a:p>
+            <a:pPr algn="l" lvl="0"/>
+            <a:r>
+              <a:rPr sz="1100">
+                <a:solidFill>
+                  <a:srgbClr val="475569"/>
+                </a:solidFill>
+                <a:latin typeface="+mn-lt"/>
+                <a:cs typeface="+mn-lt"/>
+              </a:rPr>
+              <a:t>Instant &lt;5ms cold starts</a:t>
+            </a:r>
+          </a:p>
+          <a:p>
+            <a:pPr algn="l" lvl="0"/>
+            <a:r>
+              <a:rPr sz="1100">
+                <a:solidFill>
+                  <a:srgbClr val="475569"/>
+                </a:solidFill>
+                <a:latin typeface="+mn-lt"/>
+                <a:cs typeface="+mn-lt"/>
+              </a:rPr>
+              <a:t>Streaming SSR &amp; WebSockets</a:t>
+            </a:r>
+          </a:p>
+        </p:txBody>
+      </p:sp>
+      <p:sp>
+        <p:nvSpPr>
+          <p:cNvPr id="12" name="roundRect 11"/>
+          <p:cNvSpPr/>
+          <p:nvPr/>
+        </p:nvSpPr>
+        <p:spPr>
+          <a:xfrm>
+            <a:off x="7863840" y="1828800"/>
+            <a:ext cx="3291840" cy="4114800"/>
+          </a:xfrm>
+          <a:prstGeom prst="roundRect">
+            <a:avLst/>
+          </a:prstGeom>
+          <a:solidFill>
+            <a:srgbClr val="FFFFFF"/>
+          </a:solidFill>
+          <a:ln w="13716">
+            <a:solidFill>
+              <a:srgbClr val="E2E8F0"/>
+            </a:solidFill>
+          </a:ln>
+          <a:effectLst>
+            <a:outerShdw blurRad="137160" dist="45720" dir="5400000">
+              <a:srgbClr val="0F172A">
+                <a:alpha val="12000"/>
+              </a:srgbClr>
+            </a:outerShdw>
+          </a:effectLst>
+        </p:spPr>
+        <p:txBody>
+          <a:bodyPr/>
+          <a:lstStyle/>
+          <a:p>
+            <a:endParaRPr/>
+          </a:p>
+        </p:txBody>
+      </p:sp>
+      <p:sp>
+        <p:nvSpPr>
+          <p:cNvPr id="13" name="roundRect 12"/>
+          <p:cNvSpPr/>
+          <p:nvPr/>
+        </p:nvSpPr>
+        <p:spPr>
+          <a:xfrm>
+            <a:off x="8138160" y="2103120"/>
+            <a:ext cx="1828800" cy="320040"/>
+          </a:xfrm>
+          <a:prstGeom prst="roundRect">
+            <a:avLst/>
+          </a:prstGeom>
+          <a:solidFill>
+            <a:srgbClr val="F8FAFC"/>
+          </a:solidFill>
+          <a:ln w="9144">
+            <a:solidFill>
+              <a:srgbClr val="10B981"/>
+            </a:solidFill>
+          </a:ln>
+        </p:spPr>
+        <p:txBody>
+          <a:bodyPr anchor="t"/>
+          <a:lstStyle/>
+          <a:p>
+            <a:pPr algn="ctr"/>
+            <a:r>
+              <a:rPr b="1" sz="900">
                 <a:solidFill>
                   <a:srgbClr val="10B981"/>
                 </a:solidFill>
                 <a:latin typeface="+mn-lt"/>
                 <a:cs typeface="+mn-lt"/>
               </a:rPr>
-              <a:t>1 pt = 12,700 EMU</a:t>
-            </a:r>
-          </a:p>
-          <a:p>
-            <a:pPr algn="l" lvl="2"/>
-            <a:r>
-              <a:rPr sz="1200">
-                <a:solidFill>
-                  <a:srgbClr val="E2E8F0"/>
-                </a:solidFill>
-                <a:latin typeface="+mn-lt"/>
-                <a:cs typeface="+mn-lt"/>
-              </a:rPr>
-              <a:t>1.1.2 Rotational Angles: </a:t>
-            </a:r>
-            <a:r>
-              <a:rPr b="1" sz="1200">
-                <a:solidFill>
-                  <a:srgbClr val="F59E0B"/>
-                </a:solidFill>
-                <a:latin typeface="+mn-lt"/>
-                <a:cs typeface="+mn-lt"/>
-              </a:rPr>
-              <a:t>degrees(θ)</a:t>
-            </a:r>
-            <a:r>
-              <a:rPr sz="1200">
-                <a:solidFill>
-                  <a:srgbClr val="E2E8F0"/>
-                </a:solidFill>
-                <a:latin typeface="+mn-lt"/>
-                <a:cs typeface="+mn-lt"/>
-              </a:rPr>
-              <a:t> compiles to </a:t>
-            </a:r>
-            <a:r>
-              <a:rPr b="1" sz="1200">
-                <a:solidFill>
-                  <a:srgbClr val="F59E0B"/>
-                </a:solidFill>
-                <a:latin typeface="+mn-lt"/>
-                <a:cs typeface="+mn-lt"/>
-              </a:rPr>
-              <a:t>θ × 60,000 EmuDegrees</a:t>
-            </a:r>
-          </a:p>
-          <a:p>
-            <a:pPr algn="l" lvl="2"/>
-            <a:r>
-              <a:rPr sz="1200">
-                <a:solidFill>
-                  <a:srgbClr val="E2E8F0"/>
-                </a:solidFill>
-                <a:latin typeface="+mn-lt"/>
-                <a:cs typeface="+mn-lt"/>
-              </a:rPr>
-              <a:t>1.1.3 Maximum memory ceiling: </a:t>
-            </a:r>
-            <a:r>
-              <a:rPr b="1" sz="1200">
-                <a:solidFill>
-                  <a:srgbClr val="F59E0B"/>
-                </a:solidFill>
-                <a:latin typeface="+mn-lt"/>
-                <a:cs typeface="+mn-lt"/>
-              </a:rPr>
-              <a:t>2</a:t>
-            </a:r>
-            <a:r>
-              <a:rPr b="1" baseline="30000" sz="1200">
-                <a:solidFill>
-                  <a:srgbClr val="F59E0B"/>
-                </a:solidFill>
-                <a:latin typeface="+mn-lt"/>
-                <a:cs typeface="+mn-lt"/>
-              </a:rPr>
-              <a:t>32</a:t>
-            </a:r>
-            <a:r>
-              <a:rPr sz="1200">
-                <a:solidFill>
-                  <a:srgbClr val="E2E8F0"/>
-                </a:solidFill>
-                <a:latin typeface="+mn-lt"/>
-                <a:cs typeface="+mn-lt"/>
-              </a:rPr>
-              <a:t> bytes (4 GB buffer limit)</a:t>
-            </a:r>
-          </a:p>
+              <a:t>TIER 3 • STORAGE</a:t>
+            </a:r>
+          </a:p>
+        </p:txBody>
+      </p:sp>
+      <p:sp>
+        <p:nvSpPr>
+          <p:cNvPr id="14" name="Text Box 13"/>
+          <p:cNvSpPr/>
+          <p:nvPr/>
+        </p:nvSpPr>
+        <p:spPr>
+          <a:xfrm>
+            <a:off x="8138160" y="2560320"/>
+            <a:ext cx="2743200" cy="457200"/>
+          </a:xfrm>
+          <a:prstGeom prst="rect">
+            <a:avLst/>
+          </a:prstGeom>
+        </p:spPr>
+        <p:txBody>
+          <a:bodyPr anchor="t"/>
+          <a:lstStyle/>
+          <a:p>
+            <a:pPr algn="l"/>
+            <a:r>
+              <a:rPr b="1" sz="1600">
+                <a:solidFill>
+                  <a:srgbClr val="0F172A"/>
+                </a:solidFill>
+                <a:latin typeface="+mn-lt"/>
+                <a:cs typeface="+mn-lt"/>
+              </a:rPr>
+              <a:t>Distributed State Store</a:t>
+            </a:r>
+          </a:p>
+        </p:txBody>
+      </p:sp>
+      <p:sp>
+        <p:nvSpPr>
+          <p:cNvPr id="15" name="Text Box 14"/>
+          <p:cNvSpPr/>
+          <p:nvPr/>
+        </p:nvSpPr>
+        <p:spPr>
+          <a:xfrm>
+            <a:off x="8138160" y="3108960"/>
+            <a:ext cx="2743200" cy="2286000"/>
+          </a:xfrm>
+          <a:prstGeom prst="rect">
+            <a:avLst/>
+          </a:prstGeom>
+        </p:spPr>
+        <p:txBody>
+          <a:bodyPr anchor="t"/>
+          <a:lstStyle/>
           <a:p>
             <a:pPr algn="l" lvl="0"/>
             <a:r>
-              <a:rPr sz="1200">
-                <a:solidFill>
-                  <a:srgbClr val="E2E8F0"/>
-                </a:solidFill>
-                <a:latin typeface="+mn-lt"/>
-                <a:cs typeface="+mn-lt"/>
-              </a:rPr>
-              <a:t>2. High-Performance Text Run Modifiers</a:t>
-            </a:r>
-          </a:p>
-          <a:p>
-            <a:pPr algn="l" lvl="1"/>
-            <a:r>
-              <a:rPr sz="1200">
-                <a:solidFill>
-                  <a:srgbClr val="E2E8F0"/>
-                </a:solidFill>
-                <a:latin typeface="+mn-lt"/>
-                <a:cs typeface="+mn-lt"/>
-              </a:rPr>
-              <a:t>2.1 Rich inline text runs with mixed typographic styles</a:t>
-            </a:r>
-          </a:p>
-          <a:p>
-            <a:pPr algn="l" lvl="2"/>
-            <a:r>
-              <a:rPr sz="1200">
-                <a:solidFill>
-                  <a:srgbClr val="E2E8F0"/>
-                </a:solidFill>
-                <a:latin typeface="+mn-lt"/>
-                <a:cs typeface="+mn-lt"/>
-              </a:rPr>
-              <a:t>Formatting: </a:t>
-            </a:r>
-            <a:r>
-              <a:rPr b="1" sz="1200">
-                <a:solidFill>
-                  <a:srgbClr val="E2E8F0"/>
-                </a:solidFill>
-                <a:latin typeface="+mn-lt"/>
-                <a:cs typeface="+mn-lt"/>
-              </a:rPr>
-              <a:t>Bold</a:t>
-            </a:r>
-            <a:r>
-              <a:rPr sz="1200">
-                <a:solidFill>
-                  <a:srgbClr val="E2E8F0"/>
-                </a:solidFill>
-                <a:latin typeface="+mn-lt"/>
-                <a:cs typeface="+mn-lt"/>
-              </a:rPr>
-              <a:t> | </a:t>
-            </a:r>
-            <a:r>
-              <a:rPr i="1" sz="1200">
-                <a:solidFill>
-                  <a:srgbClr val="E2E8F0"/>
-                </a:solidFill>
-                <a:latin typeface="+mn-lt"/>
-                <a:cs typeface="+mn-lt"/>
-              </a:rPr>
-              <a:t>Italic</a:t>
-            </a:r>
-            <a:r>
-              <a:rPr sz="1200">
-                <a:solidFill>
-                  <a:srgbClr val="E2E8F0"/>
-                </a:solidFill>
-                <a:latin typeface="+mn-lt"/>
-                <a:cs typeface="+mn-lt"/>
-              </a:rPr>
-              <a:t> | </a:t>
-            </a:r>
-            <a:r>
-              <a:rPr u="sng" sz="1200">
-                <a:solidFill>
-                  <a:srgbClr val="E2E8F0"/>
-                </a:solidFill>
-                <a:latin typeface="+mn-lt"/>
-                <a:cs typeface="+mn-lt"/>
-              </a:rPr>
-              <a:t>Underlined</a:t>
-            </a:r>
-            <a:r>
-              <a:rPr sz="1200">
-                <a:solidFill>
-                  <a:srgbClr val="E2E8F0"/>
-                </a:solidFill>
-                <a:latin typeface="+mn-lt"/>
-                <a:cs typeface="+mn-lt"/>
-              </a:rPr>
-              <a:t> | </a:t>
-            </a:r>
-            <a:r>
-              <a:rPr strike="sngStrike" sz="1200">
-                <a:solidFill>
-                  <a:srgbClr val="E2E8F0"/>
-                </a:solidFill>
-                <a:latin typeface="+mn-lt"/>
-                <a:cs typeface="+mn-lt"/>
-              </a:rPr>
-              <a:t>Strikethrough</a:t>
-            </a:r>
-            <a:r>
-              <a:rPr sz="1200">
-                <a:solidFill>
-                  <a:srgbClr val="E2E8F0"/>
-                </a:solidFill>
-                <a:latin typeface="+mn-lt"/>
-                <a:cs typeface="+mn-lt"/>
-              </a:rPr>
-              <a:t> | </a:t>
-            </a:r>
-            <a:r>
-              <a:rPr b="1" sz="1200">
-                <a:solidFill>
-                  <a:srgbClr val="6366F1"/>
-                </a:solidFill>
-                <a:latin typeface="+mn-lt"/>
-                <a:cs typeface="+mn-lt"/>
-              </a:rPr>
-              <a:t>Colored #6366F1</a:t>
-            </a:r>
-          </a:p>
-        </p:txBody>
-      </p:sp>
-      <p:sp>
-        <p:nvSpPr>
-          <p:cNvPr id="4" name="Text Box 3"/>
+              <a:rPr sz="1100">
+                <a:solidFill>
+                  <a:srgbClr val="475569"/>
+                </a:solidFill>
+                <a:latin typeface="+mn-lt"/>
+                <a:cs typeface="+mn-lt"/>
+              </a:rPr>
+              <a:t>Globally replicated R2 object store</a:t>
+            </a:r>
+          </a:p>
+          <a:p>
+            <a:pPr algn="l" lvl="0"/>
+            <a:r>
+              <a:rPr sz="1100">
+                <a:solidFill>
+                  <a:srgbClr val="475569"/>
+                </a:solidFill>
+                <a:latin typeface="+mn-lt"/>
+                <a:cs typeface="+mn-lt"/>
+              </a:rPr>
+              <a:t>Low-latency D1 serverless SQLite</a:t>
+            </a:r>
+          </a:p>
+          <a:p>
+            <a:pPr algn="l" lvl="0"/>
+            <a:r>
+              <a:rPr sz="1100">
+                <a:solidFill>
+                  <a:srgbClr val="475569"/>
+                </a:solidFill>
+                <a:latin typeface="+mn-lt"/>
+                <a:cs typeface="+mn-lt"/>
+              </a:rPr>
+              <a:t>Workers KV key-value cache</a:t>
+            </a:r>
+          </a:p>
+        </p:txBody>
+      </p:sp>
+      <p:sp>
+        <p:nvSpPr>
+          <p:cNvPr id="16" name="Text Box 15"/>
           <p:cNvSpPr/>
           <p:nvPr/>
         </p:nvSpPr>
@@ -6714,7 +7380,7 @@
             <a:r>
               <a:rPr i="1" sz="800">
                 <a:solidFill>
-                  <a:srgbClr val="64748B"/>
+                  <a:srgbClr val="94A3B8"/>
                 </a:solidFill>
                 <a:latin typeface="+mn-lt"/>
                 <a:cs typeface="+mn-lt"/>
@@ -6729,10 +7395,477 @@
   <p:clrMapOvr>
     <a:masterClrMapping/>
   </p:clrMapOvr>
+  <p:transition spd="fast">
+    <p:cover dir="l"/>
+  </p:transition>
 </p:sld>
 </file>
 
-<file path=ppt/slides/slide5.xml><?xml version="1.0" encoding="utf-8"?>
+<file path=ppt/slides/slide6.xml><?xml version="1.0" encoding="utf-8"?>
+<p:sld xmlns:a="http://schemas.openxmlformats.org/drawingml/2006/main" xmlns:r="http://schemas.openxmlformats.org/officeDocument/2006/relationships" xmlns:p="http://schemas.openxmlformats.org/presentationml/2006/main">
+  <p:cSld>
+    <p:bg>
+      <p:bgPr>
+        <a:solidFill>
+          <a:srgbClr val="FFFFFF"/>
+        </a:solidFill>
+        <a:effectLst/>
+      </p:bgPr>
+    </p:bg>
+    <p:spTree>
+      <p:nvGrpSpPr>
+        <p:cNvPr id="1" name=""/>
+        <p:cNvGrpSpPr/>
+        <p:nvPr/>
+      </p:nvGrpSpPr>
+      <p:grpSpPr>
+        <a:xfrm>
+          <a:off x="0" y="0"/>
+          <a:ext cx="0" cy="0"/>
+          <a:chOff x="0" y="0"/>
+          <a:chExt cx="0" cy="0"/>
+        </a:xfrm>
+      </p:grpSpPr>
+      <p:sp>
+        <p:nvSpPr>
+          <p:cNvPr id="2" name="Text Box 1"/>
+          <p:cNvSpPr/>
+          <p:nvPr/>
+        </p:nvSpPr>
+        <p:spPr>
+          <a:xfrm>
+            <a:off x="914400" y="731520"/>
+            <a:ext cx="10360152" cy="548640"/>
+          </a:xfrm>
+          <a:prstGeom prst="rect">
+            <a:avLst/>
+          </a:prstGeom>
+        </p:spPr>
+        <p:txBody>
+          <a:bodyPr anchor="t"/>
+          <a:lstStyle/>
+          <a:p>
+            <a:pPr algn="l"/>
+            <a:r>
+              <a:rPr b="1" sz="2400">
+                <a:solidFill>
+                  <a:srgbClr val="0F172A"/>
+                </a:solidFill>
+                <a:latin typeface="+mj-lt"/>
+                <a:cs typeface="+mj-lt"/>
+              </a:rPr>
+              <a:t>Isomorphic Media &amp; High-Fidelity Image Embedding</a:t>
+            </a:r>
+          </a:p>
+        </p:txBody>
+      </p:sp>
+      <p:sp>
+        <p:nvSpPr>
+          <p:cNvPr id="3" name="Text Box 2"/>
+          <p:cNvSpPr/>
+          <p:nvPr/>
+        </p:nvSpPr>
+        <p:spPr>
+          <a:xfrm>
+            <a:off x="914400" y="1280160"/>
+            <a:ext cx="10360152" cy="365760"/>
+          </a:xfrm>
+          <a:prstGeom prst="rect">
+            <a:avLst/>
+          </a:prstGeom>
+        </p:spPr>
+        <p:txBody>
+          <a:bodyPr anchor="t"/>
+          <a:lstStyle/>
+          <a:p>
+            <a:pPr algn="l"/>
+            <a:r>
+              <a:rPr sz="1400">
+                <a:solidFill>
+                  <a:srgbClr val="64748B"/>
+                </a:solidFill>
+                <a:latin typeface="+mn-lt"/>
+                <a:cs typeface="+mn-lt"/>
+              </a:rPr>
+              <a:t>Embedded raster graphics (PNG, JPEG), transparent alpha channels, aspect ratio scaling, and card layouts</a:t>
+            </a:r>
+          </a:p>
+        </p:txBody>
+      </p:sp>
+      <p:sp>
+        <p:nvSpPr>
+          <p:cNvPr id="4" name="roundRect 3"/>
+          <p:cNvSpPr/>
+          <p:nvPr/>
+        </p:nvSpPr>
+        <p:spPr>
+          <a:xfrm>
+            <a:off x="914400" y="1828800"/>
+            <a:ext cx="4937760" cy="4114800"/>
+          </a:xfrm>
+          <a:prstGeom prst="roundRect">
+            <a:avLst/>
+          </a:prstGeom>
+          <a:solidFill>
+            <a:srgbClr val="FFFFFF"/>
+          </a:solidFill>
+          <a:ln w="13716">
+            <a:solidFill>
+              <a:srgbClr val="E2E8F0"/>
+            </a:solidFill>
+          </a:ln>
+          <a:effectLst>
+            <a:outerShdw blurRad="137160" dist="45720" dir="5400000">
+              <a:srgbClr val="0F172A">
+                <a:alpha val="10000"/>
+              </a:srgbClr>
+            </a:outerShdw>
+          </a:effectLst>
+        </p:spPr>
+        <p:txBody>
+          <a:bodyPr/>
+          <a:lstStyle/>
+          <a:p>
+            <a:endParaRPr/>
+          </a:p>
+        </p:txBody>
+      </p:sp>
+      <p:sp>
+        <p:nvSpPr>
+          <p:cNvPr id="6" name="Text Box 5"/>
+          <p:cNvSpPr/>
+          <p:nvPr/>
+        </p:nvSpPr>
+        <p:spPr>
+          <a:xfrm>
+            <a:off x="1188720" y="4754880"/>
+            <a:ext cx="4389120" cy="365760"/>
+          </a:xfrm>
+          <a:prstGeom prst="rect">
+            <a:avLst/>
+          </a:prstGeom>
+        </p:spPr>
+        <p:txBody>
+          <a:bodyPr anchor="t"/>
+          <a:lstStyle/>
+          <a:p>
+            <a:pPr algn="l"/>
+            <a:r>
+              <a:rPr b="1" sz="1500">
+                <a:solidFill>
+                  <a:srgbClr val="0F172A"/>
+                </a:solidFill>
+                <a:latin typeface="+mn-lt"/>
+                <a:cs typeface="+mn-lt"/>
+              </a:rPr>
+              <a:t>Rich Visual Asset Integration</a:t>
+            </a:r>
+          </a:p>
+        </p:txBody>
+      </p:sp>
+      <p:sp>
+        <p:nvSpPr>
+          <p:cNvPr id="7" name="Text Box 6"/>
+          <p:cNvSpPr/>
+          <p:nvPr/>
+        </p:nvSpPr>
+        <p:spPr>
+          <a:xfrm>
+            <a:off x="1188720" y="5120640"/>
+            <a:ext cx="4389120" cy="548640"/>
+          </a:xfrm>
+          <a:prstGeom prst="rect">
+            <a:avLst/>
+          </a:prstGeom>
+        </p:spPr>
+        <p:txBody>
+          <a:bodyPr anchor="t"/>
+          <a:lstStyle/>
+          <a:p>
+            <a:pPr algn="l"/>
+            <a:r>
+              <a:rPr sz="1100">
+                <a:solidFill>
+                  <a:srgbClr val="64748B"/>
+                </a:solidFill>
+                <a:latin typeface="+mn-lt"/>
+                <a:cs typeface="+mn-lt"/>
+              </a:rPr>
+              <a:t>Automatic MIME-type detection, relationship mapping, and lossless OpenXML zip packaging.</a:t>
+            </a:r>
+          </a:p>
+        </p:txBody>
+      </p:sp>
+      <p:sp>
+        <p:nvSpPr>
+          <p:cNvPr id="8" name="roundRect 7"/>
+          <p:cNvSpPr/>
+          <p:nvPr/>
+        </p:nvSpPr>
+        <p:spPr>
+          <a:xfrm>
+            <a:off x="6336792" y="1828800"/>
+            <a:ext cx="4937760" cy="4114800"/>
+          </a:xfrm>
+          <a:prstGeom prst="roundRect">
+            <a:avLst/>
+          </a:prstGeom>
+          <a:solidFill>
+            <a:srgbClr val="FFFFFF"/>
+          </a:solidFill>
+          <a:ln w="13716">
+            <a:solidFill>
+              <a:srgbClr val="E2E8F0"/>
+            </a:solidFill>
+          </a:ln>
+          <a:effectLst>
+            <a:outerShdw blurRad="137160" dist="45720" dir="5400000">
+              <a:srgbClr val="0F172A">
+                <a:alpha val="10000"/>
+              </a:srgbClr>
+            </a:outerShdw>
+          </a:effectLst>
+        </p:spPr>
+        <p:txBody>
+          <a:bodyPr/>
+          <a:lstStyle/>
+          <a:p>
+            <a:endParaRPr/>
+          </a:p>
+        </p:txBody>
+      </p:sp>
+      <p:sp>
+        <p:nvSpPr>
+          <p:cNvPr id="9" name="roundRect 8"/>
+          <p:cNvSpPr/>
+          <p:nvPr/>
+        </p:nvSpPr>
+        <p:spPr>
+          <a:xfrm>
+            <a:off x="6611112" y="2103120"/>
+            <a:ext cx="4389120" cy="1097280"/>
+          </a:xfrm>
+          <a:prstGeom prst="roundRect">
+            <a:avLst/>
+          </a:prstGeom>
+          <a:solidFill>
+            <a:srgbClr val="0F172A"/>
+          </a:solidFill>
+        </p:spPr>
+        <p:txBody>
+          <a:bodyPr/>
+          <a:lstStyle/>
+          <a:p>
+            <a:endParaRPr/>
+          </a:p>
+        </p:txBody>
+      </p:sp>
+      <p:sp>
+        <p:nvSpPr>
+          <p:cNvPr id="11" name="Text Box 10"/>
+          <p:cNvSpPr/>
+          <p:nvPr/>
+        </p:nvSpPr>
+        <p:spPr>
+          <a:xfrm>
+            <a:off x="6611112" y="3383280"/>
+            <a:ext cx="4389120" cy="365760"/>
+          </a:xfrm>
+          <a:prstGeom prst="rect">
+            <a:avLst/>
+          </a:prstGeom>
+        </p:spPr>
+        <p:txBody>
+          <a:bodyPr anchor="t"/>
+          <a:lstStyle/>
+          <a:p>
+            <a:pPr algn="l"/>
+            <a:r>
+              <a:rPr b="1" sz="1500">
+                <a:solidFill>
+                  <a:srgbClr val="0F172A"/>
+                </a:solidFill>
+                <a:latin typeface="+mn-lt"/>
+                <a:cs typeface="+mn-lt"/>
+              </a:rPr>
+              <a:t>Supported Image Codecs &amp; Features</a:t>
+            </a:r>
+          </a:p>
+        </p:txBody>
+      </p:sp>
+      <p:sp>
+        <p:nvSpPr>
+          <p:cNvPr id="12" name="Text Box 11"/>
+          <p:cNvSpPr/>
+          <p:nvPr/>
+        </p:nvSpPr>
+        <p:spPr>
+          <a:xfrm>
+            <a:off x="6611112" y="3840480"/>
+            <a:ext cx="4389120" cy="2011680"/>
+          </a:xfrm>
+          <a:prstGeom prst="rect">
+            <a:avLst/>
+          </a:prstGeom>
+        </p:spPr>
+        <p:txBody>
+          <a:bodyPr anchor="t"/>
+          <a:lstStyle/>
+          <a:p>
+            <a:pPr algn="l" lvl="0" marL="152400" indent="-152400">
+              <a:buChar char="•"/>
+            </a:pPr>
+            <a:r>
+              <a:rPr sz="1100">
+                <a:solidFill>
+                  <a:srgbClr val="475569"/>
+                </a:solidFill>
+                <a:latin typeface="+mn-lt"/>
+                <a:cs typeface="+mn-lt"/>
+              </a:rPr>
+              <a:t>PNG with 32-bit RGBA alpha transparency</a:t>
+            </a:r>
+          </a:p>
+          <a:p>
+            <a:pPr algn="l" lvl="0" marL="152400" indent="-152400">
+              <a:buChar char="•"/>
+            </a:pPr>
+            <a:r>
+              <a:rPr sz="1100">
+                <a:solidFill>
+                  <a:srgbClr val="475569"/>
+                </a:solidFill>
+                <a:latin typeface="+mn-lt"/>
+                <a:cs typeface="+mn-lt"/>
+              </a:rPr>
+              <a:t>JPEG / JPG progressive and baseline encoding</a:t>
+            </a:r>
+          </a:p>
+          <a:p>
+            <a:pPr algn="l" lvl="0" marL="152400" indent="-152400">
+              <a:buChar char="•"/>
+            </a:pPr>
+            <a:r>
+              <a:rPr sz="1100">
+                <a:solidFill>
+                  <a:srgbClr val="475569"/>
+                </a:solidFill>
+                <a:latin typeface="+mn-lt"/>
+                <a:cs typeface="+mn-lt"/>
+              </a:rPr>
+              <a:t>Zero-copy ArrayBuffer &amp; Uint8Array input</a:t>
+            </a:r>
+          </a:p>
+          <a:p>
+            <a:pPr algn="l" lvl="0" marL="152400" indent="-152400">
+              <a:buChar char="•"/>
+            </a:pPr>
+            <a:r>
+              <a:rPr sz="1100">
+                <a:solidFill>
+                  <a:srgbClr val="475569"/>
+                </a:solidFill>
+                <a:latin typeface="+mn-lt"/>
+                <a:cs typeface="+mn-lt"/>
+              </a:rPr>
+              <a:t>Placeholder resolution into slide layout picture frames</a:t>
+            </a:r>
+          </a:p>
+        </p:txBody>
+      </p:sp>
+      <p:sp>
+        <p:nvSpPr>
+          <p:cNvPr id="13" name="Text Box 12"/>
+          <p:cNvSpPr/>
+          <p:nvPr/>
+        </p:nvSpPr>
+        <p:spPr>
+          <a:xfrm>
+            <a:off x="731520" y="6510528"/>
+            <a:ext cx="10725912" cy="228600"/>
+          </a:xfrm>
+          <a:prstGeom prst="rect">
+            <a:avLst/>
+          </a:prstGeom>
+        </p:spPr>
+        <p:txBody>
+          <a:bodyPr anchor="t"/>
+          <a:lstStyle/>
+          <a:p>
+            <a:pPr algn="ctr"/>
+            <a:r>
+              <a:rPr i="1" sz="800">
+                <a:solidFill>
+                  <a:srgbClr val="94A3B8"/>
+                </a:solidFill>
+                <a:latin typeface="+mn-lt"/>
+                <a:cs typeface="+mn-lt"/>
+              </a:rPr>
+              <a:t>* Disclaimer: All benchmark metrics, performance figures, and simulated architectures in this deck are synthetic demonstration values generated solely to showcase the authoring, formatting, and rendering capabilities of @hokkyss/pptx.</a:t>
+            </a:r>
+          </a:p>
+        </p:txBody>
+      </p:sp>
+      <p:pic>
+        <p:nvPicPr>
+          <p:cNvPr id="5" name="Picture 4"/>
+          <p:cNvPicPr>
+            <a:picLocks noChangeAspect="1"/>
+          </p:cNvPicPr>
+          <p:nvPr/>
+        </p:nvPicPr>
+        <p:blipFill>
+          <a:blip r:embed="rId2"/>
+          <a:stretch>
+            <a:fillRect/>
+          </a:stretch>
+        </p:blipFill>
+        <p:spPr>
+          <a:xfrm>
+            <a:off x="1188720" y="2103120"/>
+            <a:ext cx="4389120" cy="2468880"/>
+          </a:xfrm>
+          <a:prstGeom prst="rect">
+            <a:avLst/>
+          </a:prstGeom>
+        </p:spPr>
+      </p:pic>
+      <p:pic>
+        <p:nvPicPr>
+          <p:cNvPr id="10" name="Picture 9"/>
+          <p:cNvPicPr>
+            <a:picLocks noChangeAspect="1"/>
+          </p:cNvPicPr>
+          <p:nvPr/>
+        </p:nvPicPr>
+        <p:blipFill>
+          <a:blip r:embed="rId3"/>
+          <a:stretch>
+            <a:fillRect/>
+          </a:stretch>
+        </p:blipFill>
+        <p:spPr>
+          <a:xfrm>
+            <a:off x="7891272" y="2286000"/>
+            <a:ext cx="1828800" cy="731520"/>
+          </a:xfrm>
+          <a:prstGeom prst="rect">
+            <a:avLst/>
+          </a:prstGeom>
+        </p:spPr>
+      </p:pic>
+    </p:spTree>
+  </p:cSld>
+  <p:clrMapOvr>
+    <a:masterClrMapping/>
+  </p:clrMapOvr>
+  <p:transition spd="med">
+    <p:fade/>
+  </p:transition>
+</p:sld>
+</file>
+
+<file path=ppt/slides/slide7.xml><?xml version="1.0" encoding="utf-8"?>
 <p:sld xmlns:a="http://schemas.openxmlformats.org/drawingml/2006/main" xmlns:r="http://schemas.openxmlformats.org/officeDocument/2006/relationships" xmlns:p="http://schemas.openxmlformats.org/presentationml/2006/main">
   <p:cSld>
     <p:bg>
@@ -6780,1112 +7913,6 @@
             <a:r>
               <a:rPr b="1" sz="2400">
                 <a:solidFill>
-                  <a:srgbClr val="0F172A"/>
-                </a:solidFill>
-                <a:latin typeface="+mj-lt"/>
-                <a:cs typeface="+mj-lt"/>
-              </a:rPr>
-              <a:t>Three-Tier Decoupled Platform Architecture</a:t>
-            </a:r>
-          </a:p>
-        </p:txBody>
-      </p:sp>
-      <p:sp>
-        <p:nvSpPr>
-          <p:cNvPr id="3" name="Text Box 2"/>
-          <p:cNvSpPr/>
-          <p:nvPr/>
-        </p:nvSpPr>
-        <p:spPr>
-          <a:xfrm>
-            <a:off x="914400" y="1280160"/>
-            <a:ext cx="10360152" cy="365760"/>
-          </a:xfrm>
-          <a:prstGeom prst="rect">
-            <a:avLst/>
-          </a:prstGeom>
-        </p:spPr>
-        <p:txBody>
-          <a:bodyPr anchor="t"/>
-          <a:lstStyle/>
-          <a:p>
-            <a:pPr algn="l"/>
-            <a:r>
-              <a:rPr sz="1400">
-                <a:solidFill>
-                  <a:srgbClr val="64748B"/>
-                </a:solidFill>
-                <a:latin typeface="+mn-lt"/>
-                <a:cs typeface="+mn-lt"/>
-              </a:rPr>
-              <a:t>Ingress routing, stateless isolate compilation, and distributed object persistence</a:t>
-            </a:r>
-          </a:p>
-        </p:txBody>
-      </p:sp>
-      <p:sp>
-        <p:nvSpPr>
-          <p:cNvPr id="4" name="roundRect 3"/>
-          <p:cNvSpPr/>
-          <p:nvPr/>
-        </p:nvSpPr>
-        <p:spPr>
-          <a:xfrm>
-            <a:off x="914400" y="1828800"/>
-            <a:ext cx="3291840" cy="4114800"/>
-          </a:xfrm>
-          <a:prstGeom prst="roundRect">
-            <a:avLst/>
-          </a:prstGeom>
-          <a:solidFill>
-            <a:srgbClr val="FFFFFF"/>
-          </a:solidFill>
-          <a:ln w="13716">
-            <a:solidFill>
-              <a:srgbClr val="E2E8F0"/>
-            </a:solidFill>
-          </a:ln>
-          <a:effectLst>
-            <a:outerShdw blurRad="137160" dist="45720" dir="5400000">
-              <a:srgbClr val="0F172A">
-                <a:alpha val="12000"/>
-              </a:srgbClr>
-            </a:outerShdw>
-          </a:effectLst>
-        </p:spPr>
-        <p:txBody>
-          <a:bodyPr/>
-          <a:lstStyle/>
-          <a:p>
-            <a:endParaRPr/>
-          </a:p>
-        </p:txBody>
-      </p:sp>
-      <p:sp>
-        <p:nvSpPr>
-          <p:cNvPr id="5" name="roundRect 4"/>
-          <p:cNvSpPr/>
-          <p:nvPr/>
-        </p:nvSpPr>
-        <p:spPr>
-          <a:xfrm>
-            <a:off x="1188720" y="2103120"/>
-            <a:ext cx="1828800" cy="320040"/>
-          </a:xfrm>
-          <a:prstGeom prst="roundRect">
-            <a:avLst/>
-          </a:prstGeom>
-          <a:solidFill>
-            <a:srgbClr val="F8FAFC"/>
-          </a:solidFill>
-          <a:ln w="9144">
-            <a:solidFill>
-              <a:srgbClr val="0284C7"/>
-            </a:solidFill>
-          </a:ln>
-        </p:spPr>
-        <p:txBody>
-          <a:bodyPr anchor="t"/>
-          <a:lstStyle/>
-          <a:p>
-            <a:pPr algn="ctr"/>
-            <a:r>
-              <a:rPr b="1" sz="900">
-                <a:solidFill>
-                  <a:srgbClr val="0284C7"/>
-                </a:solidFill>
-                <a:latin typeface="+mn-lt"/>
-                <a:cs typeface="+mn-lt"/>
-              </a:rPr>
-              <a:t>TIER 1 • INGRESS</a:t>
-            </a:r>
-          </a:p>
-        </p:txBody>
-      </p:sp>
-      <p:sp>
-        <p:nvSpPr>
-          <p:cNvPr id="6" name="Text Box 5"/>
-          <p:cNvSpPr/>
-          <p:nvPr/>
-        </p:nvSpPr>
-        <p:spPr>
-          <a:xfrm>
-            <a:off x="1188720" y="2560320"/>
-            <a:ext cx="2743200" cy="457200"/>
-          </a:xfrm>
-          <a:prstGeom prst="rect">
-            <a:avLst/>
-          </a:prstGeom>
-        </p:spPr>
-        <p:txBody>
-          <a:bodyPr anchor="t"/>
-          <a:lstStyle/>
-          <a:p>
-            <a:pPr algn="l"/>
-            <a:r>
-              <a:rPr b="1" sz="1600">
-                <a:solidFill>
-                  <a:srgbClr val="0F172A"/>
-                </a:solidFill>
-                <a:latin typeface="+mn-lt"/>
-                <a:cs typeface="+mn-lt"/>
-              </a:rPr>
-              <a:t>Global Edge Router</a:t>
-            </a:r>
-          </a:p>
-        </p:txBody>
-      </p:sp>
-      <p:sp>
-        <p:nvSpPr>
-          <p:cNvPr id="7" name="Text Box 6"/>
-          <p:cNvSpPr/>
-          <p:nvPr/>
-        </p:nvSpPr>
-        <p:spPr>
-          <a:xfrm>
-            <a:off x="1188720" y="3108960"/>
-            <a:ext cx="2743200" cy="2286000"/>
-          </a:xfrm>
-          <a:prstGeom prst="rect">
-            <a:avLst/>
-          </a:prstGeom>
-        </p:spPr>
-        <p:txBody>
-          <a:bodyPr anchor="t"/>
-          <a:lstStyle/>
-          <a:p>
-            <a:pPr algn="l" lvl="0"/>
-            <a:r>
-              <a:rPr sz="1100">
-                <a:solidFill>
-                  <a:srgbClr val="475569"/>
-                </a:solidFill>
-                <a:latin typeface="+mn-lt"/>
-                <a:cs typeface="+mn-lt"/>
-              </a:rPr>
-              <a:t>Anycast DNS routing (330+ locations)</a:t>
-            </a:r>
-          </a:p>
-          <a:p>
-            <a:pPr algn="l" lvl="0"/>
-            <a:r>
-              <a:rPr sz="1100">
-                <a:solidFill>
-                  <a:srgbClr val="475569"/>
-                </a:solidFill>
-                <a:latin typeface="+mn-lt"/>
-                <a:cs typeface="+mn-lt"/>
-              </a:rPr>
-              <a:t>TLS 1.3 0-RTT termination</a:t>
-            </a:r>
-          </a:p>
-          <a:p>
-            <a:pPr algn="l" lvl="0"/>
-            <a:r>
-              <a:rPr sz="1100">
-                <a:solidFill>
-                  <a:srgbClr val="475569"/>
-                </a:solidFill>
-                <a:latin typeface="+mn-lt"/>
-                <a:cs typeface="+mn-lt"/>
-              </a:rPr>
-              <a:t>DDoS protection &amp; Rate limiting</a:t>
-            </a:r>
-          </a:p>
-        </p:txBody>
-      </p:sp>
-      <p:sp>
-        <p:nvSpPr>
-          <p:cNvPr id="8" name="roundRect 7"/>
-          <p:cNvSpPr/>
-          <p:nvPr/>
-        </p:nvSpPr>
-        <p:spPr>
-          <a:xfrm>
-            <a:off x="4389120" y="1828800"/>
-            <a:ext cx="3291840" cy="4114800"/>
-          </a:xfrm>
-          <a:prstGeom prst="roundRect">
-            <a:avLst/>
-          </a:prstGeom>
-          <a:solidFill>
-            <a:srgbClr val="FFFFFF"/>
-          </a:solidFill>
-          <a:ln w="13716">
-            <a:solidFill>
-              <a:srgbClr val="E2E8F0"/>
-            </a:solidFill>
-          </a:ln>
-          <a:effectLst>
-            <a:outerShdw blurRad="137160" dist="45720" dir="5400000">
-              <a:srgbClr val="0F172A">
-                <a:alpha val="12000"/>
-              </a:srgbClr>
-            </a:outerShdw>
-          </a:effectLst>
-        </p:spPr>
-        <p:txBody>
-          <a:bodyPr/>
-          <a:lstStyle/>
-          <a:p>
-            <a:endParaRPr/>
-          </a:p>
-        </p:txBody>
-      </p:sp>
-      <p:sp>
-        <p:nvSpPr>
-          <p:cNvPr id="9" name="roundRect 8"/>
-          <p:cNvSpPr/>
-          <p:nvPr/>
-        </p:nvSpPr>
-        <p:spPr>
-          <a:xfrm>
-            <a:off x="4663440" y="2103120"/>
-            <a:ext cx="1828800" cy="320040"/>
-          </a:xfrm>
-          <a:prstGeom prst="roundRect">
-            <a:avLst/>
-          </a:prstGeom>
-          <a:solidFill>
-            <a:srgbClr val="F8FAFC"/>
-          </a:solidFill>
-          <a:ln w="9144">
-            <a:solidFill>
-              <a:srgbClr val="6366F1"/>
-            </a:solidFill>
-          </a:ln>
-        </p:spPr>
-        <p:txBody>
-          <a:bodyPr anchor="t"/>
-          <a:lstStyle/>
-          <a:p>
-            <a:pPr algn="ctr"/>
-            <a:r>
-              <a:rPr b="1" sz="900">
-                <a:solidFill>
-                  <a:srgbClr val="6366F1"/>
-                </a:solidFill>
-                <a:latin typeface="+mn-lt"/>
-                <a:cs typeface="+mn-lt"/>
-              </a:rPr>
-              <a:t>TIER 2 • COMPUTE</a:t>
-            </a:r>
-          </a:p>
-        </p:txBody>
-      </p:sp>
-      <p:sp>
-        <p:nvSpPr>
-          <p:cNvPr id="10" name="Text Box 9"/>
-          <p:cNvSpPr/>
-          <p:nvPr/>
-        </p:nvSpPr>
-        <p:spPr>
-          <a:xfrm>
-            <a:off x="4663440" y="2560320"/>
-            <a:ext cx="2743200" cy="457200"/>
-          </a:xfrm>
-          <a:prstGeom prst="rect">
-            <a:avLst/>
-          </a:prstGeom>
-        </p:spPr>
-        <p:txBody>
-          <a:bodyPr anchor="t"/>
-          <a:lstStyle/>
-          <a:p>
-            <a:pPr algn="l"/>
-            <a:r>
-              <a:rPr b="1" sz="1600">
-                <a:solidFill>
-                  <a:srgbClr val="0F172A"/>
-                </a:solidFill>
-                <a:latin typeface="+mn-lt"/>
-                <a:cs typeface="+mn-lt"/>
-              </a:rPr>
-              <a:t>Stateless Worker Fleet</a:t>
-            </a:r>
-          </a:p>
-        </p:txBody>
-      </p:sp>
-      <p:sp>
-        <p:nvSpPr>
-          <p:cNvPr id="11" name="Text Box 10"/>
-          <p:cNvSpPr/>
-          <p:nvPr/>
-        </p:nvSpPr>
-        <p:spPr>
-          <a:xfrm>
-            <a:off x="4663440" y="3108960"/>
-            <a:ext cx="2743200" cy="2286000"/>
-          </a:xfrm>
-          <a:prstGeom prst="rect">
-            <a:avLst/>
-          </a:prstGeom>
-        </p:spPr>
-        <p:txBody>
-          <a:bodyPr anchor="t"/>
-          <a:lstStyle/>
-          <a:p>
-            <a:pPr algn="l" lvl="0"/>
-            <a:r>
-              <a:rPr sz="1100">
-                <a:solidFill>
-                  <a:srgbClr val="475569"/>
-                </a:solidFill>
-                <a:latin typeface="+mn-lt"/>
-                <a:cs typeface="+mn-lt"/>
-              </a:rPr>
-              <a:t>V8 Isolate sandboxed execution</a:t>
-            </a:r>
-          </a:p>
-          <a:p>
-            <a:pPr algn="l" lvl="0"/>
-            <a:r>
-              <a:rPr sz="1100">
-                <a:solidFill>
-                  <a:srgbClr val="475569"/>
-                </a:solidFill>
-                <a:latin typeface="+mn-lt"/>
-                <a:cs typeface="+mn-lt"/>
-              </a:rPr>
-              <a:t>Instant &lt;5ms cold starts</a:t>
-            </a:r>
-          </a:p>
-          <a:p>
-            <a:pPr algn="l" lvl="0"/>
-            <a:r>
-              <a:rPr sz="1100">
-                <a:solidFill>
-                  <a:srgbClr val="475569"/>
-                </a:solidFill>
-                <a:latin typeface="+mn-lt"/>
-                <a:cs typeface="+mn-lt"/>
-              </a:rPr>
-              <a:t>Streaming SSR &amp; WebSockets</a:t>
-            </a:r>
-          </a:p>
-        </p:txBody>
-      </p:sp>
-      <p:sp>
-        <p:nvSpPr>
-          <p:cNvPr id="12" name="roundRect 11"/>
-          <p:cNvSpPr/>
-          <p:nvPr/>
-        </p:nvSpPr>
-        <p:spPr>
-          <a:xfrm>
-            <a:off x="7863840" y="1828800"/>
-            <a:ext cx="3291840" cy="4114800"/>
-          </a:xfrm>
-          <a:prstGeom prst="roundRect">
-            <a:avLst/>
-          </a:prstGeom>
-          <a:solidFill>
-            <a:srgbClr val="FFFFFF"/>
-          </a:solidFill>
-          <a:ln w="13716">
-            <a:solidFill>
-              <a:srgbClr val="E2E8F0"/>
-            </a:solidFill>
-          </a:ln>
-          <a:effectLst>
-            <a:outerShdw blurRad="137160" dist="45720" dir="5400000">
-              <a:srgbClr val="0F172A">
-                <a:alpha val="12000"/>
-              </a:srgbClr>
-            </a:outerShdw>
-          </a:effectLst>
-        </p:spPr>
-        <p:txBody>
-          <a:bodyPr/>
-          <a:lstStyle/>
-          <a:p>
-            <a:endParaRPr/>
-          </a:p>
-        </p:txBody>
-      </p:sp>
-      <p:sp>
-        <p:nvSpPr>
-          <p:cNvPr id="13" name="roundRect 12"/>
-          <p:cNvSpPr/>
-          <p:nvPr/>
-        </p:nvSpPr>
-        <p:spPr>
-          <a:xfrm>
-            <a:off x="8138160" y="2103120"/>
-            <a:ext cx="1828800" cy="320040"/>
-          </a:xfrm>
-          <a:prstGeom prst="roundRect">
-            <a:avLst/>
-          </a:prstGeom>
-          <a:solidFill>
-            <a:srgbClr val="F8FAFC"/>
-          </a:solidFill>
-          <a:ln w="9144">
-            <a:solidFill>
-              <a:srgbClr val="10B981"/>
-            </a:solidFill>
-          </a:ln>
-        </p:spPr>
-        <p:txBody>
-          <a:bodyPr anchor="t"/>
-          <a:lstStyle/>
-          <a:p>
-            <a:pPr algn="ctr"/>
-            <a:r>
-              <a:rPr b="1" sz="900">
-                <a:solidFill>
-                  <a:srgbClr val="10B981"/>
-                </a:solidFill>
-                <a:latin typeface="+mn-lt"/>
-                <a:cs typeface="+mn-lt"/>
-              </a:rPr>
-              <a:t>TIER 3 • STORAGE</a:t>
-            </a:r>
-          </a:p>
-        </p:txBody>
-      </p:sp>
-      <p:sp>
-        <p:nvSpPr>
-          <p:cNvPr id="14" name="Text Box 13"/>
-          <p:cNvSpPr/>
-          <p:nvPr/>
-        </p:nvSpPr>
-        <p:spPr>
-          <a:xfrm>
-            <a:off x="8138160" y="2560320"/>
-            <a:ext cx="2743200" cy="457200"/>
-          </a:xfrm>
-          <a:prstGeom prst="rect">
-            <a:avLst/>
-          </a:prstGeom>
-        </p:spPr>
-        <p:txBody>
-          <a:bodyPr anchor="t"/>
-          <a:lstStyle/>
-          <a:p>
-            <a:pPr algn="l"/>
-            <a:r>
-              <a:rPr b="1" sz="1600">
-                <a:solidFill>
-                  <a:srgbClr val="0F172A"/>
-                </a:solidFill>
-                <a:latin typeface="+mn-lt"/>
-                <a:cs typeface="+mn-lt"/>
-              </a:rPr>
-              <a:t>Distributed State Store</a:t>
-            </a:r>
-          </a:p>
-        </p:txBody>
-      </p:sp>
-      <p:sp>
-        <p:nvSpPr>
-          <p:cNvPr id="15" name="Text Box 14"/>
-          <p:cNvSpPr/>
-          <p:nvPr/>
-        </p:nvSpPr>
-        <p:spPr>
-          <a:xfrm>
-            <a:off x="8138160" y="3108960"/>
-            <a:ext cx="2743200" cy="2286000"/>
-          </a:xfrm>
-          <a:prstGeom prst="rect">
-            <a:avLst/>
-          </a:prstGeom>
-        </p:spPr>
-        <p:txBody>
-          <a:bodyPr anchor="t"/>
-          <a:lstStyle/>
-          <a:p>
-            <a:pPr algn="l" lvl="0"/>
-            <a:r>
-              <a:rPr sz="1100">
-                <a:solidFill>
-                  <a:srgbClr val="475569"/>
-                </a:solidFill>
-                <a:latin typeface="+mn-lt"/>
-                <a:cs typeface="+mn-lt"/>
-              </a:rPr>
-              <a:t>Globally replicated R2 object store</a:t>
-            </a:r>
-          </a:p>
-          <a:p>
-            <a:pPr algn="l" lvl="0"/>
-            <a:r>
-              <a:rPr sz="1100">
-                <a:solidFill>
-                  <a:srgbClr val="475569"/>
-                </a:solidFill>
-                <a:latin typeface="+mn-lt"/>
-                <a:cs typeface="+mn-lt"/>
-              </a:rPr>
-              <a:t>Low-latency D1 serverless SQLite</a:t>
-            </a:r>
-          </a:p>
-          <a:p>
-            <a:pPr algn="l" lvl="0"/>
-            <a:r>
-              <a:rPr sz="1100">
-                <a:solidFill>
-                  <a:srgbClr val="475569"/>
-                </a:solidFill>
-                <a:latin typeface="+mn-lt"/>
-                <a:cs typeface="+mn-lt"/>
-              </a:rPr>
-              <a:t>Workers KV key-value cache</a:t>
-            </a:r>
-          </a:p>
-        </p:txBody>
-      </p:sp>
-      <p:sp>
-        <p:nvSpPr>
-          <p:cNvPr id="16" name="Text Box 15"/>
-          <p:cNvSpPr/>
-          <p:nvPr/>
-        </p:nvSpPr>
-        <p:spPr>
-          <a:xfrm>
-            <a:off x="731520" y="6510528"/>
-            <a:ext cx="10725912" cy="228600"/>
-          </a:xfrm>
-          <a:prstGeom prst="rect">
-            <a:avLst/>
-          </a:prstGeom>
-        </p:spPr>
-        <p:txBody>
-          <a:bodyPr anchor="t"/>
-          <a:lstStyle/>
-          <a:p>
-            <a:pPr algn="ctr"/>
-            <a:r>
-              <a:rPr i="1" sz="800">
-                <a:solidFill>
-                  <a:srgbClr val="94A3B8"/>
-                </a:solidFill>
-                <a:latin typeface="+mn-lt"/>
-                <a:cs typeface="+mn-lt"/>
-              </a:rPr>
-              <a:t>* Disclaimer: All benchmark metrics, performance figures, and simulated architectures in this deck are synthetic demonstration values generated solely to showcase the authoring, formatting, and rendering capabilities of @hokkyss/pptx.</a:t>
-            </a:r>
-          </a:p>
-        </p:txBody>
-      </p:sp>
-    </p:spTree>
-  </p:cSld>
-  <p:clrMapOvr>
-    <a:masterClrMapping/>
-  </p:clrMapOvr>
-</p:sld>
-</file>
-
-<file path=ppt/slides/slide6.xml><?xml version="1.0" encoding="utf-8"?>
-<p:sld xmlns:a="http://schemas.openxmlformats.org/drawingml/2006/main" xmlns:r="http://schemas.openxmlformats.org/officeDocument/2006/relationships" xmlns:p="http://schemas.openxmlformats.org/presentationml/2006/main">
-  <p:cSld>
-    <p:bg>
-      <p:bgPr>
-        <a:solidFill>
-          <a:srgbClr val="F8FAFC"/>
-        </a:solidFill>
-        <a:effectLst/>
-      </p:bgPr>
-    </p:bg>
-    <p:spTree>
-      <p:nvGrpSpPr>
-        <p:cNvPr id="1" name=""/>
-        <p:cNvGrpSpPr/>
-        <p:nvPr/>
-      </p:nvGrpSpPr>
-      <p:grpSpPr>
-        <a:xfrm>
-          <a:off x="0" y="0"/>
-          <a:ext cx="0" cy="0"/>
-          <a:chOff x="0" y="0"/>
-          <a:chExt cx="0" cy="0"/>
-        </a:xfrm>
-      </p:grpSpPr>
-      <p:sp>
-        <p:nvSpPr>
-          <p:cNvPr id="2" name="Text Box 1"/>
-          <p:cNvSpPr/>
-          <p:nvPr/>
-        </p:nvSpPr>
-        <p:spPr>
-          <a:xfrm>
-            <a:off x="914400" y="731520"/>
-            <a:ext cx="10360152" cy="548640"/>
-          </a:xfrm>
-          <a:prstGeom prst="rect">
-            <a:avLst/>
-          </a:prstGeom>
-        </p:spPr>
-        <p:txBody>
-          <a:bodyPr anchor="t"/>
-          <a:lstStyle/>
-          <a:p>
-            <a:pPr algn="l"/>
-            <a:r>
-              <a:rPr b="1" sz="2400">
-                <a:solidFill>
-                  <a:srgbClr val="0F172A"/>
-                </a:solidFill>
-                <a:latin typeface="+mj-lt"/>
-                <a:cs typeface="+mj-lt"/>
-              </a:rPr>
-              <a:t>Isomorphic Media &amp; High-Fidelity Image Embedding</a:t>
-            </a:r>
-          </a:p>
-        </p:txBody>
-      </p:sp>
-      <p:sp>
-        <p:nvSpPr>
-          <p:cNvPr id="3" name="Text Box 2"/>
-          <p:cNvSpPr/>
-          <p:nvPr/>
-        </p:nvSpPr>
-        <p:spPr>
-          <a:xfrm>
-            <a:off x="914400" y="1280160"/>
-            <a:ext cx="10360152" cy="365760"/>
-          </a:xfrm>
-          <a:prstGeom prst="rect">
-            <a:avLst/>
-          </a:prstGeom>
-        </p:spPr>
-        <p:txBody>
-          <a:bodyPr anchor="t"/>
-          <a:lstStyle/>
-          <a:p>
-            <a:pPr algn="l"/>
-            <a:r>
-              <a:rPr sz="1400">
-                <a:solidFill>
-                  <a:srgbClr val="64748B"/>
-                </a:solidFill>
-                <a:latin typeface="+mn-lt"/>
-                <a:cs typeface="+mn-lt"/>
-              </a:rPr>
-              <a:t>Embedded raster graphics (PNG, JPEG), transparent alpha channels, aspect ratio scaling, and card layouts</a:t>
-            </a:r>
-          </a:p>
-        </p:txBody>
-      </p:sp>
-      <p:sp>
-        <p:nvSpPr>
-          <p:cNvPr id="4" name="roundRect 3"/>
-          <p:cNvSpPr/>
-          <p:nvPr/>
-        </p:nvSpPr>
-        <p:spPr>
-          <a:xfrm>
-            <a:off x="914400" y="1828800"/>
-            <a:ext cx="4937760" cy="4114800"/>
-          </a:xfrm>
-          <a:prstGeom prst="roundRect">
-            <a:avLst/>
-          </a:prstGeom>
-          <a:solidFill>
-            <a:srgbClr val="FFFFFF"/>
-          </a:solidFill>
-          <a:ln w="13716">
-            <a:solidFill>
-              <a:srgbClr val="E2E8F0"/>
-            </a:solidFill>
-          </a:ln>
-          <a:effectLst>
-            <a:outerShdw blurRad="137160" dist="45720" dir="5400000">
-              <a:srgbClr val="0F172A">
-                <a:alpha val="10000"/>
-              </a:srgbClr>
-            </a:outerShdw>
-          </a:effectLst>
-        </p:spPr>
-        <p:txBody>
-          <a:bodyPr/>
-          <a:lstStyle/>
-          <a:p>
-            <a:endParaRPr/>
-          </a:p>
-        </p:txBody>
-      </p:sp>
-      <p:sp>
-        <p:nvSpPr>
-          <p:cNvPr id="6" name="Text Box 5"/>
-          <p:cNvSpPr/>
-          <p:nvPr/>
-        </p:nvSpPr>
-        <p:spPr>
-          <a:xfrm>
-            <a:off x="1188720" y="4754880"/>
-            <a:ext cx="4389120" cy="365760"/>
-          </a:xfrm>
-          <a:prstGeom prst="rect">
-            <a:avLst/>
-          </a:prstGeom>
-        </p:spPr>
-        <p:txBody>
-          <a:bodyPr anchor="t"/>
-          <a:lstStyle/>
-          <a:p>
-            <a:pPr algn="l"/>
-            <a:r>
-              <a:rPr b="1" sz="1500">
-                <a:solidFill>
-                  <a:srgbClr val="0F172A"/>
-                </a:solidFill>
-                <a:latin typeface="+mn-lt"/>
-                <a:cs typeface="+mn-lt"/>
-              </a:rPr>
-              <a:t>Rich Visual Asset Integration</a:t>
-            </a:r>
-          </a:p>
-        </p:txBody>
-      </p:sp>
-      <p:sp>
-        <p:nvSpPr>
-          <p:cNvPr id="7" name="Text Box 6"/>
-          <p:cNvSpPr/>
-          <p:nvPr/>
-        </p:nvSpPr>
-        <p:spPr>
-          <a:xfrm>
-            <a:off x="1188720" y="5120640"/>
-            <a:ext cx="4389120" cy="548640"/>
-          </a:xfrm>
-          <a:prstGeom prst="rect">
-            <a:avLst/>
-          </a:prstGeom>
-        </p:spPr>
-        <p:txBody>
-          <a:bodyPr anchor="t"/>
-          <a:lstStyle/>
-          <a:p>
-            <a:pPr algn="l"/>
-            <a:r>
-              <a:rPr sz="1100">
-                <a:solidFill>
-                  <a:srgbClr val="64748B"/>
-                </a:solidFill>
-                <a:latin typeface="+mn-lt"/>
-                <a:cs typeface="+mn-lt"/>
-              </a:rPr>
-              <a:t>Automatic MIME-type detection, relationship mapping, and lossless OpenXML zip packaging.</a:t>
-            </a:r>
-          </a:p>
-        </p:txBody>
-      </p:sp>
-      <p:sp>
-        <p:nvSpPr>
-          <p:cNvPr id="8" name="roundRect 7"/>
-          <p:cNvSpPr/>
-          <p:nvPr/>
-        </p:nvSpPr>
-        <p:spPr>
-          <a:xfrm>
-            <a:off x="6336792" y="1828800"/>
-            <a:ext cx="4937760" cy="4114800"/>
-          </a:xfrm>
-          <a:prstGeom prst="roundRect">
-            <a:avLst/>
-          </a:prstGeom>
-          <a:solidFill>
-            <a:srgbClr val="FFFFFF"/>
-          </a:solidFill>
-          <a:ln w="13716">
-            <a:solidFill>
-              <a:srgbClr val="E2E8F0"/>
-            </a:solidFill>
-          </a:ln>
-          <a:effectLst>
-            <a:outerShdw blurRad="137160" dist="45720" dir="5400000">
-              <a:srgbClr val="0F172A">
-                <a:alpha val="10000"/>
-              </a:srgbClr>
-            </a:outerShdw>
-          </a:effectLst>
-        </p:spPr>
-        <p:txBody>
-          <a:bodyPr/>
-          <a:lstStyle/>
-          <a:p>
-            <a:endParaRPr/>
-          </a:p>
-        </p:txBody>
-      </p:sp>
-      <p:sp>
-        <p:nvSpPr>
-          <p:cNvPr id="9" name="roundRect 8"/>
-          <p:cNvSpPr/>
-          <p:nvPr/>
-        </p:nvSpPr>
-        <p:spPr>
-          <a:xfrm>
-            <a:off x="6611112" y="2103120"/>
-            <a:ext cx="4389120" cy="1097280"/>
-          </a:xfrm>
-          <a:prstGeom prst="roundRect">
-            <a:avLst/>
-          </a:prstGeom>
-          <a:solidFill>
-            <a:srgbClr val="0F172A"/>
-          </a:solidFill>
-        </p:spPr>
-        <p:txBody>
-          <a:bodyPr/>
-          <a:lstStyle/>
-          <a:p>
-            <a:endParaRPr/>
-          </a:p>
-        </p:txBody>
-      </p:sp>
-      <p:sp>
-        <p:nvSpPr>
-          <p:cNvPr id="11" name="Text Box 10"/>
-          <p:cNvSpPr/>
-          <p:nvPr/>
-        </p:nvSpPr>
-        <p:spPr>
-          <a:xfrm>
-            <a:off x="6611112" y="3383280"/>
-            <a:ext cx="4389120" cy="365760"/>
-          </a:xfrm>
-          <a:prstGeom prst="rect">
-            <a:avLst/>
-          </a:prstGeom>
-        </p:spPr>
-        <p:txBody>
-          <a:bodyPr anchor="t"/>
-          <a:lstStyle/>
-          <a:p>
-            <a:pPr algn="l"/>
-            <a:r>
-              <a:rPr b="1" sz="1500">
-                <a:solidFill>
-                  <a:srgbClr val="0F172A"/>
-                </a:solidFill>
-                <a:latin typeface="+mn-lt"/>
-                <a:cs typeface="+mn-lt"/>
-              </a:rPr>
-              <a:t>Supported Image Codecs &amp; Features</a:t>
-            </a:r>
-          </a:p>
-        </p:txBody>
-      </p:sp>
-      <p:sp>
-        <p:nvSpPr>
-          <p:cNvPr id="12" name="Text Box 11"/>
-          <p:cNvSpPr/>
-          <p:nvPr/>
-        </p:nvSpPr>
-        <p:spPr>
-          <a:xfrm>
-            <a:off x="6611112" y="3840480"/>
-            <a:ext cx="4389120" cy="2011680"/>
-          </a:xfrm>
-          <a:prstGeom prst="rect">
-            <a:avLst/>
-          </a:prstGeom>
-        </p:spPr>
-        <p:txBody>
-          <a:bodyPr anchor="t"/>
-          <a:lstStyle/>
-          <a:p>
-            <a:pPr algn="l" lvl="0" marL="152400" indent="-152400">
-              <a:buChar char="•"/>
-            </a:pPr>
-            <a:r>
-              <a:rPr sz="1100">
-                <a:solidFill>
-                  <a:srgbClr val="475569"/>
-                </a:solidFill>
-                <a:latin typeface="+mn-lt"/>
-                <a:cs typeface="+mn-lt"/>
-              </a:rPr>
-              <a:t>PNG with 32-bit RGBA alpha transparency</a:t>
-            </a:r>
-          </a:p>
-          <a:p>
-            <a:pPr algn="l" lvl="0" marL="152400" indent="-152400">
-              <a:buChar char="•"/>
-            </a:pPr>
-            <a:r>
-              <a:rPr sz="1100">
-                <a:solidFill>
-                  <a:srgbClr val="475569"/>
-                </a:solidFill>
-                <a:latin typeface="+mn-lt"/>
-                <a:cs typeface="+mn-lt"/>
-              </a:rPr>
-              <a:t>JPEG / JPG progressive and baseline encoding</a:t>
-            </a:r>
-          </a:p>
-          <a:p>
-            <a:pPr algn="l" lvl="0" marL="152400" indent="-152400">
-              <a:buChar char="•"/>
-            </a:pPr>
-            <a:r>
-              <a:rPr sz="1100">
-                <a:solidFill>
-                  <a:srgbClr val="475569"/>
-                </a:solidFill>
-                <a:latin typeface="+mn-lt"/>
-                <a:cs typeface="+mn-lt"/>
-              </a:rPr>
-              <a:t>Zero-copy ArrayBuffer &amp; Uint8Array input</a:t>
-            </a:r>
-          </a:p>
-          <a:p>
-            <a:pPr algn="l" lvl="0" marL="152400" indent="-152400">
-              <a:buChar char="•"/>
-            </a:pPr>
-            <a:r>
-              <a:rPr sz="1100">
-                <a:solidFill>
-                  <a:srgbClr val="475569"/>
-                </a:solidFill>
-                <a:latin typeface="+mn-lt"/>
-                <a:cs typeface="+mn-lt"/>
-              </a:rPr>
-              <a:t>Placeholder resolution into slide layout picture frames</a:t>
-            </a:r>
-          </a:p>
-        </p:txBody>
-      </p:sp>
-      <p:sp>
-        <p:nvSpPr>
-          <p:cNvPr id="13" name="Text Box 12"/>
-          <p:cNvSpPr/>
-          <p:nvPr/>
-        </p:nvSpPr>
-        <p:spPr>
-          <a:xfrm>
-            <a:off x="731520" y="6510528"/>
-            <a:ext cx="10725912" cy="228600"/>
-          </a:xfrm>
-          <a:prstGeom prst="rect">
-            <a:avLst/>
-          </a:prstGeom>
-        </p:spPr>
-        <p:txBody>
-          <a:bodyPr anchor="t"/>
-          <a:lstStyle/>
-          <a:p>
-            <a:pPr algn="ctr"/>
-            <a:r>
-              <a:rPr i="1" sz="800">
-                <a:solidFill>
-                  <a:srgbClr val="94A3B8"/>
-                </a:solidFill>
-                <a:latin typeface="+mn-lt"/>
-                <a:cs typeface="+mn-lt"/>
-              </a:rPr>
-              <a:t>* Disclaimer: All benchmark metrics, performance figures, and simulated architectures in this deck are synthetic demonstration values generated solely to showcase the authoring, formatting, and rendering capabilities of @hokkyss/pptx.</a:t>
-            </a:r>
-          </a:p>
-        </p:txBody>
-      </p:sp>
-      <p:pic>
-        <p:nvPicPr>
-          <p:cNvPr id="5" name="Picture 4"/>
-          <p:cNvPicPr>
-            <a:picLocks noChangeAspect="1"/>
-          </p:cNvPicPr>
-          <p:nvPr/>
-        </p:nvPicPr>
-        <p:blipFill>
-          <a:blip r:embed="rId2"/>
-          <a:stretch>
-            <a:fillRect/>
-          </a:stretch>
-        </p:blipFill>
-        <p:spPr>
-          <a:xfrm>
-            <a:off x="1188720" y="2103120"/>
-            <a:ext cx="4389120" cy="2468880"/>
-          </a:xfrm>
-          <a:prstGeom prst="rect">
-            <a:avLst/>
-          </a:prstGeom>
-        </p:spPr>
-      </p:pic>
-      <p:pic>
-        <p:nvPicPr>
-          <p:cNvPr id="10" name="Picture 9"/>
-          <p:cNvPicPr>
-            <a:picLocks noChangeAspect="1"/>
-          </p:cNvPicPr>
-          <p:nvPr/>
-        </p:nvPicPr>
-        <p:blipFill>
-          <a:blip r:embed="rId3"/>
-          <a:stretch>
-            <a:fillRect/>
-          </a:stretch>
-        </p:blipFill>
-        <p:spPr>
-          <a:xfrm>
-            <a:off x="7891272" y="2286000"/>
-            <a:ext cx="1828800" cy="731520"/>
-          </a:xfrm>
-          <a:prstGeom prst="rect">
-            <a:avLst/>
-          </a:prstGeom>
-        </p:spPr>
-      </p:pic>
-    </p:spTree>
-  </p:cSld>
-  <p:clrMapOvr>
-    <a:masterClrMapping/>
-  </p:clrMapOvr>
-</p:sld>
-</file>
-
-<file path=ppt/slides/slide7.xml><?xml version="1.0" encoding="utf-8"?>
-<p:sld xmlns:a="http://schemas.openxmlformats.org/drawingml/2006/main" xmlns:r="http://schemas.openxmlformats.org/officeDocument/2006/relationships" xmlns:p="http://schemas.openxmlformats.org/presentationml/2006/main">
-  <p:cSld>
-    <p:bg>
-      <p:bgPr>
-        <a:solidFill>
-          <a:srgbClr val="0F172A"/>
-        </a:solidFill>
-        <a:effectLst/>
-      </p:bgPr>
-    </p:bg>
-    <p:spTree>
-      <p:nvGrpSpPr>
-        <p:cNvPr id="1" name=""/>
-        <p:cNvGrpSpPr/>
-        <p:nvPr/>
-      </p:nvGrpSpPr>
-      <p:grpSpPr>
-        <a:xfrm>
-          <a:off x="0" y="0"/>
-          <a:ext cx="0" cy="0"/>
-          <a:chOff x="0" y="0"/>
-          <a:chExt cx="0" cy="0"/>
-        </a:xfrm>
-      </p:grpSpPr>
-      <p:sp>
-        <p:nvSpPr>
-          <p:cNvPr id="2" name="Text Box 1"/>
-          <p:cNvSpPr/>
-          <p:nvPr/>
-        </p:nvSpPr>
-        <p:spPr>
-          <a:xfrm>
-            <a:off x="914400" y="731520"/>
-            <a:ext cx="10360152" cy="548640"/>
-          </a:xfrm>
-          <a:prstGeom prst="rect">
-            <a:avLst/>
-          </a:prstGeom>
-        </p:spPr>
-        <p:txBody>
-          <a:bodyPr anchor="t"/>
-          <a:lstStyle/>
-          <a:p>
-            <a:pPr algn="l"/>
-            <a:r>
-              <a:rPr b="1" sz="2400">
-                <a:solidFill>
                   <a:srgbClr val="38BDF8"/>
                 </a:solidFill>
                 <a:latin typeface="+mj-lt"/>
@@ -8449,6 +8476,9 @@
   <p:clrMapOvr>
     <a:masterClrMapping/>
   </p:clrMapOvr>
+  <p:transition spd="fast">
+    <p:push dir="l"/>
+  </p:transition>
 </p:sld>
 </file>
 
@@ -8458,7 +8488,7 @@
     <p:bg>
       <p:bgPr>
         <a:solidFill>
-          <a:srgbClr val="F8FAFC"/>
+          <a:srgbClr val="0F172A"/>
         </a:solidFill>
         <a:effectLst/>
       </p:bgPr>
@@ -9142,6 +9172,9 @@
   <p:clrMapOvr>
     <a:masterClrMapping/>
   </p:clrMapOvr>
+  <p:transition spd="fast">
+    <p:pull dir="r"/>
+  </p:transition>
 </p:sld>
 </file>
 
@@ -9151,7 +9184,7 @@
     <p:bg>
       <p:bgPr>
         <a:solidFill>
-          <a:srgbClr val="0F172A"/>
+          <a:srgbClr val="FFFFFF"/>
         </a:solidFill>
         <a:effectLst/>
       </p:bgPr>
@@ -9550,6 +9583,9 @@
   <p:clrMapOvr>
     <a:masterClrMapping/>
   </p:clrMapOvr>
+  <p:transition spd="med">
+    <p:wheel spokes="4"/>
+  </p:transition>
 </p:sld>
 </file>
 

</xml_diff>

<commit_message>
fix(showcase): restore intended dark/light slide background themes
</commit_message>
<xml_diff>
--- a/hokkyss_showcase_deck.pptx
+++ b/hokkyss_showcase_deck.pptx
@@ -2772,7 +2772,7 @@
     <p:bg>
       <p:bgPr>
         <a:solidFill>
-          <a:srgbClr val="0B1120"/>
+          <a:srgbClr val="0F172A"/>
         </a:solidFill>
         <a:effectLst/>
       </p:bgPr>
@@ -3534,7 +3534,7 @@
     <p:bg>
       <p:bgPr>
         <a:solidFill>
-          <a:srgbClr val="FFFFFF"/>
+          <a:srgbClr val="0F172A"/>
         </a:solidFill>
         <a:effectLst/>
       </p:bgPr>
@@ -3930,7 +3930,7 @@
     <p:bg>
       <p:bgPr>
         <a:solidFill>
-          <a:srgbClr val="0F172A"/>
+          <a:srgbClr val="F8FAFC"/>
         </a:solidFill>
         <a:effectLst/>
       </p:bgPr>
@@ -6353,6 +6353,412 @@
     <p:bg>
       <p:bgPr>
         <a:solidFill>
+          <a:srgbClr val="0F172A"/>
+        </a:solidFill>
+        <a:effectLst/>
+      </p:bgPr>
+    </p:bg>
+    <p:spTree>
+      <p:nvGrpSpPr>
+        <p:cNvPr id="1" name=""/>
+        <p:cNvGrpSpPr/>
+        <p:nvPr/>
+      </p:nvGrpSpPr>
+      <p:grpSpPr>
+        <a:xfrm>
+          <a:off x="0" y="0"/>
+          <a:ext cx="0" cy="0"/>
+          <a:chOff x="0" y="0"/>
+          <a:chExt cx="0" cy="0"/>
+        </a:xfrm>
+      </p:grpSpPr>
+      <p:sp>
+        <p:nvSpPr>
+          <p:cNvPr id="2" name="Text Box 1"/>
+          <p:cNvSpPr/>
+          <p:nvPr/>
+        </p:nvSpPr>
+        <p:spPr>
+          <a:xfrm>
+            <a:off x="914400" y="731520"/>
+            <a:ext cx="10360152" cy="548640"/>
+          </a:xfrm>
+          <a:prstGeom prst="rect">
+            <a:avLst/>
+          </a:prstGeom>
+        </p:spPr>
+        <p:txBody>
+          <a:bodyPr anchor="t"/>
+          <a:lstStyle/>
+          <a:p>
+            <a:pPr algn="l"/>
+            <a:r>
+              <a:rPr b="1" sz="2400">
+                <a:solidFill>
+                  <a:srgbClr val="38BDF8"/>
+                </a:solidFill>
+                <a:latin typeface="+mj-lt"/>
+                <a:cs typeface="+mj-lt"/>
+              </a:rPr>
+              <a:t>Type-Safe Nominal Units &amp; Coordinate System</a:t>
+            </a:r>
+          </a:p>
+        </p:txBody>
+      </p:sp>
+      <p:sp>
+        <p:nvSpPr>
+          <p:cNvPr id="3" name="Text Box 2"/>
+          <p:cNvSpPr/>
+          <p:nvPr/>
+        </p:nvSpPr>
+        <p:spPr>
+          <a:xfrm>
+            <a:off x="914400" y="1463040"/>
+            <a:ext cx="10360152" cy="4114800"/>
+          </a:xfrm>
+          <a:prstGeom prst="rect">
+            <a:avLst/>
+          </a:prstGeom>
+        </p:spPr>
+        <p:txBody>
+          <a:bodyPr anchor="t"/>
+          <a:lstStyle/>
+          <a:p>
+            <a:pPr algn="l" lvl="0"/>
+            <a:r>
+              <a:rPr sz="1200">
+                <a:solidFill>
+                  <a:srgbClr val="E2E8F0"/>
+                </a:solidFill>
+                <a:latin typeface="+mn-lt"/>
+                <a:cs typeface="+mn-lt"/>
+              </a:rPr>
+              <a:t>1. Nominal Units &amp; Compile-Time Safety</a:t>
+            </a:r>
+          </a:p>
+          <a:p>
+            <a:pPr algn="l" lvl="1"/>
+            <a:r>
+              <a:rPr sz="1200">
+                <a:solidFill>
+                  <a:srgbClr val="E2E8F0"/>
+                </a:solidFill>
+                <a:latin typeface="+mn-lt"/>
+                <a:cs typeface="+mn-lt"/>
+              </a:rPr>
+              <a:t>1.1 Zero-runtime-overhead branded types for dimensional coordinates</a:t>
+            </a:r>
+          </a:p>
+          <a:p>
+            <a:pPr algn="l" lvl="2"/>
+            <a:r>
+              <a:rPr sz="1200">
+                <a:solidFill>
+                  <a:srgbClr val="E2E8F0"/>
+                </a:solidFill>
+                <a:latin typeface="+mn-lt"/>
+                <a:cs typeface="+mn-lt"/>
+              </a:rPr>
+              <a:t>1.1.1 English Metric Units (EMU): </a:t>
+            </a:r>
+            <a:r>
+              <a:rPr b="1" sz="1200">
+                <a:solidFill>
+                  <a:srgbClr val="38BDF8"/>
+                </a:solidFill>
+                <a:latin typeface="+mn-lt"/>
+                <a:cs typeface="+mn-lt"/>
+              </a:rPr>
+              <a:t>1 inch = 914,400 EMU</a:t>
+            </a:r>
+            <a:r>
+              <a:rPr sz="1200">
+                <a:solidFill>
+                  <a:srgbClr val="E2E8F0"/>
+                </a:solidFill>
+                <a:latin typeface="+mn-lt"/>
+                <a:cs typeface="+mn-lt"/>
+              </a:rPr>
+              <a:t> — </a:t>
+            </a:r>
+            <a:r>
+              <a:rPr b="1" sz="1200">
+                <a:solidFill>
+                  <a:srgbClr val="10B981"/>
+                </a:solidFill>
+                <a:latin typeface="+mn-lt"/>
+                <a:cs typeface="+mn-lt"/>
+              </a:rPr>
+              <a:t>1 pt = 12,700 EMU</a:t>
+            </a:r>
+          </a:p>
+          <a:p>
+            <a:pPr algn="l" lvl="2"/>
+            <a:r>
+              <a:rPr sz="1200">
+                <a:solidFill>
+                  <a:srgbClr val="E2E8F0"/>
+                </a:solidFill>
+                <a:latin typeface="+mn-lt"/>
+                <a:cs typeface="+mn-lt"/>
+              </a:rPr>
+              <a:t>1.1.2 Rotational Angles: </a:t>
+            </a:r>
+            <a:r>
+              <a:rPr b="1" sz="1200">
+                <a:solidFill>
+                  <a:srgbClr val="F59E0B"/>
+                </a:solidFill>
+                <a:latin typeface="+mn-lt"/>
+                <a:cs typeface="+mn-lt"/>
+              </a:rPr>
+              <a:t>degrees(θ)</a:t>
+            </a:r>
+            <a:r>
+              <a:rPr sz="1200">
+                <a:solidFill>
+                  <a:srgbClr val="E2E8F0"/>
+                </a:solidFill>
+                <a:latin typeface="+mn-lt"/>
+                <a:cs typeface="+mn-lt"/>
+              </a:rPr>
+              <a:t> compiles to </a:t>
+            </a:r>
+            <a:r>
+              <a:rPr b="1" sz="1200">
+                <a:solidFill>
+                  <a:srgbClr val="F59E0B"/>
+                </a:solidFill>
+                <a:latin typeface="+mn-lt"/>
+                <a:cs typeface="+mn-lt"/>
+              </a:rPr>
+              <a:t>θ × 60,000 EmuDegrees</a:t>
+            </a:r>
+          </a:p>
+          <a:p>
+            <a:pPr algn="l" lvl="2"/>
+            <a:r>
+              <a:rPr sz="1200">
+                <a:solidFill>
+                  <a:srgbClr val="E2E8F0"/>
+                </a:solidFill>
+                <a:latin typeface="+mn-lt"/>
+                <a:cs typeface="+mn-lt"/>
+              </a:rPr>
+              <a:t>1.1.3 Maximum memory ceiling: </a:t>
+            </a:r>
+            <a:r>
+              <a:rPr b="1" sz="1200">
+                <a:solidFill>
+                  <a:srgbClr val="F59E0B"/>
+                </a:solidFill>
+                <a:latin typeface="+mn-lt"/>
+                <a:cs typeface="+mn-lt"/>
+              </a:rPr>
+              <a:t>2</a:t>
+            </a:r>
+            <a:r>
+              <a:rPr b="1" baseline="30000" sz="1200">
+                <a:solidFill>
+                  <a:srgbClr val="F59E0B"/>
+                </a:solidFill>
+                <a:latin typeface="+mn-lt"/>
+                <a:cs typeface="+mn-lt"/>
+              </a:rPr>
+              <a:t>32</a:t>
+            </a:r>
+            <a:r>
+              <a:rPr sz="1200">
+                <a:solidFill>
+                  <a:srgbClr val="E2E8F0"/>
+                </a:solidFill>
+                <a:latin typeface="+mn-lt"/>
+                <a:cs typeface="+mn-lt"/>
+              </a:rPr>
+              <a:t> bytes (4 GB buffer limit)</a:t>
+            </a:r>
+          </a:p>
+          <a:p>
+            <a:pPr algn="l" lvl="0"/>
+            <a:r>
+              <a:rPr sz="1200">
+                <a:solidFill>
+                  <a:srgbClr val="E2E8F0"/>
+                </a:solidFill>
+                <a:latin typeface="+mn-lt"/>
+                <a:cs typeface="+mn-lt"/>
+              </a:rPr>
+              <a:t>2. High-Performance Text Run Modifiers</a:t>
+            </a:r>
+          </a:p>
+          <a:p>
+            <a:pPr algn="l" lvl="1"/>
+            <a:r>
+              <a:rPr sz="1200">
+                <a:solidFill>
+                  <a:srgbClr val="E2E8F0"/>
+                </a:solidFill>
+                <a:latin typeface="+mn-lt"/>
+                <a:cs typeface="+mn-lt"/>
+              </a:rPr>
+              <a:t>2.1 Rich inline text runs with mixed typographic styles</a:t>
+            </a:r>
+          </a:p>
+          <a:p>
+            <a:pPr algn="l" lvl="2"/>
+            <a:r>
+              <a:rPr sz="1200">
+                <a:solidFill>
+                  <a:srgbClr val="E2E8F0"/>
+                </a:solidFill>
+                <a:latin typeface="+mn-lt"/>
+                <a:cs typeface="+mn-lt"/>
+              </a:rPr>
+              <a:t>Formatting: </a:t>
+            </a:r>
+            <a:r>
+              <a:rPr b="1" sz="1200">
+                <a:solidFill>
+                  <a:srgbClr val="E2E8F0"/>
+                </a:solidFill>
+                <a:latin typeface="+mn-lt"/>
+                <a:cs typeface="+mn-lt"/>
+              </a:rPr>
+              <a:t>Bold</a:t>
+            </a:r>
+            <a:r>
+              <a:rPr sz="1200">
+                <a:solidFill>
+                  <a:srgbClr val="E2E8F0"/>
+                </a:solidFill>
+                <a:latin typeface="+mn-lt"/>
+                <a:cs typeface="+mn-lt"/>
+              </a:rPr>
+              <a:t> | </a:t>
+            </a:r>
+            <a:r>
+              <a:rPr i="1" sz="1200">
+                <a:solidFill>
+                  <a:srgbClr val="E2E8F0"/>
+                </a:solidFill>
+                <a:latin typeface="+mn-lt"/>
+                <a:cs typeface="+mn-lt"/>
+              </a:rPr>
+              <a:t>Italic</a:t>
+            </a:r>
+            <a:r>
+              <a:rPr sz="1200">
+                <a:solidFill>
+                  <a:srgbClr val="E2E8F0"/>
+                </a:solidFill>
+                <a:latin typeface="+mn-lt"/>
+                <a:cs typeface="+mn-lt"/>
+              </a:rPr>
+              <a:t> | </a:t>
+            </a:r>
+            <a:r>
+              <a:rPr u="sng" sz="1200">
+                <a:solidFill>
+                  <a:srgbClr val="E2E8F0"/>
+                </a:solidFill>
+                <a:latin typeface="+mn-lt"/>
+                <a:cs typeface="+mn-lt"/>
+              </a:rPr>
+              <a:t>Underlined</a:t>
+            </a:r>
+            <a:r>
+              <a:rPr sz="1200">
+                <a:solidFill>
+                  <a:srgbClr val="E2E8F0"/>
+                </a:solidFill>
+                <a:latin typeface="+mn-lt"/>
+                <a:cs typeface="+mn-lt"/>
+              </a:rPr>
+              <a:t> | </a:t>
+            </a:r>
+            <a:r>
+              <a:rPr strike="sngStrike" sz="1200">
+                <a:solidFill>
+                  <a:srgbClr val="E2E8F0"/>
+                </a:solidFill>
+                <a:latin typeface="+mn-lt"/>
+                <a:cs typeface="+mn-lt"/>
+              </a:rPr>
+              <a:t>Strikethrough</a:t>
+            </a:r>
+            <a:r>
+              <a:rPr sz="1200">
+                <a:solidFill>
+                  <a:srgbClr val="E2E8F0"/>
+                </a:solidFill>
+                <a:latin typeface="+mn-lt"/>
+                <a:cs typeface="+mn-lt"/>
+              </a:rPr>
+              <a:t> | </a:t>
+            </a:r>
+            <a:r>
+              <a:rPr b="1" sz="1200">
+                <a:solidFill>
+                  <a:srgbClr val="6366F1"/>
+                </a:solidFill>
+                <a:latin typeface="+mn-lt"/>
+                <a:cs typeface="+mn-lt"/>
+              </a:rPr>
+              <a:t>Colored #6366F1</a:t>
+            </a:r>
+          </a:p>
+        </p:txBody>
+      </p:sp>
+      <p:sp>
+        <p:nvSpPr>
+          <p:cNvPr id="4" name="Text Box 3"/>
+          <p:cNvSpPr/>
+          <p:nvPr/>
+        </p:nvSpPr>
+        <p:spPr>
+          <a:xfrm>
+            <a:off x="731520" y="6510528"/>
+            <a:ext cx="10725912" cy="228600"/>
+          </a:xfrm>
+          <a:prstGeom prst="rect">
+            <a:avLst/>
+          </a:prstGeom>
+        </p:spPr>
+        <p:txBody>
+          <a:bodyPr anchor="t"/>
+          <a:lstStyle/>
+          <a:p>
+            <a:pPr algn="ctr"/>
+            <a:r>
+              <a:rPr i="1" sz="800">
+                <a:solidFill>
+                  <a:srgbClr val="64748B"/>
+                </a:solidFill>
+                <a:latin typeface="+mn-lt"/>
+                <a:cs typeface="+mn-lt"/>
+              </a:rPr>
+              <a:t>* Disclaimer: All benchmark metrics, performance figures, and simulated architectures in this deck are synthetic demonstration values generated solely to showcase the authoring, formatting, and rendering capabilities of @hokkyss/pptx.</a:t>
+            </a:r>
+          </a:p>
+        </p:txBody>
+      </p:sp>
+    </p:spTree>
+  </p:cSld>
+  <p:clrMapOvr>
+    <a:masterClrMapping/>
+  </p:clrMapOvr>
+  <p:transition spd="fast">
+    <p:split dir="in"/>
+  </p:transition>
+</p:sld>
+</file>
+
+<file path=ppt/slides/slide5.xml><?xml version="1.0" encoding="utf-8"?>
+<p:sld xmlns:a="http://schemas.openxmlformats.org/drawingml/2006/main" xmlns:r="http://schemas.openxmlformats.org/officeDocument/2006/relationships" xmlns:p="http://schemas.openxmlformats.org/presentationml/2006/main">
+  <p:cSld>
+    <p:bg>
+      <p:bgPr>
+        <a:solidFill>
           <a:srgbClr val="F8FAFC"/>
         </a:solidFill>
         <a:effectLst/>
@@ -6395,12 +6801,12 @@
             <a:r>
               <a:rPr b="1" sz="2400">
                 <a:solidFill>
-                  <a:srgbClr val="38BDF8"/>
+                  <a:srgbClr val="0F172A"/>
                 </a:solidFill>
                 <a:latin typeface="+mj-lt"/>
                 <a:cs typeface="+mj-lt"/>
               </a:rPr>
-              <a:t>Type-Safe Nominal Units &amp; Coordinate System</a:t>
+              <a:t>Three-Tier Decoupled Platform Architecture</a:t>
             </a:r>
           </a:p>
         </p:txBody>
@@ -6413,8 +6819,8 @@
         </p:nvSpPr>
         <p:spPr>
           <a:xfrm>
-            <a:off x="914400" y="1463040"/>
-            <a:ext cx="10360152" cy="4114800"/>
+            <a:off x="914400" y="1280160"/>
+            <a:ext cx="10360152" cy="365760"/>
           </a:xfrm>
           <a:prstGeom prst="rect">
             <a:avLst/>
@@ -6424,294 +6830,536 @@
           <a:bodyPr anchor="t"/>
           <a:lstStyle/>
           <a:p>
+            <a:pPr algn="l"/>
+            <a:r>
+              <a:rPr sz="1400">
+                <a:solidFill>
+                  <a:srgbClr val="64748B"/>
+                </a:solidFill>
+                <a:latin typeface="+mn-lt"/>
+                <a:cs typeface="+mn-lt"/>
+              </a:rPr>
+              <a:t>Ingress routing, stateless isolate compilation, and distributed object persistence</a:t>
+            </a:r>
+          </a:p>
+        </p:txBody>
+      </p:sp>
+      <p:sp>
+        <p:nvSpPr>
+          <p:cNvPr id="4" name="roundRect 3"/>
+          <p:cNvSpPr/>
+          <p:nvPr/>
+        </p:nvSpPr>
+        <p:spPr>
+          <a:xfrm>
+            <a:off x="914400" y="1828800"/>
+            <a:ext cx="3291840" cy="4114800"/>
+          </a:xfrm>
+          <a:prstGeom prst="roundRect">
+            <a:avLst/>
+          </a:prstGeom>
+          <a:solidFill>
+            <a:srgbClr val="FFFFFF"/>
+          </a:solidFill>
+          <a:ln w="13716">
+            <a:solidFill>
+              <a:srgbClr val="E2E8F0"/>
+            </a:solidFill>
+          </a:ln>
+          <a:effectLst>
+            <a:outerShdw blurRad="137160" dist="45720" dir="5400000">
+              <a:srgbClr val="0F172A">
+                <a:alpha val="12000"/>
+              </a:srgbClr>
+            </a:outerShdw>
+          </a:effectLst>
+        </p:spPr>
+        <p:txBody>
+          <a:bodyPr/>
+          <a:lstStyle/>
+          <a:p>
+            <a:endParaRPr/>
+          </a:p>
+        </p:txBody>
+      </p:sp>
+      <p:sp>
+        <p:nvSpPr>
+          <p:cNvPr id="5" name="roundRect 4"/>
+          <p:cNvSpPr/>
+          <p:nvPr/>
+        </p:nvSpPr>
+        <p:spPr>
+          <a:xfrm>
+            <a:off x="1188720" y="2103120"/>
+            <a:ext cx="1828800" cy="320040"/>
+          </a:xfrm>
+          <a:prstGeom prst="roundRect">
+            <a:avLst/>
+          </a:prstGeom>
+          <a:solidFill>
+            <a:srgbClr val="F8FAFC"/>
+          </a:solidFill>
+          <a:ln w="9144">
+            <a:solidFill>
+              <a:srgbClr val="0284C7"/>
+            </a:solidFill>
+          </a:ln>
+        </p:spPr>
+        <p:txBody>
+          <a:bodyPr anchor="t"/>
+          <a:lstStyle/>
+          <a:p>
+            <a:pPr algn="ctr"/>
+            <a:r>
+              <a:rPr b="1" sz="900">
+                <a:solidFill>
+                  <a:srgbClr val="0284C7"/>
+                </a:solidFill>
+                <a:latin typeface="+mn-lt"/>
+                <a:cs typeface="+mn-lt"/>
+              </a:rPr>
+              <a:t>TIER 1 • INGRESS</a:t>
+            </a:r>
+          </a:p>
+        </p:txBody>
+      </p:sp>
+      <p:sp>
+        <p:nvSpPr>
+          <p:cNvPr id="6" name="Text Box 5"/>
+          <p:cNvSpPr/>
+          <p:nvPr/>
+        </p:nvSpPr>
+        <p:spPr>
+          <a:xfrm>
+            <a:off x="1188720" y="2560320"/>
+            <a:ext cx="2743200" cy="457200"/>
+          </a:xfrm>
+          <a:prstGeom prst="rect">
+            <a:avLst/>
+          </a:prstGeom>
+        </p:spPr>
+        <p:txBody>
+          <a:bodyPr anchor="t"/>
+          <a:lstStyle/>
+          <a:p>
+            <a:pPr algn="l"/>
+            <a:r>
+              <a:rPr b="1" sz="1600">
+                <a:solidFill>
+                  <a:srgbClr val="0F172A"/>
+                </a:solidFill>
+                <a:latin typeface="+mn-lt"/>
+                <a:cs typeface="+mn-lt"/>
+              </a:rPr>
+              <a:t>Global Edge Router</a:t>
+            </a:r>
+          </a:p>
+        </p:txBody>
+      </p:sp>
+      <p:sp>
+        <p:nvSpPr>
+          <p:cNvPr id="7" name="Text Box 6"/>
+          <p:cNvSpPr/>
+          <p:nvPr/>
+        </p:nvSpPr>
+        <p:spPr>
+          <a:xfrm>
+            <a:off x="1188720" y="3108960"/>
+            <a:ext cx="2743200" cy="2286000"/>
+          </a:xfrm>
+          <a:prstGeom prst="rect">
+            <a:avLst/>
+          </a:prstGeom>
+        </p:spPr>
+        <p:txBody>
+          <a:bodyPr anchor="t"/>
+          <a:lstStyle/>
+          <a:p>
             <a:pPr algn="l" lvl="0"/>
             <a:r>
-              <a:rPr sz="1200">
-                <a:solidFill>
-                  <a:srgbClr val="E2E8F0"/>
-                </a:solidFill>
-                <a:latin typeface="+mn-lt"/>
-                <a:cs typeface="+mn-lt"/>
-              </a:rPr>
-              <a:t>1. Nominal Units &amp; Compile-Time Safety</a:t>
-            </a:r>
-          </a:p>
-          <a:p>
-            <a:pPr algn="l" lvl="1"/>
-            <a:r>
-              <a:rPr sz="1200">
-                <a:solidFill>
-                  <a:srgbClr val="E2E8F0"/>
-                </a:solidFill>
-                <a:latin typeface="+mn-lt"/>
-                <a:cs typeface="+mn-lt"/>
-              </a:rPr>
-              <a:t>1.1 Zero-runtime-overhead branded types for dimensional coordinates</a:t>
-            </a:r>
-          </a:p>
-          <a:p>
-            <a:pPr algn="l" lvl="2"/>
-            <a:r>
-              <a:rPr sz="1200">
-                <a:solidFill>
-                  <a:srgbClr val="E2E8F0"/>
-                </a:solidFill>
-                <a:latin typeface="+mn-lt"/>
-                <a:cs typeface="+mn-lt"/>
-              </a:rPr>
-              <a:t>1.1.1 English Metric Units (EMU): </a:t>
-            </a:r>
-            <a:r>
-              <a:rPr b="1" sz="1200">
-                <a:solidFill>
-                  <a:srgbClr val="38BDF8"/>
-                </a:solidFill>
-                <a:latin typeface="+mn-lt"/>
-                <a:cs typeface="+mn-lt"/>
-              </a:rPr>
-              <a:t>1 inch = 914,400 EMU</a:t>
-            </a:r>
-            <a:r>
-              <a:rPr sz="1200">
-                <a:solidFill>
-                  <a:srgbClr val="E2E8F0"/>
-                </a:solidFill>
-                <a:latin typeface="+mn-lt"/>
-                <a:cs typeface="+mn-lt"/>
-              </a:rPr>
-              <a:t> — </a:t>
-            </a:r>
-            <a:r>
-              <a:rPr b="1" sz="1200">
+              <a:rPr sz="1100">
+                <a:solidFill>
+                  <a:srgbClr val="475569"/>
+                </a:solidFill>
+                <a:latin typeface="+mn-lt"/>
+                <a:cs typeface="+mn-lt"/>
+              </a:rPr>
+              <a:t>Anycast DNS routing (330+ locations)</a:t>
+            </a:r>
+          </a:p>
+          <a:p>
+            <a:pPr algn="l" lvl="0"/>
+            <a:r>
+              <a:rPr sz="1100">
+                <a:solidFill>
+                  <a:srgbClr val="475569"/>
+                </a:solidFill>
+                <a:latin typeface="+mn-lt"/>
+                <a:cs typeface="+mn-lt"/>
+              </a:rPr>
+              <a:t>TLS 1.3 0-RTT termination</a:t>
+            </a:r>
+          </a:p>
+          <a:p>
+            <a:pPr algn="l" lvl="0"/>
+            <a:r>
+              <a:rPr sz="1100">
+                <a:solidFill>
+                  <a:srgbClr val="475569"/>
+                </a:solidFill>
+                <a:latin typeface="+mn-lt"/>
+                <a:cs typeface="+mn-lt"/>
+              </a:rPr>
+              <a:t>DDoS protection &amp; Rate limiting</a:t>
+            </a:r>
+          </a:p>
+        </p:txBody>
+      </p:sp>
+      <p:sp>
+        <p:nvSpPr>
+          <p:cNvPr id="8" name="roundRect 7"/>
+          <p:cNvSpPr/>
+          <p:nvPr/>
+        </p:nvSpPr>
+        <p:spPr>
+          <a:xfrm>
+            <a:off x="4389120" y="1828800"/>
+            <a:ext cx="3291840" cy="4114800"/>
+          </a:xfrm>
+          <a:prstGeom prst="roundRect">
+            <a:avLst/>
+          </a:prstGeom>
+          <a:solidFill>
+            <a:srgbClr val="FFFFFF"/>
+          </a:solidFill>
+          <a:ln w="13716">
+            <a:solidFill>
+              <a:srgbClr val="E2E8F0"/>
+            </a:solidFill>
+          </a:ln>
+          <a:effectLst>
+            <a:outerShdw blurRad="137160" dist="45720" dir="5400000">
+              <a:srgbClr val="0F172A">
+                <a:alpha val="12000"/>
+              </a:srgbClr>
+            </a:outerShdw>
+          </a:effectLst>
+        </p:spPr>
+        <p:txBody>
+          <a:bodyPr/>
+          <a:lstStyle/>
+          <a:p>
+            <a:endParaRPr/>
+          </a:p>
+        </p:txBody>
+      </p:sp>
+      <p:sp>
+        <p:nvSpPr>
+          <p:cNvPr id="9" name="roundRect 8"/>
+          <p:cNvSpPr/>
+          <p:nvPr/>
+        </p:nvSpPr>
+        <p:spPr>
+          <a:xfrm>
+            <a:off x="4663440" y="2103120"/>
+            <a:ext cx="1828800" cy="320040"/>
+          </a:xfrm>
+          <a:prstGeom prst="roundRect">
+            <a:avLst/>
+          </a:prstGeom>
+          <a:solidFill>
+            <a:srgbClr val="F8FAFC"/>
+          </a:solidFill>
+          <a:ln w="9144">
+            <a:solidFill>
+              <a:srgbClr val="6366F1"/>
+            </a:solidFill>
+          </a:ln>
+        </p:spPr>
+        <p:txBody>
+          <a:bodyPr anchor="t"/>
+          <a:lstStyle/>
+          <a:p>
+            <a:pPr algn="ctr"/>
+            <a:r>
+              <a:rPr b="1" sz="900">
+                <a:solidFill>
+                  <a:srgbClr val="6366F1"/>
+                </a:solidFill>
+                <a:latin typeface="+mn-lt"/>
+                <a:cs typeface="+mn-lt"/>
+              </a:rPr>
+              <a:t>TIER 2 • COMPUTE</a:t>
+            </a:r>
+          </a:p>
+        </p:txBody>
+      </p:sp>
+      <p:sp>
+        <p:nvSpPr>
+          <p:cNvPr id="10" name="Text Box 9"/>
+          <p:cNvSpPr/>
+          <p:nvPr/>
+        </p:nvSpPr>
+        <p:spPr>
+          <a:xfrm>
+            <a:off x="4663440" y="2560320"/>
+            <a:ext cx="2743200" cy="457200"/>
+          </a:xfrm>
+          <a:prstGeom prst="rect">
+            <a:avLst/>
+          </a:prstGeom>
+        </p:spPr>
+        <p:txBody>
+          <a:bodyPr anchor="t"/>
+          <a:lstStyle/>
+          <a:p>
+            <a:pPr algn="l"/>
+            <a:r>
+              <a:rPr b="1" sz="1600">
+                <a:solidFill>
+                  <a:srgbClr val="0F172A"/>
+                </a:solidFill>
+                <a:latin typeface="+mn-lt"/>
+                <a:cs typeface="+mn-lt"/>
+              </a:rPr>
+              <a:t>Stateless Worker Fleet</a:t>
+            </a:r>
+          </a:p>
+        </p:txBody>
+      </p:sp>
+      <p:sp>
+        <p:nvSpPr>
+          <p:cNvPr id="11" name="Text Box 10"/>
+          <p:cNvSpPr/>
+          <p:nvPr/>
+        </p:nvSpPr>
+        <p:spPr>
+          <a:xfrm>
+            <a:off x="4663440" y="3108960"/>
+            <a:ext cx="2743200" cy="2286000"/>
+          </a:xfrm>
+          <a:prstGeom prst="rect">
+            <a:avLst/>
+          </a:prstGeom>
+        </p:spPr>
+        <p:txBody>
+          <a:bodyPr anchor="t"/>
+          <a:lstStyle/>
+          <a:p>
+            <a:pPr algn="l" lvl="0"/>
+            <a:r>
+              <a:rPr sz="1100">
+                <a:solidFill>
+                  <a:srgbClr val="475569"/>
+                </a:solidFill>
+                <a:latin typeface="+mn-lt"/>
+                <a:cs typeface="+mn-lt"/>
+              </a:rPr>
+              <a:t>V8 Isolate sandboxed execution</a:t>
+            </a:r>
+          </a:p>
+          <a:p>
+            <a:pPr algn="l" lvl="0"/>
+            <a:r>
+              <a:rPr sz="1100">
+                <a:solidFill>
+                  <a:srgbClr val="475569"/>
+                </a:solidFill>
+                <a:latin typeface="+mn-lt"/>
+                <a:cs typeface="+mn-lt"/>
+              </a:rPr>
+              <a:t>Instant &lt;5ms cold starts</a:t>
+            </a:r>
+          </a:p>
+          <a:p>
+            <a:pPr algn="l" lvl="0"/>
+            <a:r>
+              <a:rPr sz="1100">
+                <a:solidFill>
+                  <a:srgbClr val="475569"/>
+                </a:solidFill>
+                <a:latin typeface="+mn-lt"/>
+                <a:cs typeface="+mn-lt"/>
+              </a:rPr>
+              <a:t>Streaming SSR &amp; WebSockets</a:t>
+            </a:r>
+          </a:p>
+        </p:txBody>
+      </p:sp>
+      <p:sp>
+        <p:nvSpPr>
+          <p:cNvPr id="12" name="roundRect 11"/>
+          <p:cNvSpPr/>
+          <p:nvPr/>
+        </p:nvSpPr>
+        <p:spPr>
+          <a:xfrm>
+            <a:off x="7863840" y="1828800"/>
+            <a:ext cx="3291840" cy="4114800"/>
+          </a:xfrm>
+          <a:prstGeom prst="roundRect">
+            <a:avLst/>
+          </a:prstGeom>
+          <a:solidFill>
+            <a:srgbClr val="FFFFFF"/>
+          </a:solidFill>
+          <a:ln w="13716">
+            <a:solidFill>
+              <a:srgbClr val="E2E8F0"/>
+            </a:solidFill>
+          </a:ln>
+          <a:effectLst>
+            <a:outerShdw blurRad="137160" dist="45720" dir="5400000">
+              <a:srgbClr val="0F172A">
+                <a:alpha val="12000"/>
+              </a:srgbClr>
+            </a:outerShdw>
+          </a:effectLst>
+        </p:spPr>
+        <p:txBody>
+          <a:bodyPr/>
+          <a:lstStyle/>
+          <a:p>
+            <a:endParaRPr/>
+          </a:p>
+        </p:txBody>
+      </p:sp>
+      <p:sp>
+        <p:nvSpPr>
+          <p:cNvPr id="13" name="roundRect 12"/>
+          <p:cNvSpPr/>
+          <p:nvPr/>
+        </p:nvSpPr>
+        <p:spPr>
+          <a:xfrm>
+            <a:off x="8138160" y="2103120"/>
+            <a:ext cx="1828800" cy="320040"/>
+          </a:xfrm>
+          <a:prstGeom prst="roundRect">
+            <a:avLst/>
+          </a:prstGeom>
+          <a:solidFill>
+            <a:srgbClr val="F8FAFC"/>
+          </a:solidFill>
+          <a:ln w="9144">
+            <a:solidFill>
+              <a:srgbClr val="10B981"/>
+            </a:solidFill>
+          </a:ln>
+        </p:spPr>
+        <p:txBody>
+          <a:bodyPr anchor="t"/>
+          <a:lstStyle/>
+          <a:p>
+            <a:pPr algn="ctr"/>
+            <a:r>
+              <a:rPr b="1" sz="900">
                 <a:solidFill>
                   <a:srgbClr val="10B981"/>
                 </a:solidFill>
                 <a:latin typeface="+mn-lt"/>
                 <a:cs typeface="+mn-lt"/>
               </a:rPr>
-              <a:t>1 pt = 12,700 EMU</a:t>
-            </a:r>
-          </a:p>
-          <a:p>
-            <a:pPr algn="l" lvl="2"/>
-            <a:r>
-              <a:rPr sz="1200">
-                <a:solidFill>
-                  <a:srgbClr val="E2E8F0"/>
-                </a:solidFill>
-                <a:latin typeface="+mn-lt"/>
-                <a:cs typeface="+mn-lt"/>
-              </a:rPr>
-              <a:t>1.1.2 Rotational Angles: </a:t>
-            </a:r>
-            <a:r>
-              <a:rPr b="1" sz="1200">
-                <a:solidFill>
-                  <a:srgbClr val="F59E0B"/>
-                </a:solidFill>
-                <a:latin typeface="+mn-lt"/>
-                <a:cs typeface="+mn-lt"/>
-              </a:rPr>
-              <a:t>degrees(θ)</a:t>
-            </a:r>
-            <a:r>
-              <a:rPr sz="1200">
-                <a:solidFill>
-                  <a:srgbClr val="E2E8F0"/>
-                </a:solidFill>
-                <a:latin typeface="+mn-lt"/>
-                <a:cs typeface="+mn-lt"/>
-              </a:rPr>
-              <a:t> compiles to </a:t>
-            </a:r>
-            <a:r>
-              <a:rPr b="1" sz="1200">
-                <a:solidFill>
-                  <a:srgbClr val="F59E0B"/>
-                </a:solidFill>
-                <a:latin typeface="+mn-lt"/>
-                <a:cs typeface="+mn-lt"/>
-              </a:rPr>
-              <a:t>θ × 60,000 EmuDegrees</a:t>
-            </a:r>
-          </a:p>
-          <a:p>
-            <a:pPr algn="l" lvl="2"/>
-            <a:r>
-              <a:rPr sz="1200">
-                <a:solidFill>
-                  <a:srgbClr val="E2E8F0"/>
-                </a:solidFill>
-                <a:latin typeface="+mn-lt"/>
-                <a:cs typeface="+mn-lt"/>
-              </a:rPr>
-              <a:t>1.1.3 Maximum memory ceiling: </a:t>
-            </a:r>
-            <a:r>
-              <a:rPr b="1" sz="1200">
-                <a:solidFill>
-                  <a:srgbClr val="F59E0B"/>
-                </a:solidFill>
-                <a:latin typeface="+mn-lt"/>
-                <a:cs typeface="+mn-lt"/>
-              </a:rPr>
-              <a:t>2</a:t>
-            </a:r>
-            <a:r>
-              <a:rPr b="1" baseline="30000" sz="1200">
-                <a:solidFill>
-                  <a:srgbClr val="F59E0B"/>
-                </a:solidFill>
-                <a:latin typeface="+mn-lt"/>
-                <a:cs typeface="+mn-lt"/>
-              </a:rPr>
-              <a:t>32</a:t>
-            </a:r>
-            <a:r>
-              <a:rPr sz="1200">
-                <a:solidFill>
-                  <a:srgbClr val="E2E8F0"/>
-                </a:solidFill>
-                <a:latin typeface="+mn-lt"/>
-                <a:cs typeface="+mn-lt"/>
-              </a:rPr>
-              <a:t> bytes (4 GB buffer limit)</a:t>
-            </a:r>
-          </a:p>
+              <a:t>TIER 3 • STORAGE</a:t>
+            </a:r>
+          </a:p>
+        </p:txBody>
+      </p:sp>
+      <p:sp>
+        <p:nvSpPr>
+          <p:cNvPr id="14" name="Text Box 13"/>
+          <p:cNvSpPr/>
+          <p:nvPr/>
+        </p:nvSpPr>
+        <p:spPr>
+          <a:xfrm>
+            <a:off x="8138160" y="2560320"/>
+            <a:ext cx="2743200" cy="457200"/>
+          </a:xfrm>
+          <a:prstGeom prst="rect">
+            <a:avLst/>
+          </a:prstGeom>
+        </p:spPr>
+        <p:txBody>
+          <a:bodyPr anchor="t"/>
+          <a:lstStyle/>
+          <a:p>
+            <a:pPr algn="l"/>
+            <a:r>
+              <a:rPr b="1" sz="1600">
+                <a:solidFill>
+                  <a:srgbClr val="0F172A"/>
+                </a:solidFill>
+                <a:latin typeface="+mn-lt"/>
+                <a:cs typeface="+mn-lt"/>
+              </a:rPr>
+              <a:t>Distributed State Store</a:t>
+            </a:r>
+          </a:p>
+        </p:txBody>
+      </p:sp>
+      <p:sp>
+        <p:nvSpPr>
+          <p:cNvPr id="15" name="Text Box 14"/>
+          <p:cNvSpPr/>
+          <p:nvPr/>
+        </p:nvSpPr>
+        <p:spPr>
+          <a:xfrm>
+            <a:off x="8138160" y="3108960"/>
+            <a:ext cx="2743200" cy="2286000"/>
+          </a:xfrm>
+          <a:prstGeom prst="rect">
+            <a:avLst/>
+          </a:prstGeom>
+        </p:spPr>
+        <p:txBody>
+          <a:bodyPr anchor="t"/>
+          <a:lstStyle/>
           <a:p>
             <a:pPr algn="l" lvl="0"/>
             <a:r>
-              <a:rPr sz="1200">
-                <a:solidFill>
-                  <a:srgbClr val="E2E8F0"/>
-                </a:solidFill>
-                <a:latin typeface="+mn-lt"/>
-                <a:cs typeface="+mn-lt"/>
-              </a:rPr>
-              <a:t>2. High-Performance Text Run Modifiers</a:t>
-            </a:r>
-          </a:p>
-          <a:p>
-            <a:pPr algn="l" lvl="1"/>
-            <a:r>
-              <a:rPr sz="1200">
-                <a:solidFill>
-                  <a:srgbClr val="E2E8F0"/>
-                </a:solidFill>
-                <a:latin typeface="+mn-lt"/>
-                <a:cs typeface="+mn-lt"/>
-              </a:rPr>
-              <a:t>2.1 Rich inline text runs with mixed typographic styles</a:t>
-            </a:r>
-          </a:p>
-          <a:p>
-            <a:pPr algn="l" lvl="2"/>
-            <a:r>
-              <a:rPr sz="1200">
-                <a:solidFill>
-                  <a:srgbClr val="E2E8F0"/>
-                </a:solidFill>
-                <a:latin typeface="+mn-lt"/>
-                <a:cs typeface="+mn-lt"/>
-              </a:rPr>
-              <a:t>Formatting: </a:t>
-            </a:r>
-            <a:r>
-              <a:rPr b="1" sz="1200">
-                <a:solidFill>
-                  <a:srgbClr val="E2E8F0"/>
-                </a:solidFill>
-                <a:latin typeface="+mn-lt"/>
-                <a:cs typeface="+mn-lt"/>
-              </a:rPr>
-              <a:t>Bold</a:t>
-            </a:r>
-            <a:r>
-              <a:rPr sz="1200">
-                <a:solidFill>
-                  <a:srgbClr val="E2E8F0"/>
-                </a:solidFill>
-                <a:latin typeface="+mn-lt"/>
-                <a:cs typeface="+mn-lt"/>
-              </a:rPr>
-              <a:t> | </a:t>
-            </a:r>
-            <a:r>
-              <a:rPr i="1" sz="1200">
-                <a:solidFill>
-                  <a:srgbClr val="E2E8F0"/>
-                </a:solidFill>
-                <a:latin typeface="+mn-lt"/>
-                <a:cs typeface="+mn-lt"/>
-              </a:rPr>
-              <a:t>Italic</a:t>
-            </a:r>
-            <a:r>
-              <a:rPr sz="1200">
-                <a:solidFill>
-                  <a:srgbClr val="E2E8F0"/>
-                </a:solidFill>
-                <a:latin typeface="+mn-lt"/>
-                <a:cs typeface="+mn-lt"/>
-              </a:rPr>
-              <a:t> | </a:t>
-            </a:r>
-            <a:r>
-              <a:rPr u="sng" sz="1200">
-                <a:solidFill>
-                  <a:srgbClr val="E2E8F0"/>
-                </a:solidFill>
-                <a:latin typeface="+mn-lt"/>
-                <a:cs typeface="+mn-lt"/>
-              </a:rPr>
-              <a:t>Underlined</a:t>
-            </a:r>
-            <a:r>
-              <a:rPr sz="1200">
-                <a:solidFill>
-                  <a:srgbClr val="E2E8F0"/>
-                </a:solidFill>
-                <a:latin typeface="+mn-lt"/>
-                <a:cs typeface="+mn-lt"/>
-              </a:rPr>
-              <a:t> | </a:t>
-            </a:r>
-            <a:r>
-              <a:rPr strike="sngStrike" sz="1200">
-                <a:solidFill>
-                  <a:srgbClr val="E2E8F0"/>
-                </a:solidFill>
-                <a:latin typeface="+mn-lt"/>
-                <a:cs typeface="+mn-lt"/>
-              </a:rPr>
-              <a:t>Strikethrough</a:t>
-            </a:r>
-            <a:r>
-              <a:rPr sz="1200">
-                <a:solidFill>
-                  <a:srgbClr val="E2E8F0"/>
-                </a:solidFill>
-                <a:latin typeface="+mn-lt"/>
-                <a:cs typeface="+mn-lt"/>
-              </a:rPr>
-              <a:t> | </a:t>
-            </a:r>
-            <a:r>
-              <a:rPr b="1" sz="1200">
-                <a:solidFill>
-                  <a:srgbClr val="6366F1"/>
-                </a:solidFill>
-                <a:latin typeface="+mn-lt"/>
-                <a:cs typeface="+mn-lt"/>
-              </a:rPr>
-              <a:t>Colored #6366F1</a:t>
-            </a:r>
-          </a:p>
-        </p:txBody>
-      </p:sp>
-      <p:sp>
-        <p:nvSpPr>
-          <p:cNvPr id="4" name="Text Box 3"/>
+              <a:rPr sz="1100">
+                <a:solidFill>
+                  <a:srgbClr val="475569"/>
+                </a:solidFill>
+                <a:latin typeface="+mn-lt"/>
+                <a:cs typeface="+mn-lt"/>
+              </a:rPr>
+              <a:t>Globally replicated R2 object store</a:t>
+            </a:r>
+          </a:p>
+          <a:p>
+            <a:pPr algn="l" lvl="0"/>
+            <a:r>
+              <a:rPr sz="1100">
+                <a:solidFill>
+                  <a:srgbClr val="475569"/>
+                </a:solidFill>
+                <a:latin typeface="+mn-lt"/>
+                <a:cs typeface="+mn-lt"/>
+              </a:rPr>
+              <a:t>Low-latency D1 serverless SQLite</a:t>
+            </a:r>
+          </a:p>
+          <a:p>
+            <a:pPr algn="l" lvl="0"/>
+            <a:r>
+              <a:rPr sz="1100">
+                <a:solidFill>
+                  <a:srgbClr val="475569"/>
+                </a:solidFill>
+                <a:latin typeface="+mn-lt"/>
+                <a:cs typeface="+mn-lt"/>
+              </a:rPr>
+              <a:t>Workers KV key-value cache</a:t>
+            </a:r>
+          </a:p>
+        </p:txBody>
+      </p:sp>
+      <p:sp>
+        <p:nvSpPr>
+          <p:cNvPr id="16" name="Text Box 15"/>
           <p:cNvSpPr/>
           <p:nvPr/>
         </p:nvSpPr>
@@ -6732,7 +7380,7 @@
             <a:r>
               <a:rPr i="1" sz="800">
                 <a:solidFill>
-                  <a:srgbClr val="64748B"/>
+                  <a:srgbClr val="94A3B8"/>
                 </a:solidFill>
                 <a:latin typeface="+mn-lt"/>
                 <a:cs typeface="+mn-lt"/>
@@ -6748,12 +7396,476 @@
     <a:masterClrMapping/>
   </p:clrMapOvr>
   <p:transition spd="fast">
-    <p:split dir="in"/>
+    <p:cover dir="l"/>
   </p:transition>
 </p:sld>
 </file>
 
-<file path=ppt/slides/slide5.xml><?xml version="1.0" encoding="utf-8"?>
+<file path=ppt/slides/slide6.xml><?xml version="1.0" encoding="utf-8"?>
+<p:sld xmlns:a="http://schemas.openxmlformats.org/drawingml/2006/main" xmlns:r="http://schemas.openxmlformats.org/officeDocument/2006/relationships" xmlns:p="http://schemas.openxmlformats.org/presentationml/2006/main">
+  <p:cSld>
+    <p:bg>
+      <p:bgPr>
+        <a:solidFill>
+          <a:srgbClr val="F8FAFC"/>
+        </a:solidFill>
+        <a:effectLst/>
+      </p:bgPr>
+    </p:bg>
+    <p:spTree>
+      <p:nvGrpSpPr>
+        <p:cNvPr id="1" name=""/>
+        <p:cNvGrpSpPr/>
+        <p:nvPr/>
+      </p:nvGrpSpPr>
+      <p:grpSpPr>
+        <a:xfrm>
+          <a:off x="0" y="0"/>
+          <a:ext cx="0" cy="0"/>
+          <a:chOff x="0" y="0"/>
+          <a:chExt cx="0" cy="0"/>
+        </a:xfrm>
+      </p:grpSpPr>
+      <p:sp>
+        <p:nvSpPr>
+          <p:cNvPr id="2" name="Text Box 1"/>
+          <p:cNvSpPr/>
+          <p:nvPr/>
+        </p:nvSpPr>
+        <p:spPr>
+          <a:xfrm>
+            <a:off x="914400" y="731520"/>
+            <a:ext cx="10360152" cy="548640"/>
+          </a:xfrm>
+          <a:prstGeom prst="rect">
+            <a:avLst/>
+          </a:prstGeom>
+        </p:spPr>
+        <p:txBody>
+          <a:bodyPr anchor="t"/>
+          <a:lstStyle/>
+          <a:p>
+            <a:pPr algn="l"/>
+            <a:r>
+              <a:rPr b="1" sz="2400">
+                <a:solidFill>
+                  <a:srgbClr val="0F172A"/>
+                </a:solidFill>
+                <a:latin typeface="+mj-lt"/>
+                <a:cs typeface="+mj-lt"/>
+              </a:rPr>
+              <a:t>Isomorphic Media &amp; High-Fidelity Image Embedding</a:t>
+            </a:r>
+          </a:p>
+        </p:txBody>
+      </p:sp>
+      <p:sp>
+        <p:nvSpPr>
+          <p:cNvPr id="3" name="Text Box 2"/>
+          <p:cNvSpPr/>
+          <p:nvPr/>
+        </p:nvSpPr>
+        <p:spPr>
+          <a:xfrm>
+            <a:off x="914400" y="1280160"/>
+            <a:ext cx="10360152" cy="365760"/>
+          </a:xfrm>
+          <a:prstGeom prst="rect">
+            <a:avLst/>
+          </a:prstGeom>
+        </p:spPr>
+        <p:txBody>
+          <a:bodyPr anchor="t"/>
+          <a:lstStyle/>
+          <a:p>
+            <a:pPr algn="l"/>
+            <a:r>
+              <a:rPr sz="1400">
+                <a:solidFill>
+                  <a:srgbClr val="64748B"/>
+                </a:solidFill>
+                <a:latin typeface="+mn-lt"/>
+                <a:cs typeface="+mn-lt"/>
+              </a:rPr>
+              <a:t>Embedded raster graphics (PNG, JPEG), transparent alpha channels, aspect ratio scaling, and card layouts</a:t>
+            </a:r>
+          </a:p>
+        </p:txBody>
+      </p:sp>
+      <p:sp>
+        <p:nvSpPr>
+          <p:cNvPr id="4" name="roundRect 3"/>
+          <p:cNvSpPr/>
+          <p:nvPr/>
+        </p:nvSpPr>
+        <p:spPr>
+          <a:xfrm>
+            <a:off x="914400" y="1828800"/>
+            <a:ext cx="4937760" cy="4114800"/>
+          </a:xfrm>
+          <a:prstGeom prst="roundRect">
+            <a:avLst/>
+          </a:prstGeom>
+          <a:solidFill>
+            <a:srgbClr val="FFFFFF"/>
+          </a:solidFill>
+          <a:ln w="13716">
+            <a:solidFill>
+              <a:srgbClr val="E2E8F0"/>
+            </a:solidFill>
+          </a:ln>
+          <a:effectLst>
+            <a:outerShdw blurRad="137160" dist="45720" dir="5400000">
+              <a:srgbClr val="0F172A">
+                <a:alpha val="10000"/>
+              </a:srgbClr>
+            </a:outerShdw>
+          </a:effectLst>
+        </p:spPr>
+        <p:txBody>
+          <a:bodyPr/>
+          <a:lstStyle/>
+          <a:p>
+            <a:endParaRPr/>
+          </a:p>
+        </p:txBody>
+      </p:sp>
+      <p:sp>
+        <p:nvSpPr>
+          <p:cNvPr id="6" name="Text Box 5"/>
+          <p:cNvSpPr/>
+          <p:nvPr/>
+        </p:nvSpPr>
+        <p:spPr>
+          <a:xfrm>
+            <a:off x="1188720" y="4754880"/>
+            <a:ext cx="4389120" cy="365760"/>
+          </a:xfrm>
+          <a:prstGeom prst="rect">
+            <a:avLst/>
+          </a:prstGeom>
+        </p:spPr>
+        <p:txBody>
+          <a:bodyPr anchor="t"/>
+          <a:lstStyle/>
+          <a:p>
+            <a:pPr algn="l"/>
+            <a:r>
+              <a:rPr b="1" sz="1500">
+                <a:solidFill>
+                  <a:srgbClr val="0F172A"/>
+                </a:solidFill>
+                <a:latin typeface="+mn-lt"/>
+                <a:cs typeface="+mn-lt"/>
+              </a:rPr>
+              <a:t>Rich Visual Asset Integration</a:t>
+            </a:r>
+          </a:p>
+        </p:txBody>
+      </p:sp>
+      <p:sp>
+        <p:nvSpPr>
+          <p:cNvPr id="7" name="Text Box 6"/>
+          <p:cNvSpPr/>
+          <p:nvPr/>
+        </p:nvSpPr>
+        <p:spPr>
+          <a:xfrm>
+            <a:off x="1188720" y="5120640"/>
+            <a:ext cx="4389120" cy="548640"/>
+          </a:xfrm>
+          <a:prstGeom prst="rect">
+            <a:avLst/>
+          </a:prstGeom>
+        </p:spPr>
+        <p:txBody>
+          <a:bodyPr anchor="t"/>
+          <a:lstStyle/>
+          <a:p>
+            <a:pPr algn="l"/>
+            <a:r>
+              <a:rPr sz="1100">
+                <a:solidFill>
+                  <a:srgbClr val="64748B"/>
+                </a:solidFill>
+                <a:latin typeface="+mn-lt"/>
+                <a:cs typeface="+mn-lt"/>
+              </a:rPr>
+              <a:t>Automatic MIME-type detection, relationship mapping, and lossless OpenXML zip packaging.</a:t>
+            </a:r>
+          </a:p>
+        </p:txBody>
+      </p:sp>
+      <p:sp>
+        <p:nvSpPr>
+          <p:cNvPr id="8" name="roundRect 7"/>
+          <p:cNvSpPr/>
+          <p:nvPr/>
+        </p:nvSpPr>
+        <p:spPr>
+          <a:xfrm>
+            <a:off x="6336792" y="1828800"/>
+            <a:ext cx="4937760" cy="4114800"/>
+          </a:xfrm>
+          <a:prstGeom prst="roundRect">
+            <a:avLst/>
+          </a:prstGeom>
+          <a:solidFill>
+            <a:srgbClr val="FFFFFF"/>
+          </a:solidFill>
+          <a:ln w="13716">
+            <a:solidFill>
+              <a:srgbClr val="E2E8F0"/>
+            </a:solidFill>
+          </a:ln>
+          <a:effectLst>
+            <a:outerShdw blurRad="137160" dist="45720" dir="5400000">
+              <a:srgbClr val="0F172A">
+                <a:alpha val="10000"/>
+              </a:srgbClr>
+            </a:outerShdw>
+          </a:effectLst>
+        </p:spPr>
+        <p:txBody>
+          <a:bodyPr/>
+          <a:lstStyle/>
+          <a:p>
+            <a:endParaRPr/>
+          </a:p>
+        </p:txBody>
+      </p:sp>
+      <p:sp>
+        <p:nvSpPr>
+          <p:cNvPr id="9" name="roundRect 8"/>
+          <p:cNvSpPr/>
+          <p:nvPr/>
+        </p:nvSpPr>
+        <p:spPr>
+          <a:xfrm>
+            <a:off x="6611112" y="2103120"/>
+            <a:ext cx="4389120" cy="1097280"/>
+          </a:xfrm>
+          <a:prstGeom prst="roundRect">
+            <a:avLst/>
+          </a:prstGeom>
+          <a:solidFill>
+            <a:srgbClr val="0F172A"/>
+          </a:solidFill>
+        </p:spPr>
+        <p:txBody>
+          <a:bodyPr/>
+          <a:lstStyle/>
+          <a:p>
+            <a:endParaRPr/>
+          </a:p>
+        </p:txBody>
+      </p:sp>
+      <p:sp>
+        <p:nvSpPr>
+          <p:cNvPr id="11" name="Text Box 10"/>
+          <p:cNvSpPr/>
+          <p:nvPr/>
+        </p:nvSpPr>
+        <p:spPr>
+          <a:xfrm>
+            <a:off x="6611112" y="3383280"/>
+            <a:ext cx="4389120" cy="365760"/>
+          </a:xfrm>
+          <a:prstGeom prst="rect">
+            <a:avLst/>
+          </a:prstGeom>
+        </p:spPr>
+        <p:txBody>
+          <a:bodyPr anchor="t"/>
+          <a:lstStyle/>
+          <a:p>
+            <a:pPr algn="l"/>
+            <a:r>
+              <a:rPr b="1" sz="1500">
+                <a:solidFill>
+                  <a:srgbClr val="0F172A"/>
+                </a:solidFill>
+                <a:latin typeface="+mn-lt"/>
+                <a:cs typeface="+mn-lt"/>
+              </a:rPr>
+              <a:t>Supported Image Codecs &amp; Features</a:t>
+            </a:r>
+          </a:p>
+        </p:txBody>
+      </p:sp>
+      <p:sp>
+        <p:nvSpPr>
+          <p:cNvPr id="12" name="Text Box 11"/>
+          <p:cNvSpPr/>
+          <p:nvPr/>
+        </p:nvSpPr>
+        <p:spPr>
+          <a:xfrm>
+            <a:off x="6611112" y="3840480"/>
+            <a:ext cx="4389120" cy="2011680"/>
+          </a:xfrm>
+          <a:prstGeom prst="rect">
+            <a:avLst/>
+          </a:prstGeom>
+        </p:spPr>
+        <p:txBody>
+          <a:bodyPr anchor="t"/>
+          <a:lstStyle/>
+          <a:p>
+            <a:pPr algn="l" lvl="0" marL="152400" indent="-152400">
+              <a:buChar char="•"/>
+            </a:pPr>
+            <a:r>
+              <a:rPr sz="1100">
+                <a:solidFill>
+                  <a:srgbClr val="475569"/>
+                </a:solidFill>
+                <a:latin typeface="+mn-lt"/>
+                <a:cs typeface="+mn-lt"/>
+              </a:rPr>
+              <a:t>PNG with 32-bit RGBA alpha transparency</a:t>
+            </a:r>
+          </a:p>
+          <a:p>
+            <a:pPr algn="l" lvl="0" marL="152400" indent="-152400">
+              <a:buChar char="•"/>
+            </a:pPr>
+            <a:r>
+              <a:rPr sz="1100">
+                <a:solidFill>
+                  <a:srgbClr val="475569"/>
+                </a:solidFill>
+                <a:latin typeface="+mn-lt"/>
+                <a:cs typeface="+mn-lt"/>
+              </a:rPr>
+              <a:t>JPEG / JPG progressive and baseline encoding</a:t>
+            </a:r>
+          </a:p>
+          <a:p>
+            <a:pPr algn="l" lvl="0" marL="152400" indent="-152400">
+              <a:buChar char="•"/>
+            </a:pPr>
+            <a:r>
+              <a:rPr sz="1100">
+                <a:solidFill>
+                  <a:srgbClr val="475569"/>
+                </a:solidFill>
+                <a:latin typeface="+mn-lt"/>
+                <a:cs typeface="+mn-lt"/>
+              </a:rPr>
+              <a:t>Zero-copy ArrayBuffer &amp; Uint8Array input</a:t>
+            </a:r>
+          </a:p>
+          <a:p>
+            <a:pPr algn="l" lvl="0" marL="152400" indent="-152400">
+              <a:buChar char="•"/>
+            </a:pPr>
+            <a:r>
+              <a:rPr sz="1100">
+                <a:solidFill>
+                  <a:srgbClr val="475569"/>
+                </a:solidFill>
+                <a:latin typeface="+mn-lt"/>
+                <a:cs typeface="+mn-lt"/>
+              </a:rPr>
+              <a:t>Placeholder resolution into slide layout picture frames</a:t>
+            </a:r>
+          </a:p>
+        </p:txBody>
+      </p:sp>
+      <p:sp>
+        <p:nvSpPr>
+          <p:cNvPr id="13" name="Text Box 12"/>
+          <p:cNvSpPr/>
+          <p:nvPr/>
+        </p:nvSpPr>
+        <p:spPr>
+          <a:xfrm>
+            <a:off x="731520" y="6510528"/>
+            <a:ext cx="10725912" cy="228600"/>
+          </a:xfrm>
+          <a:prstGeom prst="rect">
+            <a:avLst/>
+          </a:prstGeom>
+        </p:spPr>
+        <p:txBody>
+          <a:bodyPr anchor="t"/>
+          <a:lstStyle/>
+          <a:p>
+            <a:pPr algn="ctr"/>
+            <a:r>
+              <a:rPr i="1" sz="800">
+                <a:solidFill>
+                  <a:srgbClr val="94A3B8"/>
+                </a:solidFill>
+                <a:latin typeface="+mn-lt"/>
+                <a:cs typeface="+mn-lt"/>
+              </a:rPr>
+              <a:t>* Disclaimer: All benchmark metrics, performance figures, and simulated architectures in this deck are synthetic demonstration values generated solely to showcase the authoring, formatting, and rendering capabilities of @hokkyss/pptx.</a:t>
+            </a:r>
+          </a:p>
+        </p:txBody>
+      </p:sp>
+      <p:pic>
+        <p:nvPicPr>
+          <p:cNvPr id="5" name="Picture 4"/>
+          <p:cNvPicPr>
+            <a:picLocks noChangeAspect="1"/>
+          </p:cNvPicPr>
+          <p:nvPr/>
+        </p:nvPicPr>
+        <p:blipFill>
+          <a:blip r:embed="rId2"/>
+          <a:stretch>
+            <a:fillRect/>
+          </a:stretch>
+        </p:blipFill>
+        <p:spPr>
+          <a:xfrm>
+            <a:off x="1188720" y="2103120"/>
+            <a:ext cx="4389120" cy="2468880"/>
+          </a:xfrm>
+          <a:prstGeom prst="rect">
+            <a:avLst/>
+          </a:prstGeom>
+        </p:spPr>
+      </p:pic>
+      <p:pic>
+        <p:nvPicPr>
+          <p:cNvPr id="10" name="Picture 9"/>
+          <p:cNvPicPr>
+            <a:picLocks noChangeAspect="1"/>
+          </p:cNvPicPr>
+          <p:nvPr/>
+        </p:nvPicPr>
+        <p:blipFill>
+          <a:blip r:embed="rId3"/>
+          <a:stretch>
+            <a:fillRect/>
+          </a:stretch>
+        </p:blipFill>
+        <p:spPr>
+          <a:xfrm>
+            <a:off x="7891272" y="2286000"/>
+            <a:ext cx="1828800" cy="731520"/>
+          </a:xfrm>
+          <a:prstGeom prst="rect">
+            <a:avLst/>
+          </a:prstGeom>
+        </p:spPr>
+      </p:pic>
+    </p:spTree>
+  </p:cSld>
+  <p:clrMapOvr>
+    <a:masterClrMapping/>
+  </p:clrMapOvr>
+  <p:transition spd="med">
+    <p:fade/>
+  </p:transition>
+</p:sld>
+</file>
+
+<file path=ppt/slides/slide7.xml><?xml version="1.0" encoding="utf-8"?>
 <p:sld xmlns:a="http://schemas.openxmlformats.org/drawingml/2006/main" xmlns:r="http://schemas.openxmlformats.org/officeDocument/2006/relationships" xmlns:p="http://schemas.openxmlformats.org/presentationml/2006/main">
   <p:cSld>
     <p:bg>
@@ -6801,1118 +7913,6 @@
             <a:r>
               <a:rPr b="1" sz="2400">
                 <a:solidFill>
-                  <a:srgbClr val="0F172A"/>
-                </a:solidFill>
-                <a:latin typeface="+mj-lt"/>
-                <a:cs typeface="+mj-lt"/>
-              </a:rPr>
-              <a:t>Three-Tier Decoupled Platform Architecture</a:t>
-            </a:r>
-          </a:p>
-        </p:txBody>
-      </p:sp>
-      <p:sp>
-        <p:nvSpPr>
-          <p:cNvPr id="3" name="Text Box 2"/>
-          <p:cNvSpPr/>
-          <p:nvPr/>
-        </p:nvSpPr>
-        <p:spPr>
-          <a:xfrm>
-            <a:off x="914400" y="1280160"/>
-            <a:ext cx="10360152" cy="365760"/>
-          </a:xfrm>
-          <a:prstGeom prst="rect">
-            <a:avLst/>
-          </a:prstGeom>
-        </p:spPr>
-        <p:txBody>
-          <a:bodyPr anchor="t"/>
-          <a:lstStyle/>
-          <a:p>
-            <a:pPr algn="l"/>
-            <a:r>
-              <a:rPr sz="1400">
-                <a:solidFill>
-                  <a:srgbClr val="64748B"/>
-                </a:solidFill>
-                <a:latin typeface="+mn-lt"/>
-                <a:cs typeface="+mn-lt"/>
-              </a:rPr>
-              <a:t>Ingress routing, stateless isolate compilation, and distributed object persistence</a:t>
-            </a:r>
-          </a:p>
-        </p:txBody>
-      </p:sp>
-      <p:sp>
-        <p:nvSpPr>
-          <p:cNvPr id="4" name="roundRect 3"/>
-          <p:cNvSpPr/>
-          <p:nvPr/>
-        </p:nvSpPr>
-        <p:spPr>
-          <a:xfrm>
-            <a:off x="914400" y="1828800"/>
-            <a:ext cx="3291840" cy="4114800"/>
-          </a:xfrm>
-          <a:prstGeom prst="roundRect">
-            <a:avLst/>
-          </a:prstGeom>
-          <a:solidFill>
-            <a:srgbClr val="FFFFFF"/>
-          </a:solidFill>
-          <a:ln w="13716">
-            <a:solidFill>
-              <a:srgbClr val="E2E8F0"/>
-            </a:solidFill>
-          </a:ln>
-          <a:effectLst>
-            <a:outerShdw blurRad="137160" dist="45720" dir="5400000">
-              <a:srgbClr val="0F172A">
-                <a:alpha val="12000"/>
-              </a:srgbClr>
-            </a:outerShdw>
-          </a:effectLst>
-        </p:spPr>
-        <p:txBody>
-          <a:bodyPr/>
-          <a:lstStyle/>
-          <a:p>
-            <a:endParaRPr/>
-          </a:p>
-        </p:txBody>
-      </p:sp>
-      <p:sp>
-        <p:nvSpPr>
-          <p:cNvPr id="5" name="roundRect 4"/>
-          <p:cNvSpPr/>
-          <p:nvPr/>
-        </p:nvSpPr>
-        <p:spPr>
-          <a:xfrm>
-            <a:off x="1188720" y="2103120"/>
-            <a:ext cx="1828800" cy="320040"/>
-          </a:xfrm>
-          <a:prstGeom prst="roundRect">
-            <a:avLst/>
-          </a:prstGeom>
-          <a:solidFill>
-            <a:srgbClr val="F8FAFC"/>
-          </a:solidFill>
-          <a:ln w="9144">
-            <a:solidFill>
-              <a:srgbClr val="0284C7"/>
-            </a:solidFill>
-          </a:ln>
-        </p:spPr>
-        <p:txBody>
-          <a:bodyPr anchor="t"/>
-          <a:lstStyle/>
-          <a:p>
-            <a:pPr algn="ctr"/>
-            <a:r>
-              <a:rPr b="1" sz="900">
-                <a:solidFill>
-                  <a:srgbClr val="0284C7"/>
-                </a:solidFill>
-                <a:latin typeface="+mn-lt"/>
-                <a:cs typeface="+mn-lt"/>
-              </a:rPr>
-              <a:t>TIER 1 • INGRESS</a:t>
-            </a:r>
-          </a:p>
-        </p:txBody>
-      </p:sp>
-      <p:sp>
-        <p:nvSpPr>
-          <p:cNvPr id="6" name="Text Box 5"/>
-          <p:cNvSpPr/>
-          <p:nvPr/>
-        </p:nvSpPr>
-        <p:spPr>
-          <a:xfrm>
-            <a:off x="1188720" y="2560320"/>
-            <a:ext cx="2743200" cy="457200"/>
-          </a:xfrm>
-          <a:prstGeom prst="rect">
-            <a:avLst/>
-          </a:prstGeom>
-        </p:spPr>
-        <p:txBody>
-          <a:bodyPr anchor="t"/>
-          <a:lstStyle/>
-          <a:p>
-            <a:pPr algn="l"/>
-            <a:r>
-              <a:rPr b="1" sz="1600">
-                <a:solidFill>
-                  <a:srgbClr val="0F172A"/>
-                </a:solidFill>
-                <a:latin typeface="+mn-lt"/>
-                <a:cs typeface="+mn-lt"/>
-              </a:rPr>
-              <a:t>Global Edge Router</a:t>
-            </a:r>
-          </a:p>
-        </p:txBody>
-      </p:sp>
-      <p:sp>
-        <p:nvSpPr>
-          <p:cNvPr id="7" name="Text Box 6"/>
-          <p:cNvSpPr/>
-          <p:nvPr/>
-        </p:nvSpPr>
-        <p:spPr>
-          <a:xfrm>
-            <a:off x="1188720" y="3108960"/>
-            <a:ext cx="2743200" cy="2286000"/>
-          </a:xfrm>
-          <a:prstGeom prst="rect">
-            <a:avLst/>
-          </a:prstGeom>
-        </p:spPr>
-        <p:txBody>
-          <a:bodyPr anchor="t"/>
-          <a:lstStyle/>
-          <a:p>
-            <a:pPr algn="l" lvl="0"/>
-            <a:r>
-              <a:rPr sz="1100">
-                <a:solidFill>
-                  <a:srgbClr val="475569"/>
-                </a:solidFill>
-                <a:latin typeface="+mn-lt"/>
-                <a:cs typeface="+mn-lt"/>
-              </a:rPr>
-              <a:t>Anycast DNS routing (330+ locations)</a:t>
-            </a:r>
-          </a:p>
-          <a:p>
-            <a:pPr algn="l" lvl="0"/>
-            <a:r>
-              <a:rPr sz="1100">
-                <a:solidFill>
-                  <a:srgbClr val="475569"/>
-                </a:solidFill>
-                <a:latin typeface="+mn-lt"/>
-                <a:cs typeface="+mn-lt"/>
-              </a:rPr>
-              <a:t>TLS 1.3 0-RTT termination</a:t>
-            </a:r>
-          </a:p>
-          <a:p>
-            <a:pPr algn="l" lvl="0"/>
-            <a:r>
-              <a:rPr sz="1100">
-                <a:solidFill>
-                  <a:srgbClr val="475569"/>
-                </a:solidFill>
-                <a:latin typeface="+mn-lt"/>
-                <a:cs typeface="+mn-lt"/>
-              </a:rPr>
-              <a:t>DDoS protection &amp; Rate limiting</a:t>
-            </a:r>
-          </a:p>
-        </p:txBody>
-      </p:sp>
-      <p:sp>
-        <p:nvSpPr>
-          <p:cNvPr id="8" name="roundRect 7"/>
-          <p:cNvSpPr/>
-          <p:nvPr/>
-        </p:nvSpPr>
-        <p:spPr>
-          <a:xfrm>
-            <a:off x="4389120" y="1828800"/>
-            <a:ext cx="3291840" cy="4114800"/>
-          </a:xfrm>
-          <a:prstGeom prst="roundRect">
-            <a:avLst/>
-          </a:prstGeom>
-          <a:solidFill>
-            <a:srgbClr val="FFFFFF"/>
-          </a:solidFill>
-          <a:ln w="13716">
-            <a:solidFill>
-              <a:srgbClr val="E2E8F0"/>
-            </a:solidFill>
-          </a:ln>
-          <a:effectLst>
-            <a:outerShdw blurRad="137160" dist="45720" dir="5400000">
-              <a:srgbClr val="0F172A">
-                <a:alpha val="12000"/>
-              </a:srgbClr>
-            </a:outerShdw>
-          </a:effectLst>
-        </p:spPr>
-        <p:txBody>
-          <a:bodyPr/>
-          <a:lstStyle/>
-          <a:p>
-            <a:endParaRPr/>
-          </a:p>
-        </p:txBody>
-      </p:sp>
-      <p:sp>
-        <p:nvSpPr>
-          <p:cNvPr id="9" name="roundRect 8"/>
-          <p:cNvSpPr/>
-          <p:nvPr/>
-        </p:nvSpPr>
-        <p:spPr>
-          <a:xfrm>
-            <a:off x="4663440" y="2103120"/>
-            <a:ext cx="1828800" cy="320040"/>
-          </a:xfrm>
-          <a:prstGeom prst="roundRect">
-            <a:avLst/>
-          </a:prstGeom>
-          <a:solidFill>
-            <a:srgbClr val="F8FAFC"/>
-          </a:solidFill>
-          <a:ln w="9144">
-            <a:solidFill>
-              <a:srgbClr val="6366F1"/>
-            </a:solidFill>
-          </a:ln>
-        </p:spPr>
-        <p:txBody>
-          <a:bodyPr anchor="t"/>
-          <a:lstStyle/>
-          <a:p>
-            <a:pPr algn="ctr"/>
-            <a:r>
-              <a:rPr b="1" sz="900">
-                <a:solidFill>
-                  <a:srgbClr val="6366F1"/>
-                </a:solidFill>
-                <a:latin typeface="+mn-lt"/>
-                <a:cs typeface="+mn-lt"/>
-              </a:rPr>
-              <a:t>TIER 2 • COMPUTE</a:t>
-            </a:r>
-          </a:p>
-        </p:txBody>
-      </p:sp>
-      <p:sp>
-        <p:nvSpPr>
-          <p:cNvPr id="10" name="Text Box 9"/>
-          <p:cNvSpPr/>
-          <p:nvPr/>
-        </p:nvSpPr>
-        <p:spPr>
-          <a:xfrm>
-            <a:off x="4663440" y="2560320"/>
-            <a:ext cx="2743200" cy="457200"/>
-          </a:xfrm>
-          <a:prstGeom prst="rect">
-            <a:avLst/>
-          </a:prstGeom>
-        </p:spPr>
-        <p:txBody>
-          <a:bodyPr anchor="t"/>
-          <a:lstStyle/>
-          <a:p>
-            <a:pPr algn="l"/>
-            <a:r>
-              <a:rPr b="1" sz="1600">
-                <a:solidFill>
-                  <a:srgbClr val="0F172A"/>
-                </a:solidFill>
-                <a:latin typeface="+mn-lt"/>
-                <a:cs typeface="+mn-lt"/>
-              </a:rPr>
-              <a:t>Stateless Worker Fleet</a:t>
-            </a:r>
-          </a:p>
-        </p:txBody>
-      </p:sp>
-      <p:sp>
-        <p:nvSpPr>
-          <p:cNvPr id="11" name="Text Box 10"/>
-          <p:cNvSpPr/>
-          <p:nvPr/>
-        </p:nvSpPr>
-        <p:spPr>
-          <a:xfrm>
-            <a:off x="4663440" y="3108960"/>
-            <a:ext cx="2743200" cy="2286000"/>
-          </a:xfrm>
-          <a:prstGeom prst="rect">
-            <a:avLst/>
-          </a:prstGeom>
-        </p:spPr>
-        <p:txBody>
-          <a:bodyPr anchor="t"/>
-          <a:lstStyle/>
-          <a:p>
-            <a:pPr algn="l" lvl="0"/>
-            <a:r>
-              <a:rPr sz="1100">
-                <a:solidFill>
-                  <a:srgbClr val="475569"/>
-                </a:solidFill>
-                <a:latin typeface="+mn-lt"/>
-                <a:cs typeface="+mn-lt"/>
-              </a:rPr>
-              <a:t>V8 Isolate sandboxed execution</a:t>
-            </a:r>
-          </a:p>
-          <a:p>
-            <a:pPr algn="l" lvl="0"/>
-            <a:r>
-              <a:rPr sz="1100">
-                <a:solidFill>
-                  <a:srgbClr val="475569"/>
-                </a:solidFill>
-                <a:latin typeface="+mn-lt"/>
-                <a:cs typeface="+mn-lt"/>
-              </a:rPr>
-              <a:t>Instant &lt;5ms cold starts</a:t>
-            </a:r>
-          </a:p>
-          <a:p>
-            <a:pPr algn="l" lvl="0"/>
-            <a:r>
-              <a:rPr sz="1100">
-                <a:solidFill>
-                  <a:srgbClr val="475569"/>
-                </a:solidFill>
-                <a:latin typeface="+mn-lt"/>
-                <a:cs typeface="+mn-lt"/>
-              </a:rPr>
-              <a:t>Streaming SSR &amp; WebSockets</a:t>
-            </a:r>
-          </a:p>
-        </p:txBody>
-      </p:sp>
-      <p:sp>
-        <p:nvSpPr>
-          <p:cNvPr id="12" name="roundRect 11"/>
-          <p:cNvSpPr/>
-          <p:nvPr/>
-        </p:nvSpPr>
-        <p:spPr>
-          <a:xfrm>
-            <a:off x="7863840" y="1828800"/>
-            <a:ext cx="3291840" cy="4114800"/>
-          </a:xfrm>
-          <a:prstGeom prst="roundRect">
-            <a:avLst/>
-          </a:prstGeom>
-          <a:solidFill>
-            <a:srgbClr val="FFFFFF"/>
-          </a:solidFill>
-          <a:ln w="13716">
-            <a:solidFill>
-              <a:srgbClr val="E2E8F0"/>
-            </a:solidFill>
-          </a:ln>
-          <a:effectLst>
-            <a:outerShdw blurRad="137160" dist="45720" dir="5400000">
-              <a:srgbClr val="0F172A">
-                <a:alpha val="12000"/>
-              </a:srgbClr>
-            </a:outerShdw>
-          </a:effectLst>
-        </p:spPr>
-        <p:txBody>
-          <a:bodyPr/>
-          <a:lstStyle/>
-          <a:p>
-            <a:endParaRPr/>
-          </a:p>
-        </p:txBody>
-      </p:sp>
-      <p:sp>
-        <p:nvSpPr>
-          <p:cNvPr id="13" name="roundRect 12"/>
-          <p:cNvSpPr/>
-          <p:nvPr/>
-        </p:nvSpPr>
-        <p:spPr>
-          <a:xfrm>
-            <a:off x="8138160" y="2103120"/>
-            <a:ext cx="1828800" cy="320040"/>
-          </a:xfrm>
-          <a:prstGeom prst="roundRect">
-            <a:avLst/>
-          </a:prstGeom>
-          <a:solidFill>
-            <a:srgbClr val="F8FAFC"/>
-          </a:solidFill>
-          <a:ln w="9144">
-            <a:solidFill>
-              <a:srgbClr val="10B981"/>
-            </a:solidFill>
-          </a:ln>
-        </p:spPr>
-        <p:txBody>
-          <a:bodyPr anchor="t"/>
-          <a:lstStyle/>
-          <a:p>
-            <a:pPr algn="ctr"/>
-            <a:r>
-              <a:rPr b="1" sz="900">
-                <a:solidFill>
-                  <a:srgbClr val="10B981"/>
-                </a:solidFill>
-                <a:latin typeface="+mn-lt"/>
-                <a:cs typeface="+mn-lt"/>
-              </a:rPr>
-              <a:t>TIER 3 • STORAGE</a:t>
-            </a:r>
-          </a:p>
-        </p:txBody>
-      </p:sp>
-      <p:sp>
-        <p:nvSpPr>
-          <p:cNvPr id="14" name="Text Box 13"/>
-          <p:cNvSpPr/>
-          <p:nvPr/>
-        </p:nvSpPr>
-        <p:spPr>
-          <a:xfrm>
-            <a:off x="8138160" y="2560320"/>
-            <a:ext cx="2743200" cy="457200"/>
-          </a:xfrm>
-          <a:prstGeom prst="rect">
-            <a:avLst/>
-          </a:prstGeom>
-        </p:spPr>
-        <p:txBody>
-          <a:bodyPr anchor="t"/>
-          <a:lstStyle/>
-          <a:p>
-            <a:pPr algn="l"/>
-            <a:r>
-              <a:rPr b="1" sz="1600">
-                <a:solidFill>
-                  <a:srgbClr val="0F172A"/>
-                </a:solidFill>
-                <a:latin typeface="+mn-lt"/>
-                <a:cs typeface="+mn-lt"/>
-              </a:rPr>
-              <a:t>Distributed State Store</a:t>
-            </a:r>
-          </a:p>
-        </p:txBody>
-      </p:sp>
-      <p:sp>
-        <p:nvSpPr>
-          <p:cNvPr id="15" name="Text Box 14"/>
-          <p:cNvSpPr/>
-          <p:nvPr/>
-        </p:nvSpPr>
-        <p:spPr>
-          <a:xfrm>
-            <a:off x="8138160" y="3108960"/>
-            <a:ext cx="2743200" cy="2286000"/>
-          </a:xfrm>
-          <a:prstGeom prst="rect">
-            <a:avLst/>
-          </a:prstGeom>
-        </p:spPr>
-        <p:txBody>
-          <a:bodyPr anchor="t"/>
-          <a:lstStyle/>
-          <a:p>
-            <a:pPr algn="l" lvl="0"/>
-            <a:r>
-              <a:rPr sz="1100">
-                <a:solidFill>
-                  <a:srgbClr val="475569"/>
-                </a:solidFill>
-                <a:latin typeface="+mn-lt"/>
-                <a:cs typeface="+mn-lt"/>
-              </a:rPr>
-              <a:t>Globally replicated R2 object store</a:t>
-            </a:r>
-          </a:p>
-          <a:p>
-            <a:pPr algn="l" lvl="0"/>
-            <a:r>
-              <a:rPr sz="1100">
-                <a:solidFill>
-                  <a:srgbClr val="475569"/>
-                </a:solidFill>
-                <a:latin typeface="+mn-lt"/>
-                <a:cs typeface="+mn-lt"/>
-              </a:rPr>
-              <a:t>Low-latency D1 serverless SQLite</a:t>
-            </a:r>
-          </a:p>
-          <a:p>
-            <a:pPr algn="l" lvl="0"/>
-            <a:r>
-              <a:rPr sz="1100">
-                <a:solidFill>
-                  <a:srgbClr val="475569"/>
-                </a:solidFill>
-                <a:latin typeface="+mn-lt"/>
-                <a:cs typeface="+mn-lt"/>
-              </a:rPr>
-              <a:t>Workers KV key-value cache</a:t>
-            </a:r>
-          </a:p>
-        </p:txBody>
-      </p:sp>
-      <p:sp>
-        <p:nvSpPr>
-          <p:cNvPr id="16" name="Text Box 15"/>
-          <p:cNvSpPr/>
-          <p:nvPr/>
-        </p:nvSpPr>
-        <p:spPr>
-          <a:xfrm>
-            <a:off x="731520" y="6510528"/>
-            <a:ext cx="10725912" cy="228600"/>
-          </a:xfrm>
-          <a:prstGeom prst="rect">
-            <a:avLst/>
-          </a:prstGeom>
-        </p:spPr>
-        <p:txBody>
-          <a:bodyPr anchor="t"/>
-          <a:lstStyle/>
-          <a:p>
-            <a:pPr algn="ctr"/>
-            <a:r>
-              <a:rPr i="1" sz="800">
-                <a:solidFill>
-                  <a:srgbClr val="94A3B8"/>
-                </a:solidFill>
-                <a:latin typeface="+mn-lt"/>
-                <a:cs typeface="+mn-lt"/>
-              </a:rPr>
-              <a:t>* Disclaimer: All benchmark metrics, performance figures, and simulated architectures in this deck are synthetic demonstration values generated solely to showcase the authoring, formatting, and rendering capabilities of @hokkyss/pptx.</a:t>
-            </a:r>
-          </a:p>
-        </p:txBody>
-      </p:sp>
-    </p:spTree>
-  </p:cSld>
-  <p:clrMapOvr>
-    <a:masterClrMapping/>
-  </p:clrMapOvr>
-  <p:transition spd="fast">
-    <p:cover dir="l"/>
-  </p:transition>
-</p:sld>
-</file>
-
-<file path=ppt/slides/slide6.xml><?xml version="1.0" encoding="utf-8"?>
-<p:sld xmlns:a="http://schemas.openxmlformats.org/drawingml/2006/main" xmlns:r="http://schemas.openxmlformats.org/officeDocument/2006/relationships" xmlns:p="http://schemas.openxmlformats.org/presentationml/2006/main">
-  <p:cSld>
-    <p:bg>
-      <p:bgPr>
-        <a:solidFill>
-          <a:srgbClr val="FFFFFF"/>
-        </a:solidFill>
-        <a:effectLst/>
-      </p:bgPr>
-    </p:bg>
-    <p:spTree>
-      <p:nvGrpSpPr>
-        <p:cNvPr id="1" name=""/>
-        <p:cNvGrpSpPr/>
-        <p:nvPr/>
-      </p:nvGrpSpPr>
-      <p:grpSpPr>
-        <a:xfrm>
-          <a:off x="0" y="0"/>
-          <a:ext cx="0" cy="0"/>
-          <a:chOff x="0" y="0"/>
-          <a:chExt cx="0" cy="0"/>
-        </a:xfrm>
-      </p:grpSpPr>
-      <p:sp>
-        <p:nvSpPr>
-          <p:cNvPr id="2" name="Text Box 1"/>
-          <p:cNvSpPr/>
-          <p:nvPr/>
-        </p:nvSpPr>
-        <p:spPr>
-          <a:xfrm>
-            <a:off x="914400" y="731520"/>
-            <a:ext cx="10360152" cy="548640"/>
-          </a:xfrm>
-          <a:prstGeom prst="rect">
-            <a:avLst/>
-          </a:prstGeom>
-        </p:spPr>
-        <p:txBody>
-          <a:bodyPr anchor="t"/>
-          <a:lstStyle/>
-          <a:p>
-            <a:pPr algn="l"/>
-            <a:r>
-              <a:rPr b="1" sz="2400">
-                <a:solidFill>
-                  <a:srgbClr val="0F172A"/>
-                </a:solidFill>
-                <a:latin typeface="+mj-lt"/>
-                <a:cs typeface="+mj-lt"/>
-              </a:rPr>
-              <a:t>Isomorphic Media &amp; High-Fidelity Image Embedding</a:t>
-            </a:r>
-          </a:p>
-        </p:txBody>
-      </p:sp>
-      <p:sp>
-        <p:nvSpPr>
-          <p:cNvPr id="3" name="Text Box 2"/>
-          <p:cNvSpPr/>
-          <p:nvPr/>
-        </p:nvSpPr>
-        <p:spPr>
-          <a:xfrm>
-            <a:off x="914400" y="1280160"/>
-            <a:ext cx="10360152" cy="365760"/>
-          </a:xfrm>
-          <a:prstGeom prst="rect">
-            <a:avLst/>
-          </a:prstGeom>
-        </p:spPr>
-        <p:txBody>
-          <a:bodyPr anchor="t"/>
-          <a:lstStyle/>
-          <a:p>
-            <a:pPr algn="l"/>
-            <a:r>
-              <a:rPr sz="1400">
-                <a:solidFill>
-                  <a:srgbClr val="64748B"/>
-                </a:solidFill>
-                <a:latin typeface="+mn-lt"/>
-                <a:cs typeface="+mn-lt"/>
-              </a:rPr>
-              <a:t>Embedded raster graphics (PNG, JPEG), transparent alpha channels, aspect ratio scaling, and card layouts</a:t>
-            </a:r>
-          </a:p>
-        </p:txBody>
-      </p:sp>
-      <p:sp>
-        <p:nvSpPr>
-          <p:cNvPr id="4" name="roundRect 3"/>
-          <p:cNvSpPr/>
-          <p:nvPr/>
-        </p:nvSpPr>
-        <p:spPr>
-          <a:xfrm>
-            <a:off x="914400" y="1828800"/>
-            <a:ext cx="4937760" cy="4114800"/>
-          </a:xfrm>
-          <a:prstGeom prst="roundRect">
-            <a:avLst/>
-          </a:prstGeom>
-          <a:solidFill>
-            <a:srgbClr val="FFFFFF"/>
-          </a:solidFill>
-          <a:ln w="13716">
-            <a:solidFill>
-              <a:srgbClr val="E2E8F0"/>
-            </a:solidFill>
-          </a:ln>
-          <a:effectLst>
-            <a:outerShdw blurRad="137160" dist="45720" dir="5400000">
-              <a:srgbClr val="0F172A">
-                <a:alpha val="10000"/>
-              </a:srgbClr>
-            </a:outerShdw>
-          </a:effectLst>
-        </p:spPr>
-        <p:txBody>
-          <a:bodyPr/>
-          <a:lstStyle/>
-          <a:p>
-            <a:endParaRPr/>
-          </a:p>
-        </p:txBody>
-      </p:sp>
-      <p:sp>
-        <p:nvSpPr>
-          <p:cNvPr id="6" name="Text Box 5"/>
-          <p:cNvSpPr/>
-          <p:nvPr/>
-        </p:nvSpPr>
-        <p:spPr>
-          <a:xfrm>
-            <a:off x="1188720" y="4754880"/>
-            <a:ext cx="4389120" cy="365760"/>
-          </a:xfrm>
-          <a:prstGeom prst="rect">
-            <a:avLst/>
-          </a:prstGeom>
-        </p:spPr>
-        <p:txBody>
-          <a:bodyPr anchor="t"/>
-          <a:lstStyle/>
-          <a:p>
-            <a:pPr algn="l"/>
-            <a:r>
-              <a:rPr b="1" sz="1500">
-                <a:solidFill>
-                  <a:srgbClr val="0F172A"/>
-                </a:solidFill>
-                <a:latin typeface="+mn-lt"/>
-                <a:cs typeface="+mn-lt"/>
-              </a:rPr>
-              <a:t>Rich Visual Asset Integration</a:t>
-            </a:r>
-          </a:p>
-        </p:txBody>
-      </p:sp>
-      <p:sp>
-        <p:nvSpPr>
-          <p:cNvPr id="7" name="Text Box 6"/>
-          <p:cNvSpPr/>
-          <p:nvPr/>
-        </p:nvSpPr>
-        <p:spPr>
-          <a:xfrm>
-            <a:off x="1188720" y="5120640"/>
-            <a:ext cx="4389120" cy="548640"/>
-          </a:xfrm>
-          <a:prstGeom prst="rect">
-            <a:avLst/>
-          </a:prstGeom>
-        </p:spPr>
-        <p:txBody>
-          <a:bodyPr anchor="t"/>
-          <a:lstStyle/>
-          <a:p>
-            <a:pPr algn="l"/>
-            <a:r>
-              <a:rPr sz="1100">
-                <a:solidFill>
-                  <a:srgbClr val="64748B"/>
-                </a:solidFill>
-                <a:latin typeface="+mn-lt"/>
-                <a:cs typeface="+mn-lt"/>
-              </a:rPr>
-              <a:t>Automatic MIME-type detection, relationship mapping, and lossless OpenXML zip packaging.</a:t>
-            </a:r>
-          </a:p>
-        </p:txBody>
-      </p:sp>
-      <p:sp>
-        <p:nvSpPr>
-          <p:cNvPr id="8" name="roundRect 7"/>
-          <p:cNvSpPr/>
-          <p:nvPr/>
-        </p:nvSpPr>
-        <p:spPr>
-          <a:xfrm>
-            <a:off x="6336792" y="1828800"/>
-            <a:ext cx="4937760" cy="4114800"/>
-          </a:xfrm>
-          <a:prstGeom prst="roundRect">
-            <a:avLst/>
-          </a:prstGeom>
-          <a:solidFill>
-            <a:srgbClr val="FFFFFF"/>
-          </a:solidFill>
-          <a:ln w="13716">
-            <a:solidFill>
-              <a:srgbClr val="E2E8F0"/>
-            </a:solidFill>
-          </a:ln>
-          <a:effectLst>
-            <a:outerShdw blurRad="137160" dist="45720" dir="5400000">
-              <a:srgbClr val="0F172A">
-                <a:alpha val="10000"/>
-              </a:srgbClr>
-            </a:outerShdw>
-          </a:effectLst>
-        </p:spPr>
-        <p:txBody>
-          <a:bodyPr/>
-          <a:lstStyle/>
-          <a:p>
-            <a:endParaRPr/>
-          </a:p>
-        </p:txBody>
-      </p:sp>
-      <p:sp>
-        <p:nvSpPr>
-          <p:cNvPr id="9" name="roundRect 8"/>
-          <p:cNvSpPr/>
-          <p:nvPr/>
-        </p:nvSpPr>
-        <p:spPr>
-          <a:xfrm>
-            <a:off x="6611112" y="2103120"/>
-            <a:ext cx="4389120" cy="1097280"/>
-          </a:xfrm>
-          <a:prstGeom prst="roundRect">
-            <a:avLst/>
-          </a:prstGeom>
-          <a:solidFill>
-            <a:srgbClr val="0F172A"/>
-          </a:solidFill>
-        </p:spPr>
-        <p:txBody>
-          <a:bodyPr/>
-          <a:lstStyle/>
-          <a:p>
-            <a:endParaRPr/>
-          </a:p>
-        </p:txBody>
-      </p:sp>
-      <p:sp>
-        <p:nvSpPr>
-          <p:cNvPr id="11" name="Text Box 10"/>
-          <p:cNvSpPr/>
-          <p:nvPr/>
-        </p:nvSpPr>
-        <p:spPr>
-          <a:xfrm>
-            <a:off x="6611112" y="3383280"/>
-            <a:ext cx="4389120" cy="365760"/>
-          </a:xfrm>
-          <a:prstGeom prst="rect">
-            <a:avLst/>
-          </a:prstGeom>
-        </p:spPr>
-        <p:txBody>
-          <a:bodyPr anchor="t"/>
-          <a:lstStyle/>
-          <a:p>
-            <a:pPr algn="l"/>
-            <a:r>
-              <a:rPr b="1" sz="1500">
-                <a:solidFill>
-                  <a:srgbClr val="0F172A"/>
-                </a:solidFill>
-                <a:latin typeface="+mn-lt"/>
-                <a:cs typeface="+mn-lt"/>
-              </a:rPr>
-              <a:t>Supported Image Codecs &amp; Features</a:t>
-            </a:r>
-          </a:p>
-        </p:txBody>
-      </p:sp>
-      <p:sp>
-        <p:nvSpPr>
-          <p:cNvPr id="12" name="Text Box 11"/>
-          <p:cNvSpPr/>
-          <p:nvPr/>
-        </p:nvSpPr>
-        <p:spPr>
-          <a:xfrm>
-            <a:off x="6611112" y="3840480"/>
-            <a:ext cx="4389120" cy="2011680"/>
-          </a:xfrm>
-          <a:prstGeom prst="rect">
-            <a:avLst/>
-          </a:prstGeom>
-        </p:spPr>
-        <p:txBody>
-          <a:bodyPr anchor="t"/>
-          <a:lstStyle/>
-          <a:p>
-            <a:pPr algn="l" lvl="0" marL="152400" indent="-152400">
-              <a:buChar char="•"/>
-            </a:pPr>
-            <a:r>
-              <a:rPr sz="1100">
-                <a:solidFill>
-                  <a:srgbClr val="475569"/>
-                </a:solidFill>
-                <a:latin typeface="+mn-lt"/>
-                <a:cs typeface="+mn-lt"/>
-              </a:rPr>
-              <a:t>PNG with 32-bit RGBA alpha transparency</a:t>
-            </a:r>
-          </a:p>
-          <a:p>
-            <a:pPr algn="l" lvl="0" marL="152400" indent="-152400">
-              <a:buChar char="•"/>
-            </a:pPr>
-            <a:r>
-              <a:rPr sz="1100">
-                <a:solidFill>
-                  <a:srgbClr val="475569"/>
-                </a:solidFill>
-                <a:latin typeface="+mn-lt"/>
-                <a:cs typeface="+mn-lt"/>
-              </a:rPr>
-              <a:t>JPEG / JPG progressive and baseline encoding</a:t>
-            </a:r>
-          </a:p>
-          <a:p>
-            <a:pPr algn="l" lvl="0" marL="152400" indent="-152400">
-              <a:buChar char="•"/>
-            </a:pPr>
-            <a:r>
-              <a:rPr sz="1100">
-                <a:solidFill>
-                  <a:srgbClr val="475569"/>
-                </a:solidFill>
-                <a:latin typeface="+mn-lt"/>
-                <a:cs typeface="+mn-lt"/>
-              </a:rPr>
-              <a:t>Zero-copy ArrayBuffer &amp; Uint8Array input</a:t>
-            </a:r>
-          </a:p>
-          <a:p>
-            <a:pPr algn="l" lvl="0" marL="152400" indent="-152400">
-              <a:buChar char="•"/>
-            </a:pPr>
-            <a:r>
-              <a:rPr sz="1100">
-                <a:solidFill>
-                  <a:srgbClr val="475569"/>
-                </a:solidFill>
-                <a:latin typeface="+mn-lt"/>
-                <a:cs typeface="+mn-lt"/>
-              </a:rPr>
-              <a:t>Placeholder resolution into slide layout picture frames</a:t>
-            </a:r>
-          </a:p>
-        </p:txBody>
-      </p:sp>
-      <p:sp>
-        <p:nvSpPr>
-          <p:cNvPr id="13" name="Text Box 12"/>
-          <p:cNvSpPr/>
-          <p:nvPr/>
-        </p:nvSpPr>
-        <p:spPr>
-          <a:xfrm>
-            <a:off x="731520" y="6510528"/>
-            <a:ext cx="10725912" cy="228600"/>
-          </a:xfrm>
-          <a:prstGeom prst="rect">
-            <a:avLst/>
-          </a:prstGeom>
-        </p:spPr>
-        <p:txBody>
-          <a:bodyPr anchor="t"/>
-          <a:lstStyle/>
-          <a:p>
-            <a:pPr algn="ctr"/>
-            <a:r>
-              <a:rPr i="1" sz="800">
-                <a:solidFill>
-                  <a:srgbClr val="94A3B8"/>
-                </a:solidFill>
-                <a:latin typeface="+mn-lt"/>
-                <a:cs typeface="+mn-lt"/>
-              </a:rPr>
-              <a:t>* Disclaimer: All benchmark metrics, performance figures, and simulated architectures in this deck are synthetic demonstration values generated solely to showcase the authoring, formatting, and rendering capabilities of @hokkyss/pptx.</a:t>
-            </a:r>
-          </a:p>
-        </p:txBody>
-      </p:sp>
-      <p:pic>
-        <p:nvPicPr>
-          <p:cNvPr id="5" name="Picture 4"/>
-          <p:cNvPicPr>
-            <a:picLocks noChangeAspect="1"/>
-          </p:cNvPicPr>
-          <p:nvPr/>
-        </p:nvPicPr>
-        <p:blipFill>
-          <a:blip r:embed="rId2"/>
-          <a:stretch>
-            <a:fillRect/>
-          </a:stretch>
-        </p:blipFill>
-        <p:spPr>
-          <a:xfrm>
-            <a:off x="1188720" y="2103120"/>
-            <a:ext cx="4389120" cy="2468880"/>
-          </a:xfrm>
-          <a:prstGeom prst="rect">
-            <a:avLst/>
-          </a:prstGeom>
-        </p:spPr>
-      </p:pic>
-      <p:pic>
-        <p:nvPicPr>
-          <p:cNvPr id="10" name="Picture 9"/>
-          <p:cNvPicPr>
-            <a:picLocks noChangeAspect="1"/>
-          </p:cNvPicPr>
-          <p:nvPr/>
-        </p:nvPicPr>
-        <p:blipFill>
-          <a:blip r:embed="rId3"/>
-          <a:stretch>
-            <a:fillRect/>
-          </a:stretch>
-        </p:blipFill>
-        <p:spPr>
-          <a:xfrm>
-            <a:off x="7891272" y="2286000"/>
-            <a:ext cx="1828800" cy="731520"/>
-          </a:xfrm>
-          <a:prstGeom prst="rect">
-            <a:avLst/>
-          </a:prstGeom>
-        </p:spPr>
-      </p:pic>
-    </p:spTree>
-  </p:cSld>
-  <p:clrMapOvr>
-    <a:masterClrMapping/>
-  </p:clrMapOvr>
-  <p:transition spd="med">
-    <p:fade/>
-  </p:transition>
-</p:sld>
-</file>
-
-<file path=ppt/slides/slide7.xml><?xml version="1.0" encoding="utf-8"?>
-<p:sld xmlns:a="http://schemas.openxmlformats.org/drawingml/2006/main" xmlns:r="http://schemas.openxmlformats.org/officeDocument/2006/relationships" xmlns:p="http://schemas.openxmlformats.org/presentationml/2006/main">
-  <p:cSld>
-    <p:bg>
-      <p:bgPr>
-        <a:solidFill>
-          <a:srgbClr val="F8FAFC"/>
-        </a:solidFill>
-        <a:effectLst/>
-      </p:bgPr>
-    </p:bg>
-    <p:spTree>
-      <p:nvGrpSpPr>
-        <p:cNvPr id="1" name=""/>
-        <p:cNvGrpSpPr/>
-        <p:nvPr/>
-      </p:nvGrpSpPr>
-      <p:grpSpPr>
-        <a:xfrm>
-          <a:off x="0" y="0"/>
-          <a:ext cx="0" cy="0"/>
-          <a:chOff x="0" y="0"/>
-          <a:chExt cx="0" cy="0"/>
-        </a:xfrm>
-      </p:grpSpPr>
-      <p:sp>
-        <p:nvSpPr>
-          <p:cNvPr id="2" name="Text Box 1"/>
-          <p:cNvSpPr/>
-          <p:nvPr/>
-        </p:nvSpPr>
-        <p:spPr>
-          <a:xfrm>
-            <a:off x="914400" y="731520"/>
-            <a:ext cx="10360152" cy="548640"/>
-          </a:xfrm>
-          <a:prstGeom prst="rect">
-            <a:avLst/>
-          </a:prstGeom>
-        </p:spPr>
-        <p:txBody>
-          <a:bodyPr anchor="t"/>
-          <a:lstStyle/>
-          <a:p>
-            <a:pPr algn="l"/>
-            <a:r>
-              <a:rPr b="1" sz="2400">
-                <a:solidFill>
                   <a:srgbClr val="38BDF8"/>
                 </a:solidFill>
                 <a:latin typeface="+mj-lt"/>
@@ -8488,7 +8488,7 @@
     <p:bg>
       <p:bgPr>
         <a:solidFill>
-          <a:srgbClr val="0F172A"/>
+          <a:srgbClr val="F8FAFC"/>
         </a:solidFill>
         <a:effectLst/>
       </p:bgPr>
@@ -9184,7 +9184,7 @@
     <p:bg>
       <p:bgPr>
         <a:solidFill>
-          <a:srgbClr val="FFFFFF"/>
+          <a:srgbClr val="0F172A"/>
         </a:solidFill>
         <a:effectLst/>
       </p:bgPr>

</xml_diff>

<commit_message>
feat(sdk): add native hyperlinks and slide navigation across core, writer, reader, and sdk
</commit_message>
<xml_diff>
--- a/hokkyss_showcase_deck.pptx
+++ b/hokkyss_showcase_deck.pptx
@@ -2939,7 +2939,7 @@
           <a:bodyPr anchor="t"/>
           <a:lstStyle/>
           <a:p>
-            <a:pPr algn="l" lvl="0"/>
+            <a:pPr algn="l"/>
             <a:r>
               <a:rPr b="1" sz="1400">
                 <a:solidFill>
@@ -2948,11 +2948,15 @@
                 <a:latin typeface="+mn-lt"/>
                 <a:cs typeface="+mn-lt"/>
               </a:rPr>
-              <a:t>🚀 100% Isomorphic </a:t>
-            </a:r>
-          </a:p>
-          <a:p>
-            <a:pPr algn="l" lvl="0"/>
+              <a:t>🚀 100% Isomorphic</a:t>
+            </a:r>
+          </a:p>
+          <a:p>
+            <a:pPr algn="l"/>
+            <a:endParaRPr/>
+          </a:p>
+          <a:p>
+            <a:pPr algn="l"/>
             <a:r>
               <a:rPr sz="1200">
                 <a:solidFill>
@@ -3000,7 +3004,7 @@
           <a:bodyPr anchor="t"/>
           <a:lstStyle/>
           <a:p>
-            <a:pPr algn="l" lvl="0"/>
+            <a:pPr algn="l"/>
             <a:r>
               <a:rPr b="1" sz="1400">
                 <a:solidFill>
@@ -3009,11 +3013,15 @@
                 <a:latin typeface="+mn-lt"/>
                 <a:cs typeface="+mn-lt"/>
               </a:rPr>
-              <a:t>🌲 Zero-Dependency </a:t>
-            </a:r>
-          </a:p>
-          <a:p>
-            <a:pPr algn="l" lvl="0"/>
+              <a:t>🌲 Zero-Dependency</a:t>
+            </a:r>
+          </a:p>
+          <a:p>
+            <a:pPr algn="l"/>
+            <a:endParaRPr/>
+          </a:p>
+          <a:p>
+            <a:pPr algn="l"/>
             <a:r>
               <a:rPr sz="1200">
                 <a:solidFill>
@@ -3061,7 +3069,7 @@
           <a:bodyPr anchor="t"/>
           <a:lstStyle/>
           <a:p>
-            <a:pPr algn="l" lvl="0"/>
+            <a:pPr algn="l"/>
             <a:r>
               <a:rPr b="1" sz="1400">
                 <a:solidFill>
@@ -3070,11 +3078,15 @@
                 <a:latin typeface="+mn-lt"/>
                 <a:cs typeface="+mn-lt"/>
               </a:rPr>
-              <a:t>🛡️ Type-Safe Units </a:t>
-            </a:r>
-          </a:p>
-          <a:p>
-            <a:pPr algn="l" lvl="0"/>
+              <a:t>🛡️ Type-Safe Units</a:t>
+            </a:r>
+          </a:p>
+          <a:p>
+            <a:pPr algn="l"/>
+            <a:endParaRPr/>
+          </a:p>
+          <a:p>
+            <a:pPr algn="l"/>
             <a:r>
               <a:rPr sz="1200">
                 <a:solidFill>
@@ -5054,7 +5066,7 @@
           <a:bodyPr anchor="t"/>
           <a:lstStyle/>
           <a:p>
-            <a:pPr algn="l" lvl="0"/>
+            <a:pPr algn="l"/>
             <a:r>
               <a:rPr b="1" sz="1300">
                 <a:solidFill>
@@ -5063,11 +5075,11 @@
                 <a:latin typeface="+mn-lt"/>
                 <a:cs typeface="+mn-lt"/>
               </a:rPr>
-              <a:t>@hokkyss/pptx-core </a:t>
-            </a:r>
-          </a:p>
-          <a:p>
-            <a:pPr algn="l" lvl="0"/>
+              <a:t>@hokkyss/pptx-core</a:t>
+            </a:r>
+          </a:p>
+          <a:p>
+            <a:pPr algn="l"/>
             <a:r>
               <a:rPr sz="1000">
                 <a:solidFill>
@@ -5110,7 +5122,7 @@
           <a:bodyPr anchor="t"/>
           <a:lstStyle/>
           <a:p>
-            <a:pPr algn="l" lvl="0"/>
+            <a:pPr algn="l"/>
             <a:r>
               <a:rPr b="1" sz="1300">
                 <a:solidFill>
@@ -5119,11 +5131,11 @@
                 <a:latin typeface="+mn-lt"/>
                 <a:cs typeface="+mn-lt"/>
               </a:rPr>
-              <a:t>@hokkyss/pptx-reader </a:t>
-            </a:r>
-          </a:p>
-          <a:p>
-            <a:pPr algn="l" lvl="0"/>
+              <a:t>@hokkyss/pptx-reader</a:t>
+            </a:r>
+          </a:p>
+          <a:p>
+            <a:pPr algn="l"/>
             <a:r>
               <a:rPr sz="1000">
                 <a:solidFill>
@@ -5166,7 +5178,7 @@
           <a:bodyPr anchor="t"/>
           <a:lstStyle/>
           <a:p>
-            <a:pPr algn="l" lvl="0"/>
+            <a:pPr algn="l"/>
             <a:r>
               <a:rPr b="1" sz="1300">
                 <a:solidFill>
@@ -5175,11 +5187,11 @@
                 <a:latin typeface="+mn-lt"/>
                 <a:cs typeface="+mn-lt"/>
               </a:rPr>
-              <a:t>@hokkyss/pptx-writer </a:t>
-            </a:r>
-          </a:p>
-          <a:p>
-            <a:pPr algn="l" lvl="0"/>
+              <a:t>@hokkyss/pptx-writer</a:t>
+            </a:r>
+          </a:p>
+          <a:p>
+            <a:pPr algn="l"/>
             <a:r>
               <a:rPr sz="1000">
                 <a:solidFill>
@@ -5222,7 +5234,7 @@
           <a:bodyPr anchor="t"/>
           <a:lstStyle/>
           <a:p>
-            <a:pPr algn="l" lvl="0"/>
+            <a:pPr algn="l"/>
             <a:r>
               <a:rPr b="1" sz="1300">
                 <a:solidFill>
@@ -5231,11 +5243,11 @@
                 <a:latin typeface="+mn-lt"/>
                 <a:cs typeface="+mn-lt"/>
               </a:rPr>
-              <a:t>@hokkyss/pptx </a:t>
-            </a:r>
-          </a:p>
-          <a:p>
-            <a:pPr algn="l" lvl="0"/>
+              <a:t>@hokkyss/pptx</a:t>
+            </a:r>
+          </a:p>
+          <a:p>
+            <a:pPr algn="l"/>
             <a:r>
               <a:rPr sz="1000">
                 <a:solidFill>

</xml_diff>

<commit_message>
feat(showcase): add interactive hyperlinks and slide navigation to showcase deck
</commit_message>
<xml_diff>
--- a/hokkyss_showcase_deck.pptx
+++ b/hokkyss_showcase_deck.pptx
@@ -2841,7 +2841,9 @@
       </p:sp>
       <p:sp>
         <p:nvSpPr>
-          <p:cNvPr id="3" name="Text Box 2"/>
+          <p:cNvPr id="3" name="Text Box 2">
+            <a:hlinkClick r:id="rId2" tooltip="GitHub Repository: @hokkyss/pptx"/>
+          </p:cNvPr>
           <p:cNvSpPr/>
           <p:nvPr/>
         </p:nvSpPr>
@@ -2864,6 +2866,7 @@
                 <a:solidFill>
                   <a:srgbClr val="FFFFFF"/>
                 </a:solidFill>
+                <a:hlinkClick r:id="rId2" tooltip="GitHub Repository: @hokkyss/pptx"/>
                 <a:latin typeface="+mj-lt"/>
                 <a:cs typeface="+mj-lt"/>
               </a:rPr>
@@ -4171,7 +4174,57 @@
       </p:sp>
       <p:sp>
         <p:nvSpPr>
-          <p:cNvPr id="10" name="Text Box 9"/>
+          <p:cNvPr id="10" name="roundRect 9">
+            <a:hlinkClick tooltip="Return to Title (Slide 1)" action="ppaction://hlinkshowjump?jump=firstslide"/>
+          </p:cNvPr>
+          <p:cNvSpPr/>
+          <p:nvPr/>
+        </p:nvSpPr>
+        <p:spPr>
+          <a:xfrm>
+            <a:off x="9235440" y="731520"/>
+            <a:ext cx="2011680" cy="411480"/>
+          </a:xfrm>
+          <a:prstGeom prst="roundRect">
+            <a:avLst/>
+          </a:prstGeom>
+          <a:solidFill>
+            <a:srgbClr val="0284C7"/>
+          </a:solidFill>
+          <a:ln w="13716">
+            <a:solidFill>
+              <a:srgbClr val="38BDF8"/>
+            </a:solidFill>
+          </a:ln>
+          <a:effectLst>
+            <a:outerShdw blurRad="137160" dist="27432" dir="5400000">
+              <a:srgbClr val="0284C7">
+                <a:alpha val="30000"/>
+              </a:srgbClr>
+            </a:outerShdw>
+          </a:effectLst>
+        </p:spPr>
+        <p:txBody>
+          <a:bodyPr anchor="t"/>
+          <a:lstStyle/>
+          <a:p>
+            <a:pPr algn="ctr"/>
+            <a:r>
+              <a:rPr b="1" sz="1000">
+                <a:solidFill>
+                  <a:srgbClr val="FFFFFF"/>
+                </a:solidFill>
+                <a:latin typeface="+mn-lt"/>
+                <a:cs typeface="+mn-lt"/>
+              </a:rPr>
+              <a:t>⬅ Return to Title</a:t>
+            </a:r>
+          </a:p>
+        </p:txBody>
+      </p:sp>
+      <p:sp>
+        <p:nvSpPr>
+          <p:cNvPr id="11" name="Text Box 10"/>
           <p:cNvSpPr/>
           <p:nvPr/>
         </p:nvSpPr>
@@ -5034,7 +5087,9 @@
       </p:sp>
       <p:sp>
         <p:nvSpPr>
-          <p:cNvPr id="4" name="roundRect 3"/>
+          <p:cNvPr id="4" name="roundRect 3">
+            <a:hlinkClick r:id="rId2" tooltip="View @hokkyss/pptx-core on GitHub"/>
+          </p:cNvPr>
           <p:cNvSpPr/>
           <p:nvPr/>
         </p:nvSpPr>
@@ -5095,7 +5150,9 @@
       </p:sp>
       <p:sp>
         <p:nvSpPr>
-          <p:cNvPr id="5" name="roundRect 4"/>
+          <p:cNvPr id="5" name="roundRect 4">
+            <a:hlinkClick r:id="rId3" tooltip="View @hokkyss/pptx-reader on GitHub"/>
+          </p:cNvPr>
           <p:cNvSpPr/>
           <p:nvPr/>
         </p:nvSpPr>
@@ -5151,7 +5208,9 @@
       </p:sp>
       <p:sp>
         <p:nvSpPr>
-          <p:cNvPr id="6" name="roundRect 5"/>
+          <p:cNvPr id="6" name="roundRect 5">
+            <a:hlinkClick r:id="rId4" tooltip="View @hokkyss/pptx-writer on GitHub"/>
+          </p:cNvPr>
           <p:cNvSpPr/>
           <p:nvPr/>
         </p:nvSpPr>
@@ -5207,7 +5266,9 @@
       </p:sp>
       <p:sp>
         <p:nvSpPr>
-          <p:cNvPr id="7" name="roundRect 6"/>
+          <p:cNvPr id="7" name="roundRect 6">
+            <a:hlinkClick r:id="rId5" tooltip="View @hokkyss/pptx on GitHub"/>
+          </p:cNvPr>
           <p:cNvSpPr/>
           <p:nvPr/>
         </p:nvSpPr>

</xml_diff>

<commit_message>
feat(showcase): add dedicated Slide 12 featuring native hyperlinks, slide jumps, and action controls
</commit_message>
<xml_diff>
--- a/hokkyss_showcase_deck.pptx
+++ b/hokkyss_showcase_deck.pptx
@@ -5,7 +5,7 @@
     <p:sldMasterId id="2147483648" r:id="rId1"/>
   </p:sldMasterIdLst>
   <p:notesMasterIdLst>
-    <p:notesMasterId r:id="rId14"/>
+    <p:notesMasterId r:id="rId15"/>
   </p:notesMasterIdLst>
   <p:sldIdLst>
     <p:sldId id="256" r:id="rId2"/>
@@ -20,6 +20,7 @@
     <p:sldId id="265" r:id="rId11"/>
     <p:sldId id="266" r:id="rId12"/>
     <p:sldId id="267" r:id="rId13"/>
+    <p:sldId id="268" r:id="rId14"/>
   </p:sldIdLst>
   <p:sldSz cx="12192000" cy="6858000"/>
   <p:notesSz cx="6858000" cy="9144000"/>
@@ -1360,7 +1361,7 @@
           </c:tx>
           <c:spPr>
             <a:solidFill>
-              <a:srgbClr val="0284C7"/>
+              <a:srgbClr val="38BDF8"/>
             </a:solidFill>
           </c:spPr>
           <c:invertIfNegative val="0"/>
@@ -1485,7 +1486,7 @@
             <a:pPr>
               <a:defRPr>
                 <a:solidFill>
-                  <a:srgbClr val="334155"/>
+                  <a:srgbClr val="CBD5E1"/>
                 </a:solidFill>
               </a:defRPr>
             </a:pPr>
@@ -1533,7 +1534,7 @@
             <a:pPr>
               <a:defRPr>
                 <a:solidFill>
-                  <a:srgbClr val="334155"/>
+                  <a:srgbClr val="CBD5E1"/>
                 </a:solidFill>
               </a:defRPr>
             </a:pPr>
@@ -1555,7 +1556,7 @@
           <a:pPr>
             <a:defRPr>
               <a:solidFill>
-                <a:srgbClr val="334155"/>
+                <a:srgbClr val="CBD5E1"/>
               </a:solidFill>
             </a:defRPr>
           </a:pPr>
@@ -2559,6 +2560,112 @@
 </file>
 
 <file path=ppt/notesSlides/notesSlide8.xml><?xml version="1.0" encoding="utf-8"?>
+<p:notes xmlns:a="http://schemas.openxmlformats.org/drawingml/2006/main" xmlns:r="http://schemas.openxmlformats.org/officeDocument/2006/relationships" xmlns:p="http://schemas.openxmlformats.org/presentationml/2006/main">
+  <p:cSld>
+    <p:spTree>
+      <p:nvGrpSpPr>
+        <p:cNvPr id="1" name=""/>
+        <p:cNvGrpSpPr/>
+        <p:nvPr/>
+      </p:nvGrpSpPr>
+      <p:grpSpPr>
+        <a:xfrm>
+          <a:off x="0" y="0"/>
+          <a:ext cx="0" cy="0"/>
+          <a:chOff x="0" y="0"/>
+          <a:chExt cx="0" cy="0"/>
+        </a:xfrm>
+      </p:grpSpPr>
+      <p:sp>
+        <p:nvSpPr>
+          <p:cNvPr id="2" name="Slide Image Placeholder 1"/>
+          <p:cNvSpPr>
+            <a:spLocks noGrp="1" noRot="1" noChangeAspect="1"/>
+          </p:cNvSpPr>
+          <p:nvPr>
+            <p:ph type="sldImg"/>
+          </p:nvPr>
+        </p:nvSpPr>
+        <p:spPr/>
+      </p:sp>
+      <p:sp>
+        <p:nvSpPr>
+          <p:cNvPr id="3" name="Notes Placeholder 2"/>
+          <p:cNvSpPr>
+            <a:spLocks noGrp="1"/>
+          </p:cNvSpPr>
+          <p:nvPr>
+            <p:ph type="body" idx="1"/>
+          </p:nvPr>
+        </p:nvSpPr>
+        <p:spPr/>
+        <p:txBody>
+          <a:bodyPr anchor="t"/>
+          <a:lstStyle/>
+          <a:p>
+            <a:pPr algn="l" lvl="0"/>
+            <a:r>
+              <a:rPr b="1">
+                <a:latin typeface="+mn-lt"/>
+                <a:cs typeface="+mn-lt"/>
+              </a:rPr>
+              <a:t>Hyperlinks &amp; Slide Navigation Keynote: </a:t>
+            </a:r>
+            <a:r>
+              <a:rPr u="sng">
+                <a:latin typeface="+mn-lt"/>
+                <a:cs typeface="+mn-lt"/>
+              </a:rPr>
+              <a:t>Interactive OpenXML Actions &amp; Relationships</a:t>
+            </a:r>
+          </a:p>
+          <a:p>
+            <a:pPr algn="l" lvl="0" marL="152400" indent="-152400">
+              <a:buChar char="•"/>
+            </a:pPr>
+            <a:r>
+              <a:rPr>
+                <a:latin typeface="+mn-lt"/>
+                <a:cs typeface="+mn-lt"/>
+              </a:rPr>
+              <a:t>Full support for external web links, mailto targets, and hover tooltips.</a:t>
+            </a:r>
+          </a:p>
+          <a:p>
+            <a:pPr algn="l" lvl="0" marL="152400" indent="-152400">
+              <a:buChar char="•"/>
+            </a:pPr>
+            <a:r>
+              <a:rPr>
+                <a:latin typeface="+mn-lt"/>
+                <a:cs typeface="+mn-lt"/>
+              </a:rPr>
+              <a:t>Internal slide jumping using strongly typed slideIndex referencing.</a:t>
+            </a:r>
+          </a:p>
+          <a:p>
+            <a:pPr algn="l" lvl="0" marL="152400" indent="-152400">
+              <a:buChar char="•"/>
+            </a:pPr>
+            <a:r>
+              <a:rPr>
+                <a:latin typeface="+mn-lt"/>
+                <a:cs typeface="+mn-lt"/>
+              </a:rPr>
+              <a:t>Built-in slide show control actions: firstSlide, lastSlide, nextSlide, previousSlide, endShow.</a:t>
+            </a:r>
+          </a:p>
+        </p:txBody>
+      </p:sp>
+    </p:spTree>
+  </p:cSld>
+  <p:clrMapOvr>
+    <a:masterClrMapping/>
+  </p:clrMapOvr>
+</p:notes>
+</file>
+
+<file path=ppt/notesSlides/notesSlide9.xml><?xml version="1.0" encoding="utf-8"?>
 <p:notes xmlns:a="http://schemas.openxmlformats.org/drawingml/2006/main" xmlns:r="http://schemas.openxmlformats.org/officeDocument/2006/relationships" xmlns:p="http://schemas.openxmlformats.org/presentationml/2006/main">
   <p:cSld>
     <p:spTree>
@@ -3992,7 +4099,7 @@
                 <a:latin typeface="+mj-lt"/>
                 <a:cs typeface="+mj-lt"/>
               </a:rPr>
-              <a:t>Engine Performance &amp; Bundle Size Matrix</a:t>
+              <a:t>Native Hyperlinks &amp; Interactive Navigation System</a:t>
             </a:r>
           </a:p>
         </p:txBody>
@@ -4025,7 +4132,7 @@
                 <a:latin typeface="+mn-lt"/>
                 <a:cs typeface="+mn-lt"/>
               </a:rPr>
-              <a:t>Empirical microsecond throughput benchmarks and ultra-lean tree-shakeable bundle budgets</a:t>
+              <a:t>OpenXML DrawingML &lt;a:hlinkClick&gt; external URLs, slide navigation jumps, hover ScreenTips, and presentation controls</a:t>
             </a:r>
           </a:p>
         </p:txBody>
@@ -4096,21 +4203,278 @@
                 <a:latin typeface="+mn-lt"/>
                 <a:cs typeface="+mn-lt"/>
               </a:rPr>
-              <a:t>⚡ Throughput &amp; Latency Benchmarks (Vitest)</a:t>
-            </a:r>
-          </a:p>
-        </p:txBody>
-      </p:sp>
-      <p:sp>
-        <p:nvSpPr>
-          <p:cNvPr id="7" name="roundRect 6"/>
+              <a:t>🧭 Interactive Presentation Jump Hub</a:t>
+            </a:r>
+          </a:p>
+        </p:txBody>
+      </p:sp>
+      <p:sp>
+        <p:nvSpPr>
+          <p:cNvPr id="6" name="Text Box 5"/>
+          <p:cNvSpPr/>
+          <p:nvPr/>
+        </p:nvSpPr>
+        <p:spPr>
+          <a:xfrm>
+            <a:off x="914400" y="2331720"/>
+            <a:ext cx="4846320" cy="274320"/>
+          </a:xfrm>
+          <a:prstGeom prst="rect">
+            <a:avLst/>
+          </a:prstGeom>
+        </p:spPr>
+        <p:txBody>
+          <a:bodyPr anchor="t"/>
+          <a:lstStyle/>
+          <a:p>
+            <a:pPr algn="l"/>
+            <a:r>
+              <a:rPr sz="1050">
+                <a:solidFill>
+                  <a:srgbClr val="64748B"/>
+                </a:solidFill>
+                <a:latin typeface="+mn-lt"/>
+                <a:cs typeface="+mn-lt"/>
+              </a:rPr>
+              <a:t>Click any card below during slide show mode to immediately jump to that section:</a:t>
+            </a:r>
+          </a:p>
+        </p:txBody>
+      </p:sp>
+      <p:sp>
+        <p:nvSpPr>
+          <p:cNvPr id="7" name="roundRect 6">
+            <a:hlinkClick r:id="rId2" tooltip="Jump directly to Slide 2" action="ppaction://hlinksldjump"/>
+          </p:cNvPr>
+          <p:cNvSpPr/>
+          <p:nvPr/>
+        </p:nvSpPr>
+        <p:spPr>
+          <a:xfrm>
+            <a:off x="914400" y="2697480"/>
+            <a:ext cx="4846320" cy="749808"/>
+          </a:xfrm>
+          <a:prstGeom prst="roundRect">
+            <a:avLst/>
+          </a:prstGeom>
+          <a:solidFill>
+            <a:srgbClr val="F0F9FF"/>
+          </a:solidFill>
+          <a:ln w="13716">
+            <a:solidFill>
+              <a:srgbClr val="0284C7"/>
+            </a:solidFill>
+          </a:ln>
+        </p:spPr>
+        <p:txBody>
+          <a:bodyPr anchor="t"/>
+          <a:lstStyle/>
+          <a:p>
+            <a:pPr algn="l"/>
+            <a:r>
+              <a:rPr b="1" sz="1100">
+                <a:solidFill>
+                  <a:srgbClr val="0369A1"/>
+                </a:solidFill>
+                <a:latin typeface="+mn-lt"/>
+                <a:cs typeface="+mn-lt"/>
+              </a:rPr>
+              <a:t>📐 Slide 2: Modular Architecture ➔</a:t>
+            </a:r>
+          </a:p>
+          <a:p>
+            <a:pPr algn="l"/>
+            <a:r>
+              <a:rPr sz="950">
+                <a:solidFill>
+                  <a:srgbClr val="64748B"/>
+                </a:solidFill>
+                <a:latin typeface="+mn-lt"/>
+                <a:cs typeface="+mn-lt"/>
+              </a:rPr>
+              <a:t>Four decoupled packages &amp; DrawingML presets</a:t>
+            </a:r>
+          </a:p>
+        </p:txBody>
+      </p:sp>
+      <p:sp>
+        <p:nvSpPr>
+          <p:cNvPr id="8" name="roundRect 7">
+            <a:hlinkClick r:id="rId3" tooltip="Jump directly to Slide 3" action="ppaction://hlinksldjump"/>
+          </p:cNvPr>
+          <p:cNvSpPr/>
+          <p:nvPr/>
+        </p:nvSpPr>
+        <p:spPr>
+          <a:xfrm>
+            <a:off x="914400" y="3566160"/>
+            <a:ext cx="4846320" cy="749808"/>
+          </a:xfrm>
+          <a:prstGeom prst="roundRect">
+            <a:avLst/>
+          </a:prstGeom>
+          <a:solidFill>
+            <a:srgbClr val="EEF2FF"/>
+          </a:solidFill>
+          <a:ln w="13716">
+            <a:solidFill>
+              <a:srgbClr val="6366F1"/>
+            </a:solidFill>
+          </a:ln>
+        </p:spPr>
+        <p:txBody>
+          <a:bodyPr anchor="t"/>
+          <a:lstStyle/>
+          <a:p>
+            <a:pPr algn="l"/>
+            <a:r>
+              <a:rPr b="1" sz="1100">
+                <a:solidFill>
+                  <a:srgbClr val="4338CA"/>
+                </a:solidFill>
+                <a:latin typeface="+mn-lt"/>
+                <a:cs typeface="+mn-lt"/>
+              </a:rPr>
+              <a:t>📊 Slide 3: Enterprise Data Tables ➔</a:t>
+            </a:r>
+          </a:p>
+          <a:p>
+            <a:pPr algn="l"/>
+            <a:r>
+              <a:rPr sz="950">
+                <a:solidFill>
+                  <a:srgbClr val="64748B"/>
+                </a:solidFill>
+                <a:latin typeface="+mn-lt"/>
+                <a:cs typeface="+mn-lt"/>
+              </a:rPr>
+              <a:t>Formatted headers, zebra fills &amp; metric cells</a:t>
+            </a:r>
+          </a:p>
+        </p:txBody>
+      </p:sp>
+      <p:sp>
+        <p:nvSpPr>
+          <p:cNvPr id="9" name="roundRect 8">
+            <a:hlinkClick r:id="rId4" tooltip="Jump directly to Slide 9" action="ppaction://hlinksldjump"/>
+          </p:cNvPr>
+          <p:cNvSpPr/>
+          <p:nvPr/>
+        </p:nvSpPr>
+        <p:spPr>
+          <a:xfrm>
+            <a:off x="914400" y="4434840"/>
+            <a:ext cx="4846320" cy="749808"/>
+          </a:xfrm>
+          <a:prstGeom prst="roundRect">
+            <a:avLst/>
+          </a:prstGeom>
+          <a:solidFill>
+            <a:srgbClr val="ECFDF5"/>
+          </a:solidFill>
+          <a:ln w="13716">
+            <a:solidFill>
+              <a:srgbClr val="10B981"/>
+            </a:solidFill>
+          </a:ln>
+        </p:spPr>
+        <p:txBody>
+          <a:bodyPr anchor="t"/>
+          <a:lstStyle/>
+          <a:p>
+            <a:pPr algn="l"/>
+            <a:r>
+              <a:rPr b="1" sz="1100">
+                <a:solidFill>
+                  <a:srgbClr val="047857"/>
+                </a:solidFill>
+                <a:latin typeface="+mn-lt"/>
+                <a:cs typeface="+mn-lt"/>
+              </a:rPr>
+              <a:t>📈 Slide 9: OpenXML Charts &amp; Graphs ➔</a:t>
+            </a:r>
+          </a:p>
+          <a:p>
+            <a:pPr algn="l"/>
+            <a:r>
+              <a:rPr sz="950">
+                <a:solidFill>
+                  <a:srgbClr val="64748B"/>
+                </a:solidFill>
+                <a:latin typeface="+mn-lt"/>
+                <a:cs typeface="+mn-lt"/>
+              </a:rPr>
+              <a:t>Clustered bar &amp; line dual-series analytics</a:t>
+            </a:r>
+          </a:p>
+        </p:txBody>
+      </p:sp>
+      <p:sp>
+        <p:nvSpPr>
+          <p:cNvPr id="10" name="roundRect 9">
+            <a:hlinkClick r:id="rId5" tooltip="Jump directly to Slide 13" action="ppaction://hlinksldjump"/>
+          </p:cNvPr>
+          <p:cNvSpPr/>
+          <p:nvPr/>
+        </p:nvSpPr>
+        <p:spPr>
+          <a:xfrm>
+            <a:off x="914400" y="5303520"/>
+            <a:ext cx="4846320" cy="749808"/>
+          </a:xfrm>
+          <a:prstGeom prst="roundRect">
+            <a:avLst/>
+          </a:prstGeom>
+          <a:solidFill>
+            <a:srgbClr val="FFFBEB"/>
+          </a:solidFill>
+          <a:ln w="13716">
+            <a:solidFill>
+              <a:srgbClr val="F59E0B"/>
+            </a:solidFill>
+          </a:ln>
+        </p:spPr>
+        <p:txBody>
+          <a:bodyPr anchor="t"/>
+          <a:lstStyle/>
+          <a:p>
+            <a:pPr algn="l"/>
+            <a:r>
+              <a:rPr b="1" sz="1100">
+                <a:solidFill>
+                  <a:srgbClr val="B45309"/>
+                </a:solidFill>
+                <a:latin typeface="+mn-lt"/>
+                <a:cs typeface="+mn-lt"/>
+              </a:rPr>
+              <a:t>⚡ Slide 13: Engine Benchmark Matrix ➔</a:t>
+            </a:r>
+          </a:p>
+          <a:p>
+            <a:pPr algn="l"/>
+            <a:r>
+              <a:rPr sz="950">
+                <a:solidFill>
+                  <a:srgbClr val="64748B"/>
+                </a:solidFill>
+                <a:latin typeface="+mn-lt"/>
+                <a:cs typeface="+mn-lt"/>
+              </a:rPr>
+              <a:t>Empirical throughput &amp; bundle size matrix</a:t>
+            </a:r>
+          </a:p>
+        </p:txBody>
+      </p:sp>
+      <p:sp>
+        <p:nvSpPr>
+          <p:cNvPr id="11" name="roundRect 10"/>
           <p:cNvSpPr/>
           <p:nvPr/>
         </p:nvSpPr>
         <p:spPr>
           <a:xfrm>
             <a:off x="6217920" y="1828800"/>
-            <a:ext cx="5212080" cy="4480560"/>
+            <a:ext cx="5212080" cy="2377440"/>
           </a:xfrm>
           <a:prstGeom prst="roundRect">
             <a:avLst/>
@@ -4141,7 +4505,7 @@
       </p:sp>
       <p:sp>
         <p:nvSpPr>
-          <p:cNvPr id="8" name="Text Box 7"/>
+          <p:cNvPr id="12" name="Text Box 11"/>
           <p:cNvSpPr/>
           <p:nvPr/>
         </p:nvSpPr>
@@ -4167,6 +4531,643 @@
                 <a:latin typeface="+mn-lt"/>
                 <a:cs typeface="+mn-lt"/>
               </a:rPr>
+              <a:t>🔗 External Web &amp; Ecosystem Endpoints</a:t>
+            </a:r>
+          </a:p>
+        </p:txBody>
+      </p:sp>
+      <p:sp>
+        <p:nvSpPr>
+          <p:cNvPr id="13" name="Text Box 12"/>
+          <p:cNvSpPr/>
+          <p:nvPr/>
+        </p:nvSpPr>
+        <p:spPr>
+          <a:xfrm>
+            <a:off x="6400800" y="2377440"/>
+            <a:ext cx="4846320" cy="1645920"/>
+          </a:xfrm>
+          <a:prstGeom prst="rect">
+            <a:avLst/>
+          </a:prstGeom>
+        </p:spPr>
+        <p:txBody>
+          <a:bodyPr anchor="t"/>
+          <a:lstStyle/>
+          <a:p>
+            <a:pPr algn="l" lvl="0"/>
+            <a:r>
+              <a:rPr>
+                <a:latin typeface="+mn-lt"/>
+                <a:cs typeface="+mn-lt"/>
+              </a:rPr>
+              <a:t>• </a:t>
+            </a:r>
+            <a:r>
+              <a:rPr b="1" u="sng">
+                <a:solidFill>
+                  <a:srgbClr val="0284C7"/>
+                </a:solidFill>
+                <a:hlinkClick r:id="rId6" tooltip="View GitHub Repository &amp; Source Code"/>
+                <a:latin typeface="+mn-lt"/>
+                <a:cs typeface="+mn-lt"/>
+              </a:rPr>
+              <a:t>GitHub Repository (hokkyss/pptx-parser)</a:t>
+            </a:r>
+            <a:r>
+              <a:rPr>
+                <a:latin typeface="+mn-lt"/>
+                <a:cs typeface="+mn-lt"/>
+              </a:rPr>
+              <a:t> — Star &amp; contribute.</a:t>
+            </a:r>
+          </a:p>
+          <a:p>
+            <a:pPr algn="l" lvl="0"/>
+            <a:r>
+              <a:rPr>
+                <a:latin typeface="+mn-lt"/>
+                <a:cs typeface="+mn-lt"/>
+              </a:rPr>
+              <a:t>• </a:t>
+            </a:r>
+            <a:r>
+              <a:rPr b="1" u="sng">
+                <a:solidFill>
+                  <a:srgbClr val="6366F1"/>
+                </a:solidFill>
+                <a:hlinkClick r:id="rId7" tooltip="Inspect NPM Package Registry"/>
+                <a:latin typeface="+mn-lt"/>
+                <a:cs typeface="+mn-lt"/>
+              </a:rPr>
+              <a:t>NPM Package Registry (@hokkyss/pptx)</a:t>
+            </a:r>
+            <a:r>
+              <a:rPr>
+                <a:latin typeface="+mn-lt"/>
+                <a:cs typeface="+mn-lt"/>
+              </a:rPr>
+              <a:t> — Published release.</a:t>
+            </a:r>
+          </a:p>
+          <a:p>
+            <a:pPr algn="l" lvl="0"/>
+            <a:r>
+              <a:rPr>
+                <a:latin typeface="+mn-lt"/>
+                <a:cs typeface="+mn-lt"/>
+              </a:rPr>
+              <a:t>• </a:t>
+            </a:r>
+            <a:r>
+              <a:rPr b="1" u="sng">
+                <a:solidFill>
+                  <a:srgbClr val="10B981"/>
+                </a:solidFill>
+                <a:hlinkClick r:id="rId8" tooltip="Contact Developer Email"/>
+                <a:latin typeface="+mn-lt"/>
+                <a:cs typeface="+mn-lt"/>
+              </a:rPr>
+              <a:t>Direct Developer Contact (support@hokkyss.dev)</a:t>
+            </a:r>
+            <a:r>
+              <a:rPr>
+                <a:latin typeface="+mn-lt"/>
+                <a:cs typeface="+mn-lt"/>
+              </a:rPr>
+              <a:t> — Support.</a:t>
+            </a:r>
+          </a:p>
+        </p:txBody>
+      </p:sp>
+      <p:sp>
+        <p:nvSpPr>
+          <p:cNvPr id="14" name="roundRect 13"/>
+          <p:cNvSpPr/>
+          <p:nvPr/>
+        </p:nvSpPr>
+        <p:spPr>
+          <a:xfrm>
+            <a:off x="6217920" y="4389120"/>
+            <a:ext cx="5212080" cy="1920240"/>
+          </a:xfrm>
+          <a:prstGeom prst="roundRect">
+            <a:avLst/>
+          </a:prstGeom>
+          <a:solidFill>
+            <a:srgbClr val="FFFFFF"/>
+          </a:solidFill>
+          <a:ln w="13716">
+            <a:solidFill>
+              <a:srgbClr val="E2E8F0"/>
+            </a:solidFill>
+          </a:ln>
+          <a:effectLst>
+            <a:outerShdw blurRad="109728" dist="38100" dir="5400000">
+              <a:srgbClr val="0F172A">
+                <a:alpha val="8000"/>
+              </a:srgbClr>
+            </a:outerShdw>
+          </a:effectLst>
+        </p:spPr>
+        <p:txBody>
+          <a:bodyPr/>
+          <a:lstStyle/>
+          <a:p>
+            <a:endParaRPr/>
+          </a:p>
+        </p:txBody>
+      </p:sp>
+      <p:sp>
+        <p:nvSpPr>
+          <p:cNvPr id="15" name="Text Box 14"/>
+          <p:cNvSpPr/>
+          <p:nvPr/>
+        </p:nvSpPr>
+        <p:spPr>
+          <a:xfrm>
+            <a:off x="6400800" y="4572000"/>
+            <a:ext cx="4846320" cy="320040"/>
+          </a:xfrm>
+          <a:prstGeom prst="rect">
+            <a:avLst/>
+          </a:prstGeom>
+        </p:spPr>
+        <p:txBody>
+          <a:bodyPr anchor="t"/>
+          <a:lstStyle/>
+          <a:p>
+            <a:pPr algn="l"/>
+            <a:r>
+              <a:rPr b="1" sz="1300">
+                <a:solidFill>
+                  <a:srgbClr val="0F172A"/>
+                </a:solidFill>
+                <a:latin typeface="+mn-lt"/>
+                <a:cs typeface="+mn-lt"/>
+              </a:rPr>
+              <a:t>🎮 Native Slide Show Action Controls</a:t>
+            </a:r>
+          </a:p>
+        </p:txBody>
+      </p:sp>
+      <p:sp>
+        <p:nvSpPr>
+          <p:cNvPr id="16" name="Text Box 15"/>
+          <p:cNvSpPr/>
+          <p:nvPr/>
+        </p:nvSpPr>
+        <p:spPr>
+          <a:xfrm>
+            <a:off x="6400800" y="4892040"/>
+            <a:ext cx="4846320" cy="274320"/>
+          </a:xfrm>
+          <a:prstGeom prst="rect">
+            <a:avLst/>
+          </a:prstGeom>
+        </p:spPr>
+        <p:txBody>
+          <a:bodyPr anchor="t"/>
+          <a:lstStyle/>
+          <a:p>
+            <a:pPr algn="l"/>
+            <a:r>
+              <a:rPr sz="1000">
+                <a:solidFill>
+                  <a:srgbClr val="64748B"/>
+                </a:solidFill>
+                <a:latin typeface="+mn-lt"/>
+                <a:cs typeface="+mn-lt"/>
+              </a:rPr>
+              <a:t>OpenXML action jump commands executed directly inside PowerPoint Presentation Mode:</a:t>
+            </a:r>
+          </a:p>
+        </p:txBody>
+      </p:sp>
+      <p:sp>
+        <p:nvSpPr>
+          <p:cNvPr id="17" name="roundRect 16">
+            <a:hlinkClick tooltip="Jump to Slide 1" action="ppaction://hlinkshowjump?jump=firstslide"/>
+          </p:cNvPr>
+          <p:cNvSpPr/>
+          <p:nvPr/>
+        </p:nvSpPr>
+        <p:spPr>
+          <a:xfrm>
+            <a:off x="6400800" y="5440680"/>
+            <a:ext cx="1097280" cy="594360"/>
+          </a:xfrm>
+          <a:prstGeom prst="roundRect">
+            <a:avLst/>
+          </a:prstGeom>
+          <a:solidFill>
+            <a:srgbClr val="0F172A"/>
+          </a:solidFill>
+        </p:spPr>
+        <p:txBody>
+          <a:bodyPr anchor="t"/>
+          <a:lstStyle/>
+          <a:p>
+            <a:pPr algn="ctr"/>
+            <a:r>
+              <a:rPr b="1" sz="1050">
+                <a:solidFill>
+                  <a:srgbClr val="FFFFFF"/>
+                </a:solidFill>
+                <a:latin typeface="+mn-lt"/>
+                <a:cs typeface="+mn-lt"/>
+              </a:rPr>
+              <a:t>⏮ First</a:t>
+            </a:r>
+          </a:p>
+        </p:txBody>
+      </p:sp>
+      <p:sp>
+        <p:nvSpPr>
+          <p:cNvPr id="18" name="roundRect 17">
+            <a:hlinkClick tooltip="Jump to Slide 11" action="ppaction://hlinkshowjump?jump=previousslide"/>
+          </p:cNvPr>
+          <p:cNvSpPr/>
+          <p:nvPr/>
+        </p:nvSpPr>
+        <p:spPr>
+          <a:xfrm>
+            <a:off x="7635240" y="5440680"/>
+            <a:ext cx="1097280" cy="594360"/>
+          </a:xfrm>
+          <a:prstGeom prst="roundRect">
+            <a:avLst/>
+          </a:prstGeom>
+          <a:solidFill>
+            <a:srgbClr val="475569"/>
+          </a:solidFill>
+        </p:spPr>
+        <p:txBody>
+          <a:bodyPr anchor="t"/>
+          <a:lstStyle/>
+          <a:p>
+            <a:pPr algn="ctr"/>
+            <a:r>
+              <a:rPr b="1" sz="1050">
+                <a:solidFill>
+                  <a:srgbClr val="FFFFFF"/>
+                </a:solidFill>
+                <a:latin typeface="+mn-lt"/>
+                <a:cs typeface="+mn-lt"/>
+              </a:rPr>
+              <a:t>◀ Prev</a:t>
+            </a:r>
+          </a:p>
+        </p:txBody>
+      </p:sp>
+      <p:sp>
+        <p:nvSpPr>
+          <p:cNvPr id="19" name="roundRect 18">
+            <a:hlinkClick tooltip="Jump to Slide 13" action="ppaction://hlinkshowjump?jump=nextslide"/>
+          </p:cNvPr>
+          <p:cNvSpPr/>
+          <p:nvPr/>
+        </p:nvSpPr>
+        <p:spPr>
+          <a:xfrm>
+            <a:off x="8869680" y="5440680"/>
+            <a:ext cx="1097280" cy="594360"/>
+          </a:xfrm>
+          <a:prstGeom prst="roundRect">
+            <a:avLst/>
+          </a:prstGeom>
+          <a:solidFill>
+            <a:srgbClr val="0284C7"/>
+          </a:solidFill>
+        </p:spPr>
+        <p:txBody>
+          <a:bodyPr anchor="t"/>
+          <a:lstStyle/>
+          <a:p>
+            <a:pPr algn="ctr"/>
+            <a:r>
+              <a:rPr b="1" sz="1050">
+                <a:solidFill>
+                  <a:srgbClr val="FFFFFF"/>
+                </a:solidFill>
+                <a:latin typeface="+mn-lt"/>
+                <a:cs typeface="+mn-lt"/>
+              </a:rPr>
+              <a:t>Next ▶</a:t>
+            </a:r>
+          </a:p>
+        </p:txBody>
+      </p:sp>
+      <p:sp>
+        <p:nvSpPr>
+          <p:cNvPr id="20" name="roundRect 19">
+            <a:hlinkClick tooltip="End Slide Show" action="ppaction://hlinkshowjump?jump=endshow"/>
+          </p:cNvPr>
+          <p:cNvSpPr/>
+          <p:nvPr/>
+        </p:nvSpPr>
+        <p:spPr>
+          <a:xfrm>
+            <a:off x="10104120" y="5440680"/>
+            <a:ext cx="1097280" cy="594360"/>
+          </a:xfrm>
+          <a:prstGeom prst="roundRect">
+            <a:avLst/>
+          </a:prstGeom>
+          <a:solidFill>
+            <a:srgbClr val="EF4444"/>
+          </a:solidFill>
+        </p:spPr>
+        <p:txBody>
+          <a:bodyPr anchor="t"/>
+          <a:lstStyle/>
+          <a:p>
+            <a:pPr algn="ctr"/>
+            <a:r>
+              <a:rPr b="1" sz="1050">
+                <a:solidFill>
+                  <a:srgbClr val="FFFFFF"/>
+                </a:solidFill>
+                <a:latin typeface="+mn-lt"/>
+                <a:cs typeface="+mn-lt"/>
+              </a:rPr>
+              <a:t>⏹ End</a:t>
+            </a:r>
+          </a:p>
+        </p:txBody>
+      </p:sp>
+      <p:sp>
+        <p:nvSpPr>
+          <p:cNvPr id="21" name="Text Box 20"/>
+          <p:cNvSpPr/>
+          <p:nvPr/>
+        </p:nvSpPr>
+        <p:spPr>
+          <a:xfrm>
+            <a:off x="731520" y="6510528"/>
+            <a:ext cx="10725912" cy="228600"/>
+          </a:xfrm>
+          <a:prstGeom prst="rect">
+            <a:avLst/>
+          </a:prstGeom>
+        </p:spPr>
+        <p:txBody>
+          <a:bodyPr anchor="t"/>
+          <a:lstStyle/>
+          <a:p>
+            <a:pPr algn="ctr"/>
+            <a:r>
+              <a:rPr i="1" sz="800">
+                <a:solidFill>
+                  <a:srgbClr val="94A3B8"/>
+                </a:solidFill>
+                <a:latin typeface="+mn-lt"/>
+                <a:cs typeface="+mn-lt"/>
+              </a:rPr>
+              <a:t>* Disclaimer: All benchmark metrics, performance figures, and simulated architectures in this deck are synthetic demonstration values generated solely to showcase the authoring, formatting, and rendering capabilities of @hokkyss/pptx.</a:t>
+            </a:r>
+          </a:p>
+        </p:txBody>
+      </p:sp>
+    </p:spTree>
+  </p:cSld>
+  <p:clrMapOvr>
+    <a:masterClrMapping/>
+  </p:clrMapOvr>
+  <p:transition spd="fast">
+    <p:fade/>
+  </p:transition>
+</p:sld>
+</file>
+
+<file path=ppt/slides/slide13.xml><?xml version="1.0" encoding="utf-8"?>
+<p:sld xmlns:a="http://schemas.openxmlformats.org/drawingml/2006/main" xmlns:r="http://schemas.openxmlformats.org/officeDocument/2006/relationships" xmlns:p="http://schemas.openxmlformats.org/presentationml/2006/main">
+  <p:cSld>
+    <p:bg>
+      <p:bgPr>
+        <a:solidFill>
+          <a:srgbClr val="0F172A"/>
+        </a:solidFill>
+        <a:effectLst/>
+      </p:bgPr>
+    </p:bg>
+    <p:spTree>
+      <p:nvGrpSpPr>
+        <p:cNvPr id="1" name=""/>
+        <p:cNvGrpSpPr/>
+        <p:nvPr/>
+      </p:nvGrpSpPr>
+      <p:grpSpPr>
+        <a:xfrm>
+          <a:off x="0" y="0"/>
+          <a:ext cx="0" cy="0"/>
+          <a:chOff x="0" y="0"/>
+          <a:chExt cx="0" cy="0"/>
+        </a:xfrm>
+      </p:grpSpPr>
+      <p:sp>
+        <p:nvSpPr>
+          <p:cNvPr id="2" name="Text Box 1"/>
+          <p:cNvSpPr/>
+          <p:nvPr/>
+        </p:nvSpPr>
+        <p:spPr>
+          <a:xfrm>
+            <a:off x="731520" y="731520"/>
+            <a:ext cx="10725912" cy="548640"/>
+          </a:xfrm>
+          <a:prstGeom prst="rect">
+            <a:avLst/>
+          </a:prstGeom>
+        </p:spPr>
+        <p:txBody>
+          <a:bodyPr anchor="t"/>
+          <a:lstStyle/>
+          <a:p>
+            <a:pPr algn="l"/>
+            <a:r>
+              <a:rPr b="1" sz="2400">
+                <a:solidFill>
+                  <a:srgbClr val="FFFFFF"/>
+                </a:solidFill>
+                <a:latin typeface="+mj-lt"/>
+                <a:cs typeface="+mj-lt"/>
+              </a:rPr>
+              <a:t>Engine Performance &amp; Bundle Size Matrix</a:t>
+            </a:r>
+          </a:p>
+        </p:txBody>
+      </p:sp>
+      <p:sp>
+        <p:nvSpPr>
+          <p:cNvPr id="3" name="Text Box 2"/>
+          <p:cNvSpPr/>
+          <p:nvPr/>
+        </p:nvSpPr>
+        <p:spPr>
+          <a:xfrm>
+            <a:off x="731520" y="1280160"/>
+            <a:ext cx="10725912" cy="365760"/>
+          </a:xfrm>
+          <a:prstGeom prst="rect">
+            <a:avLst/>
+          </a:prstGeom>
+        </p:spPr>
+        <p:txBody>
+          <a:bodyPr anchor="t"/>
+          <a:lstStyle/>
+          <a:p>
+            <a:pPr algn="l"/>
+            <a:r>
+              <a:rPr sz="1400">
+                <a:solidFill>
+                  <a:srgbClr val="94A3B8"/>
+                </a:solidFill>
+                <a:latin typeface="+mn-lt"/>
+                <a:cs typeface="+mn-lt"/>
+              </a:rPr>
+              <a:t>Empirical microsecond throughput benchmarks and ultra-lean tree-shakeable bundle budgets</a:t>
+            </a:r>
+          </a:p>
+        </p:txBody>
+      </p:sp>
+      <p:sp>
+        <p:nvSpPr>
+          <p:cNvPr id="4" name="roundRect 3"/>
+          <p:cNvSpPr/>
+          <p:nvPr/>
+        </p:nvSpPr>
+        <p:spPr>
+          <a:xfrm>
+            <a:off x="731520" y="1828800"/>
+            <a:ext cx="5212080" cy="4480560"/>
+          </a:xfrm>
+          <a:prstGeom prst="roundRect">
+            <a:avLst/>
+          </a:prstGeom>
+          <a:solidFill>
+            <a:srgbClr val="1E293B"/>
+          </a:solidFill>
+          <a:ln w="13716">
+            <a:solidFill>
+              <a:srgbClr val="334155"/>
+            </a:solidFill>
+          </a:ln>
+          <a:effectLst>
+            <a:outerShdw blurRad="109728" dist="38100" dir="5400000">
+              <a:srgbClr val="000000">
+                <a:alpha val="30000"/>
+              </a:srgbClr>
+            </a:outerShdw>
+          </a:effectLst>
+        </p:spPr>
+        <p:txBody>
+          <a:bodyPr/>
+          <a:lstStyle/>
+          <a:p>
+            <a:endParaRPr/>
+          </a:p>
+        </p:txBody>
+      </p:sp>
+      <p:sp>
+        <p:nvSpPr>
+          <p:cNvPr id="5" name="Text Box 4"/>
+          <p:cNvSpPr/>
+          <p:nvPr/>
+        </p:nvSpPr>
+        <p:spPr>
+          <a:xfrm>
+            <a:off x="914400" y="2011680"/>
+            <a:ext cx="4846320" cy="320040"/>
+          </a:xfrm>
+          <a:prstGeom prst="rect">
+            <a:avLst/>
+          </a:prstGeom>
+        </p:spPr>
+        <p:txBody>
+          <a:bodyPr anchor="t"/>
+          <a:lstStyle/>
+          <a:p>
+            <a:pPr algn="l"/>
+            <a:r>
+              <a:rPr b="1" sz="1300">
+                <a:solidFill>
+                  <a:srgbClr val="FFFFFF"/>
+                </a:solidFill>
+                <a:latin typeface="+mn-lt"/>
+                <a:cs typeface="+mn-lt"/>
+              </a:rPr>
+              <a:t>⚡ Throughput &amp; Latency Benchmarks (Vitest)</a:t>
+            </a:r>
+          </a:p>
+        </p:txBody>
+      </p:sp>
+      <p:sp>
+        <p:nvSpPr>
+          <p:cNvPr id="7" name="roundRect 6"/>
+          <p:cNvSpPr/>
+          <p:nvPr/>
+        </p:nvSpPr>
+        <p:spPr>
+          <a:xfrm>
+            <a:off x="6217920" y="1828800"/>
+            <a:ext cx="5212080" cy="4480560"/>
+          </a:xfrm>
+          <a:prstGeom prst="roundRect">
+            <a:avLst/>
+          </a:prstGeom>
+          <a:solidFill>
+            <a:srgbClr val="1E293B"/>
+          </a:solidFill>
+          <a:ln w="13716">
+            <a:solidFill>
+              <a:srgbClr val="334155"/>
+            </a:solidFill>
+          </a:ln>
+          <a:effectLst>
+            <a:outerShdw blurRad="109728" dist="38100" dir="5400000">
+              <a:srgbClr val="000000">
+                <a:alpha val="30000"/>
+              </a:srgbClr>
+            </a:outerShdw>
+          </a:effectLst>
+        </p:spPr>
+        <p:txBody>
+          <a:bodyPr/>
+          <a:lstStyle/>
+          <a:p>
+            <a:endParaRPr/>
+          </a:p>
+        </p:txBody>
+      </p:sp>
+      <p:sp>
+        <p:nvSpPr>
+          <p:cNvPr id="8" name="Text Box 7"/>
+          <p:cNvSpPr/>
+          <p:nvPr/>
+        </p:nvSpPr>
+        <p:spPr>
+          <a:xfrm>
+            <a:off x="6400800" y="2011680"/>
+            <a:ext cx="4846320" cy="320040"/>
+          </a:xfrm>
+          <a:prstGeom prst="rect">
+            <a:avLst/>
+          </a:prstGeom>
+        </p:spPr>
+        <p:txBody>
+          <a:bodyPr anchor="t"/>
+          <a:lstStyle/>
+          <a:p>
+            <a:pPr algn="l"/>
+            <a:r>
+              <a:rPr b="1" sz="1300">
+                <a:solidFill>
+                  <a:srgbClr val="FFFFFF"/>
+                </a:solidFill>
+                <a:latin typeface="+mn-lt"/>
+                <a:cs typeface="+mn-lt"/>
+              </a:rPr>
               <a:t>📦 Monorepo Gzip &amp; Brotli Footprint (Bundlephobia-Aligned)</a:t>
             </a:r>
           </a:p>
@@ -4175,15 +5176,15 @@
       <p:sp>
         <p:nvSpPr>
           <p:cNvPr id="10" name="roundRect 9">
-            <a:hlinkClick tooltip="Return to Title (Slide 1)" action="ppaction://hlinkshowjump?jump=firstslide"/>
+            <a:hlinkClick r:id="rId3" tooltip="Return to Hyperlinks Hub (Slide 12)" action="ppaction://hlinksldjump"/>
           </p:cNvPr>
           <p:cNvSpPr/>
           <p:nvPr/>
         </p:nvSpPr>
         <p:spPr>
           <a:xfrm>
-            <a:off x="9235440" y="731520"/>
-            <a:ext cx="2011680" cy="411480"/>
+            <a:off x="9144000" y="731520"/>
+            <a:ext cx="2194560" cy="411480"/>
           </a:xfrm>
           <a:prstGeom prst="roundRect">
             <a:avLst/>
@@ -4217,7 +5218,7 @@
                 <a:latin typeface="+mn-lt"/>
                 <a:cs typeface="+mn-lt"/>
               </a:rPr>
-              <a:t>⬅ Return to Title</a:t>
+              <a:t>⬅ Back to Nav Hub</a:t>
             </a:r>
           </a:p>
         </p:txBody>
@@ -4245,7 +5246,7 @@
             <a:r>
               <a:rPr i="1" sz="800">
                 <a:solidFill>
-                  <a:srgbClr val="94A3B8"/>
+                  <a:srgbClr val="64748B"/>
                 </a:solidFill>
                 <a:latin typeface="+mn-lt"/>
                 <a:cs typeface="+mn-lt"/>
@@ -4298,7 +5299,7 @@
                   </a:txBody>
                   <a:tcPr>
                     <a:solidFill>
-                      <a:srgbClr val="0F172A"/>
+                      <a:srgbClr val="0284C7"/>
                     </a:solidFill>
                   </a:tcPr>
                 </a:tc>
@@ -4322,7 +5323,7 @@
                   </a:txBody>
                   <a:tcPr>
                     <a:solidFill>
-                      <a:srgbClr val="0F172A"/>
+                      <a:srgbClr val="0284C7"/>
                     </a:solidFill>
                   </a:tcPr>
                 </a:tc>
@@ -4346,7 +5347,7 @@
                   </a:txBody>
                   <a:tcPr>
                     <a:solidFill>
-                      <a:srgbClr val="0F172A"/>
+                      <a:srgbClr val="0284C7"/>
                     </a:solidFill>
                   </a:tcPr>
                 </a:tc>
@@ -4370,7 +5371,7 @@
                   </a:txBody>
                   <a:tcPr>
                     <a:solidFill>
-                      <a:srgbClr val="0F172A"/>
+                      <a:srgbClr val="0284C7"/>
                     </a:solidFill>
                   </a:tcPr>
                 </a:tc>
@@ -4385,7 +5386,7 @@
                       <a:r>
                         <a:rPr b="1" sz="950">
                           <a:solidFill>
-                            <a:srgbClr val="0F172A"/>
+                            <a:srgbClr val="FFFFFF"/>
                           </a:solidFill>
                           <a:latin typeface="+mn-lt"/>
                           <a:cs typeface="+mn-lt"/>
@@ -4396,7 +5397,7 @@
                   </a:txBody>
                   <a:tcPr>
                     <a:solidFill>
-                      <a:srgbClr val="F8FAFC"/>
+                      <a:srgbClr val="1E293B"/>
                     </a:solidFill>
                   </a:tcPr>
                 </a:tc>
@@ -4409,7 +5410,7 @@
                       <a:r>
                         <a:rPr b="1" sz="950">
                           <a:solidFill>
-                            <a:srgbClr val="0284C7"/>
+                            <a:srgbClr val="38BDF8"/>
                           </a:solidFill>
                           <a:latin typeface="+mn-lt"/>
                           <a:cs typeface="+mn-lt"/>
@@ -4420,7 +5421,7 @@
                   </a:txBody>
                   <a:tcPr>
                     <a:solidFill>
-                      <a:srgbClr val="F8FAFC"/>
+                      <a:srgbClr val="1E293B"/>
                     </a:solidFill>
                   </a:tcPr>
                 </a:tc>
@@ -4444,7 +5445,7 @@
                   </a:txBody>
                   <a:tcPr>
                     <a:solidFill>
-                      <a:srgbClr val="F8FAFC"/>
+                      <a:srgbClr val="1E293B"/>
                     </a:solidFill>
                   </a:tcPr>
                 </a:tc>
@@ -4457,7 +5458,7 @@
                       <a:r>
                         <a:rPr b="1" sz="900">
                           <a:solidFill>
-                            <a:srgbClr val="64748B"/>
+                            <a:srgbClr val="94A3B8"/>
                           </a:solidFill>
                           <a:latin typeface="+mn-lt"/>
                           <a:cs typeface="+mn-lt"/>
@@ -4468,7 +5469,7 @@
                   </a:txBody>
                   <a:tcPr>
                     <a:solidFill>
-                      <a:srgbClr val="F8FAFC"/>
+                      <a:srgbClr val="1E293B"/>
                     </a:solidFill>
                   </a:tcPr>
                 </a:tc>
@@ -4483,7 +5484,7 @@
                       <a:r>
                         <a:rPr b="1" sz="950">
                           <a:solidFill>
-                            <a:srgbClr val="0F172A"/>
+                            <a:srgbClr val="FFFFFF"/>
                           </a:solidFill>
                           <a:latin typeface="+mn-lt"/>
                           <a:cs typeface="+mn-lt"/>
@@ -4494,7 +5495,7 @@
                   </a:txBody>
                   <a:tcPr>
                     <a:solidFill>
-                      <a:srgbClr val="FFFFFF"/>
+                      <a:srgbClr val="0F172A"/>
                     </a:solidFill>
                   </a:tcPr>
                 </a:tc>
@@ -4507,7 +5508,7 @@
                       <a:r>
                         <a:rPr b="1" sz="950">
                           <a:solidFill>
-                            <a:srgbClr val="0284C7"/>
+                            <a:srgbClr val="38BDF8"/>
                           </a:solidFill>
                           <a:latin typeface="+mn-lt"/>
                           <a:cs typeface="+mn-lt"/>
@@ -4518,7 +5519,7 @@
                   </a:txBody>
                   <a:tcPr>
                     <a:solidFill>
-                      <a:srgbClr val="FFFFFF"/>
+                      <a:srgbClr val="0F172A"/>
                     </a:solidFill>
                   </a:tcPr>
                 </a:tc>
@@ -4542,7 +5543,7 @@
                   </a:txBody>
                   <a:tcPr>
                     <a:solidFill>
-                      <a:srgbClr val="FFFFFF"/>
+                      <a:srgbClr val="0F172A"/>
                     </a:solidFill>
                   </a:tcPr>
                 </a:tc>
@@ -4555,7 +5556,7 @@
                       <a:r>
                         <a:rPr b="1" sz="900">
                           <a:solidFill>
-                            <a:srgbClr val="64748B"/>
+                            <a:srgbClr val="94A3B8"/>
                           </a:solidFill>
                           <a:latin typeface="+mn-lt"/>
                           <a:cs typeface="+mn-lt"/>
@@ -4566,7 +5567,7 @@
                   </a:txBody>
                   <a:tcPr>
                     <a:solidFill>
-                      <a:srgbClr val="FFFFFF"/>
+                      <a:srgbClr val="0F172A"/>
                     </a:solidFill>
                   </a:tcPr>
                 </a:tc>
@@ -4581,7 +5582,7 @@
                       <a:r>
                         <a:rPr b="1" sz="950">
                           <a:solidFill>
-                            <a:srgbClr val="0F172A"/>
+                            <a:srgbClr val="FFFFFF"/>
                           </a:solidFill>
                           <a:latin typeface="+mn-lt"/>
                           <a:cs typeface="+mn-lt"/>
@@ -4592,7 +5593,7 @@
                   </a:txBody>
                   <a:tcPr>
                     <a:solidFill>
-                      <a:srgbClr val="F8FAFC"/>
+                      <a:srgbClr val="1E293B"/>
                     </a:solidFill>
                   </a:tcPr>
                 </a:tc>
@@ -4605,7 +5606,7 @@
                       <a:r>
                         <a:rPr b="1" sz="950">
                           <a:solidFill>
-                            <a:srgbClr val="0284C7"/>
+                            <a:srgbClr val="38BDF8"/>
                           </a:solidFill>
                           <a:latin typeface="+mn-lt"/>
                           <a:cs typeface="+mn-lt"/>
@@ -4616,7 +5617,7 @@
                   </a:txBody>
                   <a:tcPr>
                     <a:solidFill>
-                      <a:srgbClr val="F8FAFC"/>
+                      <a:srgbClr val="1E293B"/>
                     </a:solidFill>
                   </a:tcPr>
                 </a:tc>
@@ -4640,7 +5641,7 @@
                   </a:txBody>
                   <a:tcPr>
                     <a:solidFill>
-                      <a:srgbClr val="F8FAFC"/>
+                      <a:srgbClr val="1E293B"/>
                     </a:solidFill>
                   </a:tcPr>
                 </a:tc>
@@ -4653,7 +5654,7 @@
                       <a:r>
                         <a:rPr b="1" sz="900">
                           <a:solidFill>
-                            <a:srgbClr val="64748B"/>
+                            <a:srgbClr val="94A3B8"/>
                           </a:solidFill>
                           <a:latin typeface="+mn-lt"/>
                           <a:cs typeface="+mn-lt"/>
@@ -4664,7 +5665,7 @@
                   </a:txBody>
                   <a:tcPr>
                     <a:solidFill>
-                      <a:srgbClr val="F8FAFC"/>
+                      <a:srgbClr val="1E293B"/>
                     </a:solidFill>
                   </a:tcPr>
                 </a:tc>
@@ -4679,7 +5680,7 @@
                       <a:r>
                         <a:rPr b="1" sz="950">
                           <a:solidFill>
-                            <a:srgbClr val="0F172A"/>
+                            <a:srgbClr val="FFFFFF"/>
                           </a:solidFill>
                           <a:latin typeface="+mn-lt"/>
                           <a:cs typeface="+mn-lt"/>
@@ -4690,7 +5691,7 @@
                   </a:txBody>
                   <a:tcPr>
                     <a:solidFill>
-                      <a:srgbClr val="FFFFFF"/>
+                      <a:srgbClr val="0F172A"/>
                     </a:solidFill>
                   </a:tcPr>
                 </a:tc>
@@ -4703,7 +5704,7 @@
                       <a:r>
                         <a:rPr b="1" sz="950">
                           <a:solidFill>
-                            <a:srgbClr val="0284C7"/>
+                            <a:srgbClr val="38BDF8"/>
                           </a:solidFill>
                           <a:latin typeface="+mn-lt"/>
                           <a:cs typeface="+mn-lt"/>
@@ -4714,7 +5715,7 @@
                   </a:txBody>
                   <a:tcPr>
                     <a:solidFill>
-                      <a:srgbClr val="FFFFFF"/>
+                      <a:srgbClr val="0F172A"/>
                     </a:solidFill>
                   </a:tcPr>
                 </a:tc>
@@ -4738,7 +5739,7 @@
                   </a:txBody>
                   <a:tcPr>
                     <a:solidFill>
-                      <a:srgbClr val="FFFFFF"/>
+                      <a:srgbClr val="0F172A"/>
                     </a:solidFill>
                   </a:tcPr>
                 </a:tc>
@@ -4751,7 +5752,7 @@
                       <a:r>
                         <a:rPr b="1" sz="900">
                           <a:solidFill>
-                            <a:srgbClr val="64748B"/>
+                            <a:srgbClr val="94A3B8"/>
                           </a:solidFill>
                           <a:latin typeface="+mn-lt"/>
                           <a:cs typeface="+mn-lt"/>
@@ -4762,7 +5763,7 @@
                   </a:txBody>
                   <a:tcPr>
                     <a:solidFill>
-                      <a:srgbClr val="FFFFFF"/>
+                      <a:srgbClr val="0F172A"/>
                     </a:solidFill>
                   </a:tcPr>
                 </a:tc>
@@ -4777,7 +5778,7 @@
                       <a:r>
                         <a:rPr b="1" sz="950">
                           <a:solidFill>
-                            <a:srgbClr val="0F172A"/>
+                            <a:srgbClr val="FFFFFF"/>
                           </a:solidFill>
                           <a:latin typeface="+mn-lt"/>
                           <a:cs typeface="+mn-lt"/>
@@ -4788,7 +5789,7 @@
                   </a:txBody>
                   <a:tcPr>
                     <a:solidFill>
-                      <a:srgbClr val="F8FAFC"/>
+                      <a:srgbClr val="1E293B"/>
                     </a:solidFill>
                   </a:tcPr>
                 </a:tc>
@@ -4801,7 +5802,7 @@
                       <a:r>
                         <a:rPr b="1" sz="950">
                           <a:solidFill>
-                            <a:srgbClr val="0284C7"/>
+                            <a:srgbClr val="38BDF8"/>
                           </a:solidFill>
                           <a:latin typeface="+mn-lt"/>
                           <a:cs typeface="+mn-lt"/>
@@ -4812,7 +5813,7 @@
                   </a:txBody>
                   <a:tcPr>
                     <a:solidFill>
-                      <a:srgbClr val="F8FAFC"/>
+                      <a:srgbClr val="1E293B"/>
                     </a:solidFill>
                   </a:tcPr>
                 </a:tc>
@@ -4836,7 +5837,7 @@
                   </a:txBody>
                   <a:tcPr>
                     <a:solidFill>
-                      <a:srgbClr val="F8FAFC"/>
+                      <a:srgbClr val="1E293B"/>
                     </a:solidFill>
                   </a:tcPr>
                 </a:tc>
@@ -4849,7 +5850,7 @@
                       <a:r>
                         <a:rPr b="1" sz="900">
                           <a:solidFill>
-                            <a:srgbClr val="64748B"/>
+                            <a:srgbClr val="94A3B8"/>
                           </a:solidFill>
                           <a:latin typeface="+mn-lt"/>
                           <a:cs typeface="+mn-lt"/>
@@ -4860,7 +5861,7 @@
                   </a:txBody>
                   <a:tcPr>
                     <a:solidFill>
-                      <a:srgbClr val="F8FAFC"/>
+                      <a:srgbClr val="1E293B"/>
                     </a:solidFill>
                   </a:tcPr>
                 </a:tc>
@@ -4875,7 +5876,7 @@
                       <a:r>
                         <a:rPr b="1" sz="950">
                           <a:solidFill>
-                            <a:srgbClr val="0F172A"/>
+                            <a:srgbClr val="FFFFFF"/>
                           </a:solidFill>
                           <a:latin typeface="+mn-lt"/>
                           <a:cs typeface="+mn-lt"/>
@@ -4886,7 +5887,7 @@
                   </a:txBody>
                   <a:tcPr>
                     <a:solidFill>
-                      <a:srgbClr val="FFFFFF"/>
+                      <a:srgbClr val="0F172A"/>
                     </a:solidFill>
                   </a:tcPr>
                 </a:tc>
@@ -4899,7 +5900,7 @@
                       <a:r>
                         <a:rPr b="1" sz="950">
                           <a:solidFill>
-                            <a:srgbClr val="0284C7"/>
+                            <a:srgbClr val="38BDF8"/>
                           </a:solidFill>
                           <a:latin typeface="+mn-lt"/>
                           <a:cs typeface="+mn-lt"/>
@@ -4910,7 +5911,7 @@
                   </a:txBody>
                   <a:tcPr>
                     <a:solidFill>
-                      <a:srgbClr val="FFFFFF"/>
+                      <a:srgbClr val="0F172A"/>
                     </a:solidFill>
                   </a:tcPr>
                 </a:tc>
@@ -4934,7 +5935,7 @@
                   </a:txBody>
                   <a:tcPr>
                     <a:solidFill>
-                      <a:srgbClr val="FFFFFF"/>
+                      <a:srgbClr val="0F172A"/>
                     </a:solidFill>
                   </a:tcPr>
                 </a:tc>
@@ -4947,7 +5948,7 @@
                       <a:r>
                         <a:rPr b="1" sz="900">
                           <a:solidFill>
-                            <a:srgbClr val="64748B"/>
+                            <a:srgbClr val="94A3B8"/>
                           </a:solidFill>
                           <a:latin typeface="+mn-lt"/>
                           <a:cs typeface="+mn-lt"/>
@@ -4958,7 +5959,7 @@
                   </a:txBody>
                   <a:tcPr>
                     <a:solidFill>
-                      <a:srgbClr val="FFFFFF"/>
+                      <a:srgbClr val="0F172A"/>
                     </a:solidFill>
                   </a:tcPr>
                 </a:tc>

</xml_diff>

<commit_message>
fix(showcase): replace direct contact email with GitHub community issue tracker link
</commit_message>
<xml_diff>
--- a/hokkyss_showcase_deck.pptx
+++ b/hokkyss_showcase_deck.pptx
@@ -2628,7 +2628,7 @@
                 <a:latin typeface="+mn-lt"/>
                 <a:cs typeface="+mn-lt"/>
               </a:rPr>
-              <a:t>Full support for external web links, mailto targets, and hover tooltips.</a:t>
+              <a:t>Full support for external web links, custom URLs, and hover tooltips.</a:t>
             </a:r>
           </a:p>
           <a:p>
@@ -4624,18 +4624,18 @@
                 <a:solidFill>
                   <a:srgbClr val="10B981"/>
                 </a:solidFill>
-                <a:hlinkClick r:id="rId8" tooltip="Contact Developer Email"/>
-                <a:latin typeface="+mn-lt"/>
-                <a:cs typeface="+mn-lt"/>
-              </a:rPr>
-              <a:t>Direct Developer Contact (support@hokkyss.dev)</a:t>
+                <a:hlinkClick r:id="rId8" tooltip="View Issue Tracker &amp; Discussions"/>
+                <a:latin typeface="+mn-lt"/>
+                <a:cs typeface="+mn-lt"/>
+              </a:rPr>
+              <a:t>GitHub Issue Tracker &amp; Community</a:t>
             </a:r>
             <a:r>
               <a:rPr>
                 <a:latin typeface="+mn-lt"/>
                 <a:cs typeface="+mn-lt"/>
               </a:rPr>
-              <a:t> — Support.</a:t>
+              <a:t> — Discussions &amp; issues.</a:t>
             </a:r>
           </a:p>
         </p:txBody>

</xml_diff>

<commit_message>
feat(sdk): add native OpenXML DrawingML gradient engine (linear, radial, multi-stop, alpha, background)
</commit_message>
<xml_diff>
--- a/hokkyss_showcase_deck.pptx
+++ b/hokkyss_showcase_deck.pptx
@@ -5,7 +5,7 @@
     <p:sldMasterId id="2147483648" r:id="rId1"/>
   </p:sldMasterIdLst>
   <p:notesMasterIdLst>
-    <p:notesMasterId r:id="rId15"/>
+    <p:notesMasterId r:id="rId16"/>
   </p:notesMasterIdLst>
   <p:sldIdLst>
     <p:sldId id="256" r:id="rId2"/>
@@ -21,6 +21,7 @@
     <p:sldId id="266" r:id="rId12"/>
     <p:sldId id="267" r:id="rId13"/>
     <p:sldId id="268" r:id="rId14"/>
+    <p:sldId id="269" r:id="rId15"/>
   </p:sldIdLst>
   <p:sldSz cx="12192000" cy="6858000"/>
   <p:notesSz cx="6858000" cy="9144000"/>
@@ -1918,6 +1919,112 @@
 </p:notes>
 </file>
 
+<file path=ppt/notesSlides/notesSlide10.xml><?xml version="1.0" encoding="utf-8"?>
+<p:notes xmlns:a="http://schemas.openxmlformats.org/drawingml/2006/main" xmlns:r="http://schemas.openxmlformats.org/officeDocument/2006/relationships" xmlns:p="http://schemas.openxmlformats.org/presentationml/2006/main">
+  <p:cSld>
+    <p:spTree>
+      <p:nvGrpSpPr>
+        <p:cNvPr id="1" name=""/>
+        <p:cNvGrpSpPr/>
+        <p:nvPr/>
+      </p:nvGrpSpPr>
+      <p:grpSpPr>
+        <a:xfrm>
+          <a:off x="0" y="0"/>
+          <a:ext cx="0" cy="0"/>
+          <a:chOff x="0" y="0"/>
+          <a:chExt cx="0" cy="0"/>
+        </a:xfrm>
+      </p:grpSpPr>
+      <p:sp>
+        <p:nvSpPr>
+          <p:cNvPr id="2" name="Slide Image Placeholder 1"/>
+          <p:cNvSpPr>
+            <a:spLocks noGrp="1" noRot="1" noChangeAspect="1"/>
+          </p:cNvSpPr>
+          <p:nvPr>
+            <p:ph type="sldImg"/>
+          </p:nvPr>
+        </p:nvSpPr>
+        <p:spPr/>
+      </p:sp>
+      <p:sp>
+        <p:nvSpPr>
+          <p:cNvPr id="3" name="Notes Placeholder 2"/>
+          <p:cNvSpPr>
+            <a:spLocks noGrp="1"/>
+          </p:cNvSpPr>
+          <p:nvPr>
+            <p:ph type="body" idx="1"/>
+          </p:nvPr>
+        </p:nvSpPr>
+        <p:spPr/>
+        <p:txBody>
+          <a:bodyPr anchor="t"/>
+          <a:lstStyle/>
+          <a:p>
+            <a:pPr algn="l" lvl="0"/>
+            <a:r>
+              <a:rPr b="1">
+                <a:latin typeface="+mn-lt"/>
+                <a:cs typeface="+mn-lt"/>
+              </a:rPr>
+              <a:t>Empirical Benchmark Keynote: </a:t>
+            </a:r>
+            <a:r>
+              <a:rPr u="sng">
+                <a:latin typeface="+mn-lt"/>
+                <a:cs typeface="+mn-lt"/>
+              </a:rPr>
+              <a:t>Sub-Millisecond Speed &amp; Zero Native Dependencies</a:t>
+            </a:r>
+          </a:p>
+          <a:p>
+            <a:pPr algn="l" lvl="0" marL="152400" indent="-152400">
+              <a:buChar char="•"/>
+            </a:pPr>
+            <a:r>
+              <a:rPr>
+                <a:latin typeface="+mn-lt"/>
+                <a:cs typeface="+mn-lt"/>
+              </a:rPr>
+              <a:t>Single slide emits in ~0.55ms (&gt; 1,800 ops/sec).</a:t>
+            </a:r>
+          </a:p>
+          <a:p>
+            <a:pPr algn="l" lvl="0" marL="152400" indent="-152400">
+              <a:buChar char="•"/>
+            </a:pPr>
+            <a:r>
+              <a:rPr>
+                <a:latin typeface="+mn-lt"/>
+                <a:cs typeface="+mn-lt"/>
+              </a:rPr>
+              <a:t>Shape serialization exceeds 5 Million ops/sec.</a:t>
+            </a:r>
+          </a:p>
+          <a:p>
+            <a:pPr algn="l" lvl="0" marL="152400" indent="-152400">
+              <a:buChar char="•"/>
+            </a:pPr>
+            <a:r>
+              <a:rPr>
+                <a:latin typeface="+mn-lt"/>
+                <a:cs typeface="+mn-lt"/>
+              </a:rPr>
+              <a:t>Total bundle size under 49 KB gzipped with full PresentationML &amp; DrawingML engines.</a:t>
+            </a:r>
+          </a:p>
+        </p:txBody>
+      </p:sp>
+    </p:spTree>
+  </p:cSld>
+  <p:clrMapOvr>
+    <a:masterClrMapping/>
+  </p:clrMapOvr>
+</p:notes>
+</file>
+
 <file path=ppt/notesSlides/notesSlide2.xml><?xml version="1.0" encoding="utf-8"?>
 <p:notes xmlns:a="http://schemas.openxmlformats.org/drawingml/2006/main" xmlns:r="http://schemas.openxmlformats.org/officeDocument/2006/relationships" xmlns:p="http://schemas.openxmlformats.org/presentationml/2006/main">
   <p:cSld>
@@ -2715,14 +2822,14 @@
                 <a:latin typeface="+mn-lt"/>
                 <a:cs typeface="+mn-lt"/>
               </a:rPr>
-              <a:t>Empirical Benchmark Keynote: </a:t>
+              <a:t>DrawingML Gradient Engine Keynote: </a:t>
             </a:r>
             <a:r>
               <a:rPr u="sng">
                 <a:latin typeface="+mn-lt"/>
                 <a:cs typeface="+mn-lt"/>
               </a:rPr>
-              <a:t>Sub-Millisecond Speed &amp; Zero Native Dependencies</a:t>
+              <a:t>Full Vector Fidelity &amp; Transparency</a:t>
             </a:r>
           </a:p>
           <a:p>
@@ -2734,7 +2841,7 @@
                 <a:latin typeface="+mn-lt"/>
                 <a:cs typeface="+mn-lt"/>
               </a:rPr>
-              <a:t>Single slide emits in ~0.55ms (&gt; 1,800 ops/sec).</a:t>
+              <a:t>Native &lt;a:gradFill&gt; support with linear, radial, and path gradients.</a:t>
             </a:r>
           </a:p>
           <a:p>
@@ -2746,7 +2853,7 @@
                 <a:latin typeface="+mn-lt"/>
                 <a:cs typeface="+mn-lt"/>
               </a:rPr>
-              <a:t>Shape serialization exceeds 5 Million ops/sec.</a:t>
+              <a:t>Full alpha transparency channel support across all color stops.</a:t>
             </a:r>
           </a:p>
           <a:p>
@@ -2758,7 +2865,7 @@
                 <a:latin typeface="+mn-lt"/>
                 <a:cs typeface="+mn-lt"/>
               </a:rPr>
-              <a:t>Total bundle size under 49 KB gzipped with full PresentationML &amp; DrawingML engines.</a:t>
+              <a:t>Seamless integration with shapes, cards, outlines, and slide backgrounds.</a:t>
             </a:r>
           </a:p>
         </p:txBody>
@@ -4258,11 +4365,11 @@
             <a:avLst/>
           </a:prstGeom>
           <a:solidFill>
-            <a:srgbClr val="F0F9FF"/>
+            <a:srgbClr val="EFF6FF"/>
           </a:solidFill>
           <a:ln w="13716">
             <a:solidFill>
-              <a:srgbClr val="0284C7"/>
+              <a:srgbClr val="3B82F6"/>
             </a:solidFill>
           </a:ln>
         </p:spPr>
@@ -4274,7 +4381,7 @@
             <a:r>
               <a:rPr b="1" sz="1100">
                 <a:solidFill>
-                  <a:srgbClr val="0369A1"/>
+                  <a:srgbClr val="1D4ED8"/>
                 </a:solidFill>
                 <a:latin typeface="+mn-lt"/>
                 <a:cs typeface="+mn-lt"/>
@@ -4292,7 +4399,7 @@
                 <a:latin typeface="+mn-lt"/>
                 <a:cs typeface="+mn-lt"/>
               </a:rPr>
-              <a:t>Four decoupled packages &amp; DrawingML presets</a:t>
+              <a:t>3-tier modular schemas &amp; strict units</a:t>
             </a:r>
           </a:p>
         </p:txBody>
@@ -4300,7 +4407,7 @@
       <p:sp>
         <p:nvSpPr>
           <p:cNvPr id="8" name="roundRect 7">
-            <a:hlinkClick r:id="rId3" tooltip="Jump directly to Slide 3" action="ppaction://hlinksldjump"/>
+            <a:hlinkClick r:id="rId3" tooltip="Jump directly to Slide 9" action="ppaction://hlinksldjump"/>
           </p:cNvPr>
           <p:cNvSpPr/>
           <p:nvPr/>
@@ -4308,62 +4415,6 @@
         <p:spPr>
           <a:xfrm>
             <a:off x="914400" y="3566160"/>
-            <a:ext cx="4846320" cy="749808"/>
-          </a:xfrm>
-          <a:prstGeom prst="roundRect">
-            <a:avLst/>
-          </a:prstGeom>
-          <a:solidFill>
-            <a:srgbClr val="EEF2FF"/>
-          </a:solidFill>
-          <a:ln w="13716">
-            <a:solidFill>
-              <a:srgbClr val="6366F1"/>
-            </a:solidFill>
-          </a:ln>
-        </p:spPr>
-        <p:txBody>
-          <a:bodyPr anchor="t"/>
-          <a:lstStyle/>
-          <a:p>
-            <a:pPr algn="l"/>
-            <a:r>
-              <a:rPr b="1" sz="1100">
-                <a:solidFill>
-                  <a:srgbClr val="4338CA"/>
-                </a:solidFill>
-                <a:latin typeface="+mn-lt"/>
-                <a:cs typeface="+mn-lt"/>
-              </a:rPr>
-              <a:t>📊 Slide 3: Enterprise Data Tables ➔</a:t>
-            </a:r>
-          </a:p>
-          <a:p>
-            <a:pPr algn="l"/>
-            <a:r>
-              <a:rPr sz="950">
-                <a:solidFill>
-                  <a:srgbClr val="64748B"/>
-                </a:solidFill>
-                <a:latin typeface="+mn-lt"/>
-                <a:cs typeface="+mn-lt"/>
-              </a:rPr>
-              <a:t>Formatted headers, zebra fills &amp; metric cells</a:t>
-            </a:r>
-          </a:p>
-        </p:txBody>
-      </p:sp>
-      <p:sp>
-        <p:nvSpPr>
-          <p:cNvPr id="9" name="roundRect 8">
-            <a:hlinkClick r:id="rId4" tooltip="Jump directly to Slide 9" action="ppaction://hlinksldjump"/>
-          </p:cNvPr>
-          <p:cNvSpPr/>
-          <p:nvPr/>
-        </p:nvSpPr>
-        <p:spPr>
-          <a:xfrm>
-            <a:off x="914400" y="4434840"/>
             <a:ext cx="4846320" cy="749808"/>
           </a:xfrm>
           <a:prstGeom prst="roundRect">
@@ -4411,8 +4462,64 @@
       </p:sp>
       <p:sp>
         <p:nvSpPr>
+          <p:cNvPr id="9" name="roundRect 8">
+            <a:hlinkClick r:id="rId4" tooltip="Jump directly to Slide 13" action="ppaction://hlinksldjump"/>
+          </p:cNvPr>
+          <p:cNvSpPr/>
+          <p:nvPr/>
+        </p:nvSpPr>
+        <p:spPr>
+          <a:xfrm>
+            <a:off x="914400" y="4434840"/>
+            <a:ext cx="4846320" cy="749808"/>
+          </a:xfrm>
+          <a:prstGeom prst="roundRect">
+            <a:avLst/>
+          </a:prstGeom>
+          <a:solidFill>
+            <a:srgbClr val="F5F3FF"/>
+          </a:solidFill>
+          <a:ln w="13716">
+            <a:solidFill>
+              <a:srgbClr val="8B5CF6"/>
+            </a:solidFill>
+          </a:ln>
+        </p:spPr>
+        <p:txBody>
+          <a:bodyPr anchor="t"/>
+          <a:lstStyle/>
+          <a:p>
+            <a:pPr algn="l"/>
+            <a:r>
+              <a:rPr b="1" sz="1100">
+                <a:solidFill>
+                  <a:srgbClr val="6D28D9"/>
+                </a:solidFill>
+                <a:latin typeface="+mn-lt"/>
+                <a:cs typeface="+mn-lt"/>
+              </a:rPr>
+              <a:t>🎨 Slide 13: DrawingML Gradient Engine ➔</a:t>
+            </a:r>
+          </a:p>
+          <a:p>
+            <a:pPr algn="l"/>
+            <a:r>
+              <a:rPr sz="950">
+                <a:solidFill>
+                  <a:srgbClr val="64748B"/>
+                </a:solidFill>
+                <a:latin typeface="+mn-lt"/>
+                <a:cs typeface="+mn-lt"/>
+              </a:rPr>
+              <a:t>Linear, radial, alpha &amp; multi-stop mesh cards</a:t>
+            </a:r>
+          </a:p>
+        </p:txBody>
+      </p:sp>
+      <p:sp>
+        <p:nvSpPr>
           <p:cNvPr id="10" name="roundRect 9">
-            <a:hlinkClick r:id="rId5" tooltip="Jump directly to Slide 13" action="ppaction://hlinksldjump"/>
+            <a:hlinkClick r:id="rId5" tooltip="Jump directly to Slide 14" action="ppaction://hlinksldjump"/>
           </p:cNvPr>
           <p:cNvSpPr/>
           <p:nvPr/>
@@ -4447,7 +4554,7 @@
                 <a:latin typeface="+mn-lt"/>
                 <a:cs typeface="+mn-lt"/>
               </a:rPr>
-              <a:t>⚡ Slide 13: Engine Benchmark Matrix ➔</a:t>
+              <a:t>⚡ Slide 14: Engine Benchmark Matrix ➔</a:t>
             </a:r>
           </a:p>
           <a:p>
@@ -4941,6 +5048,873 @@
 </file>
 
 <file path=ppt/slides/slide13.xml><?xml version="1.0" encoding="utf-8"?>
+<p:sld xmlns:a="http://schemas.openxmlformats.org/drawingml/2006/main" xmlns:r="http://schemas.openxmlformats.org/officeDocument/2006/relationships" xmlns:p="http://schemas.openxmlformats.org/presentationml/2006/main">
+  <p:cSld>
+    <p:bg>
+      <p:bgPr>
+        <a:gradFill>
+          <a:gsLst>
+            <a:gs pos="0">
+              <a:srgbClr val="090D16"/>
+            </a:gs>
+            <a:gs pos="50000">
+              <a:srgbClr val="0F172A"/>
+            </a:gs>
+            <a:gs pos="100000">
+              <a:srgbClr val="1E293B"/>
+            </a:gs>
+          </a:gsLst>
+          <a:lin ang="8100000" scaled="1"/>
+        </a:gradFill>
+        <a:effectLst/>
+      </p:bgPr>
+    </p:bg>
+    <p:spTree>
+      <p:nvGrpSpPr>
+        <p:cNvPr id="1" name=""/>
+        <p:cNvGrpSpPr/>
+        <p:nvPr/>
+      </p:nvGrpSpPr>
+      <p:grpSpPr>
+        <a:xfrm>
+          <a:off x="0" y="0"/>
+          <a:ext cx="0" cy="0"/>
+          <a:chOff x="0" y="0"/>
+          <a:chExt cx="0" cy="0"/>
+        </a:xfrm>
+      </p:grpSpPr>
+      <p:sp>
+        <p:nvSpPr>
+          <p:cNvPr id="2" name="Text Box 1"/>
+          <p:cNvSpPr/>
+          <p:nvPr/>
+        </p:nvSpPr>
+        <p:spPr>
+          <a:xfrm>
+            <a:off x="731520" y="731520"/>
+            <a:ext cx="10725912" cy="548640"/>
+          </a:xfrm>
+          <a:prstGeom prst="rect">
+            <a:avLst/>
+          </a:prstGeom>
+        </p:spPr>
+        <p:txBody>
+          <a:bodyPr anchor="t"/>
+          <a:lstStyle/>
+          <a:p>
+            <a:pPr algn="l"/>
+            <a:r>
+              <a:rPr b="1" sz="2400">
+                <a:solidFill>
+                  <a:srgbClr val="FFFFFF"/>
+                </a:solidFill>
+                <a:latin typeface="+mj-lt"/>
+                <a:cs typeface="+mj-lt"/>
+              </a:rPr>
+              <a:t>Native OpenXML DrawingML Gradient Engine</a:t>
+            </a:r>
+          </a:p>
+        </p:txBody>
+      </p:sp>
+      <p:sp>
+        <p:nvSpPr>
+          <p:cNvPr id="3" name="Text Box 2"/>
+          <p:cNvSpPr/>
+          <p:nvPr/>
+        </p:nvSpPr>
+        <p:spPr>
+          <a:xfrm>
+            <a:off x="731520" y="1280160"/>
+            <a:ext cx="10725912" cy="365760"/>
+          </a:xfrm>
+          <a:prstGeom prst="rect">
+            <a:avLst/>
+          </a:prstGeom>
+        </p:spPr>
+        <p:txBody>
+          <a:bodyPr anchor="t"/>
+          <a:lstStyle/>
+          <a:p>
+            <a:pPr algn="l"/>
+            <a:r>
+              <a:rPr sz="1400">
+                <a:solidFill>
+                  <a:srgbClr val="94A3B8"/>
+                </a:solidFill>
+                <a:latin typeface="+mn-lt"/>
+                <a:cs typeface="+mn-lt"/>
+              </a:rPr>
+              <a:t>Linear, radial, multi-stop vector meshes, alpha transparency, and angle rotation</a:t>
+            </a:r>
+          </a:p>
+        </p:txBody>
+      </p:sp>
+      <p:sp>
+        <p:nvSpPr>
+          <p:cNvPr id="4" name="roundRect 3">
+            <a:hlinkClick r:id="rId2" tooltip="Return to Hyperlinks Hub (Slide 12)" action="ppaction://hlinksldjump"/>
+          </p:cNvPr>
+          <p:cNvSpPr/>
+          <p:nvPr/>
+        </p:nvSpPr>
+        <p:spPr>
+          <a:xfrm>
+            <a:off x="7315200" y="731520"/>
+            <a:ext cx="2011680" cy="411480"/>
+          </a:xfrm>
+          <a:prstGeom prst="roundRect">
+            <a:avLst/>
+          </a:prstGeom>
+          <a:solidFill>
+            <a:srgbClr val="0284C7"/>
+          </a:solidFill>
+          <a:ln w="13716">
+            <a:solidFill>
+              <a:srgbClr val="38BDF8"/>
+            </a:solidFill>
+          </a:ln>
+          <a:effectLst>
+            <a:outerShdw blurRad="109728" dist="38100" dir="5400000">
+              <a:srgbClr val="0284C7">
+                <a:alpha val="30000"/>
+              </a:srgbClr>
+            </a:outerShdw>
+          </a:effectLst>
+        </p:spPr>
+        <p:txBody>
+          <a:bodyPr anchor="t"/>
+          <a:lstStyle/>
+          <a:p>
+            <a:pPr algn="ctr"/>
+            <a:r>
+              <a:rPr b="1" sz="1000">
+                <a:solidFill>
+                  <a:srgbClr val="FFFFFF"/>
+                </a:solidFill>
+                <a:latin typeface="+mn-lt"/>
+                <a:cs typeface="+mn-lt"/>
+              </a:rPr>
+              <a:t>⬅ Back to Nav Hub</a:t>
+            </a:r>
+          </a:p>
+        </p:txBody>
+      </p:sp>
+      <p:sp>
+        <p:nvSpPr>
+          <p:cNvPr id="5" name="roundRect 4">
+            <a:hlinkClick r:id="rId3" tooltip="Advance to Live Benchmarks (Slide 14)" action="ppaction://hlinksldjump"/>
+          </p:cNvPr>
+          <p:cNvSpPr/>
+          <p:nvPr/>
+        </p:nvSpPr>
+        <p:spPr>
+          <a:xfrm>
+            <a:off x="9509760" y="731520"/>
+            <a:ext cx="1828800" cy="411480"/>
+          </a:xfrm>
+          <a:prstGeom prst="roundRect">
+            <a:avLst/>
+          </a:prstGeom>
+          <a:gradFill>
+            <a:gsLst>
+              <a:gs pos="0">
+                <a:srgbClr val="10B981"/>
+              </a:gs>
+              <a:gs pos="100000">
+                <a:srgbClr val="059669"/>
+              </a:gs>
+            </a:gsLst>
+            <a:lin ang="5400000" scaled="1"/>
+          </a:gradFill>
+          <a:ln w="13716">
+            <a:solidFill>
+              <a:srgbClr val="34D399"/>
+            </a:solidFill>
+          </a:ln>
+          <a:effectLst>
+            <a:outerShdw blurRad="109728" dist="38100" dir="5400000">
+              <a:srgbClr val="10B981">
+                <a:alpha val="30000"/>
+              </a:srgbClr>
+            </a:outerShdw>
+          </a:effectLst>
+        </p:spPr>
+        <p:txBody>
+          <a:bodyPr anchor="t"/>
+          <a:lstStyle/>
+          <a:p>
+            <a:pPr algn="ctr"/>
+            <a:r>
+              <a:rPr b="1" sz="1000">
+                <a:solidFill>
+                  <a:srgbClr val="FFFFFF"/>
+                </a:solidFill>
+                <a:latin typeface="+mn-lt"/>
+                <a:cs typeface="+mn-lt"/>
+              </a:rPr>
+              <a:t>Benchmarks ➔</a:t>
+            </a:r>
+          </a:p>
+        </p:txBody>
+      </p:sp>
+      <p:sp>
+        <p:nvSpPr>
+          <p:cNvPr id="6" name="roundRect 5"/>
+          <p:cNvSpPr/>
+          <p:nvPr/>
+        </p:nvSpPr>
+        <p:spPr>
+          <a:xfrm>
+            <a:off x="731520" y="1828800"/>
+            <a:ext cx="5212080" cy="4480560"/>
+          </a:xfrm>
+          <a:prstGeom prst="roundRect">
+            <a:avLst/>
+          </a:prstGeom>
+          <a:solidFill>
+            <a:srgbClr val="0F172A"/>
+          </a:solidFill>
+          <a:ln w="13716">
+            <a:solidFill>
+              <a:srgbClr val="334155"/>
+            </a:solidFill>
+          </a:ln>
+          <a:effectLst>
+            <a:outerShdw blurRad="109728" dist="38100" dir="5400000">
+              <a:srgbClr val="000000">
+                <a:alpha val="40000"/>
+              </a:srgbClr>
+            </a:outerShdw>
+          </a:effectLst>
+        </p:spPr>
+        <p:txBody>
+          <a:bodyPr/>
+          <a:lstStyle/>
+          <a:p>
+            <a:endParaRPr/>
+          </a:p>
+        </p:txBody>
+      </p:sp>
+      <p:sp>
+        <p:nvSpPr>
+          <p:cNvPr id="7" name="Text Box 6"/>
+          <p:cNvSpPr/>
+          <p:nvPr/>
+        </p:nvSpPr>
+        <p:spPr>
+          <a:xfrm>
+            <a:off x="914400" y="2011680"/>
+            <a:ext cx="4846320" cy="320040"/>
+          </a:xfrm>
+          <a:prstGeom prst="rect">
+            <a:avLst/>
+          </a:prstGeom>
+        </p:spPr>
+        <p:txBody>
+          <a:bodyPr anchor="t"/>
+          <a:lstStyle/>
+          <a:p>
+            <a:pPr algn="l"/>
+            <a:r>
+              <a:rPr b="1" sz="1300">
+                <a:solidFill>
+                  <a:srgbClr val="FFFFFF"/>
+                </a:solidFill>
+                <a:latin typeface="+mn-lt"/>
+                <a:cs typeface="+mn-lt"/>
+              </a:rPr>
+              <a:t>🌈 Multi-Angle Linear Gradient Topologies</a:t>
+            </a:r>
+          </a:p>
+        </p:txBody>
+      </p:sp>
+      <p:sp>
+        <p:nvSpPr>
+          <p:cNvPr id="8" name="roundRect 7"/>
+          <p:cNvSpPr/>
+          <p:nvPr/>
+        </p:nvSpPr>
+        <p:spPr>
+          <a:xfrm>
+            <a:off x="914400" y="2423160"/>
+            <a:ext cx="4846320" cy="960120"/>
+          </a:xfrm>
+          <a:prstGeom prst="roundRect">
+            <a:avLst/>
+          </a:prstGeom>
+          <a:gradFill>
+            <a:gsLst>
+              <a:gs pos="0">
+                <a:srgbClr val="0284C7"/>
+              </a:gs>
+              <a:gs pos="50000">
+                <a:srgbClr val="38BDF8"/>
+              </a:gs>
+              <a:gs pos="100000">
+                <a:srgbClr val="818CF8"/>
+              </a:gs>
+            </a:gsLst>
+            <a:lin ang="2700000" scaled="1"/>
+          </a:gradFill>
+          <a:ln w="9144">
+            <a:solidFill>
+              <a:srgbClr val="FFFFFF"/>
+            </a:solidFill>
+          </a:ln>
+          <a:effectLst>
+            <a:outerShdw blurRad="91440" dist="38100" dir="5400000">
+              <a:srgbClr val="0284C7">
+                <a:alpha val="35000"/>
+              </a:srgbClr>
+            </a:outerShdw>
+          </a:effectLst>
+        </p:spPr>
+        <p:txBody>
+          <a:bodyPr anchor="t"/>
+          <a:lstStyle/>
+          <a:p>
+            <a:pPr algn="l"/>
+            <a:r>
+              <a:rPr b="1" sz="1200">
+                <a:solidFill>
+                  <a:srgbClr val="FFFFFF"/>
+                </a:solidFill>
+                <a:latin typeface="+mn-lt"/>
+                <a:cs typeface="+mn-lt"/>
+              </a:rPr>
+              <a:t>Oceanic Aurora Mesh</a:t>
+            </a:r>
+          </a:p>
+          <a:p>
+            <a:pPr algn="l"/>
+            <a:r>
+              <a:rPr sz="950">
+                <a:solidFill>
+                  <a:srgbClr val="F1F5F9"/>
+                </a:solidFill>
+                <a:latin typeface="+mn-lt"/>
+                <a:cs typeface="+mn-lt"/>
+              </a:rPr>
+              <a:t>45° Diagonal • Sky to Indigo Vector Fusion</a:t>
+            </a:r>
+          </a:p>
+        </p:txBody>
+      </p:sp>
+      <p:sp>
+        <p:nvSpPr>
+          <p:cNvPr id="9" name="roundRect 8"/>
+          <p:cNvSpPr/>
+          <p:nvPr/>
+        </p:nvSpPr>
+        <p:spPr>
+          <a:xfrm>
+            <a:off x="914400" y="3520440"/>
+            <a:ext cx="4846320" cy="960120"/>
+          </a:xfrm>
+          <a:prstGeom prst="roundRect">
+            <a:avLst/>
+          </a:prstGeom>
+          <a:gradFill>
+            <a:gsLst>
+              <a:gs pos="0">
+                <a:srgbClr val="F59E0B"/>
+              </a:gs>
+              <a:gs pos="50000">
+                <a:srgbClr val="EF4444"/>
+              </a:gs>
+              <a:gs pos="100000">
+                <a:srgbClr val="EC4899"/>
+              </a:gs>
+            </a:gsLst>
+            <a:lin ang="5400000" scaled="1"/>
+          </a:gradFill>
+          <a:ln w="9144">
+            <a:solidFill>
+              <a:srgbClr val="FFFFFF"/>
+            </a:solidFill>
+          </a:ln>
+          <a:effectLst>
+            <a:outerShdw blurRad="91440" dist="38100" dir="5400000">
+              <a:srgbClr val="F59E0B">
+                <a:alpha val="35000"/>
+              </a:srgbClr>
+            </a:outerShdw>
+          </a:effectLst>
+        </p:spPr>
+        <p:txBody>
+          <a:bodyPr anchor="t"/>
+          <a:lstStyle/>
+          <a:p>
+            <a:pPr algn="l"/>
+            <a:r>
+              <a:rPr b="1" sz="1200">
+                <a:solidFill>
+                  <a:srgbClr val="FFFFFF"/>
+                </a:solidFill>
+                <a:latin typeface="+mn-lt"/>
+                <a:cs typeface="+mn-lt"/>
+              </a:rPr>
+              <a:t>Sunset Ember Gradient</a:t>
+            </a:r>
+          </a:p>
+          <a:p>
+            <a:pPr algn="l"/>
+            <a:r>
+              <a:rPr sz="950">
+                <a:solidFill>
+                  <a:srgbClr val="F1F5F9"/>
+                </a:solidFill>
+                <a:latin typeface="+mn-lt"/>
+                <a:cs typeface="+mn-lt"/>
+              </a:rPr>
+              <a:t>90° Vertical • Amber to Crimson Sunset</a:t>
+            </a:r>
+          </a:p>
+        </p:txBody>
+      </p:sp>
+      <p:sp>
+        <p:nvSpPr>
+          <p:cNvPr id="10" name="roundRect 9"/>
+          <p:cNvSpPr/>
+          <p:nvPr/>
+        </p:nvSpPr>
+        <p:spPr>
+          <a:xfrm>
+            <a:off x="914400" y="4617720"/>
+            <a:ext cx="4846320" cy="960120"/>
+          </a:xfrm>
+          <a:prstGeom prst="roundRect">
+            <a:avLst/>
+          </a:prstGeom>
+          <a:gradFill>
+            <a:gsLst>
+              <a:gs pos="0">
+                <a:srgbClr val="059669"/>
+              </a:gs>
+              <a:gs pos="50000">
+                <a:srgbClr val="10B981"/>
+              </a:gs>
+              <a:gs pos="100000">
+                <a:srgbClr val="34D399"/>
+              </a:gs>
+            </a:gsLst>
+            <a:lin ang="8100000" scaled="1"/>
+          </a:gradFill>
+          <a:ln w="9144">
+            <a:solidFill>
+              <a:srgbClr val="FFFFFF"/>
+            </a:solidFill>
+          </a:ln>
+          <a:effectLst>
+            <a:outerShdw blurRad="91440" dist="38100" dir="5400000">
+              <a:srgbClr val="059669">
+                <a:alpha val="35000"/>
+              </a:srgbClr>
+            </a:outerShdw>
+          </a:effectLst>
+        </p:spPr>
+        <p:txBody>
+          <a:bodyPr anchor="t"/>
+          <a:lstStyle/>
+          <a:p>
+            <a:pPr algn="l"/>
+            <a:r>
+              <a:rPr b="1" sz="1200">
+                <a:solidFill>
+                  <a:srgbClr val="FFFFFF"/>
+                </a:solidFill>
+                <a:latin typeface="+mn-lt"/>
+                <a:cs typeface="+mn-lt"/>
+              </a:rPr>
+              <a:t>Emerald Surge Vector</a:t>
+            </a:r>
+          </a:p>
+          <a:p>
+            <a:pPr algn="l"/>
+            <a:r>
+              <a:rPr sz="950">
+                <a:solidFill>
+                  <a:srgbClr val="F1F5F9"/>
+                </a:solidFill>
+                <a:latin typeface="+mn-lt"/>
+                <a:cs typeface="+mn-lt"/>
+              </a:rPr>
+              <a:t>135° Diagonal • Forest to Emerald Glow</a:t>
+            </a:r>
+          </a:p>
+        </p:txBody>
+      </p:sp>
+      <p:sp>
+        <p:nvSpPr>
+          <p:cNvPr id="11" name="roundRect 10"/>
+          <p:cNvSpPr/>
+          <p:nvPr/>
+        </p:nvSpPr>
+        <p:spPr>
+          <a:xfrm>
+            <a:off x="6217920" y="1828800"/>
+            <a:ext cx="5212080" cy="4480560"/>
+          </a:xfrm>
+          <a:prstGeom prst="roundRect">
+            <a:avLst/>
+          </a:prstGeom>
+          <a:solidFill>
+            <a:srgbClr val="0F172A"/>
+          </a:solidFill>
+          <a:ln w="13716">
+            <a:solidFill>
+              <a:srgbClr val="334155"/>
+            </a:solidFill>
+          </a:ln>
+          <a:effectLst>
+            <a:outerShdw blurRad="109728" dist="38100" dir="5400000">
+              <a:srgbClr val="000000">
+                <a:alpha val="40000"/>
+              </a:srgbClr>
+            </a:outerShdw>
+          </a:effectLst>
+        </p:spPr>
+        <p:txBody>
+          <a:bodyPr/>
+          <a:lstStyle/>
+          <a:p>
+            <a:endParaRPr/>
+          </a:p>
+        </p:txBody>
+      </p:sp>
+      <p:sp>
+        <p:nvSpPr>
+          <p:cNvPr id="12" name="Text Box 11"/>
+          <p:cNvSpPr/>
+          <p:nvPr/>
+        </p:nvSpPr>
+        <p:spPr>
+          <a:xfrm>
+            <a:off x="6400800" y="2011680"/>
+            <a:ext cx="4846320" cy="320040"/>
+          </a:xfrm>
+          <a:prstGeom prst="rect">
+            <a:avLst/>
+          </a:prstGeom>
+        </p:spPr>
+        <p:txBody>
+          <a:bodyPr anchor="t"/>
+          <a:lstStyle/>
+          <a:p>
+            <a:pPr algn="l"/>
+            <a:r>
+              <a:rPr b="1" sz="1300">
+                <a:solidFill>
+                  <a:srgbClr val="FFFFFF"/>
+                </a:solidFill>
+                <a:latin typeface="+mn-lt"/>
+                <a:cs typeface="+mn-lt"/>
+              </a:rPr>
+              <a:t>🔮 Radial Glow &amp; Alpha Opacity Transparency</a:t>
+            </a:r>
+          </a:p>
+        </p:txBody>
+      </p:sp>
+      <p:sp>
+        <p:nvSpPr>
+          <p:cNvPr id="13" name="ellipse 12"/>
+          <p:cNvSpPr/>
+          <p:nvPr/>
+        </p:nvSpPr>
+        <p:spPr>
+          <a:xfrm>
+            <a:off x="6492240" y="2423160"/>
+            <a:ext cx="1463040" cy="1463040"/>
+          </a:xfrm>
+          <a:prstGeom prst="ellipse">
+            <a:avLst/>
+          </a:prstGeom>
+          <a:gradFill>
+            <a:gsLst>
+              <a:gs pos="0">
+                <a:srgbClr val="38BDF8"/>
+              </a:gs>
+              <a:gs pos="50000">
+                <a:srgbClr val="0284C7"/>
+              </a:gs>
+              <a:gs pos="100000">
+                <a:srgbClr val="0F172A"/>
+              </a:gs>
+            </a:gsLst>
+            <a:path path="circle">
+              <a:fillToRect b="50000" l="50000" r="50000" t="50000"/>
+            </a:path>
+          </a:gradFill>
+          <a:ln w="13716">
+            <a:solidFill>
+              <a:srgbClr val="38BDF8"/>
+            </a:solidFill>
+          </a:ln>
+          <a:effectLst>
+            <a:outerShdw blurRad="182880" dist="38100" dir="5400000">
+              <a:srgbClr val="38BDF8">
+                <a:alpha val="40000"/>
+              </a:srgbClr>
+            </a:outerShdw>
+          </a:effectLst>
+        </p:spPr>
+        <p:txBody>
+          <a:bodyPr/>
+          <a:lstStyle/>
+          <a:p>
+            <a:endParaRPr/>
+          </a:p>
+        </p:txBody>
+      </p:sp>
+      <p:sp>
+        <p:nvSpPr>
+          <p:cNvPr id="14" name="Text Box 13"/>
+          <p:cNvSpPr/>
+          <p:nvPr/>
+        </p:nvSpPr>
+        <p:spPr>
+          <a:xfrm>
+            <a:off x="8138160" y="2514600"/>
+            <a:ext cx="3200400" cy="1280160"/>
+          </a:xfrm>
+          <a:prstGeom prst="rect">
+            <a:avLst/>
+          </a:prstGeom>
+        </p:spPr>
+        <p:txBody>
+          <a:bodyPr anchor="t"/>
+          <a:lstStyle/>
+          <a:p>
+            <a:pPr algn="l"/>
+            <a:r>
+              <a:rPr sz="1000">
+                <a:solidFill>
+                  <a:srgbClr val="E2E8F0"/>
+                </a:solidFill>
+                <a:latin typeface="+mn-lt"/>
+                <a:cs typeface="+mn-lt"/>
+              </a:rPr>
+              <a:t>Radial Orb Focus</a:t>
+            </a:r>
+          </a:p>
+          <a:p>
+            <a:pPr algn="l"/>
+            <a:r>
+              <a:rPr sz="1000">
+                <a:solidFill>
+                  <a:srgbClr val="E2E8F0"/>
+                </a:solidFill>
+                <a:latin typeface="+mn-lt"/>
+                <a:cs typeface="+mn-lt"/>
+              </a:rPr>
+              <a:t>3-Stop Centered Radial Gradient (&lt;a:path path="circle"&gt;) with automatic edge falloff</a:t>
+            </a:r>
+          </a:p>
+        </p:txBody>
+      </p:sp>
+      <p:sp>
+        <p:nvSpPr>
+          <p:cNvPr id="15" name="roundRect 14"/>
+          <p:cNvSpPr/>
+          <p:nvPr/>
+        </p:nvSpPr>
+        <p:spPr>
+          <a:xfrm>
+            <a:off x="6400800" y="4023360"/>
+            <a:ext cx="4846320" cy="960120"/>
+          </a:xfrm>
+          <a:prstGeom prst="roundRect">
+            <a:avLst/>
+          </a:prstGeom>
+          <a:gradFill>
+            <a:gsLst>
+              <a:gs pos="0">
+                <a:srgbClr val="FFFFFF">
+                  <a:alpha val="25000"/>
+                </a:srgbClr>
+              </a:gs>
+              <a:gs pos="50000">
+                <a:srgbClr val="6366F1">
+                  <a:alpha val="15000"/>
+                </a:srgbClr>
+              </a:gs>
+              <a:gs pos="100000">
+                <a:srgbClr val="0F172A">
+                  <a:alpha val="40000"/>
+                </a:srgbClr>
+              </a:gs>
+            </a:gsLst>
+            <a:lin ang="8100000" scaled="1"/>
+          </a:gradFill>
+          <a:ln w="13716">
+            <a:solidFill>
+              <a:srgbClr val="818CF8"/>
+            </a:solidFill>
+          </a:ln>
+          <a:effectLst>
+            <a:outerShdw blurRad="109728" dist="38100" dir="5400000">
+              <a:srgbClr val="6366F1">
+                <a:alpha val="25000"/>
+              </a:srgbClr>
+            </a:outerShdw>
+          </a:effectLst>
+        </p:spPr>
+        <p:txBody>
+          <a:bodyPr anchor="t"/>
+          <a:lstStyle/>
+          <a:p>
+            <a:pPr algn="l"/>
+            <a:r>
+              <a:rPr b="1" sz="1100">
+                <a:solidFill>
+                  <a:srgbClr val="FFFFFF"/>
+                </a:solidFill>
+                <a:latin typeface="+mn-lt"/>
+                <a:cs typeface="+mn-lt"/>
+              </a:rPr>
+              <a:t>🪟 Alpha Transparency &amp; Frosted Glass</a:t>
+            </a:r>
+          </a:p>
+          <a:p>
+            <a:pPr algn="l"/>
+            <a:r>
+              <a:rPr sz="950">
+                <a:solidFill>
+                  <a:srgbClr val="CBD5E1"/>
+                </a:solidFill>
+                <a:latin typeface="+mn-lt"/>
+                <a:cs typeface="+mn-lt"/>
+              </a:rPr>
+              <a:t>Multi-stop alpha stops (10% to 80% opacity) for glassmorphic card overlays</a:t>
+            </a:r>
+          </a:p>
+        </p:txBody>
+      </p:sp>
+      <p:sp>
+        <p:nvSpPr>
+          <p:cNvPr id="16" name="roundRect 15"/>
+          <p:cNvSpPr/>
+          <p:nvPr/>
+        </p:nvSpPr>
+        <p:spPr>
+          <a:xfrm>
+            <a:off x="6400800" y="5074920"/>
+            <a:ext cx="4846320" cy="1051560"/>
+          </a:xfrm>
+          <a:prstGeom prst="roundRect">
+            <a:avLst/>
+          </a:prstGeom>
+          <a:solidFill>
+            <a:srgbClr val="020617"/>
+          </a:solidFill>
+          <a:ln w="13716">
+            <a:solidFill>
+              <a:srgbClr val="1E293B"/>
+            </a:solidFill>
+          </a:ln>
+        </p:spPr>
+        <p:txBody>
+          <a:bodyPr anchor="t"/>
+          <a:lstStyle/>
+          <a:p>
+            <a:pPr algn="l"/>
+            <a:r>
+              <a:rPr b="1" sz="900">
+                <a:solidFill>
+                  <a:srgbClr val="38BDF8"/>
+                </a:solidFill>
+                <a:latin typeface="+mn-lt"/>
+                <a:cs typeface="+mn-lt"/>
+              </a:rPr>
+              <a:t>// 3-Line Fluent Gradient Fill</a:t>
+            </a:r>
+          </a:p>
+          <a:p>
+            <a:pPr algn="l"/>
+            <a:r>
+              <a:rPr sz="900">
+                <a:solidFill>
+                  <a:srgbClr val="E2E8F0"/>
+                </a:solidFill>
+                <a:latin typeface="+mn-lt"/>
+                <a:cs typeface="+mn-lt"/>
+              </a:rPr>
+              <a:t>slide.addShape('roundRect', {</a:t>
+            </a:r>
+          </a:p>
+          <a:p>
+            <a:pPr algn="l"/>
+            <a:r>
+              <a:rPr sz="900">
+                <a:solidFill>
+                  <a:srgbClr val="E2E8F0"/>
+                </a:solidFill>
+                <a:latin typeface="+mn-lt"/>
+                <a:cs typeface="+mn-lt"/>
+              </a:rPr>
+              <a:t>  fill: { type: 'linear', angle: degrees(135), stops: ['#0284C7', '#6366F1'] }</a:t>
+            </a:r>
+          </a:p>
+          <a:p>
+            <a:pPr algn="l"/>
+            <a:r>
+              <a:rPr sz="900">
+                <a:solidFill>
+                  <a:srgbClr val="E2E8F0"/>
+                </a:solidFill>
+                <a:latin typeface="+mn-lt"/>
+                <a:cs typeface="+mn-lt"/>
+              </a:rPr>
+              <a:t>});</a:t>
+            </a:r>
+          </a:p>
+        </p:txBody>
+      </p:sp>
+      <p:sp>
+        <p:nvSpPr>
+          <p:cNvPr id="17" name="Text Box 16"/>
+          <p:cNvSpPr/>
+          <p:nvPr/>
+        </p:nvSpPr>
+        <p:spPr>
+          <a:xfrm>
+            <a:off x="731520" y="6510528"/>
+            <a:ext cx="10725912" cy="228600"/>
+          </a:xfrm>
+          <a:prstGeom prst="rect">
+            <a:avLst/>
+          </a:prstGeom>
+        </p:spPr>
+        <p:txBody>
+          <a:bodyPr anchor="t"/>
+          <a:lstStyle/>
+          <a:p>
+            <a:pPr algn="ctr"/>
+            <a:r>
+              <a:rPr i="1" sz="800">
+                <a:solidFill>
+                  <a:srgbClr val="64748B"/>
+                </a:solidFill>
+                <a:latin typeface="+mn-lt"/>
+                <a:cs typeface="+mn-lt"/>
+              </a:rPr>
+              <a:t>* Disclaimer: All benchmark metrics, performance figures, and simulated architectures in this deck are synthetic demonstration values generated solely to showcase the authoring, formatting, and rendering capabilities of @hokkyss/pptx.</a:t>
+            </a:r>
+          </a:p>
+        </p:txBody>
+      </p:sp>
+    </p:spTree>
+  </p:cSld>
+  <p:clrMapOvr>
+    <a:masterClrMapping/>
+  </p:clrMapOvr>
+  <p:transition spd="fast">
+    <p:wipe dir="r"/>
+  </p:transition>
+</p:sld>
+</file>
+
+<file path=ppt/slides/slide14.xml><?xml version="1.0" encoding="utf-8"?>
 <p:sld xmlns:a="http://schemas.openxmlformats.org/drawingml/2006/main" xmlns:r="http://schemas.openxmlformats.org/officeDocument/2006/relationships" xmlns:p="http://schemas.openxmlformats.org/presentationml/2006/main">
   <p:cSld>
     <p:bg>

</xml_diff>

<commit_message>
feat(connectors): add customizable start and end arrowheads
- core: define PptxLineEnd, PptxLineEndType, PptxLineEndWidth, PptxLineEndLength in PptxLine
- reader: parse headEnd and tailEnd line properties from OpenXML <a:ln>
- writer: serialize <a:headEnd> and <a:tailEnd> under <a:ln>
- sdk: expose endArrow, startArrow, headEnd, and tailEnd on addConnector() and GroupBuilder.addConnector()
- showcase: regenerate showcase deck featuring customized connector arrows
</commit_message>
<xml_diff>
--- a/hokkyss_showcase_deck.pptx
+++ b/hokkyss_showcase_deck.pptx
@@ -11168,6 +11168,7 @@
               <a:srgbClr val="0284C7"/>
             </a:solidFill>
             <a:prstDash val="solid"/>
+            <a:headEnd type="triangle" w="lg" len="lg"/>
           </a:ln>
         </p:spPr>
       </p:cxnSp>
@@ -11190,6 +11191,7 @@
               <a:srgbClr val="6366F1"/>
             </a:solidFill>
             <a:prstDash val="solid"/>
+            <a:headEnd type="stealth" w="lg" len="lg"/>
           </a:ln>
         </p:spPr>
       </p:cxnSp>
@@ -11207,11 +11209,13 @@
           <a:prstGeom prst="line">
             <a:avLst/>
           </a:prstGeom>
-          <a:ln w="13716">
+          <a:ln w="18288">
             <a:solidFill>
               <a:srgbClr val="94A3B8"/>
             </a:solidFill>
             <a:prstDash val="dash"/>
+            <a:headEnd type="triangle"/>
+            <a:tailEnd type="oval"/>
           </a:ln>
         </p:spPr>
       </p:cxnSp>

</xml_diff>

<commit_message>
feat(connectors): attach connectors to shapes via shapeId and position
- core: define PptxConnectionPosition and PptxShapeAttachment on PptxConnectorElement
- reader: parse <a:stCxn> and <a:endCxn> from <p:cNvCxnSpPr>
- writer: serialize <a:stCxn> and <a:endCxn> under <p:cNvCxnSpPr>
- sdk: support { shapeId: string, position: 'top' | 'bottom' | 'left' | 'right' } in from/to with automatic coordinate calculation and OpenXML glue attachment
- showcase: attach Stage 1, 2, and 3 cards with glued connectors in Slide 8
</commit_message>
<xml_diff>
--- a/hokkyss_showcase_deck.pptx
+++ b/hokkyss_showcase_deck.pptx
@@ -10623,7 +10623,7 @@
       </p:sp>
       <p:sp>
         <p:nvSpPr>
-          <p:cNvPr id="19" name="Text Box 9"/>
+          <p:cNvPr id="16" name="Text Box 6"/>
           <p:cNvSpPr/>
           <p:nvPr/>
         </p:nvSpPr>
@@ -10656,7 +10656,7 @@
       </p:sp>
       <p:sp>
         <p:nvSpPr>
-          <p:cNvPr id="20" name="Text Box 10"/>
+          <p:cNvPr id="17" name="Text Box 7"/>
           <p:cNvSpPr/>
           <p:nvPr/>
         </p:nvSpPr>
@@ -10689,7 +10689,7 @@
       </p:sp>
       <p:grpSp>
         <p:nvGrpSpPr>
-          <p:cNvPr id="4" name="Stage 1 Ingress Container"/>
+          <p:cNvPr id="stage-1" name="Stage 1 Ingress Container"/>
           <p:cNvGrpSpPr/>
           <p:nvPr/>
         </p:nvGrpSpPr>
@@ -10703,7 +10703,7 @@
         </p:grpSpPr>
         <p:sp>
           <p:nvSpPr>
-            <p:cNvPr id="5" name="roundRect 1"/>
+            <p:cNvPr id="4" name="roundRect 1"/>
             <p:cNvSpPr/>
             <p:nvPr/>
           </p:nvSpPr>
@@ -10741,7 +10741,7 @@
         </p:sp>
         <p:sp>
           <p:nvSpPr>
-            <p:cNvPr id="6" name="roundRect 2"/>
+            <p:cNvPr id="5" name="roundRect 2"/>
             <p:cNvSpPr/>
             <p:nvPr/>
           </p:nvSpPr>
@@ -10777,7 +10777,7 @@
         </p:sp>
         <p:sp>
           <p:nvSpPr>
-            <p:cNvPr id="7" name="Text Box 3"/>
+            <p:cNvPr id="6" name="Text Box 3"/>
             <p:cNvSpPr/>
             <p:nvPr/>
           </p:nvSpPr>
@@ -10843,7 +10843,7 @@
       </p:grpSp>
       <p:grpSp>
         <p:nvGrpSpPr>
-          <p:cNvPr id="9" name="Stage 2 AST Container"/>
+          <p:cNvPr id="stage-2" name="Stage 2 AST Container"/>
           <p:cNvGrpSpPr/>
           <p:nvPr/>
         </p:nvGrpSpPr>
@@ -10857,7 +10857,7 @@
         </p:grpSpPr>
         <p:sp>
           <p:nvSpPr>
-            <p:cNvPr id="10" name="roundRect 1"/>
+            <p:cNvPr id="7" name="roundRect 1"/>
             <p:cNvSpPr/>
             <p:nvPr/>
           </p:nvSpPr>
@@ -10895,7 +10895,7 @@
         </p:sp>
         <p:sp>
           <p:nvSpPr>
-            <p:cNvPr id="11" name="roundRect 2"/>
+            <p:cNvPr id="8" name="roundRect 2"/>
             <p:cNvSpPr/>
             <p:nvPr/>
           </p:nvSpPr>
@@ -10931,7 +10931,7 @@
         </p:sp>
         <p:sp>
           <p:nvSpPr>
-            <p:cNvPr id="12" name="Text Box 3"/>
+            <p:cNvPr id="9" name="Text Box 3"/>
             <p:cNvSpPr/>
             <p:nvPr/>
           </p:nvSpPr>
@@ -10997,7 +10997,7 @@
       </p:grpSp>
       <p:grpSp>
         <p:nvGrpSpPr>
-          <p:cNvPr id="14" name="Stage 3 Packaging Container"/>
+          <p:cNvPr id="stage-3" name="Stage 3 Packaging Container"/>
           <p:cNvGrpSpPr/>
           <p:nvPr/>
         </p:nvGrpSpPr>
@@ -11011,7 +11011,7 @@
         </p:grpSpPr>
         <p:sp>
           <p:nvSpPr>
-            <p:cNvPr id="15" name="roundRect 1"/>
+            <p:cNvPr id="10" name="roundRect 1"/>
             <p:cNvSpPr/>
             <p:nvPr/>
           </p:nvSpPr>
@@ -11049,7 +11049,7 @@
         </p:sp>
         <p:sp>
           <p:nvSpPr>
-            <p:cNvPr id="16" name="roundRect 2"/>
+            <p:cNvPr id="11" name="roundRect 2"/>
             <p:cNvSpPr/>
             <p:nvPr/>
           </p:nvSpPr>
@@ -11085,7 +11085,7 @@
         </p:sp>
         <p:sp>
           <p:nvSpPr>
-            <p:cNvPr id="17" name="Text Box 3"/>
+            <p:cNvPr id="12" name="Text Box 3"/>
             <p:cNvSpPr/>
             <p:nvPr/>
           </p:nvSpPr>
@@ -11151,8 +11151,11 @@
       </p:grpSp>
       <p:cxnSp>
         <p:nvCxnSpPr>
-          <p:cNvPr id="8" name="Connector 4"/>
-          <p:cNvCxnSpPr/>
+          <p:cNvPr id="13" name="Connector 3"/>
+          <p:cNvCxnSpPr>
+            <a:stCxn id="stage-1" idx="3"/>
+            <a:endCxn id="stage-2" idx="1"/>
+          </p:cNvCxnSpPr>
           <p:nvPr/>
         </p:nvCxnSpPr>
         <p:spPr>
@@ -11174,8 +11177,11 @@
       </p:cxnSp>
       <p:cxnSp>
         <p:nvCxnSpPr>
-          <p:cNvPr id="13" name="Connector 6"/>
-          <p:cNvCxnSpPr/>
+          <p:cNvPr id="14" name="Connector 4"/>
+          <p:cNvCxnSpPr>
+            <a:stCxn id="stage-2" idx="3"/>
+            <a:endCxn id="stage-3" idx="1"/>
+          </p:cNvCxnSpPr>
           <p:nvPr/>
         </p:nvCxnSpPr>
         <p:spPr>
@@ -11197,7 +11203,7 @@
       </p:cxnSp>
       <p:cxnSp>
         <p:nvCxnSpPr>
-          <p:cNvPr id="18" name="Connector 8"/>
+          <p:cNvPr id="15" name="Connector 5"/>
           <p:cNvCxnSpPr/>
           <p:nvPr/>
         </p:nvCxnSpPr>

</xml_diff>

<commit_message>
fix(writer): normalize non-numeric element IDs to unsigned integers for strict OpenXML compliance
- ensure all p:cNvPr and a:stCxn/a:endCxn IDs strictly conform to xsd:unsignedInt
- maintain idMap to correctly resolve connector attachments with arbitrary string shape IDs
- prevents PowerPoint repair prompts on file open
</commit_message>
<xml_diff>
--- a/hokkyss_showcase_deck.pptx
+++ b/hokkyss_showcase_deck.pptx
@@ -10623,7 +10623,7 @@
       </p:sp>
       <p:sp>
         <p:nvSpPr>
-          <p:cNvPr id="16" name="Text Box 6"/>
+          <p:cNvPr id="19" name="Text Box 6"/>
           <p:cNvSpPr/>
           <p:nvPr/>
         </p:nvSpPr>
@@ -10656,7 +10656,7 @@
       </p:sp>
       <p:sp>
         <p:nvSpPr>
-          <p:cNvPr id="17" name="Text Box 7"/>
+          <p:cNvPr id="20" name="Text Box 7"/>
           <p:cNvSpPr/>
           <p:nvPr/>
         </p:nvSpPr>
@@ -10689,7 +10689,7 @@
       </p:sp>
       <p:grpSp>
         <p:nvGrpSpPr>
-          <p:cNvPr id="stage-1" name="Stage 1 Ingress Container"/>
+          <p:cNvPr id="4" name="Stage 1 Ingress Container"/>
           <p:cNvGrpSpPr/>
           <p:nvPr/>
         </p:nvGrpSpPr>
@@ -10703,7 +10703,7 @@
         </p:grpSpPr>
         <p:sp>
           <p:nvSpPr>
-            <p:cNvPr id="4" name="roundRect 1"/>
+            <p:cNvPr id="5" name="roundRect 1"/>
             <p:cNvSpPr/>
             <p:nvPr/>
           </p:nvSpPr>
@@ -10741,7 +10741,7 @@
         </p:sp>
         <p:sp>
           <p:nvSpPr>
-            <p:cNvPr id="5" name="roundRect 2"/>
+            <p:cNvPr id="6" name="roundRect 2"/>
             <p:cNvSpPr/>
             <p:nvPr/>
           </p:nvSpPr>
@@ -10777,7 +10777,7 @@
         </p:sp>
         <p:sp>
           <p:nvSpPr>
-            <p:cNvPr id="6" name="Text Box 3"/>
+            <p:cNvPr id="7" name="Text Box 3"/>
             <p:cNvSpPr/>
             <p:nvPr/>
           </p:nvSpPr>
@@ -10843,7 +10843,7 @@
       </p:grpSp>
       <p:grpSp>
         <p:nvGrpSpPr>
-          <p:cNvPr id="stage-2" name="Stage 2 AST Container"/>
+          <p:cNvPr id="8" name="Stage 2 AST Container"/>
           <p:cNvGrpSpPr/>
           <p:nvPr/>
         </p:nvGrpSpPr>
@@ -10857,7 +10857,7 @@
         </p:grpSpPr>
         <p:sp>
           <p:nvSpPr>
-            <p:cNvPr id="7" name="roundRect 1"/>
+            <p:cNvPr id="9" name="roundRect 1"/>
             <p:cNvSpPr/>
             <p:nvPr/>
           </p:nvSpPr>
@@ -10895,7 +10895,7 @@
         </p:sp>
         <p:sp>
           <p:nvSpPr>
-            <p:cNvPr id="8" name="roundRect 2"/>
+            <p:cNvPr id="10" name="roundRect 2"/>
             <p:cNvSpPr/>
             <p:nvPr/>
           </p:nvSpPr>
@@ -10931,7 +10931,7 @@
         </p:sp>
         <p:sp>
           <p:nvSpPr>
-            <p:cNvPr id="9" name="Text Box 3"/>
+            <p:cNvPr id="11" name="Text Box 3"/>
             <p:cNvSpPr/>
             <p:nvPr/>
           </p:nvSpPr>
@@ -10997,7 +10997,7 @@
       </p:grpSp>
       <p:grpSp>
         <p:nvGrpSpPr>
-          <p:cNvPr id="stage-3" name="Stage 3 Packaging Container"/>
+          <p:cNvPr id="12" name="Stage 3 Packaging Container"/>
           <p:cNvGrpSpPr/>
           <p:nvPr/>
         </p:nvGrpSpPr>
@@ -11011,7 +11011,7 @@
         </p:grpSpPr>
         <p:sp>
           <p:nvSpPr>
-            <p:cNvPr id="10" name="roundRect 1"/>
+            <p:cNvPr id="13" name="roundRect 1"/>
             <p:cNvSpPr/>
             <p:nvPr/>
           </p:nvSpPr>
@@ -11049,7 +11049,7 @@
         </p:sp>
         <p:sp>
           <p:nvSpPr>
-            <p:cNvPr id="11" name="roundRect 2"/>
+            <p:cNvPr id="14" name="roundRect 2"/>
             <p:cNvSpPr/>
             <p:nvPr/>
           </p:nvSpPr>
@@ -11085,7 +11085,7 @@
         </p:sp>
         <p:sp>
           <p:nvSpPr>
-            <p:cNvPr id="12" name="Text Box 3"/>
+            <p:cNvPr id="15" name="Text Box 3"/>
             <p:cNvSpPr/>
             <p:nvPr/>
           </p:nvSpPr>
@@ -11151,10 +11151,10 @@
       </p:grpSp>
       <p:cxnSp>
         <p:nvCxnSpPr>
-          <p:cNvPr id="13" name="Connector 3"/>
+          <p:cNvPr id="16" name="Connector 3"/>
           <p:cNvCxnSpPr>
-            <a:stCxn id="stage-1" idx="3"/>
-            <a:endCxn id="stage-2" idx="1"/>
+            <a:stCxn id="4" idx="3"/>
+            <a:endCxn id="8" idx="1"/>
           </p:cNvCxnSpPr>
           <p:nvPr/>
         </p:nvCxnSpPr>
@@ -11177,10 +11177,10 @@
       </p:cxnSp>
       <p:cxnSp>
         <p:nvCxnSpPr>
-          <p:cNvPr id="14" name="Connector 4"/>
+          <p:cNvPr id="17" name="Connector 4"/>
           <p:cNvCxnSpPr>
-            <a:stCxn id="stage-2" idx="3"/>
-            <a:endCxn id="stage-3" idx="1"/>
+            <a:stCxn id="8" idx="3"/>
+            <a:endCxn id="12" idx="1"/>
           </p:cNvCxnSpPr>
           <p:nvPr/>
         </p:nvCxnSpPr>
@@ -11203,7 +11203,7 @@
       </p:cxnSp>
       <p:cxnSp>
         <p:nvCxnSpPr>
-          <p:cNvPr id="15" name="Connector 5"/>
+          <p:cNvPr id="18" name="Connector 5"/>
           <p:cNvCxnSpPr/>
           <p:nvPr/>
         </p:nvCxnSpPr>

</xml_diff>

<commit_message>
feat(connectors): throw explicit error on group attachments & emit cxnSpLocks
- throw clear error if connector endpoint targets a group instead of an individual shape
- emit a:cxnSpLocks in cNvCxnSpPr for connector shapes
- allow exact 0 cy/cx extents on orthogonal connectors
- update Slide 8 showcase cards to top-level shape targets
</commit_message>
<xml_diff>
--- a/hokkyss_showcase_deck.pptx
+++ b/hokkyss_showcase_deck.pptx
@@ -10623,545 +10623,501 @@
       </p:sp>
       <p:sp>
         <p:nvSpPr>
-          <p:cNvPr id="19" name="Text Box 6"/>
-          <p:cNvSpPr/>
-          <p:nvPr/>
-        </p:nvSpPr>
-        <p:spPr>
-          <a:xfrm>
-            <a:off x="914400" y="5806440"/>
-            <a:ext cx="10241280" cy="365760"/>
-          </a:xfrm>
-          <a:prstGeom prst="rect">
-            <a:avLst/>
-          </a:prstGeom>
-        </p:spPr>
-        <p:txBody>
-          <a:bodyPr anchor="t"/>
-          <a:lstStyle/>
-          <a:p>
-            <a:pPr algn="ctr"/>
-            <a:r>
-              <a:rPr sz="1100">
-                <a:solidFill>
-                  <a:srgbClr val="64748B"/>
-                </a:solidFill>
-                <a:latin typeface="+mn-lt"/>
-                <a:cs typeface="+mn-lt"/>
-              </a:rPr>
-              <a:t>Isomorphic Pipeline Feedback Loop: 100% Roundtrip Bit-Exact Precision</a:t>
-            </a:r>
-          </a:p>
-        </p:txBody>
-      </p:sp>
-      <p:sp>
-        <p:nvSpPr>
-          <p:cNvPr id="20" name="Text Box 7"/>
-          <p:cNvSpPr/>
-          <p:nvPr/>
-        </p:nvSpPr>
-        <p:spPr>
-          <a:xfrm>
-            <a:off x="731520" y="6510528"/>
-            <a:ext cx="10725912" cy="228600"/>
-          </a:xfrm>
-          <a:prstGeom prst="rect">
-            <a:avLst/>
-          </a:prstGeom>
-        </p:spPr>
-        <p:txBody>
-          <a:bodyPr anchor="t"/>
-          <a:lstStyle/>
-          <a:p>
-            <a:pPr algn="ctr"/>
-            <a:r>
-              <a:rPr i="1" sz="800">
-                <a:solidFill>
-                  <a:srgbClr val="94A3B8"/>
-                </a:solidFill>
-                <a:latin typeface="+mn-lt"/>
-                <a:cs typeface="+mn-lt"/>
-              </a:rPr>
-              <a:t>* Disclaimer: All benchmark metrics, performance figures, and simulated architectures in this deck are synthetic demonstration values generated solely to showcase the authoring, formatting, and rendering capabilities of @hokkyss/pptx.</a:t>
-            </a:r>
-          </a:p>
-        </p:txBody>
-      </p:sp>
-      <p:grpSp>
-        <p:nvGrpSpPr>
-          <p:cNvPr id="4" name="Stage 1 Ingress Container"/>
-          <p:cNvGrpSpPr/>
-          <p:nvPr/>
-        </p:nvGrpSpPr>
-        <p:grpSpPr>
+          <p:cNvPr id="4" name="Stage 1 Card"/>
+          <p:cNvSpPr/>
+          <p:nvPr/>
+        </p:nvSpPr>
+        <p:spPr>
           <a:xfrm>
             <a:off x="914400" y="2011680"/>
             <a:ext cx="2926080" cy="3200400"/>
-            <a:chOff x="914400" y="2011680"/>
-            <a:chExt cx="2926080" cy="3200400"/>
-          </a:xfrm>
-        </p:grpSpPr>
-        <p:sp>
-          <p:nvSpPr>
-            <p:cNvPr id="5" name="roundRect 1"/>
-            <p:cNvSpPr/>
-            <p:nvPr/>
-          </p:nvSpPr>
-          <p:spPr>
-            <a:xfrm>
-              <a:off x="914400" y="2011680"/>
-              <a:ext cx="2926080" cy="3200400"/>
-            </a:xfrm>
-            <a:prstGeom prst="roundRect">
-              <a:avLst/>
-            </a:prstGeom>
-            <a:solidFill>
-              <a:srgbClr val="FFFFFF"/>
-            </a:solidFill>
-            <a:ln w="13716">
-              <a:solidFill>
-                <a:srgbClr val="0284C7"/>
-              </a:solidFill>
-            </a:ln>
-            <a:effectLst>
-              <a:outerShdw blurRad="109728" dist="38100" dir="5400000">
-                <a:srgbClr val="0F172A">
-                  <a:alpha val="10000"/>
-                </a:srgbClr>
-              </a:outerShdw>
-            </a:effectLst>
-          </p:spPr>
-          <p:txBody>
-            <a:bodyPr/>
-            <a:lstStyle/>
-            <a:p>
-              <a:endParaRPr/>
-            </a:p>
-          </p:txBody>
-        </p:sp>
-        <p:sp>
-          <p:nvSpPr>
-            <p:cNvPr id="6" name="roundRect 2"/>
-            <p:cNvSpPr/>
-            <p:nvPr/>
-          </p:nvSpPr>
-          <p:spPr>
-            <a:xfrm>
-              <a:off x="1188720" y="2286000"/>
-              <a:ext cx="2377440" cy="365760"/>
-            </a:xfrm>
-            <a:prstGeom prst="roundRect">
-              <a:avLst/>
-            </a:prstGeom>
+          </a:xfrm>
+          <a:prstGeom prst="roundRect">
+            <a:avLst/>
+          </a:prstGeom>
+          <a:solidFill>
+            <a:srgbClr val="FFFFFF"/>
+          </a:solidFill>
+          <a:ln w="13716">
             <a:solidFill>
               <a:srgbClr val="0284C7"/>
             </a:solidFill>
-          </p:spPr>
-          <p:txBody>
-            <a:bodyPr anchor="t"/>
-            <a:lstStyle/>
-            <a:p>
-              <a:pPr algn="ctr"/>
-              <a:r>
-                <a:rPr b="1" sz="1000">
-                  <a:solidFill>
-                    <a:srgbClr val="FFFFFF"/>
-                  </a:solidFill>
-                  <a:latin typeface="+mn-lt"/>
-                  <a:cs typeface="+mn-lt"/>
-                </a:rPr>
-                <a:t>STEP 1: INGESTION</a:t>
-              </a:r>
-            </a:p>
-          </p:txBody>
-        </p:sp>
-        <p:sp>
-          <p:nvSpPr>
-            <p:cNvPr id="7" name="Text Box 3"/>
-            <p:cNvSpPr/>
-            <p:nvPr/>
-          </p:nvSpPr>
-          <p:spPr>
-            <a:xfrm>
-              <a:off x="1188720" y="2926080"/>
-              <a:ext cx="2377440" cy="1828800"/>
-            </a:xfrm>
-            <a:prstGeom prst="rect">
-              <a:avLst/>
-            </a:prstGeom>
-          </p:spPr>
-          <p:txBody>
-            <a:bodyPr anchor="t"/>
-            <a:lstStyle/>
-            <a:p>
-              <a:pPr algn="l" lvl="0" marL="152400" indent="-152400">
-                <a:buChar char="•"/>
-              </a:pPr>
-              <a:r>
-                <a:rPr sz="1100">
-                  <a:solidFill>
-                    <a:srgbClr val="475569"/>
-                  </a:solidFill>
-                  <a:latin typeface="+mn-lt"/>
-                  <a:cs typeface="+mn-lt"/>
-                </a:rPr>
-                <a:t>Streaming ZIP decompression</a:t>
-              </a:r>
-            </a:p>
-            <a:p>
-              <a:pPr algn="l" lvl="0" marL="152400" indent="-152400">
-                <a:buChar char="•"/>
-              </a:pPr>
-              <a:r>
-                <a:rPr sz="1100">
-                  <a:solidFill>
-                    <a:srgbClr val="475569"/>
-                  </a:solidFill>
-                  <a:latin typeface="+mn-lt"/>
-                  <a:cs typeface="+mn-lt"/>
-                </a:rPr>
-                <a:t>XML DOM part resolution</a:t>
-              </a:r>
-            </a:p>
-            <a:p>
-              <a:pPr algn="l" lvl="0" marL="152400" indent="-152400">
-                <a:buChar char="•"/>
-              </a:pPr>
-              <a:r>
-                <a:rPr sz="1100">
-                  <a:solidFill>
-                    <a:srgbClr val="475569"/>
-                  </a:solidFill>
-                  <a:latin typeface="+mn-lt"/>
-                  <a:cs typeface="+mn-lt"/>
-                </a:rPr>
-                <a:t>Extract relationships map</a:t>
-              </a:r>
-            </a:p>
-          </p:txBody>
-        </p:sp>
-      </p:grpSp>
-      <p:grpSp>
-        <p:nvGrpSpPr>
-          <p:cNvPr id="8" name="Stage 2 AST Container"/>
-          <p:cNvGrpSpPr/>
-          <p:nvPr/>
-        </p:nvGrpSpPr>
-        <p:grpSpPr>
+          </a:ln>
+          <a:effectLst>
+            <a:outerShdw blurRad="109728" dist="38100" dir="5400000">
+              <a:srgbClr val="0F172A">
+                <a:alpha val="10000"/>
+              </a:srgbClr>
+            </a:outerShdw>
+          </a:effectLst>
+        </p:spPr>
+        <p:txBody>
+          <a:bodyPr/>
+          <a:lstStyle/>
+          <a:p>
+            <a:endParaRPr/>
+          </a:p>
+        </p:txBody>
+      </p:sp>
+      <p:sp>
+        <p:nvSpPr>
+          <p:cNvPr id="5" name="roundRect 4"/>
+          <p:cNvSpPr/>
+          <p:nvPr/>
+        </p:nvSpPr>
+        <p:spPr>
+          <a:xfrm>
+            <a:off x="1188720" y="2286000"/>
+            <a:ext cx="2377440" cy="365760"/>
+          </a:xfrm>
+          <a:prstGeom prst="roundRect">
+            <a:avLst/>
+          </a:prstGeom>
+          <a:solidFill>
+            <a:srgbClr val="0284C7"/>
+          </a:solidFill>
+        </p:spPr>
+        <p:txBody>
+          <a:bodyPr anchor="t"/>
+          <a:lstStyle/>
+          <a:p>
+            <a:pPr algn="ctr"/>
+            <a:r>
+              <a:rPr b="1" sz="1000">
+                <a:solidFill>
+                  <a:srgbClr val="FFFFFF"/>
+                </a:solidFill>
+                <a:latin typeface="+mn-lt"/>
+                <a:cs typeface="+mn-lt"/>
+              </a:rPr>
+              <a:t>STEP 1: INGESTION</a:t>
+            </a:r>
+          </a:p>
+        </p:txBody>
+      </p:sp>
+      <p:sp>
+        <p:nvSpPr>
+          <p:cNvPr id="6" name="Text Box 5"/>
+          <p:cNvSpPr/>
+          <p:nvPr/>
+        </p:nvSpPr>
+        <p:spPr>
+          <a:xfrm>
+            <a:off x="1188720" y="2926080"/>
+            <a:ext cx="2377440" cy="1828800"/>
+          </a:xfrm>
+          <a:prstGeom prst="rect">
+            <a:avLst/>
+          </a:prstGeom>
+        </p:spPr>
+        <p:txBody>
+          <a:bodyPr anchor="t"/>
+          <a:lstStyle/>
+          <a:p>
+            <a:pPr algn="l" lvl="0" marL="152400" indent="-152400">
+              <a:buChar char="•"/>
+            </a:pPr>
+            <a:r>
+              <a:rPr sz="1100">
+                <a:solidFill>
+                  <a:srgbClr val="475569"/>
+                </a:solidFill>
+                <a:latin typeface="+mn-lt"/>
+                <a:cs typeface="+mn-lt"/>
+              </a:rPr>
+              <a:t>Streaming ZIP decompression</a:t>
+            </a:r>
+          </a:p>
+          <a:p>
+            <a:pPr algn="l" lvl="0" marL="152400" indent="-152400">
+              <a:buChar char="•"/>
+            </a:pPr>
+            <a:r>
+              <a:rPr sz="1100">
+                <a:solidFill>
+                  <a:srgbClr val="475569"/>
+                </a:solidFill>
+                <a:latin typeface="+mn-lt"/>
+                <a:cs typeface="+mn-lt"/>
+              </a:rPr>
+              <a:t>XML DOM part resolution</a:t>
+            </a:r>
+          </a:p>
+          <a:p>
+            <a:pPr algn="l" lvl="0" marL="152400" indent="-152400">
+              <a:buChar char="•"/>
+            </a:pPr>
+            <a:r>
+              <a:rPr sz="1100">
+                <a:solidFill>
+                  <a:srgbClr val="475569"/>
+                </a:solidFill>
+                <a:latin typeface="+mn-lt"/>
+                <a:cs typeface="+mn-lt"/>
+              </a:rPr>
+              <a:t>Extract relationships map</a:t>
+            </a:r>
+          </a:p>
+        </p:txBody>
+      </p:sp>
+      <p:sp>
+        <p:nvSpPr>
+          <p:cNvPr id="7" name="Stage 2 Card"/>
+          <p:cNvSpPr/>
+          <p:nvPr/>
+        </p:nvSpPr>
+        <p:spPr>
           <a:xfrm>
             <a:off x="4572000" y="2011680"/>
             <a:ext cx="2926080" cy="3200400"/>
-            <a:chOff x="4572000" y="2011680"/>
-            <a:chExt cx="2926080" cy="3200400"/>
-          </a:xfrm>
-        </p:grpSpPr>
-        <p:sp>
-          <p:nvSpPr>
-            <p:cNvPr id="9" name="roundRect 1"/>
-            <p:cNvSpPr/>
-            <p:nvPr/>
-          </p:nvSpPr>
-          <p:spPr>
-            <a:xfrm>
-              <a:off x="4572000" y="2011680"/>
-              <a:ext cx="2926080" cy="3200400"/>
-            </a:xfrm>
-            <a:prstGeom prst="roundRect">
-              <a:avLst/>
-            </a:prstGeom>
-            <a:solidFill>
-              <a:srgbClr val="FFFFFF"/>
-            </a:solidFill>
-            <a:ln w="13716">
-              <a:solidFill>
-                <a:srgbClr val="6366F1"/>
-              </a:solidFill>
-            </a:ln>
-            <a:effectLst>
-              <a:outerShdw blurRad="109728" dist="38100" dir="5400000">
-                <a:srgbClr val="0F172A">
-                  <a:alpha val="10000"/>
-                </a:srgbClr>
-              </a:outerShdw>
-            </a:effectLst>
-          </p:spPr>
-          <p:txBody>
-            <a:bodyPr/>
-            <a:lstStyle/>
-            <a:p>
-              <a:endParaRPr/>
-            </a:p>
-          </p:txBody>
-        </p:sp>
-        <p:sp>
-          <p:nvSpPr>
-            <p:cNvPr id="10" name="roundRect 2"/>
-            <p:cNvSpPr/>
-            <p:nvPr/>
-          </p:nvSpPr>
-          <p:spPr>
-            <a:xfrm>
-              <a:off x="4846320" y="2286000"/>
-              <a:ext cx="2377440" cy="365760"/>
-            </a:xfrm>
-            <a:prstGeom prst="roundRect">
-              <a:avLst/>
-            </a:prstGeom>
+          </a:xfrm>
+          <a:prstGeom prst="roundRect">
+            <a:avLst/>
+          </a:prstGeom>
+          <a:solidFill>
+            <a:srgbClr val="FFFFFF"/>
+          </a:solidFill>
+          <a:ln w="13716">
             <a:solidFill>
               <a:srgbClr val="6366F1"/>
             </a:solidFill>
-          </p:spPr>
-          <p:txBody>
-            <a:bodyPr anchor="t"/>
-            <a:lstStyle/>
-            <a:p>
-              <a:pPr algn="ctr"/>
-              <a:r>
-                <a:rPr b="1" sz="1000">
-                  <a:solidFill>
-                    <a:srgbClr val="FFFFFF"/>
-                  </a:solidFill>
-                  <a:latin typeface="+mn-lt"/>
-                  <a:cs typeface="+mn-lt"/>
-                </a:rPr>
-                <a:t>STEP 2: MODELING</a:t>
-              </a:r>
-            </a:p>
-          </p:txBody>
-        </p:sp>
-        <p:sp>
-          <p:nvSpPr>
-            <p:cNvPr id="11" name="Text Box 3"/>
-            <p:cNvSpPr/>
-            <p:nvPr/>
-          </p:nvSpPr>
-          <p:spPr>
-            <a:xfrm>
-              <a:off x="4846320" y="2926080"/>
-              <a:ext cx="2377440" cy="1828800"/>
-            </a:xfrm>
-            <a:prstGeom prst="rect">
-              <a:avLst/>
-            </a:prstGeom>
-          </p:spPr>
-          <p:txBody>
-            <a:bodyPr anchor="t"/>
-            <a:lstStyle/>
-            <a:p>
-              <a:pPr algn="l" lvl="0" marL="152400" indent="-152400">
-                <a:buChar char="•"/>
-              </a:pPr>
-              <a:r>
-                <a:rPr sz="1100">
-                  <a:solidFill>
-                    <a:srgbClr val="475569"/>
-                  </a:solidFill>
-                  <a:latin typeface="+mn-lt"/>
-                  <a:cs typeface="+mn-lt"/>
-                </a:rPr>
-                <a:t>Type-safe AST generation</a:t>
-              </a:r>
-            </a:p>
-            <a:p>
-              <a:pPr algn="l" lvl="0" marL="152400" indent="-152400">
-                <a:buChar char="•"/>
-              </a:pPr>
-              <a:r>
-                <a:rPr sz="1100">
-                  <a:solidFill>
-                    <a:srgbClr val="475569"/>
-                  </a:solidFill>
-                  <a:latin typeface="+mn-lt"/>
-                  <a:cs typeface="+mn-lt"/>
-                </a:rPr>
-                <a:t>Layer &amp; placeholder cascade</a:t>
-              </a:r>
-            </a:p>
-            <a:p>
-              <a:pPr algn="l" lvl="0" marL="152400" indent="-152400">
-                <a:buChar char="•"/>
-              </a:pPr>
-              <a:r>
-                <a:rPr sz="1100">
-                  <a:solidFill>
-                    <a:srgbClr val="475569"/>
-                  </a:solidFill>
-                  <a:latin typeface="+mn-lt"/>
-                  <a:cs typeface="+mn-lt"/>
-                </a:rPr>
-                <a:t>Fluent mutations &amp; styling</a:t>
-              </a:r>
-            </a:p>
-          </p:txBody>
-        </p:sp>
-      </p:grpSp>
-      <p:grpSp>
-        <p:nvGrpSpPr>
-          <p:cNvPr id="12" name="Stage 3 Packaging Container"/>
-          <p:cNvGrpSpPr/>
-          <p:nvPr/>
-        </p:nvGrpSpPr>
-        <p:grpSpPr>
+          </a:ln>
+          <a:effectLst>
+            <a:outerShdw blurRad="109728" dist="38100" dir="5400000">
+              <a:srgbClr val="0F172A">
+                <a:alpha val="10000"/>
+              </a:srgbClr>
+            </a:outerShdw>
+          </a:effectLst>
+        </p:spPr>
+        <p:txBody>
+          <a:bodyPr/>
+          <a:lstStyle/>
+          <a:p>
+            <a:endParaRPr/>
+          </a:p>
+        </p:txBody>
+      </p:sp>
+      <p:sp>
+        <p:nvSpPr>
+          <p:cNvPr id="8" name="roundRect 7"/>
+          <p:cNvSpPr/>
+          <p:nvPr/>
+        </p:nvSpPr>
+        <p:spPr>
+          <a:xfrm>
+            <a:off x="4846320" y="2286000"/>
+            <a:ext cx="2377440" cy="365760"/>
+          </a:xfrm>
+          <a:prstGeom prst="roundRect">
+            <a:avLst/>
+          </a:prstGeom>
+          <a:solidFill>
+            <a:srgbClr val="6366F1"/>
+          </a:solidFill>
+        </p:spPr>
+        <p:txBody>
+          <a:bodyPr anchor="t"/>
+          <a:lstStyle/>
+          <a:p>
+            <a:pPr algn="ctr"/>
+            <a:r>
+              <a:rPr b="1" sz="1000">
+                <a:solidFill>
+                  <a:srgbClr val="FFFFFF"/>
+                </a:solidFill>
+                <a:latin typeface="+mn-lt"/>
+                <a:cs typeface="+mn-lt"/>
+              </a:rPr>
+              <a:t>STEP 2: MODELING</a:t>
+            </a:r>
+          </a:p>
+        </p:txBody>
+      </p:sp>
+      <p:sp>
+        <p:nvSpPr>
+          <p:cNvPr id="9" name="Text Box 8"/>
+          <p:cNvSpPr/>
+          <p:nvPr/>
+        </p:nvSpPr>
+        <p:spPr>
+          <a:xfrm>
+            <a:off x="4846320" y="2926080"/>
+            <a:ext cx="2377440" cy="1828800"/>
+          </a:xfrm>
+          <a:prstGeom prst="rect">
+            <a:avLst/>
+          </a:prstGeom>
+        </p:spPr>
+        <p:txBody>
+          <a:bodyPr anchor="t"/>
+          <a:lstStyle/>
+          <a:p>
+            <a:pPr algn="l" lvl="0" marL="152400" indent="-152400">
+              <a:buChar char="•"/>
+            </a:pPr>
+            <a:r>
+              <a:rPr sz="1100">
+                <a:solidFill>
+                  <a:srgbClr val="475569"/>
+                </a:solidFill>
+                <a:latin typeface="+mn-lt"/>
+                <a:cs typeface="+mn-lt"/>
+              </a:rPr>
+              <a:t>Type-safe AST generation</a:t>
+            </a:r>
+          </a:p>
+          <a:p>
+            <a:pPr algn="l" lvl="0" marL="152400" indent="-152400">
+              <a:buChar char="•"/>
+            </a:pPr>
+            <a:r>
+              <a:rPr sz="1100">
+                <a:solidFill>
+                  <a:srgbClr val="475569"/>
+                </a:solidFill>
+                <a:latin typeface="+mn-lt"/>
+                <a:cs typeface="+mn-lt"/>
+              </a:rPr>
+              <a:t>Layer &amp; placeholder cascade</a:t>
+            </a:r>
+          </a:p>
+          <a:p>
+            <a:pPr algn="l" lvl="0" marL="152400" indent="-152400">
+              <a:buChar char="•"/>
+            </a:pPr>
+            <a:r>
+              <a:rPr sz="1100">
+                <a:solidFill>
+                  <a:srgbClr val="475569"/>
+                </a:solidFill>
+                <a:latin typeface="+mn-lt"/>
+                <a:cs typeface="+mn-lt"/>
+              </a:rPr>
+              <a:t>Fluent mutations &amp; styling</a:t>
+            </a:r>
+          </a:p>
+        </p:txBody>
+      </p:sp>
+      <p:sp>
+        <p:nvSpPr>
+          <p:cNvPr id="10" name="Stage 3 Card"/>
+          <p:cNvSpPr/>
+          <p:nvPr/>
+        </p:nvSpPr>
+        <p:spPr>
           <a:xfrm>
             <a:off x="8229600" y="2011680"/>
             <a:ext cx="2926080" cy="3200400"/>
-            <a:chOff x="8229600" y="2011680"/>
-            <a:chExt cx="2926080" cy="3200400"/>
-          </a:xfrm>
-        </p:grpSpPr>
-        <p:sp>
-          <p:nvSpPr>
-            <p:cNvPr id="13" name="roundRect 1"/>
-            <p:cNvSpPr/>
-            <p:nvPr/>
-          </p:nvSpPr>
-          <p:spPr>
-            <a:xfrm>
-              <a:off x="8229600" y="2011680"/>
-              <a:ext cx="2926080" cy="3200400"/>
-            </a:xfrm>
-            <a:prstGeom prst="roundRect">
-              <a:avLst/>
-            </a:prstGeom>
-            <a:solidFill>
-              <a:srgbClr val="FFFFFF"/>
-            </a:solidFill>
-            <a:ln w="13716">
-              <a:solidFill>
-                <a:srgbClr val="10B981"/>
-              </a:solidFill>
-            </a:ln>
-            <a:effectLst>
-              <a:outerShdw blurRad="109728" dist="38100" dir="5400000">
-                <a:srgbClr val="0F172A">
-                  <a:alpha val="10000"/>
-                </a:srgbClr>
-              </a:outerShdw>
-            </a:effectLst>
-          </p:spPr>
-          <p:txBody>
-            <a:bodyPr/>
-            <a:lstStyle/>
-            <a:p>
-              <a:endParaRPr/>
-            </a:p>
-          </p:txBody>
-        </p:sp>
-        <p:sp>
-          <p:nvSpPr>
-            <p:cNvPr id="14" name="roundRect 2"/>
-            <p:cNvSpPr/>
-            <p:nvPr/>
-          </p:nvSpPr>
-          <p:spPr>
-            <a:xfrm>
-              <a:off x="8503920" y="2286000"/>
-              <a:ext cx="2377440" cy="365760"/>
-            </a:xfrm>
-            <a:prstGeom prst="roundRect">
-              <a:avLst/>
-            </a:prstGeom>
+          </a:xfrm>
+          <a:prstGeom prst="roundRect">
+            <a:avLst/>
+          </a:prstGeom>
+          <a:solidFill>
+            <a:srgbClr val="FFFFFF"/>
+          </a:solidFill>
+          <a:ln w="13716">
             <a:solidFill>
               <a:srgbClr val="10B981"/>
             </a:solidFill>
-          </p:spPr>
-          <p:txBody>
-            <a:bodyPr anchor="t"/>
-            <a:lstStyle/>
-            <a:p>
-              <a:pPr algn="ctr"/>
-              <a:r>
-                <a:rPr b="1" sz="1000">
-                  <a:solidFill>
-                    <a:srgbClr val="FFFFFF"/>
-                  </a:solidFill>
-                  <a:latin typeface="+mn-lt"/>
-                  <a:cs typeface="+mn-lt"/>
-                </a:rPr>
-                <a:t>STEP 3: COMPILATION</a:t>
-              </a:r>
-            </a:p>
-          </p:txBody>
-        </p:sp>
-        <p:sp>
-          <p:nvSpPr>
-            <p:cNvPr id="15" name="Text Box 3"/>
-            <p:cNvSpPr/>
-            <p:nvPr/>
-          </p:nvSpPr>
-          <p:spPr>
-            <a:xfrm>
-              <a:off x="8503920" y="2926080"/>
-              <a:ext cx="2377440" cy="1828800"/>
-            </a:xfrm>
-            <a:prstGeom prst="rect">
-              <a:avLst/>
-            </a:prstGeom>
-          </p:spPr>
-          <p:txBody>
-            <a:bodyPr anchor="t"/>
-            <a:lstStyle/>
-            <a:p>
-              <a:pPr algn="l" lvl="0" marL="152400" indent="-152400">
-                <a:buChar char="•"/>
-              </a:pPr>
-              <a:r>
-                <a:rPr sz="1100">
-                  <a:solidFill>
-                    <a:srgbClr val="475569"/>
-                  </a:solidFill>
-                  <a:latin typeface="+mn-lt"/>
-                  <a:cs typeface="+mn-lt"/>
-                </a:rPr>
-                <a:t>Deterministic XML emission</a:t>
-              </a:r>
-            </a:p>
-            <a:p>
-              <a:pPr algn="l" lvl="0" marL="152400" indent="-152400">
-                <a:buChar char="•"/>
-              </a:pPr>
-              <a:r>
-                <a:rPr sz="1100">
-                  <a:solidFill>
-                    <a:srgbClr val="475569"/>
-                  </a:solidFill>
-                  <a:latin typeface="+mn-lt"/>
-                  <a:cs typeface="+mn-lt"/>
-                </a:rPr>
-                <a:t>Zero-copy fflate compression</a:t>
-              </a:r>
-            </a:p>
-            <a:p>
-              <a:pPr algn="l" lvl="0" marL="152400" indent="-152400">
-                <a:buChar char="•"/>
-              </a:pPr>
-              <a:r>
-                <a:rPr sz="1100">
-                  <a:solidFill>
-                    <a:srgbClr val="475569"/>
-                  </a:solidFill>
-                  <a:latin typeface="+mn-lt"/>
-                  <a:cs typeface="+mn-lt"/>
-                </a:rPr>
-                <a:t>ECMA-376 compliant PPTX</a:t>
-              </a:r>
-            </a:p>
-          </p:txBody>
-        </p:sp>
-      </p:grpSp>
+          </a:ln>
+          <a:effectLst>
+            <a:outerShdw blurRad="109728" dist="38100" dir="5400000">
+              <a:srgbClr val="0F172A">
+                <a:alpha val="10000"/>
+              </a:srgbClr>
+            </a:outerShdw>
+          </a:effectLst>
+        </p:spPr>
+        <p:txBody>
+          <a:bodyPr/>
+          <a:lstStyle/>
+          <a:p>
+            <a:endParaRPr/>
+          </a:p>
+        </p:txBody>
+      </p:sp>
+      <p:sp>
+        <p:nvSpPr>
+          <p:cNvPr id="11" name="roundRect 10"/>
+          <p:cNvSpPr/>
+          <p:nvPr/>
+        </p:nvSpPr>
+        <p:spPr>
+          <a:xfrm>
+            <a:off x="8503920" y="2286000"/>
+            <a:ext cx="2377440" cy="365760"/>
+          </a:xfrm>
+          <a:prstGeom prst="roundRect">
+            <a:avLst/>
+          </a:prstGeom>
+          <a:solidFill>
+            <a:srgbClr val="10B981"/>
+          </a:solidFill>
+        </p:spPr>
+        <p:txBody>
+          <a:bodyPr anchor="t"/>
+          <a:lstStyle/>
+          <a:p>
+            <a:pPr algn="ctr"/>
+            <a:r>
+              <a:rPr b="1" sz="1000">
+                <a:solidFill>
+                  <a:srgbClr val="FFFFFF"/>
+                </a:solidFill>
+                <a:latin typeface="+mn-lt"/>
+                <a:cs typeface="+mn-lt"/>
+              </a:rPr>
+              <a:t>STEP 3: COMPILATION</a:t>
+            </a:r>
+          </a:p>
+        </p:txBody>
+      </p:sp>
+      <p:sp>
+        <p:nvSpPr>
+          <p:cNvPr id="12" name="Text Box 11"/>
+          <p:cNvSpPr/>
+          <p:nvPr/>
+        </p:nvSpPr>
+        <p:spPr>
+          <a:xfrm>
+            <a:off x="8503920" y="2926080"/>
+            <a:ext cx="2377440" cy="1828800"/>
+          </a:xfrm>
+          <a:prstGeom prst="rect">
+            <a:avLst/>
+          </a:prstGeom>
+        </p:spPr>
+        <p:txBody>
+          <a:bodyPr anchor="t"/>
+          <a:lstStyle/>
+          <a:p>
+            <a:pPr algn="l" lvl="0" marL="152400" indent="-152400">
+              <a:buChar char="•"/>
+            </a:pPr>
+            <a:r>
+              <a:rPr sz="1100">
+                <a:solidFill>
+                  <a:srgbClr val="475569"/>
+                </a:solidFill>
+                <a:latin typeface="+mn-lt"/>
+                <a:cs typeface="+mn-lt"/>
+              </a:rPr>
+              <a:t>Deterministic XML emission</a:t>
+            </a:r>
+          </a:p>
+          <a:p>
+            <a:pPr algn="l" lvl="0" marL="152400" indent="-152400">
+              <a:buChar char="•"/>
+            </a:pPr>
+            <a:r>
+              <a:rPr sz="1100">
+                <a:solidFill>
+                  <a:srgbClr val="475569"/>
+                </a:solidFill>
+                <a:latin typeface="+mn-lt"/>
+                <a:cs typeface="+mn-lt"/>
+              </a:rPr>
+              <a:t>Zero-copy fflate compression</a:t>
+            </a:r>
+          </a:p>
+          <a:p>
+            <a:pPr algn="l" lvl="0" marL="152400" indent="-152400">
+              <a:buChar char="•"/>
+            </a:pPr>
+            <a:r>
+              <a:rPr sz="1100">
+                <a:solidFill>
+                  <a:srgbClr val="475569"/>
+                </a:solidFill>
+                <a:latin typeface="+mn-lt"/>
+                <a:cs typeface="+mn-lt"/>
+              </a:rPr>
+              <a:t>ECMA-376 compliant PPTX</a:t>
+            </a:r>
+          </a:p>
+        </p:txBody>
+      </p:sp>
+      <p:sp>
+        <p:nvSpPr>
+          <p:cNvPr id="16" name="Text Box 15"/>
+          <p:cNvSpPr/>
+          <p:nvPr/>
+        </p:nvSpPr>
+        <p:spPr>
+          <a:xfrm>
+            <a:off x="914400" y="5806440"/>
+            <a:ext cx="10241280" cy="365760"/>
+          </a:xfrm>
+          <a:prstGeom prst="rect">
+            <a:avLst/>
+          </a:prstGeom>
+        </p:spPr>
+        <p:txBody>
+          <a:bodyPr anchor="t"/>
+          <a:lstStyle/>
+          <a:p>
+            <a:pPr algn="ctr"/>
+            <a:r>
+              <a:rPr sz="1100">
+                <a:solidFill>
+                  <a:srgbClr val="64748B"/>
+                </a:solidFill>
+                <a:latin typeface="+mn-lt"/>
+                <a:cs typeface="+mn-lt"/>
+              </a:rPr>
+              <a:t>Isomorphic Pipeline Feedback Loop: 100% Roundtrip Bit-Exact Precision</a:t>
+            </a:r>
+          </a:p>
+        </p:txBody>
+      </p:sp>
+      <p:sp>
+        <p:nvSpPr>
+          <p:cNvPr id="17" name="Text Box 16"/>
+          <p:cNvSpPr/>
+          <p:nvPr/>
+        </p:nvSpPr>
+        <p:spPr>
+          <a:xfrm>
+            <a:off x="731520" y="6510528"/>
+            <a:ext cx="10725912" cy="228600"/>
+          </a:xfrm>
+          <a:prstGeom prst="rect">
+            <a:avLst/>
+          </a:prstGeom>
+        </p:spPr>
+        <p:txBody>
+          <a:bodyPr anchor="t"/>
+          <a:lstStyle/>
+          <a:p>
+            <a:pPr algn="ctr"/>
+            <a:r>
+              <a:rPr i="1" sz="800">
+                <a:solidFill>
+                  <a:srgbClr val="94A3B8"/>
+                </a:solidFill>
+                <a:latin typeface="+mn-lt"/>
+                <a:cs typeface="+mn-lt"/>
+              </a:rPr>
+              <a:t>* Disclaimer: All benchmark metrics, performance figures, and simulated architectures in this deck are synthetic demonstration values generated solely to showcase the authoring, formatting, and rendering capabilities of @hokkyss/pptx.</a:t>
+            </a:r>
+          </a:p>
+        </p:txBody>
+      </p:sp>
       <p:cxnSp>
         <p:nvCxnSpPr>
-          <p:cNvPr id="16" name="Connector 3"/>
+          <p:cNvPr id="13" name="Connector 12"/>
           <p:cNvCxnSpPr>
+            <a:cxnSpLocks/>
             <a:stCxn id="4" idx="3"/>
-            <a:endCxn id="8" idx="1"/>
+            <a:endCxn id="7" idx="1"/>
           </p:cNvCxnSpPr>
           <p:nvPr/>
         </p:nvCxnSpPr>
         <p:spPr>
           <a:xfrm>
             <a:off x="3840480" y="3611880"/>
-            <a:ext cx="731520" cy="1"/>
+            <a:ext cx="731520" cy="0"/>
           </a:xfrm>
           <a:prstGeom prst="line">
             <a:avLst/>
@@ -11177,17 +11133,18 @@
       </p:cxnSp>
       <p:cxnSp>
         <p:nvCxnSpPr>
-          <p:cNvPr id="17" name="Connector 4"/>
+          <p:cNvPr id="14" name="Connector 13"/>
           <p:cNvCxnSpPr>
-            <a:stCxn id="8" idx="3"/>
-            <a:endCxn id="12" idx="1"/>
+            <a:cxnSpLocks/>
+            <a:stCxn id="7" idx="3"/>
+            <a:endCxn id="10" idx="1"/>
           </p:cNvCxnSpPr>
           <p:nvPr/>
         </p:nvCxnSpPr>
         <p:spPr>
           <a:xfrm>
             <a:off x="7498080" y="3611880"/>
-            <a:ext cx="731520" cy="1"/>
+            <a:ext cx="731520" cy="0"/>
           </a:xfrm>
           <a:prstGeom prst="line">
             <a:avLst/>
@@ -11203,14 +11160,16 @@
       </p:cxnSp>
       <p:cxnSp>
         <p:nvCxnSpPr>
-          <p:cNvPr id="18" name="Connector 5"/>
-          <p:cNvCxnSpPr/>
+          <p:cNvPr id="15" name="Connector 14"/>
+          <p:cNvCxnSpPr>
+            <a:cxnSpLocks/>
+          </p:cNvCxnSpPr>
           <p:nvPr/>
         </p:nvCxnSpPr>
         <p:spPr>
           <a:xfrm>
             <a:off x="914400" y="5669280"/>
-            <a:ext cx="10241280" cy="1"/>
+            <a:ext cx="10241280" cy="0"/>
           </a:xfrm>
           <a:prstGeom prst="line">
             <a:avLst/>

</xml_diff>

<commit_message>
feat(connectors): support recursive shape lookup inside groups & group Slide 8 pipeline cards
- resolveEndpoint now recursively searches inside group children for shapeId
- Slide 8 cards are composite groups (addGroup) with connector attached to the card background shape
- moving the group in PowerPoint now moves the whole card and smoothly stretches the connector
</commit_message>
<xml_diff>
--- a/hokkyss_showcase_deck.pptx
+++ b/hokkyss_showcase_deck.pptx
@@ -10623,494 +10623,539 @@
       </p:sp>
       <p:sp>
         <p:nvSpPr>
-          <p:cNvPr id="4" name="Stage 1 Card"/>
-          <p:cNvSpPr/>
-          <p:nvPr/>
-        </p:nvSpPr>
-        <p:spPr>
+          <p:cNvPr id="19" name="Text Box 9"/>
+          <p:cNvSpPr/>
+          <p:nvPr/>
+        </p:nvSpPr>
+        <p:spPr>
+          <a:xfrm>
+            <a:off x="914400" y="5806440"/>
+            <a:ext cx="10241280" cy="365760"/>
+          </a:xfrm>
+          <a:prstGeom prst="rect">
+            <a:avLst/>
+          </a:prstGeom>
+        </p:spPr>
+        <p:txBody>
+          <a:bodyPr anchor="t"/>
+          <a:lstStyle/>
+          <a:p>
+            <a:pPr algn="ctr"/>
+            <a:r>
+              <a:rPr sz="1100">
+                <a:solidFill>
+                  <a:srgbClr val="64748B"/>
+                </a:solidFill>
+                <a:latin typeface="+mn-lt"/>
+                <a:cs typeface="+mn-lt"/>
+              </a:rPr>
+              <a:t>Isomorphic Pipeline Feedback Loop: 100% Roundtrip Bit-Exact Precision</a:t>
+            </a:r>
+          </a:p>
+        </p:txBody>
+      </p:sp>
+      <p:sp>
+        <p:nvSpPr>
+          <p:cNvPr id="20" name="Text Box 10"/>
+          <p:cNvSpPr/>
+          <p:nvPr/>
+        </p:nvSpPr>
+        <p:spPr>
+          <a:xfrm>
+            <a:off x="731520" y="6510528"/>
+            <a:ext cx="10725912" cy="228600"/>
+          </a:xfrm>
+          <a:prstGeom prst="rect">
+            <a:avLst/>
+          </a:prstGeom>
+        </p:spPr>
+        <p:txBody>
+          <a:bodyPr anchor="t"/>
+          <a:lstStyle/>
+          <a:p>
+            <a:pPr algn="ctr"/>
+            <a:r>
+              <a:rPr i="1" sz="800">
+                <a:solidFill>
+                  <a:srgbClr val="94A3B8"/>
+                </a:solidFill>
+                <a:latin typeface="+mn-lt"/>
+                <a:cs typeface="+mn-lt"/>
+              </a:rPr>
+              <a:t>* Disclaimer: All benchmark metrics, performance figures, and simulated architectures in this deck are synthetic demonstration values generated solely to showcase the authoring, formatting, and rendering capabilities of @hokkyss/pptx.</a:t>
+            </a:r>
+          </a:p>
+        </p:txBody>
+      </p:sp>
+      <p:grpSp>
+        <p:nvGrpSpPr>
+          <p:cNvPr id="4" name="Stage 1 Ingress Container"/>
+          <p:cNvGrpSpPr/>
+          <p:nvPr/>
+        </p:nvGrpSpPr>
+        <p:grpSpPr>
           <a:xfrm>
             <a:off x="914400" y="2011680"/>
             <a:ext cx="2926080" cy="3200400"/>
-          </a:xfrm>
-          <a:prstGeom prst="roundRect">
-            <a:avLst/>
-          </a:prstGeom>
-          <a:solidFill>
-            <a:srgbClr val="FFFFFF"/>
-          </a:solidFill>
-          <a:ln w="13716">
+            <a:chOff x="914400" y="2011680"/>
+            <a:chExt cx="2926080" cy="3200400"/>
+          </a:xfrm>
+        </p:grpSpPr>
+        <p:sp>
+          <p:nvSpPr>
+            <p:cNvPr id="5" name="Stage 1 Background"/>
+            <p:cNvSpPr/>
+            <p:nvPr/>
+          </p:nvSpPr>
+          <p:spPr>
+            <a:xfrm>
+              <a:off x="914400" y="2011680"/>
+              <a:ext cx="2926080" cy="3200400"/>
+            </a:xfrm>
+            <a:prstGeom prst="roundRect">
+              <a:avLst/>
+            </a:prstGeom>
+            <a:solidFill>
+              <a:srgbClr val="FFFFFF"/>
+            </a:solidFill>
+            <a:ln w="13716">
+              <a:solidFill>
+                <a:srgbClr val="0284C7"/>
+              </a:solidFill>
+            </a:ln>
+            <a:effectLst>
+              <a:outerShdw blurRad="109728" dist="38100" dir="5400000">
+                <a:srgbClr val="0F172A">
+                  <a:alpha val="10000"/>
+                </a:srgbClr>
+              </a:outerShdw>
+            </a:effectLst>
+          </p:spPr>
+          <p:txBody>
+            <a:bodyPr/>
+            <a:lstStyle/>
+            <a:p>
+              <a:endParaRPr/>
+            </a:p>
+          </p:txBody>
+        </p:sp>
+        <p:sp>
+          <p:nvSpPr>
+            <p:cNvPr id="6" name="roundRect 2"/>
+            <p:cNvSpPr/>
+            <p:nvPr/>
+          </p:nvSpPr>
+          <p:spPr>
+            <a:xfrm>
+              <a:off x="1188720" y="2286000"/>
+              <a:ext cx="2377440" cy="365760"/>
+            </a:xfrm>
+            <a:prstGeom prst="roundRect">
+              <a:avLst/>
+            </a:prstGeom>
             <a:solidFill>
               <a:srgbClr val="0284C7"/>
             </a:solidFill>
-          </a:ln>
-          <a:effectLst>
-            <a:outerShdw blurRad="109728" dist="38100" dir="5400000">
-              <a:srgbClr val="0F172A">
-                <a:alpha val="10000"/>
-              </a:srgbClr>
-            </a:outerShdw>
-          </a:effectLst>
-        </p:spPr>
-        <p:txBody>
-          <a:bodyPr/>
-          <a:lstStyle/>
-          <a:p>
-            <a:endParaRPr/>
-          </a:p>
-        </p:txBody>
-      </p:sp>
-      <p:sp>
-        <p:nvSpPr>
-          <p:cNvPr id="5" name="roundRect 4"/>
-          <p:cNvSpPr/>
-          <p:nvPr/>
-        </p:nvSpPr>
-        <p:spPr>
-          <a:xfrm>
-            <a:off x="1188720" y="2286000"/>
-            <a:ext cx="2377440" cy="365760"/>
-          </a:xfrm>
-          <a:prstGeom prst="roundRect">
-            <a:avLst/>
-          </a:prstGeom>
-          <a:solidFill>
-            <a:srgbClr val="0284C7"/>
-          </a:solidFill>
-        </p:spPr>
-        <p:txBody>
-          <a:bodyPr anchor="t"/>
-          <a:lstStyle/>
-          <a:p>
-            <a:pPr algn="ctr"/>
-            <a:r>
-              <a:rPr b="1" sz="1000">
-                <a:solidFill>
-                  <a:srgbClr val="FFFFFF"/>
-                </a:solidFill>
-                <a:latin typeface="+mn-lt"/>
-                <a:cs typeface="+mn-lt"/>
-              </a:rPr>
-              <a:t>STEP 1: INGESTION</a:t>
-            </a:r>
-          </a:p>
-        </p:txBody>
-      </p:sp>
-      <p:sp>
-        <p:nvSpPr>
-          <p:cNvPr id="6" name="Text Box 5"/>
-          <p:cNvSpPr/>
-          <p:nvPr/>
-        </p:nvSpPr>
-        <p:spPr>
-          <a:xfrm>
-            <a:off x="1188720" y="2926080"/>
-            <a:ext cx="2377440" cy="1828800"/>
-          </a:xfrm>
-          <a:prstGeom prst="rect">
-            <a:avLst/>
-          </a:prstGeom>
-        </p:spPr>
-        <p:txBody>
-          <a:bodyPr anchor="t"/>
-          <a:lstStyle/>
-          <a:p>
-            <a:pPr algn="l" lvl="0" marL="152400" indent="-152400">
-              <a:buChar char="•"/>
-            </a:pPr>
-            <a:r>
-              <a:rPr sz="1100">
-                <a:solidFill>
-                  <a:srgbClr val="475569"/>
-                </a:solidFill>
-                <a:latin typeface="+mn-lt"/>
-                <a:cs typeface="+mn-lt"/>
-              </a:rPr>
-              <a:t>Streaming ZIP decompression</a:t>
-            </a:r>
-          </a:p>
-          <a:p>
-            <a:pPr algn="l" lvl="0" marL="152400" indent="-152400">
-              <a:buChar char="•"/>
-            </a:pPr>
-            <a:r>
-              <a:rPr sz="1100">
-                <a:solidFill>
-                  <a:srgbClr val="475569"/>
-                </a:solidFill>
-                <a:latin typeface="+mn-lt"/>
-                <a:cs typeface="+mn-lt"/>
-              </a:rPr>
-              <a:t>XML DOM part resolution</a:t>
-            </a:r>
-          </a:p>
-          <a:p>
-            <a:pPr algn="l" lvl="0" marL="152400" indent="-152400">
-              <a:buChar char="•"/>
-            </a:pPr>
-            <a:r>
-              <a:rPr sz="1100">
-                <a:solidFill>
-                  <a:srgbClr val="475569"/>
-                </a:solidFill>
-                <a:latin typeface="+mn-lt"/>
-                <a:cs typeface="+mn-lt"/>
-              </a:rPr>
-              <a:t>Extract relationships map</a:t>
-            </a:r>
-          </a:p>
-        </p:txBody>
-      </p:sp>
-      <p:sp>
-        <p:nvSpPr>
-          <p:cNvPr id="7" name="Stage 2 Card"/>
-          <p:cNvSpPr/>
-          <p:nvPr/>
-        </p:nvSpPr>
-        <p:spPr>
+          </p:spPr>
+          <p:txBody>
+            <a:bodyPr anchor="t"/>
+            <a:lstStyle/>
+            <a:p>
+              <a:pPr algn="ctr"/>
+              <a:r>
+                <a:rPr b="1" sz="1000">
+                  <a:solidFill>
+                    <a:srgbClr val="FFFFFF"/>
+                  </a:solidFill>
+                  <a:latin typeface="+mn-lt"/>
+                  <a:cs typeface="+mn-lt"/>
+                </a:rPr>
+                <a:t>STEP 1: INGESTION</a:t>
+              </a:r>
+            </a:p>
+          </p:txBody>
+        </p:sp>
+        <p:sp>
+          <p:nvSpPr>
+            <p:cNvPr id="7" name="Text Box 3"/>
+            <p:cNvSpPr/>
+            <p:nvPr/>
+          </p:nvSpPr>
+          <p:spPr>
+            <a:xfrm>
+              <a:off x="1188720" y="2926080"/>
+              <a:ext cx="2377440" cy="1828800"/>
+            </a:xfrm>
+            <a:prstGeom prst="rect">
+              <a:avLst/>
+            </a:prstGeom>
+          </p:spPr>
+          <p:txBody>
+            <a:bodyPr anchor="t"/>
+            <a:lstStyle/>
+            <a:p>
+              <a:pPr algn="l" lvl="0" marL="152400" indent="-152400">
+                <a:buChar char="•"/>
+              </a:pPr>
+              <a:r>
+                <a:rPr sz="1100">
+                  <a:solidFill>
+                    <a:srgbClr val="475569"/>
+                  </a:solidFill>
+                  <a:latin typeface="+mn-lt"/>
+                  <a:cs typeface="+mn-lt"/>
+                </a:rPr>
+                <a:t>Streaming ZIP decompression</a:t>
+              </a:r>
+            </a:p>
+            <a:p>
+              <a:pPr algn="l" lvl="0" marL="152400" indent="-152400">
+                <a:buChar char="•"/>
+              </a:pPr>
+              <a:r>
+                <a:rPr sz="1100">
+                  <a:solidFill>
+                    <a:srgbClr val="475569"/>
+                  </a:solidFill>
+                  <a:latin typeface="+mn-lt"/>
+                  <a:cs typeface="+mn-lt"/>
+                </a:rPr>
+                <a:t>XML DOM part resolution</a:t>
+              </a:r>
+            </a:p>
+            <a:p>
+              <a:pPr algn="l" lvl="0" marL="152400" indent="-152400">
+                <a:buChar char="•"/>
+              </a:pPr>
+              <a:r>
+                <a:rPr sz="1100">
+                  <a:solidFill>
+                    <a:srgbClr val="475569"/>
+                  </a:solidFill>
+                  <a:latin typeface="+mn-lt"/>
+                  <a:cs typeface="+mn-lt"/>
+                </a:rPr>
+                <a:t>Extract relationships map</a:t>
+              </a:r>
+            </a:p>
+          </p:txBody>
+        </p:sp>
+      </p:grpSp>
+      <p:grpSp>
+        <p:nvGrpSpPr>
+          <p:cNvPr id="8" name="Stage 2 AST Container"/>
+          <p:cNvGrpSpPr/>
+          <p:nvPr/>
+        </p:nvGrpSpPr>
+        <p:grpSpPr>
           <a:xfrm>
             <a:off x="4572000" y="2011680"/>
             <a:ext cx="2926080" cy="3200400"/>
-          </a:xfrm>
-          <a:prstGeom prst="roundRect">
-            <a:avLst/>
-          </a:prstGeom>
-          <a:solidFill>
-            <a:srgbClr val="FFFFFF"/>
-          </a:solidFill>
-          <a:ln w="13716">
+            <a:chOff x="4572000" y="2011680"/>
+            <a:chExt cx="2926080" cy="3200400"/>
+          </a:xfrm>
+        </p:grpSpPr>
+        <p:sp>
+          <p:nvSpPr>
+            <p:cNvPr id="9" name="Stage 2 Background"/>
+            <p:cNvSpPr/>
+            <p:nvPr/>
+          </p:nvSpPr>
+          <p:spPr>
+            <a:xfrm>
+              <a:off x="4572000" y="2011680"/>
+              <a:ext cx="2926080" cy="3200400"/>
+            </a:xfrm>
+            <a:prstGeom prst="roundRect">
+              <a:avLst/>
+            </a:prstGeom>
+            <a:solidFill>
+              <a:srgbClr val="FFFFFF"/>
+            </a:solidFill>
+            <a:ln w="13716">
+              <a:solidFill>
+                <a:srgbClr val="6366F1"/>
+              </a:solidFill>
+            </a:ln>
+            <a:effectLst>
+              <a:outerShdw blurRad="109728" dist="38100" dir="5400000">
+                <a:srgbClr val="0F172A">
+                  <a:alpha val="10000"/>
+                </a:srgbClr>
+              </a:outerShdw>
+            </a:effectLst>
+          </p:spPr>
+          <p:txBody>
+            <a:bodyPr/>
+            <a:lstStyle/>
+            <a:p>
+              <a:endParaRPr/>
+            </a:p>
+          </p:txBody>
+        </p:sp>
+        <p:sp>
+          <p:nvSpPr>
+            <p:cNvPr id="10" name="roundRect 2"/>
+            <p:cNvSpPr/>
+            <p:nvPr/>
+          </p:nvSpPr>
+          <p:spPr>
+            <a:xfrm>
+              <a:off x="4846320" y="2286000"/>
+              <a:ext cx="2377440" cy="365760"/>
+            </a:xfrm>
+            <a:prstGeom prst="roundRect">
+              <a:avLst/>
+            </a:prstGeom>
             <a:solidFill>
               <a:srgbClr val="6366F1"/>
             </a:solidFill>
-          </a:ln>
-          <a:effectLst>
-            <a:outerShdw blurRad="109728" dist="38100" dir="5400000">
-              <a:srgbClr val="0F172A">
-                <a:alpha val="10000"/>
-              </a:srgbClr>
-            </a:outerShdw>
-          </a:effectLst>
-        </p:spPr>
-        <p:txBody>
-          <a:bodyPr/>
-          <a:lstStyle/>
-          <a:p>
-            <a:endParaRPr/>
-          </a:p>
-        </p:txBody>
-      </p:sp>
-      <p:sp>
-        <p:nvSpPr>
-          <p:cNvPr id="8" name="roundRect 7"/>
-          <p:cNvSpPr/>
-          <p:nvPr/>
-        </p:nvSpPr>
-        <p:spPr>
-          <a:xfrm>
-            <a:off x="4846320" y="2286000"/>
-            <a:ext cx="2377440" cy="365760"/>
-          </a:xfrm>
-          <a:prstGeom prst="roundRect">
-            <a:avLst/>
-          </a:prstGeom>
-          <a:solidFill>
-            <a:srgbClr val="6366F1"/>
-          </a:solidFill>
-        </p:spPr>
-        <p:txBody>
-          <a:bodyPr anchor="t"/>
-          <a:lstStyle/>
-          <a:p>
-            <a:pPr algn="ctr"/>
-            <a:r>
-              <a:rPr b="1" sz="1000">
-                <a:solidFill>
-                  <a:srgbClr val="FFFFFF"/>
-                </a:solidFill>
-                <a:latin typeface="+mn-lt"/>
-                <a:cs typeface="+mn-lt"/>
-              </a:rPr>
-              <a:t>STEP 2: MODELING</a:t>
-            </a:r>
-          </a:p>
-        </p:txBody>
-      </p:sp>
-      <p:sp>
-        <p:nvSpPr>
-          <p:cNvPr id="9" name="Text Box 8"/>
-          <p:cNvSpPr/>
-          <p:nvPr/>
-        </p:nvSpPr>
-        <p:spPr>
-          <a:xfrm>
-            <a:off x="4846320" y="2926080"/>
-            <a:ext cx="2377440" cy="1828800"/>
-          </a:xfrm>
-          <a:prstGeom prst="rect">
-            <a:avLst/>
-          </a:prstGeom>
-        </p:spPr>
-        <p:txBody>
-          <a:bodyPr anchor="t"/>
-          <a:lstStyle/>
-          <a:p>
-            <a:pPr algn="l" lvl="0" marL="152400" indent="-152400">
-              <a:buChar char="•"/>
-            </a:pPr>
-            <a:r>
-              <a:rPr sz="1100">
-                <a:solidFill>
-                  <a:srgbClr val="475569"/>
-                </a:solidFill>
-                <a:latin typeface="+mn-lt"/>
-                <a:cs typeface="+mn-lt"/>
-              </a:rPr>
-              <a:t>Type-safe AST generation</a:t>
-            </a:r>
-          </a:p>
-          <a:p>
-            <a:pPr algn="l" lvl="0" marL="152400" indent="-152400">
-              <a:buChar char="•"/>
-            </a:pPr>
-            <a:r>
-              <a:rPr sz="1100">
-                <a:solidFill>
-                  <a:srgbClr val="475569"/>
-                </a:solidFill>
-                <a:latin typeface="+mn-lt"/>
-                <a:cs typeface="+mn-lt"/>
-              </a:rPr>
-              <a:t>Layer &amp; placeholder cascade</a:t>
-            </a:r>
-          </a:p>
-          <a:p>
-            <a:pPr algn="l" lvl="0" marL="152400" indent="-152400">
-              <a:buChar char="•"/>
-            </a:pPr>
-            <a:r>
-              <a:rPr sz="1100">
-                <a:solidFill>
-                  <a:srgbClr val="475569"/>
-                </a:solidFill>
-                <a:latin typeface="+mn-lt"/>
-                <a:cs typeface="+mn-lt"/>
-              </a:rPr>
-              <a:t>Fluent mutations &amp; styling</a:t>
-            </a:r>
-          </a:p>
-        </p:txBody>
-      </p:sp>
-      <p:sp>
-        <p:nvSpPr>
-          <p:cNvPr id="10" name="Stage 3 Card"/>
-          <p:cNvSpPr/>
-          <p:nvPr/>
-        </p:nvSpPr>
-        <p:spPr>
+          </p:spPr>
+          <p:txBody>
+            <a:bodyPr anchor="t"/>
+            <a:lstStyle/>
+            <a:p>
+              <a:pPr algn="ctr"/>
+              <a:r>
+                <a:rPr b="1" sz="1000">
+                  <a:solidFill>
+                    <a:srgbClr val="FFFFFF"/>
+                  </a:solidFill>
+                  <a:latin typeface="+mn-lt"/>
+                  <a:cs typeface="+mn-lt"/>
+                </a:rPr>
+                <a:t>STEP 2: MODELING</a:t>
+              </a:r>
+            </a:p>
+          </p:txBody>
+        </p:sp>
+        <p:sp>
+          <p:nvSpPr>
+            <p:cNvPr id="11" name="Text Box 3"/>
+            <p:cNvSpPr/>
+            <p:nvPr/>
+          </p:nvSpPr>
+          <p:spPr>
+            <a:xfrm>
+              <a:off x="4846320" y="2926080"/>
+              <a:ext cx="2377440" cy="1828800"/>
+            </a:xfrm>
+            <a:prstGeom prst="rect">
+              <a:avLst/>
+            </a:prstGeom>
+          </p:spPr>
+          <p:txBody>
+            <a:bodyPr anchor="t"/>
+            <a:lstStyle/>
+            <a:p>
+              <a:pPr algn="l" lvl="0" marL="152400" indent="-152400">
+                <a:buChar char="•"/>
+              </a:pPr>
+              <a:r>
+                <a:rPr sz="1100">
+                  <a:solidFill>
+                    <a:srgbClr val="475569"/>
+                  </a:solidFill>
+                  <a:latin typeface="+mn-lt"/>
+                  <a:cs typeface="+mn-lt"/>
+                </a:rPr>
+                <a:t>Type-safe AST generation</a:t>
+              </a:r>
+            </a:p>
+            <a:p>
+              <a:pPr algn="l" lvl="0" marL="152400" indent="-152400">
+                <a:buChar char="•"/>
+              </a:pPr>
+              <a:r>
+                <a:rPr sz="1100">
+                  <a:solidFill>
+                    <a:srgbClr val="475569"/>
+                  </a:solidFill>
+                  <a:latin typeface="+mn-lt"/>
+                  <a:cs typeface="+mn-lt"/>
+                </a:rPr>
+                <a:t>Layer &amp; placeholder cascade</a:t>
+              </a:r>
+            </a:p>
+            <a:p>
+              <a:pPr algn="l" lvl="0" marL="152400" indent="-152400">
+                <a:buChar char="•"/>
+              </a:pPr>
+              <a:r>
+                <a:rPr sz="1100">
+                  <a:solidFill>
+                    <a:srgbClr val="475569"/>
+                  </a:solidFill>
+                  <a:latin typeface="+mn-lt"/>
+                  <a:cs typeface="+mn-lt"/>
+                </a:rPr>
+                <a:t>Fluent mutations &amp; styling</a:t>
+              </a:r>
+            </a:p>
+          </p:txBody>
+        </p:sp>
+      </p:grpSp>
+      <p:grpSp>
+        <p:nvGrpSpPr>
+          <p:cNvPr id="12" name="Stage 3 Packaging Container"/>
+          <p:cNvGrpSpPr/>
+          <p:nvPr/>
+        </p:nvGrpSpPr>
+        <p:grpSpPr>
           <a:xfrm>
             <a:off x="8229600" y="2011680"/>
             <a:ext cx="2926080" cy="3200400"/>
-          </a:xfrm>
-          <a:prstGeom prst="roundRect">
-            <a:avLst/>
-          </a:prstGeom>
-          <a:solidFill>
-            <a:srgbClr val="FFFFFF"/>
-          </a:solidFill>
-          <a:ln w="13716">
+            <a:chOff x="8229600" y="2011680"/>
+            <a:chExt cx="2926080" cy="3200400"/>
+          </a:xfrm>
+        </p:grpSpPr>
+        <p:sp>
+          <p:nvSpPr>
+            <p:cNvPr id="13" name="Stage 3 Background"/>
+            <p:cNvSpPr/>
+            <p:nvPr/>
+          </p:nvSpPr>
+          <p:spPr>
+            <a:xfrm>
+              <a:off x="8229600" y="2011680"/>
+              <a:ext cx="2926080" cy="3200400"/>
+            </a:xfrm>
+            <a:prstGeom prst="roundRect">
+              <a:avLst/>
+            </a:prstGeom>
+            <a:solidFill>
+              <a:srgbClr val="FFFFFF"/>
+            </a:solidFill>
+            <a:ln w="13716">
+              <a:solidFill>
+                <a:srgbClr val="10B981"/>
+              </a:solidFill>
+            </a:ln>
+            <a:effectLst>
+              <a:outerShdw blurRad="109728" dist="38100" dir="5400000">
+                <a:srgbClr val="0F172A">
+                  <a:alpha val="10000"/>
+                </a:srgbClr>
+              </a:outerShdw>
+            </a:effectLst>
+          </p:spPr>
+          <p:txBody>
+            <a:bodyPr/>
+            <a:lstStyle/>
+            <a:p>
+              <a:endParaRPr/>
+            </a:p>
+          </p:txBody>
+        </p:sp>
+        <p:sp>
+          <p:nvSpPr>
+            <p:cNvPr id="14" name="roundRect 2"/>
+            <p:cNvSpPr/>
+            <p:nvPr/>
+          </p:nvSpPr>
+          <p:spPr>
+            <a:xfrm>
+              <a:off x="8503920" y="2286000"/>
+              <a:ext cx="2377440" cy="365760"/>
+            </a:xfrm>
+            <a:prstGeom prst="roundRect">
+              <a:avLst/>
+            </a:prstGeom>
             <a:solidFill>
               <a:srgbClr val="10B981"/>
             </a:solidFill>
-          </a:ln>
-          <a:effectLst>
-            <a:outerShdw blurRad="109728" dist="38100" dir="5400000">
-              <a:srgbClr val="0F172A">
-                <a:alpha val="10000"/>
-              </a:srgbClr>
-            </a:outerShdw>
-          </a:effectLst>
-        </p:spPr>
-        <p:txBody>
-          <a:bodyPr/>
-          <a:lstStyle/>
-          <a:p>
-            <a:endParaRPr/>
-          </a:p>
-        </p:txBody>
-      </p:sp>
-      <p:sp>
-        <p:nvSpPr>
-          <p:cNvPr id="11" name="roundRect 10"/>
-          <p:cNvSpPr/>
-          <p:nvPr/>
-        </p:nvSpPr>
-        <p:spPr>
-          <a:xfrm>
-            <a:off x="8503920" y="2286000"/>
-            <a:ext cx="2377440" cy="365760"/>
-          </a:xfrm>
-          <a:prstGeom prst="roundRect">
-            <a:avLst/>
-          </a:prstGeom>
-          <a:solidFill>
-            <a:srgbClr val="10B981"/>
-          </a:solidFill>
-        </p:spPr>
-        <p:txBody>
-          <a:bodyPr anchor="t"/>
-          <a:lstStyle/>
-          <a:p>
-            <a:pPr algn="ctr"/>
-            <a:r>
-              <a:rPr b="1" sz="1000">
-                <a:solidFill>
-                  <a:srgbClr val="FFFFFF"/>
-                </a:solidFill>
-                <a:latin typeface="+mn-lt"/>
-                <a:cs typeface="+mn-lt"/>
-              </a:rPr>
-              <a:t>STEP 3: COMPILATION</a:t>
-            </a:r>
-          </a:p>
-        </p:txBody>
-      </p:sp>
-      <p:sp>
-        <p:nvSpPr>
-          <p:cNvPr id="12" name="Text Box 11"/>
-          <p:cNvSpPr/>
-          <p:nvPr/>
-        </p:nvSpPr>
-        <p:spPr>
-          <a:xfrm>
-            <a:off x="8503920" y="2926080"/>
-            <a:ext cx="2377440" cy="1828800"/>
-          </a:xfrm>
-          <a:prstGeom prst="rect">
-            <a:avLst/>
-          </a:prstGeom>
-        </p:spPr>
-        <p:txBody>
-          <a:bodyPr anchor="t"/>
-          <a:lstStyle/>
-          <a:p>
-            <a:pPr algn="l" lvl="0" marL="152400" indent="-152400">
-              <a:buChar char="•"/>
-            </a:pPr>
-            <a:r>
-              <a:rPr sz="1100">
-                <a:solidFill>
-                  <a:srgbClr val="475569"/>
-                </a:solidFill>
-                <a:latin typeface="+mn-lt"/>
-                <a:cs typeface="+mn-lt"/>
-              </a:rPr>
-              <a:t>Deterministic XML emission</a:t>
-            </a:r>
-          </a:p>
-          <a:p>
-            <a:pPr algn="l" lvl="0" marL="152400" indent="-152400">
-              <a:buChar char="•"/>
-            </a:pPr>
-            <a:r>
-              <a:rPr sz="1100">
-                <a:solidFill>
-                  <a:srgbClr val="475569"/>
-                </a:solidFill>
-                <a:latin typeface="+mn-lt"/>
-                <a:cs typeface="+mn-lt"/>
-              </a:rPr>
-              <a:t>Zero-copy fflate compression</a:t>
-            </a:r>
-          </a:p>
-          <a:p>
-            <a:pPr algn="l" lvl="0" marL="152400" indent="-152400">
-              <a:buChar char="•"/>
-            </a:pPr>
-            <a:r>
-              <a:rPr sz="1100">
-                <a:solidFill>
-                  <a:srgbClr val="475569"/>
-                </a:solidFill>
-                <a:latin typeface="+mn-lt"/>
-                <a:cs typeface="+mn-lt"/>
-              </a:rPr>
-              <a:t>ECMA-376 compliant PPTX</a:t>
-            </a:r>
-          </a:p>
-        </p:txBody>
-      </p:sp>
-      <p:sp>
-        <p:nvSpPr>
-          <p:cNvPr id="16" name="Text Box 15"/>
-          <p:cNvSpPr/>
-          <p:nvPr/>
-        </p:nvSpPr>
-        <p:spPr>
-          <a:xfrm>
-            <a:off x="914400" y="5806440"/>
-            <a:ext cx="10241280" cy="365760"/>
-          </a:xfrm>
-          <a:prstGeom prst="rect">
-            <a:avLst/>
-          </a:prstGeom>
-        </p:spPr>
-        <p:txBody>
-          <a:bodyPr anchor="t"/>
-          <a:lstStyle/>
-          <a:p>
-            <a:pPr algn="ctr"/>
-            <a:r>
-              <a:rPr sz="1100">
-                <a:solidFill>
-                  <a:srgbClr val="64748B"/>
-                </a:solidFill>
-                <a:latin typeface="+mn-lt"/>
-                <a:cs typeface="+mn-lt"/>
-              </a:rPr>
-              <a:t>Isomorphic Pipeline Feedback Loop: 100% Roundtrip Bit-Exact Precision</a:t>
-            </a:r>
-          </a:p>
-        </p:txBody>
-      </p:sp>
-      <p:sp>
-        <p:nvSpPr>
-          <p:cNvPr id="17" name="Text Box 16"/>
-          <p:cNvSpPr/>
-          <p:nvPr/>
-        </p:nvSpPr>
-        <p:spPr>
-          <a:xfrm>
-            <a:off x="731520" y="6510528"/>
-            <a:ext cx="10725912" cy="228600"/>
-          </a:xfrm>
-          <a:prstGeom prst="rect">
-            <a:avLst/>
-          </a:prstGeom>
-        </p:spPr>
-        <p:txBody>
-          <a:bodyPr anchor="t"/>
-          <a:lstStyle/>
-          <a:p>
-            <a:pPr algn="ctr"/>
-            <a:r>
-              <a:rPr i="1" sz="800">
-                <a:solidFill>
-                  <a:srgbClr val="94A3B8"/>
-                </a:solidFill>
-                <a:latin typeface="+mn-lt"/>
-                <a:cs typeface="+mn-lt"/>
-              </a:rPr>
-              <a:t>* Disclaimer: All benchmark metrics, performance figures, and simulated architectures in this deck are synthetic demonstration values generated solely to showcase the authoring, formatting, and rendering capabilities of @hokkyss/pptx.</a:t>
-            </a:r>
-          </a:p>
-        </p:txBody>
-      </p:sp>
+          </p:spPr>
+          <p:txBody>
+            <a:bodyPr anchor="t"/>
+            <a:lstStyle/>
+            <a:p>
+              <a:pPr algn="ctr"/>
+              <a:r>
+                <a:rPr b="1" sz="1000">
+                  <a:solidFill>
+                    <a:srgbClr val="FFFFFF"/>
+                  </a:solidFill>
+                  <a:latin typeface="+mn-lt"/>
+                  <a:cs typeface="+mn-lt"/>
+                </a:rPr>
+                <a:t>STEP 3: COMPILATION</a:t>
+              </a:r>
+            </a:p>
+          </p:txBody>
+        </p:sp>
+        <p:sp>
+          <p:nvSpPr>
+            <p:cNvPr id="15" name="Text Box 3"/>
+            <p:cNvSpPr/>
+            <p:nvPr/>
+          </p:nvSpPr>
+          <p:spPr>
+            <a:xfrm>
+              <a:off x="8503920" y="2926080"/>
+              <a:ext cx="2377440" cy="1828800"/>
+            </a:xfrm>
+            <a:prstGeom prst="rect">
+              <a:avLst/>
+            </a:prstGeom>
+          </p:spPr>
+          <p:txBody>
+            <a:bodyPr anchor="t"/>
+            <a:lstStyle/>
+            <a:p>
+              <a:pPr algn="l" lvl="0" marL="152400" indent="-152400">
+                <a:buChar char="•"/>
+              </a:pPr>
+              <a:r>
+                <a:rPr sz="1100">
+                  <a:solidFill>
+                    <a:srgbClr val="475569"/>
+                  </a:solidFill>
+                  <a:latin typeface="+mn-lt"/>
+                  <a:cs typeface="+mn-lt"/>
+                </a:rPr>
+                <a:t>Deterministic XML emission</a:t>
+              </a:r>
+            </a:p>
+            <a:p>
+              <a:pPr algn="l" lvl="0" marL="152400" indent="-152400">
+                <a:buChar char="•"/>
+              </a:pPr>
+              <a:r>
+                <a:rPr sz="1100">
+                  <a:solidFill>
+                    <a:srgbClr val="475569"/>
+                  </a:solidFill>
+                  <a:latin typeface="+mn-lt"/>
+                  <a:cs typeface="+mn-lt"/>
+                </a:rPr>
+                <a:t>Zero-copy fflate compression</a:t>
+              </a:r>
+            </a:p>
+            <a:p>
+              <a:pPr algn="l" lvl="0" marL="152400" indent="-152400">
+                <a:buChar char="•"/>
+              </a:pPr>
+              <a:r>
+                <a:rPr sz="1100">
+                  <a:solidFill>
+                    <a:srgbClr val="475569"/>
+                  </a:solidFill>
+                  <a:latin typeface="+mn-lt"/>
+                  <a:cs typeface="+mn-lt"/>
+                </a:rPr>
+                <a:t>ECMA-376 compliant PPTX</a:t>
+              </a:r>
+            </a:p>
+          </p:txBody>
+        </p:sp>
+      </p:grpSp>
       <p:cxnSp>
         <p:nvCxnSpPr>
-          <p:cNvPr id="13" name="Connector 12"/>
+          <p:cNvPr id="16" name="Connector 6"/>
           <p:cNvCxnSpPr>
             <a:cxnSpLocks/>
-            <a:stCxn id="4" idx="3"/>
-            <a:endCxn id="7" idx="1"/>
+            <a:stCxn id="5" idx="3"/>
+            <a:endCxn id="9" idx="1"/>
           </p:cNvCxnSpPr>
           <p:nvPr/>
         </p:nvCxnSpPr>
@@ -11133,11 +11178,11 @@
       </p:cxnSp>
       <p:cxnSp>
         <p:nvCxnSpPr>
-          <p:cNvPr id="14" name="Connector 13"/>
+          <p:cNvPr id="17" name="Connector 7"/>
           <p:cNvCxnSpPr>
             <a:cxnSpLocks/>
-            <a:stCxn id="7" idx="3"/>
-            <a:endCxn id="10" idx="1"/>
+            <a:stCxn id="9" idx="3"/>
+            <a:endCxn id="13" idx="1"/>
           </p:cNvCxnSpPr>
           <p:nvPr/>
         </p:nvCxnSpPr>
@@ -11160,7 +11205,7 @@
       </p:cxnSp>
       <p:cxnSp>
         <p:nvCxnSpPr>
-          <p:cNvPr id="15" name="Connector 14"/>
+          <p:cNvPr id="18" name="Connector 8"/>
           <p:cNvCxnSpPr>
             <a:cxnSpLocks/>
           </p:cNvCxnSpPr>

</xml_diff>

<commit_message>
test(slide): add comprehensive unit test suite for duplicate element IDs
- tests collision across mixed element types (shape, table, chart, connector, text, group)
- tests collision between top-level shapes and nested group children
- tests ID reusability after removeElement()
- tests auto-increment ID generation safely avoiding manual numeric ID collisions
- passes slide ID generator to GroupBuilder to guarantee seamless sequential child IDs
</commit_message>
<xml_diff>
--- a/hokkyss_showcase_deck.pptx
+++ b/hokkyss_showcase_deck.pptx
@@ -10623,7 +10623,7 @@
       </p:sp>
       <p:sp>
         <p:nvSpPr>
-          <p:cNvPr id="19" name="Text Box 9"/>
+          <p:cNvPr id="19" name="Text Box 18"/>
           <p:cNvSpPr/>
           <p:nvPr/>
         </p:nvSpPr>
@@ -10656,7 +10656,7 @@
       </p:sp>
       <p:sp>
         <p:nvSpPr>
-          <p:cNvPr id="20" name="Text Box 10"/>
+          <p:cNvPr id="20" name="Text Box 19"/>
           <p:cNvSpPr/>
           <p:nvPr/>
         </p:nvSpPr>
@@ -10741,7 +10741,7 @@
         </p:sp>
         <p:sp>
           <p:nvSpPr>
-            <p:cNvPr id="6" name="roundRect 2"/>
+            <p:cNvPr id="6" name="roundRect 5"/>
             <p:cNvSpPr/>
             <p:nvPr/>
           </p:nvSpPr>
@@ -10777,7 +10777,7 @@
         </p:sp>
         <p:sp>
           <p:nvSpPr>
-            <p:cNvPr id="7" name="Text Box 3"/>
+            <p:cNvPr id="7" name="Text Box 6"/>
             <p:cNvSpPr/>
             <p:nvPr/>
           </p:nvSpPr>
@@ -10895,7 +10895,7 @@
         </p:sp>
         <p:sp>
           <p:nvSpPr>
-            <p:cNvPr id="10" name="roundRect 2"/>
+            <p:cNvPr id="10" name="roundRect 9"/>
             <p:cNvSpPr/>
             <p:nvPr/>
           </p:nvSpPr>
@@ -10931,7 +10931,7 @@
         </p:sp>
         <p:sp>
           <p:nvSpPr>
-            <p:cNvPr id="11" name="Text Box 3"/>
+            <p:cNvPr id="11" name="Text Box 10"/>
             <p:cNvSpPr/>
             <p:nvPr/>
           </p:nvSpPr>
@@ -11049,7 +11049,7 @@
         </p:sp>
         <p:sp>
           <p:nvSpPr>
-            <p:cNvPr id="14" name="roundRect 2"/>
+            <p:cNvPr id="14" name="roundRect 13"/>
             <p:cNvSpPr/>
             <p:nvPr/>
           </p:nvSpPr>
@@ -11085,7 +11085,7 @@
         </p:sp>
         <p:sp>
           <p:nvSpPr>
-            <p:cNvPr id="15" name="Text Box 3"/>
+            <p:cNvPr id="15" name="Text Box 14"/>
             <p:cNvSpPr/>
             <p:nvPr/>
           </p:nvSpPr>
@@ -11151,7 +11151,7 @@
       </p:grpSp>
       <p:cxnSp>
         <p:nvCxnSpPr>
-          <p:cNvPr id="16" name="Connector 6"/>
+          <p:cNvPr id="16" name="Connector 15"/>
           <p:cNvCxnSpPr>
             <a:cxnSpLocks/>
             <a:stCxn id="5" idx="3"/>
@@ -11178,7 +11178,7 @@
       </p:cxnSp>
       <p:cxnSp>
         <p:nvCxnSpPr>
-          <p:cNvPr id="17" name="Connector 7"/>
+          <p:cNvPr id="17" name="Connector 16"/>
           <p:cNvCxnSpPr>
             <a:cxnSpLocks/>
             <a:stCxn id="9" idx="3"/>
@@ -11205,7 +11205,7 @@
       </p:cxnSp>
       <p:cxnSp>
         <p:nvCxnSpPr>
-          <p:cNvPr id="18" name="Connector 8"/>
+          <p:cNvPr id="18" name="Connector 17"/>
           <p:cNvCxnSpPr>
             <a:cxnSpLocks/>
           </p:cNvCxnSpPr>

</xml_diff>

<commit_message>
Feat/customizable connector arrows (#15)
## 📋 Pull Request Description

### Summary of Changes
<!-- Provide a clear and concise summary of what this PR introduces or
fixes -->

### Target Package(s)
- [ ] `@hokkyss/pptx` (Fluent SDK)
- [ ] `@hokkyss/pptx-reader` (Parser)
- [ ] `@hokkyss/pptx-writer` (Serializer)
- [ ] `@hokkyss/pptx-core` (AST & Units)
- [ ] Documentation / Tooling

---

## 🧪 Verification & Quality Checklist

- [ ] `pnpm lint` passes with 0 errors across all workspace packages
- [ ] `pnpm build` compiles cleanly and generates type definitions
(`.d.ts`)
- [ ] `pnpm test` runs and all unit & integration test suites pass
- [ ] Type-safe branded units (`inches()`, `points()`, `emu()`,
`emuDegree()`) are used exclusively for physical coordinates and
dimensions
- [ ] Code is 100% isomorphic (compatible with Node.js, Web Browsers,
Cloudflare Workers, Deno, and Bun)
- [ ] OpenXML XML elements follow ECMA-376 schema sequence and standard
naming
</commit_message>
<xml_diff>
--- a/hokkyss_showcase_deck.pptx
+++ b/hokkyss_showcase_deck.pptx
@@ -10623,7 +10623,7 @@
       </p:sp>
       <p:sp>
         <p:nvSpPr>
-          <p:cNvPr id="19" name="Text Box 9"/>
+          <p:cNvPr id="19" name="Text Box 18"/>
           <p:cNvSpPr/>
           <p:nvPr/>
         </p:nvSpPr>
@@ -10656,7 +10656,7 @@
       </p:sp>
       <p:sp>
         <p:nvSpPr>
-          <p:cNvPr id="20" name="Text Box 10"/>
+          <p:cNvPr id="20" name="Text Box 19"/>
           <p:cNvSpPr/>
           <p:nvPr/>
         </p:nvSpPr>
@@ -10703,7 +10703,7 @@
         </p:grpSpPr>
         <p:sp>
           <p:nvSpPr>
-            <p:cNvPr id="5" name="roundRect 1"/>
+            <p:cNvPr id="5" name="Stage 1 Background"/>
             <p:cNvSpPr/>
             <p:nvPr/>
           </p:nvSpPr>
@@ -10741,7 +10741,7 @@
         </p:sp>
         <p:sp>
           <p:nvSpPr>
-            <p:cNvPr id="6" name="roundRect 2"/>
+            <p:cNvPr id="6" name="roundRect 5"/>
             <p:cNvSpPr/>
             <p:nvPr/>
           </p:nvSpPr>
@@ -10777,7 +10777,7 @@
         </p:sp>
         <p:sp>
           <p:nvSpPr>
-            <p:cNvPr id="7" name="Text Box 3"/>
+            <p:cNvPr id="7" name="Text Box 6"/>
             <p:cNvSpPr/>
             <p:nvPr/>
           </p:nvSpPr>
@@ -10843,7 +10843,7 @@
       </p:grpSp>
       <p:grpSp>
         <p:nvGrpSpPr>
-          <p:cNvPr id="9" name="Stage 2 AST Container"/>
+          <p:cNvPr id="8" name="Stage 2 AST Container"/>
           <p:cNvGrpSpPr/>
           <p:nvPr/>
         </p:nvGrpSpPr>
@@ -10857,7 +10857,7 @@
         </p:grpSpPr>
         <p:sp>
           <p:nvSpPr>
-            <p:cNvPr id="10" name="roundRect 1"/>
+            <p:cNvPr id="9" name="Stage 2 Background"/>
             <p:cNvSpPr/>
             <p:nvPr/>
           </p:nvSpPr>
@@ -10895,7 +10895,7 @@
         </p:sp>
         <p:sp>
           <p:nvSpPr>
-            <p:cNvPr id="11" name="roundRect 2"/>
+            <p:cNvPr id="10" name="roundRect 9"/>
             <p:cNvSpPr/>
             <p:nvPr/>
           </p:nvSpPr>
@@ -10931,7 +10931,7 @@
         </p:sp>
         <p:sp>
           <p:nvSpPr>
-            <p:cNvPr id="12" name="Text Box 3"/>
+            <p:cNvPr id="11" name="Text Box 10"/>
             <p:cNvSpPr/>
             <p:nvPr/>
           </p:nvSpPr>
@@ -10997,7 +10997,7 @@
       </p:grpSp>
       <p:grpSp>
         <p:nvGrpSpPr>
-          <p:cNvPr id="14" name="Stage 3 Packaging Container"/>
+          <p:cNvPr id="12" name="Stage 3 Packaging Container"/>
           <p:cNvGrpSpPr/>
           <p:nvPr/>
         </p:nvGrpSpPr>
@@ -11011,7 +11011,7 @@
         </p:grpSpPr>
         <p:sp>
           <p:nvSpPr>
-            <p:cNvPr id="15" name="roundRect 1"/>
+            <p:cNvPr id="13" name="Stage 3 Background"/>
             <p:cNvSpPr/>
             <p:nvPr/>
           </p:nvSpPr>
@@ -11049,7 +11049,7 @@
         </p:sp>
         <p:sp>
           <p:nvSpPr>
-            <p:cNvPr id="16" name="roundRect 2"/>
+            <p:cNvPr id="14" name="roundRect 13"/>
             <p:cNvSpPr/>
             <p:nvPr/>
           </p:nvSpPr>
@@ -11085,7 +11085,7 @@
         </p:sp>
         <p:sp>
           <p:nvSpPr>
-            <p:cNvPr id="17" name="Text Box 3"/>
+            <p:cNvPr id="15" name="Text Box 14"/>
             <p:cNvSpPr/>
             <p:nvPr/>
           </p:nvSpPr>
@@ -11151,14 +11151,18 @@
       </p:grpSp>
       <p:cxnSp>
         <p:nvCxnSpPr>
-          <p:cNvPr id="8" name="Connector 4"/>
-          <p:cNvCxnSpPr/>
+          <p:cNvPr id="16" name="Connector 15"/>
+          <p:cNvCxnSpPr>
+            <a:cxnSpLocks/>
+            <a:stCxn id="5" idx="3"/>
+            <a:endCxn id="9" idx="1"/>
+          </p:cNvCxnSpPr>
           <p:nvPr/>
         </p:nvCxnSpPr>
         <p:spPr>
           <a:xfrm>
             <a:off x="3840480" y="3611880"/>
-            <a:ext cx="731520" cy="1"/>
+            <a:ext cx="731520" cy="0"/>
           </a:xfrm>
           <a:prstGeom prst="line">
             <a:avLst/>
@@ -11168,19 +11172,24 @@
               <a:srgbClr val="0284C7"/>
             </a:solidFill>
             <a:prstDash val="solid"/>
+            <a:headEnd type="triangle" w="lg" len="lg"/>
           </a:ln>
         </p:spPr>
       </p:cxnSp>
       <p:cxnSp>
         <p:nvCxnSpPr>
-          <p:cNvPr id="13" name="Connector 6"/>
-          <p:cNvCxnSpPr/>
+          <p:cNvPr id="17" name="Connector 16"/>
+          <p:cNvCxnSpPr>
+            <a:cxnSpLocks/>
+            <a:stCxn id="9" idx="3"/>
+            <a:endCxn id="13" idx="1"/>
+          </p:cNvCxnSpPr>
           <p:nvPr/>
         </p:nvCxnSpPr>
         <p:spPr>
           <a:xfrm>
             <a:off x="7498080" y="3611880"/>
-            <a:ext cx="731520" cy="1"/>
+            <a:ext cx="731520" cy="0"/>
           </a:xfrm>
           <a:prstGeom prst="line">
             <a:avLst/>
@@ -11190,28 +11199,33 @@
               <a:srgbClr val="6366F1"/>
             </a:solidFill>
             <a:prstDash val="solid"/>
+            <a:headEnd type="stealth" w="lg" len="lg"/>
           </a:ln>
         </p:spPr>
       </p:cxnSp>
       <p:cxnSp>
         <p:nvCxnSpPr>
-          <p:cNvPr id="18" name="Connector 8"/>
-          <p:cNvCxnSpPr/>
+          <p:cNvPr id="18" name="Connector 17"/>
+          <p:cNvCxnSpPr>
+            <a:cxnSpLocks/>
+          </p:cNvCxnSpPr>
           <p:nvPr/>
         </p:nvCxnSpPr>
         <p:spPr>
           <a:xfrm>
             <a:off x="914400" y="5669280"/>
-            <a:ext cx="10241280" cy="1"/>
+            <a:ext cx="10241280" cy="0"/>
           </a:xfrm>
           <a:prstGeom prst="line">
             <a:avLst/>
           </a:prstGeom>
-          <a:ln w="13716">
+          <a:ln w="18288">
             <a:solidFill>
               <a:srgbClr val="94A3B8"/>
             </a:solidFill>
             <a:prstDash val="dash"/>
+            <a:headEnd type="triangle"/>
+            <a:tailEnd type="oval"/>
           </a:ln>
         </p:spPr>
       </p:cxnSp>

</xml_diff>

<commit_message>
chore: customize row height
</commit_message>
<xml_diff>
--- a/hokkyss_showcase_deck.pptx
+++ b/hokkyss_showcase_deck.pptx
@@ -6350,7 +6350,7 @@
                   </a:tcPr>
                 </a:tc>
               </a:tr>
-              <a:tr h="329184">
+              <a:tr h="658368">
                 <a:tc>
                   <a:txBody>
                     <a:bodyPr anchor="ctr"/>
@@ -6546,7 +6546,7 @@
                   </a:tcPr>
                 </a:tc>
               </a:tr>
-              <a:tr h="329184">
+              <a:tr h="658368">
                 <a:tc>
                   <a:txBody>
                     <a:bodyPr anchor="ctr"/>
@@ -6742,7 +6742,7 @@
                   </a:tcPr>
                 </a:tc>
               </a:tr>
-              <a:tr h="329184">
+              <a:tr h="658368">
                 <a:tc>
                   <a:txBody>
                     <a:bodyPr anchor="ctr"/>

</xml_diff>

<commit_message>
feat(media): add audio and video embedding support with playback controls and round-trip fidelity
</commit_message>
<xml_diff>
--- a/hokkyss_showcase_deck.pptx
+++ b/hokkyss_showcase_deck.pptx
@@ -5,7 +5,7 @@
     <p:sldMasterId id="2147483648" r:id="rId1"/>
   </p:sldMasterIdLst>
   <p:notesMasterIdLst>
-    <p:notesMasterId r:id="rId16"/>
+    <p:notesMasterId r:id="rId17"/>
   </p:notesMasterIdLst>
   <p:sldIdLst>
     <p:sldId id="256" r:id="rId2"/>
@@ -22,6 +22,7 @@
     <p:sldId id="267" r:id="rId13"/>
     <p:sldId id="268" r:id="rId14"/>
     <p:sldId id="269" r:id="rId15"/>
+    <p:sldId id="270" r:id="rId16"/>
   </p:sldIdLst>
   <p:sldSz cx="12192000" cy="6858000"/>
   <p:notesSz cx="6858000" cy="9144000"/>
@@ -1969,6 +1970,112 @@
                 <a:latin typeface="+mn-lt"/>
                 <a:cs typeface="+mn-lt"/>
               </a:rPr>
+              <a:t>Multimedia Embedding Keynote: </a:t>
+            </a:r>
+            <a:r>
+              <a:rPr u="sng">
+                <a:latin typeface="+mn-lt"/>
+                <a:cs typeface="+mn-lt"/>
+              </a:rPr>
+              <a:t>Full OpenXML Audio &amp; Video Integration</a:t>
+            </a:r>
+          </a:p>
+          <a:p>
+            <a:pPr algn="l" lvl="0" marL="152400" indent="-152400">
+              <a:buChar char="•"/>
+            </a:pPr>
+            <a:r>
+              <a:rPr>
+                <a:latin typeface="+mn-lt"/>
+                <a:cs typeface="+mn-lt"/>
+              </a:rPr>
+              <a:t>Native PowerPoint speaker/film strip icons rendered with zero client-side dependencies.</a:t>
+            </a:r>
+          </a:p>
+          <a:p>
+            <a:pPr algn="l" lvl="0" marL="152400" indent="-152400">
+              <a:buChar char="•"/>
+            </a:pPr>
+            <a:r>
+              <a:rPr>
+                <a:latin typeface="+mn-lt"/>
+                <a:cs typeface="+mn-lt"/>
+              </a:rPr>
+              <a:t>Full relationship management with dual r:link (media) and r:embed (p14:media) entries.</a:t>
+            </a:r>
+          </a:p>
+          <a:p>
+            <a:pPr algn="l" lvl="0" marL="152400" indent="-152400">
+              <a:buChar char="•"/>
+            </a:pPr>
+            <a:r>
+              <a:rPr>
+                <a:latin typeface="+mn-lt"/>
+                <a:cs typeface="+mn-lt"/>
+              </a:rPr>
+              <a:t>Complete round-trip preservation when parsed and resaved with @hokkyss/pptx-reader.</a:t>
+            </a:r>
+          </a:p>
+        </p:txBody>
+      </p:sp>
+    </p:spTree>
+  </p:cSld>
+  <p:clrMapOvr>
+    <a:masterClrMapping/>
+  </p:clrMapOvr>
+</p:notes>
+</file>
+
+<file path=ppt/notesSlides/notesSlide11.xml><?xml version="1.0" encoding="utf-8"?>
+<p:notes xmlns:a="http://schemas.openxmlformats.org/drawingml/2006/main" xmlns:r="http://schemas.openxmlformats.org/officeDocument/2006/relationships" xmlns:p="http://schemas.openxmlformats.org/presentationml/2006/main">
+  <p:cSld>
+    <p:spTree>
+      <p:nvGrpSpPr>
+        <p:cNvPr id="1" name=""/>
+        <p:cNvGrpSpPr/>
+        <p:nvPr/>
+      </p:nvGrpSpPr>
+      <p:grpSpPr>
+        <a:xfrm>
+          <a:off x="0" y="0"/>
+          <a:ext cx="0" cy="0"/>
+          <a:chOff x="0" y="0"/>
+          <a:chExt cx="0" cy="0"/>
+        </a:xfrm>
+      </p:grpSpPr>
+      <p:sp>
+        <p:nvSpPr>
+          <p:cNvPr id="2" name="Slide Image Placeholder 1"/>
+          <p:cNvSpPr>
+            <a:spLocks noGrp="1" noRot="1" noChangeAspect="1"/>
+          </p:cNvSpPr>
+          <p:nvPr>
+            <p:ph type="sldImg"/>
+          </p:nvPr>
+        </p:nvSpPr>
+        <p:spPr/>
+      </p:sp>
+      <p:sp>
+        <p:nvSpPr>
+          <p:cNvPr id="3" name="Notes Placeholder 2"/>
+          <p:cNvSpPr>
+            <a:spLocks noGrp="1"/>
+          </p:cNvSpPr>
+          <p:nvPr>
+            <p:ph type="body" idx="1"/>
+          </p:nvPr>
+        </p:nvSpPr>
+        <p:spPr/>
+        <p:txBody>
+          <a:bodyPr anchor="t"/>
+          <a:lstStyle/>
+          <a:p>
+            <a:pPr algn="l" lvl="0"/>
+            <a:r>
+              <a:rPr b="1">
+                <a:latin typeface="+mn-lt"/>
+                <a:cs typeface="+mn-lt"/>
+              </a:rPr>
               <a:t>Empirical Benchmark Keynote: </a:t>
             </a:r>
             <a:r>
@@ -2981,7 +3088,7 @@
 </file>
 
 <file path=ppt/slides/slide1.xml><?xml version="1.0" encoding="utf-8"?>
-<p:sld xmlns:a="http://schemas.openxmlformats.org/drawingml/2006/main" xmlns:r="http://schemas.openxmlformats.org/officeDocument/2006/relationships" xmlns:p="http://schemas.openxmlformats.org/presentationml/2006/main">
+<p:sld xmlns:a="http://schemas.openxmlformats.org/drawingml/2006/main" xmlns:p="http://schemas.openxmlformats.org/presentationml/2006/main" xmlns:r="http://schemas.openxmlformats.org/officeDocument/2006/relationships">
   <p:cSld>
     <p:bg>
       <p:bgPr>
@@ -3362,7 +3469,7 @@
 </file>
 
 <file path=ppt/slides/slide10.xml><?xml version="1.0" encoding="utf-8"?>
-<p:sld xmlns:a="http://schemas.openxmlformats.org/drawingml/2006/main" xmlns:r="http://schemas.openxmlformats.org/officeDocument/2006/relationships" xmlns:p="http://schemas.openxmlformats.org/presentationml/2006/main">
+<p:sld xmlns:a="http://schemas.openxmlformats.org/drawingml/2006/main" xmlns:p="http://schemas.openxmlformats.org/presentationml/2006/main" xmlns:r="http://schemas.openxmlformats.org/officeDocument/2006/relationships">
   <p:cSld>
     <p:bg>
       <p:bgPr>
@@ -3758,7 +3865,7 @@
 </file>
 
 <file path=ppt/slides/slide11.xml><?xml version="1.0" encoding="utf-8"?>
-<p:sld xmlns:a="http://schemas.openxmlformats.org/drawingml/2006/main" xmlns:r="http://schemas.openxmlformats.org/officeDocument/2006/relationships" xmlns:p="http://schemas.openxmlformats.org/presentationml/2006/main">
+<p:sld xmlns:a="http://schemas.openxmlformats.org/drawingml/2006/main" xmlns:p="http://schemas.openxmlformats.org/presentationml/2006/main" xmlns:r="http://schemas.openxmlformats.org/officeDocument/2006/relationships">
   <p:cSld>
     <p:bg>
       <p:bgPr>
@@ -4154,7 +4261,7 @@
 </file>
 
 <file path=ppt/slides/slide12.xml><?xml version="1.0" encoding="utf-8"?>
-<p:sld xmlns:a="http://schemas.openxmlformats.org/drawingml/2006/main" xmlns:r="http://schemas.openxmlformats.org/officeDocument/2006/relationships" xmlns:p="http://schemas.openxmlformats.org/presentationml/2006/main">
+<p:sld xmlns:a="http://schemas.openxmlformats.org/drawingml/2006/main" xmlns:p="http://schemas.openxmlformats.org/presentationml/2006/main" xmlns:r="http://schemas.openxmlformats.org/officeDocument/2006/relationships">
   <p:cSld>
     <p:bg>
       <p:bgPr>
@@ -4463,7 +4570,7 @@
       <p:sp>
         <p:nvSpPr>
           <p:cNvPr id="9" name="roundRect 8">
-            <a:hlinkClick r:id="rId4" tooltip="Jump directly to Slide 13" action="ppaction://hlinksldjump"/>
+            <a:hlinkClick r:id="rId4" tooltip="Jump directly to Slide 14" action="ppaction://hlinksldjump"/>
           </p:cNvPr>
           <p:cNvSpPr/>
           <p:nvPr/>
@@ -4498,7 +4605,7 @@
                 <a:latin typeface="+mn-lt"/>
                 <a:cs typeface="+mn-lt"/>
               </a:rPr>
-              <a:t>🎨 Slide 13: DrawingML Gradient Engine ➔</a:t>
+              <a:t>🎬 Slide 14: Audio &amp; Video Media Engine ➔</a:t>
             </a:r>
           </a:p>
           <a:p>
@@ -4511,7 +4618,7 @@
                 <a:latin typeface="+mn-lt"/>
                 <a:cs typeface="+mn-lt"/>
               </a:rPr>
-              <a:t>Linear, radial, alpha &amp; multi-stop mesh cards</a:t>
+              <a:t>Embedded MP3/MP4, playback triggers &amp; timing</a:t>
             </a:r>
           </a:p>
         </p:txBody>
@@ -4519,7 +4626,7 @@
       <p:sp>
         <p:nvSpPr>
           <p:cNvPr id="10" name="roundRect 9">
-            <a:hlinkClick r:id="rId5" tooltip="Jump directly to Slide 14" action="ppaction://hlinksldjump"/>
+            <a:hlinkClick r:id="rId5" tooltip="Jump directly to Slide 15" action="ppaction://hlinksldjump"/>
           </p:cNvPr>
           <p:cNvSpPr/>
           <p:nvPr/>
@@ -4554,7 +4661,7 @@
                 <a:latin typeface="+mn-lt"/>
                 <a:cs typeface="+mn-lt"/>
               </a:rPr>
-              <a:t>⚡ Slide 14: Engine Benchmark Matrix ➔</a:t>
+              <a:t>⚡ Slide 15: Engine Benchmark Matrix ➔</a:t>
             </a:r>
           </a:p>
           <a:p>
@@ -5048,7 +5155,7 @@
 </file>
 
 <file path=ppt/slides/slide13.xml><?xml version="1.0" encoding="utf-8"?>
-<p:sld xmlns:a="http://schemas.openxmlformats.org/drawingml/2006/main" xmlns:r="http://schemas.openxmlformats.org/officeDocument/2006/relationships" xmlns:p="http://schemas.openxmlformats.org/presentationml/2006/main">
+<p:sld xmlns:a="http://schemas.openxmlformats.org/drawingml/2006/main" xmlns:p="http://schemas.openxmlformats.org/presentationml/2006/main" xmlns:r="http://schemas.openxmlformats.org/officeDocument/2006/relationships">
   <p:cSld>
     <p:bg>
       <p:bgPr>
@@ -5915,7 +6022,1011 @@
 </file>
 
 <file path=ppt/slides/slide14.xml><?xml version="1.0" encoding="utf-8"?>
-<p:sld xmlns:a="http://schemas.openxmlformats.org/drawingml/2006/main" xmlns:r="http://schemas.openxmlformats.org/officeDocument/2006/relationships" xmlns:p="http://schemas.openxmlformats.org/presentationml/2006/main">
+<p:sld xmlns:a="http://schemas.openxmlformats.org/drawingml/2006/main" xmlns:p="http://schemas.openxmlformats.org/presentationml/2006/main" xmlns:r="http://schemas.openxmlformats.org/officeDocument/2006/relationships">
+  <p:cSld>
+    <p:bg>
+      <p:bgPr>
+        <a:solidFill>
+          <a:srgbClr val="F8FAFC"/>
+        </a:solidFill>
+        <a:effectLst/>
+      </p:bgPr>
+    </p:bg>
+    <p:spTree>
+      <p:nvGrpSpPr>
+        <p:cNvPr id="1" name=""/>
+        <p:cNvGrpSpPr/>
+        <p:nvPr/>
+      </p:nvGrpSpPr>
+      <p:grpSpPr>
+        <a:xfrm>
+          <a:off x="0" y="0"/>
+          <a:ext cx="0" cy="0"/>
+          <a:chOff x="0" y="0"/>
+          <a:chExt cx="0" cy="0"/>
+        </a:xfrm>
+      </p:grpSpPr>
+      <p:sp>
+        <p:nvSpPr>
+          <p:cNvPr id="2" name="Text Box 1"/>
+          <p:cNvSpPr/>
+          <p:nvPr/>
+        </p:nvSpPr>
+        <p:spPr>
+          <a:xfrm>
+            <a:off x="731520" y="731520"/>
+            <a:ext cx="10725912" cy="548640"/>
+          </a:xfrm>
+          <a:prstGeom prst="rect">
+            <a:avLst/>
+          </a:prstGeom>
+        </p:spPr>
+        <p:txBody>
+          <a:bodyPr anchor="t"/>
+          <a:lstStyle/>
+          <a:p>
+            <a:pPr algn="l"/>
+            <a:r>
+              <a:rPr b="1" sz="2400">
+                <a:solidFill>
+                  <a:srgbClr val="0F172A"/>
+                </a:solidFill>
+                <a:latin typeface="+mj-lt"/>
+                <a:cs typeface="+mj-lt"/>
+              </a:rPr>
+              <a:t>Native Audio &amp; Video Media Embedding Engine</a:t>
+            </a:r>
+          </a:p>
+        </p:txBody>
+      </p:sp>
+      <p:sp>
+        <p:nvSpPr>
+          <p:cNvPr id="3" name="Text Box 2"/>
+          <p:cNvSpPr/>
+          <p:nvPr/>
+        </p:nvSpPr>
+        <p:spPr>
+          <a:xfrm>
+            <a:off x="731520" y="1280160"/>
+            <a:ext cx="10725912" cy="365760"/>
+          </a:xfrm>
+          <a:prstGeom prst="rect">
+            <a:avLst/>
+          </a:prstGeom>
+        </p:spPr>
+        <p:txBody>
+          <a:bodyPr anchor="t"/>
+          <a:lstStyle/>
+          <a:p>
+            <a:pPr algn="l"/>
+            <a:r>
+              <a:rPr sz="1400">
+                <a:solidFill>
+                  <a:srgbClr val="64748B"/>
+                </a:solidFill>
+                <a:latin typeface="+mn-lt"/>
+                <a:cs typeface="+mn-lt"/>
+              </a:rPr>
+              <a:t>OpenXML DrawingML &lt;p:pic&gt; multimedia integration with automatic relationship linking, playback triggers &amp; timing</a:t>
+            </a:r>
+          </a:p>
+        </p:txBody>
+      </p:sp>
+      <p:sp>
+        <p:nvSpPr>
+          <p:cNvPr id="4" name="roundRect 3"/>
+          <p:cNvSpPr/>
+          <p:nvPr/>
+        </p:nvSpPr>
+        <p:spPr>
+          <a:xfrm>
+            <a:off x="731520" y="1828800"/>
+            <a:ext cx="5212080" cy="4480560"/>
+          </a:xfrm>
+          <a:prstGeom prst="roundRect">
+            <a:avLst/>
+          </a:prstGeom>
+          <a:solidFill>
+            <a:srgbClr val="FFFFFF"/>
+          </a:solidFill>
+          <a:ln w="13716">
+            <a:solidFill>
+              <a:srgbClr val="E2E8F0"/>
+            </a:solidFill>
+          </a:ln>
+          <a:effectLst>
+            <a:outerShdw blurRad="109728" dist="38100" dir="5400000">
+              <a:srgbClr val="0F172A">
+                <a:alpha val="8000"/>
+              </a:srgbClr>
+            </a:outerShdw>
+          </a:effectLst>
+        </p:spPr>
+        <p:txBody>
+          <a:bodyPr/>
+          <a:lstStyle/>
+          <a:p>
+            <a:endParaRPr/>
+          </a:p>
+        </p:txBody>
+      </p:sp>
+      <p:sp>
+        <p:nvSpPr>
+          <p:cNvPr id="5" name="Text Box 4"/>
+          <p:cNvSpPr/>
+          <p:nvPr/>
+        </p:nvSpPr>
+        <p:spPr>
+          <a:xfrm>
+            <a:off x="914400" y="2011680"/>
+            <a:ext cx="4846320" cy="320040"/>
+          </a:xfrm>
+          <a:prstGeom prst="rect">
+            <a:avLst/>
+          </a:prstGeom>
+        </p:spPr>
+        <p:txBody>
+          <a:bodyPr anchor="t"/>
+          <a:lstStyle/>
+          <a:p>
+            <a:pPr algn="l"/>
+            <a:r>
+              <a:rPr b="1" sz="1300">
+                <a:solidFill>
+                  <a:srgbClr val="0F172A"/>
+                </a:solidFill>
+                <a:latin typeface="+mn-lt"/>
+                <a:cs typeface="+mn-lt"/>
+              </a:rPr>
+              <a:t>🔊 Embedded Audio &amp; Narration Tracks</a:t>
+            </a:r>
+          </a:p>
+        </p:txBody>
+      </p:sp>
+      <p:sp>
+        <p:nvSpPr>
+          <p:cNvPr id="6" name="Text Box 5"/>
+          <p:cNvSpPr/>
+          <p:nvPr/>
+        </p:nvSpPr>
+        <p:spPr>
+          <a:xfrm>
+            <a:off x="914400" y="2331720"/>
+            <a:ext cx="4846320" cy="411480"/>
+          </a:xfrm>
+          <a:prstGeom prst="rect">
+            <a:avLst/>
+          </a:prstGeom>
+        </p:spPr>
+        <p:txBody>
+          <a:bodyPr anchor="t"/>
+          <a:lstStyle/>
+          <a:p>
+            <a:pPr algn="l"/>
+            <a:r>
+              <a:rPr sz="1050">
+                <a:solidFill>
+                  <a:srgbClr val="64748B"/>
+                </a:solidFill>
+                <a:latin typeface="+mn-lt"/>
+                <a:cs typeface="+mn-lt"/>
+              </a:rPr>
+              <a:t>Native speaker icon rendered automatically with interactive click-to-play &amp; automatic slide load triggers:</a:t>
+            </a:r>
+          </a:p>
+        </p:txBody>
+      </p:sp>
+      <p:sp>
+        <p:nvSpPr>
+          <p:cNvPr id="7" name="roundRect 6"/>
+          <p:cNvSpPr/>
+          <p:nvPr/>
+        </p:nvSpPr>
+        <p:spPr>
+          <a:xfrm>
+            <a:off x="914400" y="2788920"/>
+            <a:ext cx="4846320" cy="1371600"/>
+          </a:xfrm>
+          <a:prstGeom prst="roundRect">
+            <a:avLst/>
+          </a:prstGeom>
+          <a:solidFill>
+            <a:srgbClr val="F1F5F9"/>
+          </a:solidFill>
+          <a:ln w="13716">
+            <a:solidFill>
+              <a:srgbClr val="CBD5E1"/>
+            </a:solidFill>
+          </a:ln>
+        </p:spPr>
+        <p:txBody>
+          <a:bodyPr/>
+          <a:lstStyle/>
+          <a:p>
+            <a:endParaRPr/>
+          </a:p>
+        </p:txBody>
+      </p:sp>
+      <p:sp>
+        <p:nvSpPr>
+          <p:cNvPr id="9" name="Text Box 8"/>
+          <p:cNvSpPr/>
+          <p:nvPr/>
+        </p:nvSpPr>
+        <p:spPr>
+          <a:xfrm>
+            <a:off x="2103120" y="2926080"/>
+            <a:ext cx="3566160" cy="1097280"/>
+          </a:xfrm>
+          <a:prstGeom prst="rect">
+            <a:avLst/>
+          </a:prstGeom>
+        </p:spPr>
+        <p:txBody>
+          <a:bodyPr anchor="t"/>
+          <a:lstStyle/>
+          <a:p>
+            <a:pPr algn="l"/>
+            <a:r>
+              <a:rPr b="1" sz="1100">
+                <a:solidFill>
+                  <a:srgbClr val="0F172A"/>
+                </a:solidFill>
+                <a:latin typeface="+mn-lt"/>
+                <a:cs typeface="+mn-lt"/>
+              </a:rPr>
+              <a:t>Interactive Audio Clip (Click speaker icon in slideshow)</a:t>
+            </a:r>
+          </a:p>
+          <a:p>
+            <a:pPr algn="l"/>
+            <a:r>
+              <a:rPr sz="950">
+                <a:solidFill>
+                  <a:srgbClr val="0284C7"/>
+                </a:solidFill>
+                <a:latin typeface="+mn-lt"/>
+                <a:cs typeface="+mn-lt"/>
+              </a:rPr>
+              <a:t>• Source: assets/sample-audio.mp3</a:t>
+            </a:r>
+          </a:p>
+          <a:p>
+            <a:pPr algn="l"/>
+            <a:r>
+              <a:rPr sz="950">
+                <a:solidFill>
+                  <a:srgbClr val="64748B"/>
+                </a:solidFill>
+                <a:latin typeface="+mn-lt"/>
+                <a:cs typeface="+mn-lt"/>
+              </a:rPr>
+              <a:t>• Trigger: onClick | Loop: true | Vol: 80%</a:t>
+            </a:r>
+          </a:p>
+          <a:p>
+            <a:pPr algn="l"/>
+            <a:r>
+              <a:rPr sz="950">
+                <a:solidFill>
+                  <a:srgbClr val="64748B"/>
+                </a:solidFill>
+                <a:latin typeface="+mn-lt"/>
+                <a:cs typeface="+mn-lt"/>
+              </a:rPr>
+              <a:t>• OpenXML: &lt;p:audioFile&gt; + &lt;p14:media&gt;</a:t>
+            </a:r>
+          </a:p>
+        </p:txBody>
+      </p:sp>
+      <p:sp>
+        <p:nvSpPr>
+          <p:cNvPr id="10" name="roundRect 9"/>
+          <p:cNvSpPr/>
+          <p:nvPr/>
+        </p:nvSpPr>
+        <p:spPr>
+          <a:xfrm>
+            <a:off x="914400" y="4343400"/>
+            <a:ext cx="4846320" cy="1737360"/>
+          </a:xfrm>
+          <a:prstGeom prst="roundRect">
+            <a:avLst/>
+          </a:prstGeom>
+          <a:solidFill>
+            <a:srgbClr val="0F172A"/>
+          </a:solidFill>
+        </p:spPr>
+        <p:txBody>
+          <a:bodyPr/>
+          <a:lstStyle/>
+          <a:p>
+            <a:endParaRPr/>
+          </a:p>
+        </p:txBody>
+      </p:sp>
+      <p:sp>
+        <p:nvSpPr>
+          <p:cNvPr id="11" name="Text Box 10"/>
+          <p:cNvSpPr/>
+          <p:nvPr/>
+        </p:nvSpPr>
+        <p:spPr>
+          <a:xfrm>
+            <a:off x="1005840" y="4389120"/>
+            <a:ext cx="4663440" cy="1645920"/>
+          </a:xfrm>
+          <a:prstGeom prst="rect">
+            <a:avLst/>
+          </a:prstGeom>
+        </p:spPr>
+        <p:txBody>
+          <a:bodyPr anchor="t"/>
+          <a:lstStyle/>
+          <a:p>
+            <a:pPr algn="l"/>
+            <a:r>
+              <a:rPr b="1" sz="900">
+                <a:solidFill>
+                  <a:srgbClr val="38BDF8"/>
+                </a:solidFill>
+                <a:latin typeface="+mn-lt"/>
+                <a:cs typeface="+mn-lt"/>
+              </a:rPr>
+              <a:t>// Embed audio with custom playback controls</a:t>
+            </a:r>
+          </a:p>
+          <a:p>
+            <a:pPr algn="l"/>
+            <a:r>
+              <a:rPr sz="850">
+                <a:solidFill>
+                  <a:srgbClr val="E2E8F0"/>
+                </a:solidFill>
+                <a:latin typeface="+mn-lt"/>
+                <a:cs typeface="+mn-lt"/>
+              </a:rPr>
+              <a:t>slide.addAudio(audioBuffer, {</a:t>
+            </a:r>
+          </a:p>
+          <a:p>
+            <a:pPr algn="l"/>
+            <a:r>
+              <a:rPr sz="850">
+                <a:solidFill>
+                  <a:srgbClr val="E2E8F0"/>
+                </a:solidFill>
+                <a:latin typeface="+mn-lt"/>
+                <a:cs typeface="+mn-lt"/>
+              </a:rPr>
+              <a:t>  fileName: 'sample-audio.mp3',</a:t>
+            </a:r>
+          </a:p>
+          <a:p>
+            <a:pPr algn="l"/>
+            <a:r>
+              <a:rPr sz="850">
+                <a:solidFill>
+                  <a:srgbClr val="E2E8F0"/>
+                </a:solidFill>
+                <a:latin typeface="+mn-lt"/>
+                <a:cs typeface="+mn-lt"/>
+              </a:rPr>
+              <a:t>  mimeType: 'audio/mpeg',</a:t>
+            </a:r>
+          </a:p>
+          <a:p>
+            <a:pPr algn="l"/>
+            <a:r>
+              <a:rPr sz="850">
+                <a:solidFill>
+                  <a:srgbClr val="E2E8F0"/>
+                </a:solidFill>
+                <a:latin typeface="+mn-lt"/>
+                <a:cs typeface="+mn-lt"/>
+              </a:rPr>
+              <a:t>  trigger: 'onClick', // or 'automatic'</a:t>
+            </a:r>
+          </a:p>
+          <a:p>
+            <a:pPr algn="l"/>
+            <a:r>
+              <a:rPr sz="850">
+                <a:solidFill>
+                  <a:srgbClr val="E2E8F0"/>
+                </a:solidFill>
+                <a:latin typeface="+mn-lt"/>
+                <a:cs typeface="+mn-lt"/>
+              </a:rPr>
+              <a:t>  loop: true,</a:t>
+            </a:r>
+          </a:p>
+          <a:p>
+            <a:pPr algn="l"/>
+            <a:r>
+              <a:rPr sz="850">
+                <a:solidFill>
+                  <a:srgbClr val="E2E8F0"/>
+                </a:solidFill>
+                <a:latin typeface="+mn-lt"/>
+                <a:cs typeface="+mn-lt"/>
+              </a:rPr>
+              <a:t>  volume: 0.8,</a:t>
+            </a:r>
+          </a:p>
+          <a:p>
+            <a:pPr algn="l"/>
+            <a:r>
+              <a:rPr sz="850">
+                <a:solidFill>
+                  <a:srgbClr val="E2E8F0"/>
+                </a:solidFill>
+                <a:latin typeface="+mn-lt"/>
+                <a:cs typeface="+mn-lt"/>
+              </a:rPr>
+              <a:t>  startTime: 1000, endTime: 15000</a:t>
+            </a:r>
+          </a:p>
+          <a:p>
+            <a:pPr algn="l"/>
+            <a:r>
+              <a:rPr sz="850">
+                <a:solidFill>
+                  <a:srgbClr val="E2E8F0"/>
+                </a:solidFill>
+                <a:latin typeface="+mn-lt"/>
+                <a:cs typeface="+mn-lt"/>
+              </a:rPr>
+              <a:t>});</a:t>
+            </a:r>
+          </a:p>
+        </p:txBody>
+      </p:sp>
+      <p:sp>
+        <p:nvSpPr>
+          <p:cNvPr id="12" name="roundRect 11"/>
+          <p:cNvSpPr/>
+          <p:nvPr/>
+        </p:nvSpPr>
+        <p:spPr>
+          <a:xfrm>
+            <a:off x="6217920" y="1828800"/>
+            <a:ext cx="5212080" cy="4480560"/>
+          </a:xfrm>
+          <a:prstGeom prst="roundRect">
+            <a:avLst/>
+          </a:prstGeom>
+          <a:solidFill>
+            <a:srgbClr val="FFFFFF"/>
+          </a:solidFill>
+          <a:ln w="13716">
+            <a:solidFill>
+              <a:srgbClr val="E2E8F0"/>
+            </a:solidFill>
+          </a:ln>
+          <a:effectLst>
+            <a:outerShdw blurRad="109728" dist="38100" dir="5400000">
+              <a:srgbClr val="0F172A">
+                <a:alpha val="8000"/>
+              </a:srgbClr>
+            </a:outerShdw>
+          </a:effectLst>
+        </p:spPr>
+        <p:txBody>
+          <a:bodyPr/>
+          <a:lstStyle/>
+          <a:p>
+            <a:endParaRPr/>
+          </a:p>
+        </p:txBody>
+      </p:sp>
+      <p:sp>
+        <p:nvSpPr>
+          <p:cNvPr id="13" name="Text Box 12"/>
+          <p:cNvSpPr/>
+          <p:nvPr/>
+        </p:nvSpPr>
+        <p:spPr>
+          <a:xfrm>
+            <a:off x="6400800" y="2011680"/>
+            <a:ext cx="4846320" cy="320040"/>
+          </a:xfrm>
+          <a:prstGeom prst="rect">
+            <a:avLst/>
+          </a:prstGeom>
+        </p:spPr>
+        <p:txBody>
+          <a:bodyPr anchor="t"/>
+          <a:lstStyle/>
+          <a:p>
+            <a:pPr algn="l"/>
+            <a:r>
+              <a:rPr b="1" sz="1300">
+                <a:solidFill>
+                  <a:srgbClr val="0F172A"/>
+                </a:solidFill>
+                <a:latin typeface="+mn-lt"/>
+                <a:cs typeface="+mn-lt"/>
+              </a:rPr>
+              <a:t>🎬 High-Fidelity Video &amp; Motion Graphics</a:t>
+            </a:r>
+          </a:p>
+        </p:txBody>
+      </p:sp>
+      <p:sp>
+        <p:nvSpPr>
+          <p:cNvPr id="14" name="Text Box 13"/>
+          <p:cNvSpPr/>
+          <p:nvPr/>
+        </p:nvSpPr>
+        <p:spPr>
+          <a:xfrm>
+            <a:off x="6400800" y="2331720"/>
+            <a:ext cx="4846320" cy="411480"/>
+          </a:xfrm>
+          <a:prstGeom prst="rect">
+            <a:avLst/>
+          </a:prstGeom>
+        </p:spPr>
+        <p:txBody>
+          <a:bodyPr anchor="t"/>
+          <a:lstStyle/>
+          <a:p>
+            <a:pPr algn="l"/>
+            <a:r>
+              <a:rPr sz="1050">
+                <a:solidFill>
+                  <a:srgbClr val="64748B"/>
+                </a:solidFill>
+                <a:latin typeface="+mn-lt"/>
+                <a:cs typeface="+mn-lt"/>
+              </a:rPr>
+              <a:t>Embed cross-platform MP4/MOV/AVI video containers with custom dimensions, looping, and mute:</a:t>
+            </a:r>
+          </a:p>
+        </p:txBody>
+      </p:sp>
+      <p:sp>
+        <p:nvSpPr>
+          <p:cNvPr id="15" name="roundRect 14"/>
+          <p:cNvSpPr/>
+          <p:nvPr/>
+        </p:nvSpPr>
+        <p:spPr>
+          <a:xfrm>
+            <a:off x="6400800" y="2788920"/>
+            <a:ext cx="4846320" cy="1371600"/>
+          </a:xfrm>
+          <a:prstGeom prst="roundRect">
+            <a:avLst/>
+          </a:prstGeom>
+          <a:solidFill>
+            <a:srgbClr val="0F172A"/>
+          </a:solidFill>
+          <a:ln w="13716">
+            <a:solidFill>
+              <a:srgbClr val="334155"/>
+            </a:solidFill>
+          </a:ln>
+        </p:spPr>
+        <p:txBody>
+          <a:bodyPr/>
+          <a:lstStyle/>
+          <a:p>
+            <a:endParaRPr/>
+          </a:p>
+        </p:txBody>
+      </p:sp>
+      <p:sp>
+        <p:nvSpPr>
+          <p:cNvPr id="17" name="Text Box 16"/>
+          <p:cNvSpPr/>
+          <p:nvPr/>
+        </p:nvSpPr>
+        <p:spPr>
+          <a:xfrm>
+            <a:off x="8321040" y="2926080"/>
+            <a:ext cx="2834640" cy="1097280"/>
+          </a:xfrm>
+          <a:prstGeom prst="rect">
+            <a:avLst/>
+          </a:prstGeom>
+        </p:spPr>
+        <p:txBody>
+          <a:bodyPr anchor="t"/>
+          <a:lstStyle/>
+          <a:p>
+            <a:pPr algn="l"/>
+            <a:r>
+              <a:rPr b="1" sz="1100">
+                <a:solidFill>
+                  <a:srgbClr val="FFFFFF"/>
+                </a:solidFill>
+                <a:latin typeface="+mn-lt"/>
+                <a:cs typeface="+mn-lt"/>
+              </a:rPr>
+              <a:t>Embedded Video Player Container</a:t>
+            </a:r>
+          </a:p>
+          <a:p>
+            <a:pPr algn="l"/>
+            <a:r>
+              <a:rPr sz="950">
+                <a:solidFill>
+                  <a:srgbClr val="38BDF8"/>
+                </a:solidFill>
+                <a:latin typeface="+mn-lt"/>
+                <a:cs typeface="+mn-lt"/>
+              </a:rPr>
+              <a:t>• Source: assets/sample-video.mp4 (H.264)</a:t>
+            </a:r>
+          </a:p>
+          <a:p>
+            <a:pPr algn="l"/>
+            <a:r>
+              <a:rPr sz="950">
+                <a:solidFill>
+                  <a:srgbClr val="94A3B8"/>
+                </a:solidFill>
+                <a:latin typeface="+mn-lt"/>
+                <a:cs typeface="+mn-lt"/>
+              </a:rPr>
+              <a:t>• Trigger: automatic | Muted: true</a:t>
+            </a:r>
+          </a:p>
+          <a:p>
+            <a:pPr algn="l"/>
+            <a:r>
+              <a:rPr sz="950">
+                <a:solidFill>
+                  <a:srgbClr val="94A3B8"/>
+                </a:solidFill>
+                <a:latin typeface="+mn-lt"/>
+                <a:cs typeface="+mn-lt"/>
+              </a:rPr>
+              <a:t>• OpenXML: &lt;p:videoFile&gt; + &lt;p14:media&gt;</a:t>
+            </a:r>
+          </a:p>
+        </p:txBody>
+      </p:sp>
+      <p:sp>
+        <p:nvSpPr>
+          <p:cNvPr id="18" name="roundRect 17"/>
+          <p:cNvSpPr/>
+          <p:nvPr/>
+        </p:nvSpPr>
+        <p:spPr>
+          <a:xfrm>
+            <a:off x="6400800" y="4343400"/>
+            <a:ext cx="4846320" cy="1737360"/>
+          </a:xfrm>
+          <a:prstGeom prst="roundRect">
+            <a:avLst/>
+          </a:prstGeom>
+          <a:solidFill>
+            <a:srgbClr val="0F172A"/>
+          </a:solidFill>
+        </p:spPr>
+        <p:txBody>
+          <a:bodyPr/>
+          <a:lstStyle/>
+          <a:p>
+            <a:endParaRPr/>
+          </a:p>
+        </p:txBody>
+      </p:sp>
+      <p:sp>
+        <p:nvSpPr>
+          <p:cNvPr id="19" name="Text Box 18"/>
+          <p:cNvSpPr/>
+          <p:nvPr/>
+        </p:nvSpPr>
+        <p:spPr>
+          <a:xfrm>
+            <a:off x="6492240" y="4389120"/>
+            <a:ext cx="4663440" cy="1645920"/>
+          </a:xfrm>
+          <a:prstGeom prst="rect">
+            <a:avLst/>
+          </a:prstGeom>
+        </p:spPr>
+        <p:txBody>
+          <a:bodyPr anchor="t"/>
+          <a:lstStyle/>
+          <a:p>
+            <a:pPr algn="l"/>
+            <a:r>
+              <a:rPr b="1" sz="900">
+                <a:solidFill>
+                  <a:srgbClr val="38BDF8"/>
+                </a:solidFill>
+                <a:latin typeface="+mn-lt"/>
+                <a:cs typeface="+mn-lt"/>
+              </a:rPr>
+              <a:t>// Embed video with custom dimensions &amp; muted</a:t>
+            </a:r>
+          </a:p>
+          <a:p>
+            <a:pPr algn="l"/>
+            <a:r>
+              <a:rPr sz="850">
+                <a:solidFill>
+                  <a:srgbClr val="E2E8F0"/>
+                </a:solidFill>
+                <a:latin typeface="+mn-lt"/>
+                <a:cs typeface="+mn-lt"/>
+              </a:rPr>
+              <a:t>slide.addVideo(videoBuffer, {</a:t>
+            </a:r>
+          </a:p>
+          <a:p>
+            <a:pPr algn="l"/>
+            <a:r>
+              <a:rPr sz="850">
+                <a:solidFill>
+                  <a:srgbClr val="E2E8F0"/>
+                </a:solidFill>
+                <a:latin typeface="+mn-lt"/>
+                <a:cs typeface="+mn-lt"/>
+              </a:rPr>
+              <a:t>  fileName: 'product_demo.mp4',</a:t>
+            </a:r>
+          </a:p>
+          <a:p>
+            <a:pPr algn="l"/>
+            <a:r>
+              <a:rPr sz="850">
+                <a:solidFill>
+                  <a:srgbClr val="E2E8F0"/>
+                </a:solidFill>
+                <a:latin typeface="+mn-lt"/>
+                <a:cs typeface="+mn-lt"/>
+              </a:rPr>
+              <a:t>  mimeType: 'video/mp4',</a:t>
+            </a:r>
+          </a:p>
+          <a:p>
+            <a:pPr algn="l"/>
+            <a:r>
+              <a:rPr sz="850">
+                <a:solidFill>
+                  <a:srgbClr val="E2E8F0"/>
+                </a:solidFill>
+                <a:latin typeface="+mn-lt"/>
+                <a:cs typeface="+mn-lt"/>
+              </a:rPr>
+              <a:t>  x: inches(2), y: inches(1.5),</a:t>
+            </a:r>
+          </a:p>
+          <a:p>
+            <a:pPr algn="l"/>
+            <a:r>
+              <a:rPr sz="850">
+                <a:solidFill>
+                  <a:srgbClr val="E2E8F0"/>
+                </a:solidFill>
+                <a:latin typeface="+mn-lt"/>
+                <a:cs typeface="+mn-lt"/>
+              </a:rPr>
+              <a:t>  w: inches(6), h: inches(4.5),</a:t>
+            </a:r>
+          </a:p>
+          <a:p>
+            <a:pPr algn="l"/>
+            <a:r>
+              <a:rPr sz="850">
+                <a:solidFill>
+                  <a:srgbClr val="E2E8F0"/>
+                </a:solidFill>
+                <a:latin typeface="+mn-lt"/>
+                <a:cs typeface="+mn-lt"/>
+              </a:rPr>
+              <a:t>  muted: true, loop: true,</a:t>
+            </a:r>
+          </a:p>
+          <a:p>
+            <a:pPr algn="l"/>
+            <a:r>
+              <a:rPr sz="850">
+                <a:solidFill>
+                  <a:srgbClr val="E2E8F0"/>
+                </a:solidFill>
+                <a:latin typeface="+mn-lt"/>
+                <a:cs typeface="+mn-lt"/>
+              </a:rPr>
+              <a:t>  trigger: 'automatic'</a:t>
+            </a:r>
+          </a:p>
+          <a:p>
+            <a:pPr algn="l"/>
+            <a:r>
+              <a:rPr sz="850">
+                <a:solidFill>
+                  <a:srgbClr val="E2E8F0"/>
+                </a:solidFill>
+                <a:latin typeface="+mn-lt"/>
+                <a:cs typeface="+mn-lt"/>
+              </a:rPr>
+              <a:t>});</a:t>
+            </a:r>
+          </a:p>
+        </p:txBody>
+      </p:sp>
+      <p:sp>
+        <p:nvSpPr>
+          <p:cNvPr id="20" name="Text Box 19"/>
+          <p:cNvSpPr/>
+          <p:nvPr/>
+        </p:nvSpPr>
+        <p:spPr>
+          <a:xfrm>
+            <a:off x="731520" y="6510528"/>
+            <a:ext cx="10725912" cy="228600"/>
+          </a:xfrm>
+          <a:prstGeom prst="rect">
+            <a:avLst/>
+          </a:prstGeom>
+        </p:spPr>
+        <p:txBody>
+          <a:bodyPr anchor="t"/>
+          <a:lstStyle/>
+          <a:p>
+            <a:pPr algn="ctr"/>
+            <a:r>
+              <a:rPr i="1" sz="800">
+                <a:solidFill>
+                  <a:srgbClr val="94A3B8"/>
+                </a:solidFill>
+                <a:latin typeface="+mn-lt"/>
+                <a:cs typeface="+mn-lt"/>
+              </a:rPr>
+              <a:t>* Disclaimer: All benchmark metrics, performance figures, and simulated architectures in this deck are synthetic demonstration values generated solely to showcase the authoring, formatting, and rendering capabilities of @hokkyss/pptx.</a:t>
+            </a:r>
+          </a:p>
+        </p:txBody>
+      </p:sp>
+      <p:pic>
+        <p:nvPicPr>
+          <p:cNvPr id="8" name="Showcase Audio Track"/>
+          <p:cNvPicPr>
+            <a:picLocks noChangeAspect="1"/>
+          </p:cNvPicPr>
+          <p:nvPr>
+            <a:audioFile r:link="rId3"/>
+            <p:extLst>
+              <p:ext uri="{DAA4B4D4-6D71-4841-9C94-3DE7FCFB9230}">
+                <p14:media xmlns:p14="http://schemas.microsoft.com/office/powerpoint/2010/main" r:embed="rId4"/>
+              </p:ext>
+            </p:extLst>
+          </p:nvPr>
+        </p:nvPicPr>
+        <p:blipFill>
+          <a:blip r:embed="rId2"/>
+          <a:stretch>
+            <a:fillRect/>
+          </a:stretch>
+        </p:blipFill>
+        <p:spPr>
+          <a:xfrm>
+            <a:off x="1097280" y="3017520"/>
+            <a:ext cx="914400" cy="914400"/>
+          </a:xfrm>
+          <a:prstGeom prst="rect">
+            <a:avLst/>
+          </a:prstGeom>
+          <a:noFill/>
+          <a:ln>
+            <a:noFill/>
+          </a:ln>
+        </p:spPr>
+      </p:pic>
+      <p:pic>
+        <p:nvPicPr>
+          <p:cNvPr id="16" name="Showcase Video Track"/>
+          <p:cNvPicPr>
+            <a:picLocks noChangeAspect="1"/>
+          </p:cNvPicPr>
+          <p:nvPr>
+            <a:videoFile r:link="rId6"/>
+            <p:extLst>
+              <p:ext uri="{DAA4B4D4-6D71-4841-9C94-3DE7FCFB9230}">
+                <p14:media xmlns:p14="http://schemas.microsoft.com/office/powerpoint/2010/main" r:embed="rId7"/>
+              </p:ext>
+            </p:extLst>
+          </p:nvPr>
+        </p:nvPicPr>
+        <p:blipFill>
+          <a:blip r:embed="rId5"/>
+          <a:stretch>
+            <a:fillRect/>
+          </a:stretch>
+        </p:blipFill>
+        <p:spPr>
+          <a:xfrm>
+            <a:off x="6537960" y="2880360"/>
+            <a:ext cx="1645920" cy="1188720"/>
+          </a:xfrm>
+          <a:prstGeom prst="rect">
+            <a:avLst/>
+          </a:prstGeom>
+          <a:noFill/>
+          <a:ln>
+            <a:noFill/>
+          </a:ln>
+        </p:spPr>
+      </p:pic>
+    </p:spTree>
+  </p:cSld>
+  <p:clrMapOvr>
+    <a:masterClrMapping/>
+  </p:clrMapOvr>
+  <p:transition spd="fast">
+    <p:fade/>
+  </p:transition>
+  <p:timing>
+    <p:tnLst>
+      <p:par>
+        <p:cTn dur="indefinite" id="1" nodeType="tmRoot" restart="never">
+          <p:childTnLst>
+            <p:seq concurrent="1" nextAc="seek">
+              <p:cTn dur="indefinite" id="2" nodeType="mainSeq">
+                <p:childTnLst>
+                  <p:video>
+                    <p:cMediaNode vol="0">
+                      <p:cTn dur="indefinite" id="6" nodeType="withEffect" repeatCount="indefinite">
+                        <p:stCondLst>
+                          <p:cond delay="0"/>
+                        </p:stCondLst>
+                        <p:endCondLst>
+                          <p:cond delay="0" evt="onStopAudio"/>
+                        </p:endCondLst>
+                      </p:cTn>
+                      <p:tgtEl>
+                        <p:spTgt spid="16"/>
+                      </p:tgtEl>
+                    </p:cMediaNode>
+                  </p:video>
+                </p:childTnLst>
+              </p:cTn>
+            </p:seq>
+            <p:seq concurrent="1" nextAc="seek">
+              <p:cTn evtFilter="cancelBubble" fill="hold" id="4" nodeType="interactiveSeq" restart="whenNotActive">
+                <p:stCondLst>
+                  <p:cond delay="0" evt="onClick">
+                    <p:tgtEl>
+                      <p:spTgt spid="8"/>
+                    </p:tgtEl>
+                  </p:cond>
+                </p:stCondLst>
+                <p:childTnLst>
+                  <p:audio>
+                    <p:cMediaNode vol="80000">
+                      <p:cTn dur="indefinite" id="3" nodeType="clickEffect" restart="never" repeatCount="indefinite">
+                        <p:stCondLst>
+                          <p:cond delay="0"/>
+                        </p:stCondLst>
+                        <p:endCondLst>
+                          <p:cond delay="0" evt="onStopAudio"/>
+                        </p:endCondLst>
+                      </p:cTn>
+                      <p:tgtEl>
+                        <p:spTgt spid="8"/>
+                      </p:tgtEl>
+                    </p:cMediaNode>
+                  </p:audio>
+                </p:childTnLst>
+              </p:cTn>
+            </p:seq>
+          </p:childTnLst>
+        </p:cTn>
+      </p:par>
+    </p:tnLst>
+  </p:timing>
+</p:sld>
+</file>
+
+<file path=ppt/slides/slide15.xml><?xml version="1.0" encoding="utf-8"?>
+<p:sld xmlns:a="http://schemas.openxmlformats.org/drawingml/2006/main" xmlns:p="http://schemas.openxmlformats.org/presentationml/2006/main" xmlns:r="http://schemas.openxmlformats.org/officeDocument/2006/relationships">
   <p:cSld>
     <p:bg>
       <p:bgPr>
@@ -6970,7 +8081,7 @@
 </file>
 
 <file path=ppt/slides/slide2.xml><?xml version="1.0" encoding="utf-8"?>
-<p:sld xmlns:a="http://schemas.openxmlformats.org/drawingml/2006/main" xmlns:r="http://schemas.openxmlformats.org/officeDocument/2006/relationships" xmlns:p="http://schemas.openxmlformats.org/presentationml/2006/main">
+<p:sld xmlns:a="http://schemas.openxmlformats.org/drawingml/2006/main" xmlns:p="http://schemas.openxmlformats.org/presentationml/2006/main" xmlns:r="http://schemas.openxmlformats.org/officeDocument/2006/relationships">
   <p:cSld>
     <p:bg>
       <p:bgPr>
@@ -7502,7 +8613,7 @@
 </file>
 
 <file path=ppt/slides/slide3.xml><?xml version="1.0" encoding="utf-8"?>
-<p:sld xmlns:a="http://schemas.openxmlformats.org/drawingml/2006/main" xmlns:r="http://schemas.openxmlformats.org/officeDocument/2006/relationships" xmlns:p="http://schemas.openxmlformats.org/presentationml/2006/main">
+<p:sld xmlns:a="http://schemas.openxmlformats.org/drawingml/2006/main" xmlns:p="http://schemas.openxmlformats.org/presentationml/2006/main" xmlns:r="http://schemas.openxmlformats.org/officeDocument/2006/relationships">
   <p:cSld>
     <p:bg>
       <p:bgPr>
@@ -8396,7 +9507,7 @@
 </file>
 
 <file path=ppt/slides/slide4.xml><?xml version="1.0" encoding="utf-8"?>
-<p:sld xmlns:a="http://schemas.openxmlformats.org/drawingml/2006/main" xmlns:r="http://schemas.openxmlformats.org/officeDocument/2006/relationships" xmlns:p="http://schemas.openxmlformats.org/presentationml/2006/main">
+<p:sld xmlns:a="http://schemas.openxmlformats.org/drawingml/2006/main" xmlns:p="http://schemas.openxmlformats.org/presentationml/2006/main" xmlns:r="http://schemas.openxmlformats.org/officeDocument/2006/relationships">
   <p:cSld>
     <p:bg>
       <p:bgPr>
@@ -8802,7 +9913,7 @@
 </file>
 
 <file path=ppt/slides/slide5.xml><?xml version="1.0" encoding="utf-8"?>
-<p:sld xmlns:a="http://schemas.openxmlformats.org/drawingml/2006/main" xmlns:r="http://schemas.openxmlformats.org/officeDocument/2006/relationships" xmlns:p="http://schemas.openxmlformats.org/presentationml/2006/main">
+<p:sld xmlns:a="http://schemas.openxmlformats.org/drawingml/2006/main" xmlns:p="http://schemas.openxmlformats.org/presentationml/2006/main" xmlns:r="http://schemas.openxmlformats.org/officeDocument/2006/relationships">
   <p:cSld>
     <p:bg>
       <p:bgPr>
@@ -9450,7 +10561,7 @@
 </file>
 
 <file path=ppt/slides/slide6.xml><?xml version="1.0" encoding="utf-8"?>
-<p:sld xmlns:a="http://schemas.openxmlformats.org/drawingml/2006/main" xmlns:r="http://schemas.openxmlformats.org/officeDocument/2006/relationships" xmlns:p="http://schemas.openxmlformats.org/presentationml/2006/main">
+<p:sld xmlns:a="http://schemas.openxmlformats.org/drawingml/2006/main" xmlns:p="http://schemas.openxmlformats.org/presentationml/2006/main" xmlns:r="http://schemas.openxmlformats.org/officeDocument/2006/relationships">
   <p:cSld>
     <p:bg>
       <p:bgPr>
@@ -9914,7 +11025,7 @@
 </file>
 
 <file path=ppt/slides/slide7.xml><?xml version="1.0" encoding="utf-8"?>
-<p:sld xmlns:a="http://schemas.openxmlformats.org/drawingml/2006/main" xmlns:r="http://schemas.openxmlformats.org/officeDocument/2006/relationships" xmlns:p="http://schemas.openxmlformats.org/presentationml/2006/main">
+<p:sld xmlns:a="http://schemas.openxmlformats.org/drawingml/2006/main" xmlns:p="http://schemas.openxmlformats.org/presentationml/2006/main" xmlns:r="http://schemas.openxmlformats.org/officeDocument/2006/relationships">
   <p:cSld>
     <p:bg>
       <p:bgPr>
@@ -10531,7 +11642,7 @@
 </file>
 
 <file path=ppt/slides/slide8.xml><?xml version="1.0" encoding="utf-8"?>
-<p:sld xmlns:a="http://schemas.openxmlformats.org/drawingml/2006/main" xmlns:r="http://schemas.openxmlformats.org/officeDocument/2006/relationships" xmlns:p="http://schemas.openxmlformats.org/presentationml/2006/main">
+<p:sld xmlns:a="http://schemas.openxmlformats.org/drawingml/2006/main" xmlns:p="http://schemas.openxmlformats.org/presentationml/2006/main" xmlns:r="http://schemas.openxmlformats.org/officeDocument/2006/relationships">
   <p:cSld>
     <p:bg>
       <p:bgPr>
@@ -11241,7 +12352,7 @@
 </file>
 
 <file path=ppt/slides/slide9.xml><?xml version="1.0" encoding="utf-8"?>
-<p:sld xmlns:a="http://schemas.openxmlformats.org/drawingml/2006/main" xmlns:r="http://schemas.openxmlformats.org/officeDocument/2006/relationships" xmlns:p="http://schemas.openxmlformats.org/presentationml/2006/main">
+<p:sld xmlns:a="http://schemas.openxmlformats.org/drawingml/2006/main" xmlns:p="http://schemas.openxmlformats.org/presentationml/2006/main" xmlns:r="http://schemas.openxmlformats.org/officeDocument/2006/relationships">
   <p:cSld>
     <p:bg>
       <p:bgPr>

</xml_diff>

<commit_message>
feat(media): add custom poster frame (thumbnail) support for audio and video elements
</commit_message>
<xml_diff>
--- a/hokkyss_showcase_deck.pptx
+++ b/hokkyss_showcase_deck.pptx
@@ -6301,20 +6301,20 @@
                 <a:latin typeface="+mn-lt"/>
                 <a:cs typeface="+mn-lt"/>
               </a:rPr>
+              <a:t>• Poster: custom-audio-poster.png (Custom thumbnail)</a:t>
+            </a:r>
+          </a:p>
+          <a:p>
+            <a:pPr algn="l"/>
+            <a:r>
+              <a:rPr sz="950">
+                <a:solidFill>
+                  <a:srgbClr val="64748B"/>
+                </a:solidFill>
+                <a:latin typeface="+mn-lt"/>
+                <a:cs typeface="+mn-lt"/>
+              </a:rPr>
               <a:t>• Trigger: onClick | Loop: true | Vol: 80%</a:t>
-            </a:r>
-          </a:p>
-          <a:p>
-            <a:pPr algn="l"/>
-            <a:r>
-              <a:rPr sz="950">
-                <a:solidFill>
-                  <a:srgbClr val="64748B"/>
-                </a:solidFill>
-                <a:latin typeface="+mn-lt"/>
-                <a:cs typeface="+mn-lt"/>
-              </a:rPr>
-              <a:t>• OpenXML: &lt;p:audioFile&gt; + &lt;p14:media&gt;</a:t>
             </a:r>
           </a:p>
         </p:txBody>
@@ -6373,7 +6373,7 @@
                 <a:latin typeface="+mn-lt"/>
                 <a:cs typeface="+mn-lt"/>
               </a:rPr>
-              <a:t>// Embed audio with custom playback controls</a:t>
+              <a:t>// Embed audio with custom poster thumbnail &amp; controls</a:t>
             </a:r>
           </a:p>
           <a:p>
@@ -6425,6 +6425,19 @@
                 <a:latin typeface="+mn-lt"/>
                 <a:cs typeface="+mn-lt"/>
               </a:rPr>
+              <a:t>  poster: { data: coverBytes, mimeType: 'image/png' },</a:t>
+            </a:r>
+          </a:p>
+          <a:p>
+            <a:pPr algn="l"/>
+            <a:r>
+              <a:rPr sz="850">
+                <a:solidFill>
+                  <a:srgbClr val="E2E8F0"/>
+                </a:solidFill>
+                <a:latin typeface="+mn-lt"/>
+                <a:cs typeface="+mn-lt"/>
+              </a:rPr>
               <a:t>  trigger: 'onClick', // or 'automatic'</a:t>
             </a:r>
           </a:p>
@@ -6451,20 +6464,7 @@
                 <a:latin typeface="+mn-lt"/>
                 <a:cs typeface="+mn-lt"/>
               </a:rPr>
-              <a:t>  volume: 0.8,</a:t>
-            </a:r>
-          </a:p>
-          <a:p>
-            <a:pPr algn="l"/>
-            <a:r>
-              <a:rPr sz="850">
-                <a:solidFill>
-                  <a:srgbClr val="E2E8F0"/>
-                </a:solidFill>
-                <a:latin typeface="+mn-lt"/>
-                <a:cs typeface="+mn-lt"/>
-              </a:rPr>
-              <a:t>  startTime: 1000, endTime: 15000</a:t>
+              <a:t>  volume: 0.8</a:t>
             </a:r>
           </a:p>
           <a:p>
@@ -6581,7 +6581,7 @@
                 <a:latin typeface="+mn-lt"/>
                 <a:cs typeface="+mn-lt"/>
               </a:rPr>
-              <a:t>Embed cross-platform MP4/MOV/AVI video containers with custom dimensions, looping, and mute:</a:t>
+              <a:t>Embed cross-platform MP4/MOV/AVI video containers with custom poster thumbnails, looping, and mute:</a:t>
             </a:r>
           </a:p>
         </p:txBody>
@@ -6671,20 +6671,20 @@
                 <a:latin typeface="+mn-lt"/>
                 <a:cs typeface="+mn-lt"/>
               </a:rPr>
+              <a:t>• Poster: custom-video-poster.png (Custom thumbnail)</a:t>
+            </a:r>
+          </a:p>
+          <a:p>
+            <a:pPr algn="l"/>
+            <a:r>
+              <a:rPr sz="950">
+                <a:solidFill>
+                  <a:srgbClr val="94A3B8"/>
+                </a:solidFill>
+                <a:latin typeface="+mn-lt"/>
+                <a:cs typeface="+mn-lt"/>
+              </a:rPr>
               <a:t>• Trigger: automatic | Muted: true</a:t>
-            </a:r>
-          </a:p>
-          <a:p>
-            <a:pPr algn="l"/>
-            <a:r>
-              <a:rPr sz="950">
-                <a:solidFill>
-                  <a:srgbClr val="94A3B8"/>
-                </a:solidFill>
-                <a:latin typeface="+mn-lt"/>
-                <a:cs typeface="+mn-lt"/>
-              </a:rPr>
-              <a:t>• OpenXML: &lt;p:videoFile&gt; + &lt;p14:media&gt;</a:t>
             </a:r>
           </a:p>
         </p:txBody>
@@ -6743,7 +6743,7 @@
                 <a:latin typeface="+mn-lt"/>
                 <a:cs typeface="+mn-lt"/>
               </a:rPr>
-              <a:t>// Embed video with custom dimensions &amp; muted</a:t>
+              <a:t>// Embed video with custom poster thumbnail &amp; controls</a:t>
             </a:r>
           </a:p>
           <a:p>
@@ -6795,6 +6795,19 @@
                 <a:latin typeface="+mn-lt"/>
                 <a:cs typeface="+mn-lt"/>
               </a:rPr>
+              <a:t>  poster: { data: posterBytes, mimeType: 'image/png' },</a:t>
+            </a:r>
+          </a:p>
+          <a:p>
+            <a:pPr algn="l"/>
+            <a:r>
+              <a:rPr sz="850">
+                <a:solidFill>
+                  <a:srgbClr val="E2E8F0"/>
+                </a:solidFill>
+                <a:latin typeface="+mn-lt"/>
+                <a:cs typeface="+mn-lt"/>
+              </a:rPr>
               <a:t>  x: inches(2), y: inches(1.5),</a:t>
             </a:r>
           </a:p>
@@ -6821,20 +6834,7 @@
                 <a:latin typeface="+mn-lt"/>
                 <a:cs typeface="+mn-lt"/>
               </a:rPr>
-              <a:t>  muted: true, loop: true,</a:t>
-            </a:r>
-          </a:p>
-          <a:p>
-            <a:pPr algn="l"/>
-            <a:r>
-              <a:rPr sz="850">
-                <a:solidFill>
-                  <a:srgbClr val="E2E8F0"/>
-                </a:solidFill>
-                <a:latin typeface="+mn-lt"/>
-                <a:cs typeface="+mn-lt"/>
-              </a:rPr>
-              <a:t>  trigger: 'automatic'</a:t>
+              <a:t>  muted: true, loop: true</a:t>
             </a:r>
           </a:p>
           <a:p>

</xml_diff>

<commit_message>
feat(demo): showcase distinct custom audio album art and video cinematic thumbnails on Slide 14
</commit_message>
<xml_diff>
--- a/hokkyss_showcase_deck.pptx
+++ b/hokkyss_showcase_deck.pptx
@@ -6275,7 +6275,7 @@
                 <a:latin typeface="+mn-lt"/>
                 <a:cs typeface="+mn-lt"/>
               </a:rPr>
-              <a:t>Interactive Audio Clip (Click speaker icon in slideshow)</a:t>
+              <a:t>Interactive Audio Clip (Click custom cover in slideshow)</a:t>
             </a:r>
           </a:p>
           <a:p>
@@ -6301,7 +6301,7 @@
                 <a:latin typeface="+mn-lt"/>
                 <a:cs typeface="+mn-lt"/>
               </a:rPr>
-              <a:t>• Poster: custom-audio-poster.png (Custom thumbnail)</a:t>
+              <a:t>• Poster: custom-audio-thumbnail.png (Album art)</a:t>
             </a:r>
           </a:p>
           <a:p>
@@ -6373,7 +6373,7 @@
                 <a:latin typeface="+mn-lt"/>
                 <a:cs typeface="+mn-lt"/>
               </a:rPr>
-              <a:t>// Embed audio with custom poster thumbnail &amp; controls</a:t>
+              <a:t>// Embed audio with custom album artwork poster</a:t>
             </a:r>
           </a:p>
           <a:p>
@@ -6425,7 +6425,7 @@
                 <a:latin typeface="+mn-lt"/>
                 <a:cs typeface="+mn-lt"/>
               </a:rPr>
-              <a:t>  poster: { data: coverBytes, mimeType: 'image/png' },</a:t>
+              <a:t>  poster: { data: albumArtBytes, mimeType: 'image/png' },</a:t>
             </a:r>
           </a:p>
           <a:p>
@@ -6671,7 +6671,7 @@
                 <a:latin typeface="+mn-lt"/>
                 <a:cs typeface="+mn-lt"/>
               </a:rPr>
-              <a:t>• Poster: custom-video-poster.png (Custom thumbnail)</a:t>
+              <a:t>• Poster: custom-video-thumbnail.png (Cinematic 4K)</a:t>
             </a:r>
           </a:p>
           <a:p>

</xml_diff>

<commit_message>
chore: more showcase variant and docs
</commit_message>
<xml_diff>
--- a/hokkyss_showcase_deck.pptx
+++ b/hokkyss_showcase_deck.pptx
@@ -5,7 +5,7 @@
     <p:sldMasterId id="2147483648" r:id="rId1"/>
   </p:sldMasterIdLst>
   <p:notesMasterIdLst>
-    <p:notesMasterId r:id="rId17"/>
+    <p:notesMasterId r:id="rId18"/>
   </p:notesMasterIdLst>
   <p:sldIdLst>
     <p:sldId id="256" r:id="rId2"/>
@@ -23,6 +23,7 @@
     <p:sldId id="268" r:id="rId14"/>
     <p:sldId id="269" r:id="rId15"/>
     <p:sldId id="270" r:id="rId16"/>
+    <p:sldId id="271" r:id="rId17"/>
   </p:sldIdLst>
   <p:sldSz cx="12192000" cy="6858000"/>
   <p:notesSz cx="6858000" cy="9144000"/>
@@ -2065,14 +2066,14 @@
                 <a:latin typeface="+mn-lt"/>
                 <a:cs typeface="+mn-lt"/>
               </a:rPr>
-              <a:t>DrawingML Gradient Engine Keynote: </a:t>
+              <a:t>Hyperlinks &amp; Slide Navigation Keynote: </a:t>
             </a:r>
             <a:r>
               <a:rPr u="sng">
                 <a:latin typeface="+mn-lt"/>
                 <a:cs typeface="+mn-lt"/>
               </a:rPr>
-              <a:t>Full Vector Fidelity &amp; Transparency</a:t>
+              <a:t>Interactive OpenXML Actions &amp; Relationships</a:t>
             </a:r>
           </a:p>
           <a:p>
@@ -2085,7 +2086,7 @@
                 <a:latin typeface="+mn-lt"/>
                 <a:cs typeface="+mn-lt"/>
               </a:rPr>
-              <a:t>Native &lt;a:gradFill&gt; support with linear, radial, and path gradients.</a:t>
+              <a:t>Full support for external web links, custom URLs, and hover tooltips.</a:t>
             </a:r>
           </a:p>
           <a:p>
@@ -2098,7 +2099,7 @@
                 <a:latin typeface="+mn-lt"/>
                 <a:cs typeface="+mn-lt"/>
               </a:rPr>
-              <a:t>Full alpha transparency channel support across all color stops.</a:t>
+              <a:t>Internal slide jumping using strongly typed slideIndex referencing.</a:t>
             </a:r>
           </a:p>
           <a:p>
@@ -2111,7 +2112,7 @@
                 <a:latin typeface="+mn-lt"/>
                 <a:cs typeface="+mn-lt"/>
               </a:rPr>
-              <a:t>Seamless integration with shapes, cards, outlines, and slide backgrounds.</a:t>
+              <a:t>Built-in slide show control actions: firstSlide, lastSlide, nextSlide, previousSlide, endShow.</a:t>
             </a:r>
           </a:p>
         </p:txBody>
@@ -2173,6 +2174,114 @@
                 <a:latin typeface="+mn-lt"/>
                 <a:cs typeface="+mn-lt"/>
               </a:rPr>
+              <a:t>DrawingML Gradient Engine Keynote: </a:t>
+            </a:r>
+            <a:r>
+              <a:rPr u="sng">
+                <a:latin typeface="+mn-lt"/>
+                <a:cs typeface="+mn-lt"/>
+              </a:rPr>
+              <a:t>Full Vector Fidelity &amp; Transparency</a:t>
+            </a:r>
+          </a:p>
+          <a:p>
+            <a:pPr marL="285750" indent="-285750">
+              <a:buFont typeface="Arial" panose="020B0604020202020204" pitchFamily="34" charset="0"/>
+              <a:buChar char="•"/>
+            </a:pPr>
+            <a:r>
+              <a:rPr>
+                <a:latin typeface="+mn-lt"/>
+                <a:cs typeface="+mn-lt"/>
+              </a:rPr>
+              <a:t>Native &lt;a:gradFill&gt; support with linear, radial, and path gradients.</a:t>
+            </a:r>
+          </a:p>
+          <a:p>
+            <a:pPr marL="285750" indent="-285750">
+              <a:buFont typeface="Arial" panose="020B0604020202020204" pitchFamily="34" charset="0"/>
+              <a:buChar char="•"/>
+            </a:pPr>
+            <a:r>
+              <a:rPr>
+                <a:latin typeface="+mn-lt"/>
+                <a:cs typeface="+mn-lt"/>
+              </a:rPr>
+              <a:t>Full alpha transparency channel support across all color stops.</a:t>
+            </a:r>
+          </a:p>
+          <a:p>
+            <a:pPr marL="285750" indent="-285750">
+              <a:buFont typeface="Arial" panose="020B0604020202020204" pitchFamily="34" charset="0"/>
+              <a:buChar char="•"/>
+            </a:pPr>
+            <a:r>
+              <a:rPr>
+                <a:latin typeface="+mn-lt"/>
+                <a:cs typeface="+mn-lt"/>
+              </a:rPr>
+              <a:t>Seamless integration with shapes, cards, outlines, and slide backgrounds.</a:t>
+            </a:r>
+          </a:p>
+        </p:txBody>
+      </p:sp>
+    </p:spTree>
+  </p:cSld>
+  <p:clrMapOvr>
+    <a:masterClrMapping/>
+  </p:clrMapOvr>
+</p:notes>
+</file>
+
+<file path=ppt/notesSlides/notesSlide12.xml><?xml version="1.0" encoding="utf-8"?>
+<p:notes xmlns:a="http://schemas.openxmlformats.org/drawingml/2006/main" xmlns:r="http://schemas.openxmlformats.org/officeDocument/2006/relationships" xmlns:p="http://schemas.openxmlformats.org/presentationml/2006/main">
+  <p:cSld>
+    <p:spTree>
+      <p:nvGrpSpPr>
+        <p:cNvPr id="1" name=""/>
+        <p:cNvGrpSpPr/>
+        <p:nvPr/>
+      </p:nvGrpSpPr>
+      <p:grpSpPr>
+        <a:xfrm>
+          <a:off x="0" y="0"/>
+          <a:ext cx="0" cy="0"/>
+          <a:chOff x="0" y="0"/>
+          <a:chExt cx="0" cy="0"/>
+        </a:xfrm>
+      </p:grpSpPr>
+      <p:sp>
+        <p:nvSpPr>
+          <p:cNvPr id="2" name="Slide Image Placeholder 1"/>
+          <p:cNvSpPr>
+            <a:spLocks noGrp="1" noRot="1" noChangeAspect="1"/>
+          </p:cNvSpPr>
+          <p:nvPr>
+            <p:ph type="sldImg"/>
+          </p:nvPr>
+        </p:nvSpPr>
+        <p:spPr/>
+      </p:sp>
+      <p:sp>
+        <p:nvSpPr>
+          <p:cNvPr id="3" name="Notes Placeholder 2"/>
+          <p:cNvSpPr>
+            <a:spLocks noGrp="1"/>
+          </p:cNvSpPr>
+          <p:nvPr>
+            <p:ph type="body" idx="1"/>
+          </p:nvPr>
+        </p:nvSpPr>
+        <p:spPr/>
+        <p:txBody>
+          <a:bodyPr/>
+          <a:lstStyle/>
+          <a:p>
+            <a:r>
+              <a:rPr b="1">
+                <a:latin typeface="+mn-lt"/>
+                <a:cs typeface="+mn-lt"/>
+              </a:rPr>
               <a:t>Empirical Benchmark Keynote: </a:t>
             </a:r>
             <a:r>
@@ -2638,18 +2747,11 @@
           <a:lstStyle/>
           <a:p>
             <a:r>
-              <a:rPr b="1">
-                <a:latin typeface="+mn-lt"/>
-                <a:cs typeface="+mn-lt"/>
-              </a:rPr>
-              <a:t>Architecture Deep Dive: </a:t>
-            </a:r>
-            <a:r>
-              <a:rPr u="sng">
-                <a:latin typeface="+mn-lt"/>
-                <a:cs typeface="+mn-lt"/>
-              </a:rPr>
-              <a:t>Composite Groups &amp; Vector Connectors</a:t>
+              <a:rPr b="1" u="sng">
+                <a:latin typeface="+mn-lt"/>
+                <a:cs typeface="+mn-lt"/>
+              </a:rPr>
+              <a:t>Presenter Notes — Non-Bulleted Hierarchical Indentation: </a:t>
             </a:r>
           </a:p>
           <a:p>
@@ -2662,7 +2764,7 @@
                 <a:latin typeface="+mn-lt"/>
                 <a:cs typeface="+mn-lt"/>
               </a:rPr>
-              <a:t>addGroup wraps child elements inside &lt;p:grpSp&gt; with coordinated bounding transforms.</a:t>
+              <a:t>Demonstrates { level: N, bullet: false } which emits &lt;a:buNone/&gt; with &lt;a:pPr lvl="N"&gt;.</a:t>
             </a:r>
           </a:p>
           <a:p>
@@ -2675,7 +2777,20 @@
                 <a:latin typeface="+mn-lt"/>
                 <a:cs typeface="+mn-lt"/>
               </a:rPr>
-              <a:t>addConnector emits &lt;p:cxnSp&gt; connecting arbitrary coordinates across slide elements.</a:t>
+              <a:t>Enables block quotes, explanatory notes, and code blocks that indent hierarchically under bullets without rendering a dot.</a:t>
+            </a:r>
+          </a:p>
+          <a:p>
+            <a:pPr lvl="1" marL="742950" indent="-285750">
+              <a:buFont typeface="Arial" panose="020B0604020202020204" pitchFamily="34" charset="0"/>
+              <a:buChar char="•"/>
+            </a:pPr>
+            <a:r>
+              <a:rPr>
+                <a:latin typeface="+mn-lt"/>
+                <a:cs typeface="+mn-lt"/>
+              </a:rPr>
+              <a:t>Tab and Shift+Tab continue to promote and demote indentation depth seamlessly.</a:t>
             </a:r>
           </a:p>
         </p:txBody>
@@ -2737,14 +2852,14 @@
                 <a:latin typeface="+mn-lt"/>
                 <a:cs typeface="+mn-lt"/>
               </a:rPr>
-              <a:t>Chart Keynote: </a:t>
+              <a:t>Architecture Deep Dive: </a:t>
             </a:r>
             <a:r>
               <a:rPr u="sng">
                 <a:latin typeface="+mn-lt"/>
                 <a:cs typeface="+mn-lt"/>
               </a:rPr>
-              <a:t>Native OpenXML DrawingML Charts</a:t>
+              <a:t>Composite Groups &amp; Vector Connectors</a:t>
             </a:r>
           </a:p>
           <a:p>
@@ -2757,7 +2872,7 @@
                 <a:latin typeface="+mn-lt"/>
                 <a:cs typeface="+mn-lt"/>
               </a:rPr>
-              <a:t>Emits standard &lt;c:chartSpace&gt; parts under ppt/charts/chartN.xml.</a:t>
+              <a:t>addGroup wraps child elements inside &lt;p:grpSp&gt; with coordinated bounding transforms.</a:t>
             </a:r>
           </a:p>
           <a:p>
@@ -2770,20 +2885,7 @@
                 <a:latin typeface="+mn-lt"/>
                 <a:cs typeface="+mn-lt"/>
               </a:rPr>
-              <a:t>Fully editable in PowerPoint without external Excel binary dependencies.</a:t>
-            </a:r>
-          </a:p>
-          <a:p>
-            <a:pPr marL="285750" indent="-285750">
-              <a:buFont typeface="Arial" panose="020B0604020202020204" pitchFamily="34" charset="0"/>
-              <a:buChar char="•"/>
-            </a:pPr>
-            <a:r>
-              <a:rPr>
-                <a:latin typeface="+mn-lt"/>
-                <a:cs typeface="+mn-lt"/>
-              </a:rPr>
-              <a:t>Custom series color fills and categorical string/number axis mapping.</a:t>
+              <a:t>addConnector emits &lt;p:cxnSp&gt; connecting arbitrary coordinates across slide elements.</a:t>
             </a:r>
           </a:p>
         </p:txBody>
@@ -2845,14 +2947,14 @@
                 <a:latin typeface="+mn-lt"/>
                 <a:cs typeface="+mn-lt"/>
               </a:rPr>
-              <a:t>Chart Suite Overview: </a:t>
+              <a:t>Chart Keynote: </a:t>
             </a:r>
             <a:r>
               <a:rPr u="sng">
                 <a:latin typeface="+mn-lt"/>
                 <a:cs typeface="+mn-lt"/>
               </a:rPr>
-              <a:t>Line, Doughnut &amp; Horizontal Bar Support</a:t>
+              <a:t>Native OpenXML DrawingML Charts</a:t>
             </a:r>
           </a:p>
           <a:p>
@@ -2865,7 +2967,7 @@
                 <a:latin typeface="+mn-lt"/>
                 <a:cs typeface="+mn-lt"/>
               </a:rPr>
-              <a:t>Smooth spline curves for continuous time-series metrics.</a:t>
+              <a:t>Emits standard &lt;c:chartSpace&gt; parts under ppt/charts/chartN.xml.</a:t>
             </a:r>
           </a:p>
           <a:p>
@@ -2878,7 +2980,7 @@
                 <a:latin typeface="+mn-lt"/>
                 <a:cs typeface="+mn-lt"/>
               </a:rPr>
-              <a:t>Customizable doughnut hole radii and automated data label percentages.</a:t>
+              <a:t>Fully editable in PowerPoint without external Excel binary dependencies.</a:t>
             </a:r>
           </a:p>
           <a:p>
@@ -2891,7 +2993,7 @@
                 <a:latin typeface="+mn-lt"/>
                 <a:cs typeface="+mn-lt"/>
               </a:rPr>
-              <a:t>Horizontal bar orientation for ranked ordinal comparisons.</a:t>
+              <a:t>Custom series color fills and categorical string/number axis mapping.</a:t>
             </a:r>
           </a:p>
         </p:txBody>
@@ -2953,14 +3055,14 @@
                 <a:latin typeface="+mn-lt"/>
                 <a:cs typeface="+mn-lt"/>
               </a:rPr>
-              <a:t>Analytical Topology Keynote: </a:t>
+              <a:t>Chart Suite Overview: </a:t>
             </a:r>
             <a:r>
               <a:rPr u="sng">
                 <a:latin typeface="+mn-lt"/>
                 <a:cs typeface="+mn-lt"/>
               </a:rPr>
-              <a:t>Area, Pie &amp; Radar Spider Visualizations</a:t>
+              <a:t>Line, Doughnut &amp; Horizontal Bar Support</a:t>
             </a:r>
           </a:p>
           <a:p>
@@ -2973,7 +3075,7 @@
                 <a:latin typeface="+mn-lt"/>
                 <a:cs typeface="+mn-lt"/>
               </a:rPr>
-              <a:t>Stacked area topologies for cumulative resource metric trends.</a:t>
+              <a:t>Smooth spline curves for continuous time-series metrics.</a:t>
             </a:r>
           </a:p>
           <a:p>
@@ -2986,7 +3088,7 @@
                 <a:latin typeface="+mn-lt"/>
                 <a:cs typeface="+mn-lt"/>
               </a:rPr>
-              <a:t>Standard pie charts with automatic slice percentage data labels.</a:t>
+              <a:t>Customizable doughnut hole radii and automated data label percentages.</a:t>
             </a:r>
           </a:p>
           <a:p>
@@ -2999,7 +3101,7 @@
                 <a:latin typeface="+mn-lt"/>
                 <a:cs typeface="+mn-lt"/>
               </a:rPr>
-              <a:t>Radar / spider charts for multi-dimensional multi-series competitive scorecards.</a:t>
+              <a:t>Horizontal bar orientation for ranked ordinal comparisons.</a:t>
             </a:r>
           </a:p>
         </p:txBody>
@@ -3061,14 +3163,14 @@
                 <a:latin typeface="+mn-lt"/>
                 <a:cs typeface="+mn-lt"/>
               </a:rPr>
-              <a:t>Hyperlinks &amp; Slide Navigation Keynote: </a:t>
+              <a:t>Analytical Topology Keynote: </a:t>
             </a:r>
             <a:r>
               <a:rPr u="sng">
                 <a:latin typeface="+mn-lt"/>
                 <a:cs typeface="+mn-lt"/>
               </a:rPr>
-              <a:t>Interactive OpenXML Actions &amp; Relationships</a:t>
+              <a:t>Area, Pie &amp; Radar Spider Visualizations</a:t>
             </a:r>
           </a:p>
           <a:p>
@@ -3081,7 +3183,7 @@
                 <a:latin typeface="+mn-lt"/>
                 <a:cs typeface="+mn-lt"/>
               </a:rPr>
-              <a:t>Full support for external web links, custom URLs, and hover tooltips.</a:t>
+              <a:t>Stacked area topologies for cumulative resource metric trends.</a:t>
             </a:r>
           </a:p>
           <a:p>
@@ -3094,7 +3196,7 @@
                 <a:latin typeface="+mn-lt"/>
                 <a:cs typeface="+mn-lt"/>
               </a:rPr>
-              <a:t>Internal slide jumping using strongly typed slideIndex referencing.</a:t>
+              <a:t>Standard pie charts with automatic slice percentage data labels.</a:t>
             </a:r>
           </a:p>
           <a:p>
@@ -3107,7 +3209,7 @@
                 <a:latin typeface="+mn-lt"/>
                 <a:cs typeface="+mn-lt"/>
               </a:rPr>
-              <a:t>Built-in slide show control actions: firstSlide, lastSlide, nextSlide, previousSlide, endShow.</a:t>
+              <a:t>Radar / spider charts for multi-dimensional multi-series competitive scorecards.</a:t>
             </a:r>
           </a:p>
         </p:txBody>
@@ -3834,6 +3936,723 @@
     <p:bg>
       <p:bgPr>
         <a:solidFill>
+          <a:srgbClr val="F8FAFC"/>
+        </a:solidFill>
+        <a:effectLst/>
+      </p:bgPr>
+    </p:bg>
+    <p:spTree>
+      <p:nvGrpSpPr>
+        <p:cNvPr id="1" name=""/>
+        <p:cNvGrpSpPr/>
+        <p:nvPr/>
+      </p:nvGrpSpPr>
+      <p:grpSpPr>
+        <a:xfrm>
+          <a:off x="0" y="0"/>
+          <a:ext cx="0" cy="0"/>
+          <a:chOff x="0" y="0"/>
+          <a:chExt cx="0" cy="0"/>
+        </a:xfrm>
+      </p:grpSpPr>
+      <p:sp>
+        <p:nvSpPr>
+          <p:cNvPr id="2" name="Text Box 1"/>
+          <p:cNvSpPr txBox="1"/>
+          <p:nvPr/>
+        </p:nvSpPr>
+        <p:spPr>
+          <a:xfrm>
+            <a:off x="914400" y="731520"/>
+            <a:ext cx="10360152" cy="548640"/>
+          </a:xfrm>
+          <a:prstGeom prst="rect">
+            <a:avLst/>
+          </a:prstGeom>
+        </p:spPr>
+        <p:txBody>
+          <a:bodyPr/>
+          <a:lstStyle/>
+          <a:p>
+            <a:r>
+              <a:rPr b="1" sz="2400">
+                <a:solidFill>
+                  <a:srgbClr val="0F172A"/>
+                </a:solidFill>
+                <a:latin typeface="+mj-lt"/>
+                <a:cs typeface="+mj-lt"/>
+              </a:rPr>
+              <a:t>Flow Connectors &amp; Composite Group Architecture</a:t>
+            </a:r>
+          </a:p>
+        </p:txBody>
+      </p:sp>
+      <p:sp>
+        <p:nvSpPr>
+          <p:cNvPr id="3" name="Text Box 2"/>
+          <p:cNvSpPr txBox="1"/>
+          <p:nvPr/>
+        </p:nvSpPr>
+        <p:spPr>
+          <a:xfrm>
+            <a:off x="914400" y="1280160"/>
+            <a:ext cx="10360152" cy="365760"/>
+          </a:xfrm>
+          <a:prstGeom prst="rect">
+            <a:avLst/>
+          </a:prstGeom>
+        </p:spPr>
+        <p:txBody>
+          <a:bodyPr/>
+          <a:lstStyle/>
+          <a:p>
+            <a:r>
+              <a:rPr sz="1400">
+                <a:solidFill>
+                  <a:srgbClr val="64748B"/>
+                </a:solidFill>
+                <a:latin typeface="+mn-lt"/>
+                <a:cs typeface="+mn-lt"/>
+              </a:rPr>
+              <a:t>Demonstrating vector connectors (solid, dashed), coordinates, and composite group containers (addGroup)</a:t>
+            </a:r>
+          </a:p>
+        </p:txBody>
+      </p:sp>
+      <p:sp>
+        <p:nvSpPr>
+          <p:cNvPr id="19" name="Text Box 18"/>
+          <p:cNvSpPr txBox="1"/>
+          <p:nvPr/>
+        </p:nvSpPr>
+        <p:spPr>
+          <a:xfrm>
+            <a:off x="914400" y="5806440"/>
+            <a:ext cx="10241280" cy="365760"/>
+          </a:xfrm>
+          <a:prstGeom prst="rect">
+            <a:avLst/>
+          </a:prstGeom>
+        </p:spPr>
+        <p:txBody>
+          <a:bodyPr/>
+          <a:lstStyle/>
+          <a:p>
+            <a:pPr algn="ctr"/>
+            <a:r>
+              <a:rPr sz="1100">
+                <a:solidFill>
+                  <a:srgbClr val="64748B"/>
+                </a:solidFill>
+                <a:latin typeface="+mn-lt"/>
+                <a:cs typeface="+mn-lt"/>
+              </a:rPr>
+              <a:t>Isomorphic Pipeline Feedback Loop: 100% Roundtrip Bit-Exact Precision</a:t>
+            </a:r>
+          </a:p>
+        </p:txBody>
+      </p:sp>
+      <p:sp>
+        <p:nvSpPr>
+          <p:cNvPr id="20" name="Text Box 19"/>
+          <p:cNvSpPr txBox="1"/>
+          <p:nvPr/>
+        </p:nvSpPr>
+        <p:spPr>
+          <a:xfrm>
+            <a:off x="731520" y="6510528"/>
+            <a:ext cx="10725912" cy="228600"/>
+          </a:xfrm>
+          <a:prstGeom prst="rect">
+            <a:avLst/>
+          </a:prstGeom>
+        </p:spPr>
+        <p:txBody>
+          <a:bodyPr/>
+          <a:lstStyle/>
+          <a:p>
+            <a:pPr algn="ctr"/>
+            <a:r>
+              <a:rPr i="1" sz="800">
+                <a:solidFill>
+                  <a:srgbClr val="94A3B8"/>
+                </a:solidFill>
+                <a:latin typeface="+mn-lt"/>
+                <a:cs typeface="+mn-lt"/>
+              </a:rPr>
+              <a:t>* Disclaimer: All benchmark metrics, performance figures, and simulated architectures in this deck are synthetic demonstration values generated solely to showcase the authoring, formatting, and rendering capabilities of @hokkyss/pptx.</a:t>
+            </a:r>
+          </a:p>
+        </p:txBody>
+      </p:sp>
+      <p:grpSp>
+        <p:nvGrpSpPr>
+          <p:cNvPr id="4" name="Stage 1 Ingress Container"/>
+          <p:cNvGrpSpPr/>
+          <p:nvPr/>
+        </p:nvGrpSpPr>
+        <p:grpSpPr>
+          <a:xfrm>
+            <a:off x="914400" y="2011680"/>
+            <a:ext cx="2926080" cy="3200400"/>
+            <a:chOff x="914400" y="2011680"/>
+            <a:chExt cx="2926080" cy="3200400"/>
+          </a:xfrm>
+        </p:grpSpPr>
+        <p:sp>
+          <p:nvSpPr>
+            <p:cNvPr id="5" name="Stage 1 Background"/>
+            <p:cNvSpPr/>
+            <p:nvPr/>
+          </p:nvSpPr>
+          <p:spPr>
+            <a:xfrm>
+              <a:off x="914400" y="2011680"/>
+              <a:ext cx="2926080" cy="3200400"/>
+            </a:xfrm>
+            <a:prstGeom prst="roundRect">
+              <a:avLst/>
+            </a:prstGeom>
+            <a:solidFill>
+              <a:srgbClr val="FFFFFF"/>
+            </a:solidFill>
+            <a:ln w="13716">
+              <a:solidFill>
+                <a:srgbClr val="0284C7"/>
+              </a:solidFill>
+            </a:ln>
+            <a:effectLst>
+              <a:outerShdw blurRad="109728" dist="38100" dir="5400000">
+                <a:srgbClr val="0F172A">
+                  <a:alpha val="10000"/>
+                </a:srgbClr>
+              </a:outerShdw>
+            </a:effectLst>
+          </p:spPr>
+          <p:txBody>
+            <a:bodyPr/>
+            <a:lstStyle/>
+            <a:p>
+              <a:endParaRPr/>
+            </a:p>
+          </p:txBody>
+        </p:sp>
+        <p:sp>
+          <p:nvSpPr>
+            <p:cNvPr id="6" name="roundRect 5"/>
+            <p:cNvSpPr/>
+            <p:nvPr/>
+          </p:nvSpPr>
+          <p:spPr>
+            <a:xfrm>
+              <a:off x="1188720" y="2286000"/>
+              <a:ext cx="2377440" cy="365760"/>
+            </a:xfrm>
+            <a:prstGeom prst="roundRect">
+              <a:avLst/>
+            </a:prstGeom>
+            <a:solidFill>
+              <a:srgbClr val="0284C7"/>
+            </a:solidFill>
+          </p:spPr>
+          <p:txBody>
+            <a:bodyPr/>
+            <a:lstStyle/>
+            <a:p>
+              <a:pPr algn="ctr"/>
+              <a:r>
+                <a:rPr b="1" sz="1000">
+                  <a:solidFill>
+                    <a:srgbClr val="FFFFFF"/>
+                  </a:solidFill>
+                  <a:latin typeface="+mn-lt"/>
+                  <a:cs typeface="+mn-lt"/>
+                </a:rPr>
+                <a:t>STEP 1: INGESTION</a:t>
+              </a:r>
+            </a:p>
+          </p:txBody>
+        </p:sp>
+        <p:sp>
+          <p:nvSpPr>
+            <p:cNvPr id="7" name="Text Box 6"/>
+            <p:cNvSpPr/>
+            <p:nvPr/>
+          </p:nvSpPr>
+          <p:spPr>
+            <a:xfrm>
+              <a:off x="1188720" y="2926080"/>
+              <a:ext cx="2377440" cy="1828800"/>
+            </a:xfrm>
+            <a:prstGeom prst="rect">
+              <a:avLst/>
+            </a:prstGeom>
+          </p:spPr>
+          <p:txBody>
+            <a:bodyPr/>
+            <a:lstStyle/>
+            <a:p>
+              <a:pPr marL="285750" indent="-285750">
+                <a:buFont typeface="Arial" panose="020B0604020202020204" pitchFamily="34" charset="0"/>
+                <a:buChar char="•"/>
+              </a:pPr>
+              <a:r>
+                <a:rPr sz="1100">
+                  <a:solidFill>
+                    <a:srgbClr val="475569"/>
+                  </a:solidFill>
+                  <a:latin typeface="+mn-lt"/>
+                  <a:cs typeface="+mn-lt"/>
+                </a:rPr>
+                <a:t>Streaming ZIP decompression</a:t>
+              </a:r>
+            </a:p>
+            <a:p>
+              <a:pPr marL="285750" indent="-285750">
+                <a:buFont typeface="Arial" panose="020B0604020202020204" pitchFamily="34" charset="0"/>
+                <a:buChar char="•"/>
+              </a:pPr>
+              <a:r>
+                <a:rPr sz="1100">
+                  <a:solidFill>
+                    <a:srgbClr val="475569"/>
+                  </a:solidFill>
+                  <a:latin typeface="+mn-lt"/>
+                  <a:cs typeface="+mn-lt"/>
+                </a:rPr>
+                <a:t>XML DOM part resolution</a:t>
+              </a:r>
+            </a:p>
+            <a:p>
+              <a:pPr marL="285750" indent="-285750">
+                <a:buFont typeface="Arial" panose="020B0604020202020204" pitchFamily="34" charset="0"/>
+                <a:buChar char="•"/>
+              </a:pPr>
+              <a:r>
+                <a:rPr sz="1100">
+                  <a:solidFill>
+                    <a:srgbClr val="475569"/>
+                  </a:solidFill>
+                  <a:latin typeface="+mn-lt"/>
+                  <a:cs typeface="+mn-lt"/>
+                </a:rPr>
+                <a:t>Extract relationships map</a:t>
+              </a:r>
+            </a:p>
+          </p:txBody>
+        </p:sp>
+      </p:grpSp>
+      <p:grpSp>
+        <p:nvGrpSpPr>
+          <p:cNvPr id="8" name="Stage 2 AST Container"/>
+          <p:cNvGrpSpPr/>
+          <p:nvPr/>
+        </p:nvGrpSpPr>
+        <p:grpSpPr>
+          <a:xfrm>
+            <a:off x="4572000" y="2011680"/>
+            <a:ext cx="2926080" cy="3200400"/>
+            <a:chOff x="4572000" y="2011680"/>
+            <a:chExt cx="2926080" cy="3200400"/>
+          </a:xfrm>
+        </p:grpSpPr>
+        <p:sp>
+          <p:nvSpPr>
+            <p:cNvPr id="9" name="Stage 2 Background"/>
+            <p:cNvSpPr/>
+            <p:nvPr/>
+          </p:nvSpPr>
+          <p:spPr>
+            <a:xfrm>
+              <a:off x="4572000" y="2011680"/>
+              <a:ext cx="2926080" cy="3200400"/>
+            </a:xfrm>
+            <a:prstGeom prst="roundRect">
+              <a:avLst/>
+            </a:prstGeom>
+            <a:solidFill>
+              <a:srgbClr val="FFFFFF"/>
+            </a:solidFill>
+            <a:ln w="13716">
+              <a:solidFill>
+                <a:srgbClr val="6366F1"/>
+              </a:solidFill>
+            </a:ln>
+            <a:effectLst>
+              <a:outerShdw blurRad="109728" dist="38100" dir="5400000">
+                <a:srgbClr val="0F172A">
+                  <a:alpha val="10000"/>
+                </a:srgbClr>
+              </a:outerShdw>
+            </a:effectLst>
+          </p:spPr>
+          <p:txBody>
+            <a:bodyPr/>
+            <a:lstStyle/>
+            <a:p>
+              <a:endParaRPr/>
+            </a:p>
+          </p:txBody>
+        </p:sp>
+        <p:sp>
+          <p:nvSpPr>
+            <p:cNvPr id="10" name="roundRect 9"/>
+            <p:cNvSpPr/>
+            <p:nvPr/>
+          </p:nvSpPr>
+          <p:spPr>
+            <a:xfrm>
+              <a:off x="4846320" y="2286000"/>
+              <a:ext cx="2377440" cy="365760"/>
+            </a:xfrm>
+            <a:prstGeom prst="roundRect">
+              <a:avLst/>
+            </a:prstGeom>
+            <a:solidFill>
+              <a:srgbClr val="6366F1"/>
+            </a:solidFill>
+          </p:spPr>
+          <p:txBody>
+            <a:bodyPr/>
+            <a:lstStyle/>
+            <a:p>
+              <a:pPr algn="ctr"/>
+              <a:r>
+                <a:rPr b="1" sz="1000">
+                  <a:solidFill>
+                    <a:srgbClr val="FFFFFF"/>
+                  </a:solidFill>
+                  <a:latin typeface="+mn-lt"/>
+                  <a:cs typeface="+mn-lt"/>
+                </a:rPr>
+                <a:t>STEP 2: MODELING</a:t>
+              </a:r>
+            </a:p>
+          </p:txBody>
+        </p:sp>
+        <p:sp>
+          <p:nvSpPr>
+            <p:cNvPr id="11" name="Text Box 10"/>
+            <p:cNvSpPr/>
+            <p:nvPr/>
+          </p:nvSpPr>
+          <p:spPr>
+            <a:xfrm>
+              <a:off x="4846320" y="2926080"/>
+              <a:ext cx="2377440" cy="1828800"/>
+            </a:xfrm>
+            <a:prstGeom prst="rect">
+              <a:avLst/>
+            </a:prstGeom>
+          </p:spPr>
+          <p:txBody>
+            <a:bodyPr/>
+            <a:lstStyle/>
+            <a:p>
+              <a:pPr marL="285750" indent="-285750">
+                <a:buFont typeface="Arial" panose="020B0604020202020204" pitchFamily="34" charset="0"/>
+                <a:buChar char="•"/>
+              </a:pPr>
+              <a:r>
+                <a:rPr sz="1100">
+                  <a:solidFill>
+                    <a:srgbClr val="475569"/>
+                  </a:solidFill>
+                  <a:latin typeface="+mn-lt"/>
+                  <a:cs typeface="+mn-lt"/>
+                </a:rPr>
+                <a:t>Type-safe AST generation</a:t>
+              </a:r>
+            </a:p>
+            <a:p>
+              <a:pPr marL="285750" indent="-285750">
+                <a:buFont typeface="Arial" panose="020B0604020202020204" pitchFamily="34" charset="0"/>
+                <a:buChar char="•"/>
+              </a:pPr>
+              <a:r>
+                <a:rPr sz="1100">
+                  <a:solidFill>
+                    <a:srgbClr val="475569"/>
+                  </a:solidFill>
+                  <a:latin typeface="+mn-lt"/>
+                  <a:cs typeface="+mn-lt"/>
+                </a:rPr>
+                <a:t>Layer &amp; placeholder cascade</a:t>
+              </a:r>
+            </a:p>
+            <a:p>
+              <a:pPr marL="285750" indent="-285750">
+                <a:buFont typeface="Arial" panose="020B0604020202020204" pitchFamily="34" charset="0"/>
+                <a:buChar char="•"/>
+              </a:pPr>
+              <a:r>
+                <a:rPr sz="1100">
+                  <a:solidFill>
+                    <a:srgbClr val="475569"/>
+                  </a:solidFill>
+                  <a:latin typeface="+mn-lt"/>
+                  <a:cs typeface="+mn-lt"/>
+                </a:rPr>
+                <a:t>Fluent mutations &amp; styling</a:t>
+              </a:r>
+            </a:p>
+          </p:txBody>
+        </p:sp>
+      </p:grpSp>
+      <p:grpSp>
+        <p:nvGrpSpPr>
+          <p:cNvPr id="12" name="Stage 3 Packaging Container"/>
+          <p:cNvGrpSpPr/>
+          <p:nvPr/>
+        </p:nvGrpSpPr>
+        <p:grpSpPr>
+          <a:xfrm>
+            <a:off x="8229600" y="2011680"/>
+            <a:ext cx="2926080" cy="3200400"/>
+            <a:chOff x="8229600" y="2011680"/>
+            <a:chExt cx="2926080" cy="3200400"/>
+          </a:xfrm>
+        </p:grpSpPr>
+        <p:sp>
+          <p:nvSpPr>
+            <p:cNvPr id="13" name="Stage 3 Background"/>
+            <p:cNvSpPr/>
+            <p:nvPr/>
+          </p:nvSpPr>
+          <p:spPr>
+            <a:xfrm>
+              <a:off x="8229600" y="2011680"/>
+              <a:ext cx="2926080" cy="3200400"/>
+            </a:xfrm>
+            <a:prstGeom prst="roundRect">
+              <a:avLst/>
+            </a:prstGeom>
+            <a:solidFill>
+              <a:srgbClr val="FFFFFF"/>
+            </a:solidFill>
+            <a:ln w="13716">
+              <a:solidFill>
+                <a:srgbClr val="10B981"/>
+              </a:solidFill>
+            </a:ln>
+            <a:effectLst>
+              <a:outerShdw blurRad="109728" dist="38100" dir="5400000">
+                <a:srgbClr val="0F172A">
+                  <a:alpha val="10000"/>
+                </a:srgbClr>
+              </a:outerShdw>
+            </a:effectLst>
+          </p:spPr>
+          <p:txBody>
+            <a:bodyPr/>
+            <a:lstStyle/>
+            <a:p>
+              <a:endParaRPr/>
+            </a:p>
+          </p:txBody>
+        </p:sp>
+        <p:sp>
+          <p:nvSpPr>
+            <p:cNvPr id="14" name="roundRect 13"/>
+            <p:cNvSpPr/>
+            <p:nvPr/>
+          </p:nvSpPr>
+          <p:spPr>
+            <a:xfrm>
+              <a:off x="8503920" y="2286000"/>
+              <a:ext cx="2377440" cy="365760"/>
+            </a:xfrm>
+            <a:prstGeom prst="roundRect">
+              <a:avLst/>
+            </a:prstGeom>
+            <a:solidFill>
+              <a:srgbClr val="10B981"/>
+            </a:solidFill>
+          </p:spPr>
+          <p:txBody>
+            <a:bodyPr/>
+            <a:lstStyle/>
+            <a:p>
+              <a:pPr algn="ctr"/>
+              <a:r>
+                <a:rPr b="1" sz="1000">
+                  <a:solidFill>
+                    <a:srgbClr val="FFFFFF"/>
+                  </a:solidFill>
+                  <a:latin typeface="+mn-lt"/>
+                  <a:cs typeface="+mn-lt"/>
+                </a:rPr>
+                <a:t>STEP 3: COMPILATION</a:t>
+              </a:r>
+            </a:p>
+          </p:txBody>
+        </p:sp>
+        <p:sp>
+          <p:nvSpPr>
+            <p:cNvPr id="15" name="Text Box 14"/>
+            <p:cNvSpPr/>
+            <p:nvPr/>
+          </p:nvSpPr>
+          <p:spPr>
+            <a:xfrm>
+              <a:off x="8503920" y="2926080"/>
+              <a:ext cx="2377440" cy="1828800"/>
+            </a:xfrm>
+            <a:prstGeom prst="rect">
+              <a:avLst/>
+            </a:prstGeom>
+          </p:spPr>
+          <p:txBody>
+            <a:bodyPr/>
+            <a:lstStyle/>
+            <a:p>
+              <a:pPr marL="285750" indent="-285750">
+                <a:buFont typeface="Arial" panose="020B0604020202020204" pitchFamily="34" charset="0"/>
+                <a:buChar char="•"/>
+              </a:pPr>
+              <a:r>
+                <a:rPr sz="1100">
+                  <a:solidFill>
+                    <a:srgbClr val="475569"/>
+                  </a:solidFill>
+                  <a:latin typeface="+mn-lt"/>
+                  <a:cs typeface="+mn-lt"/>
+                </a:rPr>
+                <a:t>Deterministic XML emission</a:t>
+              </a:r>
+            </a:p>
+            <a:p>
+              <a:pPr marL="285750" indent="-285750">
+                <a:buFont typeface="Arial" panose="020B0604020202020204" pitchFamily="34" charset="0"/>
+                <a:buChar char="•"/>
+              </a:pPr>
+              <a:r>
+                <a:rPr sz="1100">
+                  <a:solidFill>
+                    <a:srgbClr val="475569"/>
+                  </a:solidFill>
+                  <a:latin typeface="+mn-lt"/>
+                  <a:cs typeface="+mn-lt"/>
+                </a:rPr>
+                <a:t>Zero-copy fflate compression</a:t>
+              </a:r>
+            </a:p>
+            <a:p>
+              <a:pPr marL="285750" indent="-285750">
+                <a:buFont typeface="Arial" panose="020B0604020202020204" pitchFamily="34" charset="0"/>
+                <a:buChar char="•"/>
+              </a:pPr>
+              <a:r>
+                <a:rPr sz="1100">
+                  <a:solidFill>
+                    <a:srgbClr val="475569"/>
+                  </a:solidFill>
+                  <a:latin typeface="+mn-lt"/>
+                  <a:cs typeface="+mn-lt"/>
+                </a:rPr>
+                <a:t>ECMA-376 compliant PPTX</a:t>
+              </a:r>
+            </a:p>
+          </p:txBody>
+        </p:sp>
+      </p:grpSp>
+      <p:cxnSp>
+        <p:nvCxnSpPr>
+          <p:cNvPr id="16" name="Connector 15"/>
+          <p:cNvCxnSpPr>
+            <a:cxnSpLocks/>
+            <a:stCxn id="5" idx="3"/>
+            <a:endCxn id="9" idx="1"/>
+          </p:cNvCxnSpPr>
+          <p:nvPr/>
+        </p:nvCxnSpPr>
+        <p:spPr>
+          <a:xfrm>
+            <a:off x="3840480" y="3611880"/>
+            <a:ext cx="731520" cy="0"/>
+          </a:xfrm>
+          <a:prstGeom prst="line">
+            <a:avLst/>
+          </a:prstGeom>
+          <a:ln w="27432">
+            <a:solidFill>
+              <a:srgbClr val="0284C7"/>
+            </a:solidFill>
+            <a:prstDash val="solid"/>
+            <a:headEnd type="triangle" w="lg" len="lg"/>
+          </a:ln>
+        </p:spPr>
+      </p:cxnSp>
+      <p:cxnSp>
+        <p:nvCxnSpPr>
+          <p:cNvPr id="17" name="Connector 16"/>
+          <p:cNvCxnSpPr>
+            <a:cxnSpLocks/>
+            <a:stCxn id="9" idx="3"/>
+            <a:endCxn id="13" idx="1"/>
+          </p:cNvCxnSpPr>
+          <p:nvPr/>
+        </p:nvCxnSpPr>
+        <p:spPr>
+          <a:xfrm>
+            <a:off x="7498080" y="3611880"/>
+            <a:ext cx="731520" cy="0"/>
+          </a:xfrm>
+          <a:prstGeom prst="line">
+            <a:avLst/>
+          </a:prstGeom>
+          <a:ln w="27432">
+            <a:solidFill>
+              <a:srgbClr val="6366F1"/>
+            </a:solidFill>
+            <a:prstDash val="solid"/>
+            <a:headEnd type="stealth" w="lg" len="lg"/>
+          </a:ln>
+        </p:spPr>
+      </p:cxnSp>
+      <p:cxnSp>
+        <p:nvCxnSpPr>
+          <p:cNvPr id="18" name="Connector 17"/>
+          <p:cNvCxnSpPr>
+            <a:cxnSpLocks/>
+          </p:cNvCxnSpPr>
+          <p:nvPr/>
+        </p:nvCxnSpPr>
+        <p:spPr>
+          <a:xfrm>
+            <a:off x="914400" y="5669280"/>
+            <a:ext cx="10241280" cy="0"/>
+          </a:xfrm>
+          <a:prstGeom prst="line">
+            <a:avLst/>
+          </a:prstGeom>
+          <a:ln w="18288">
+            <a:solidFill>
+              <a:srgbClr val="94A3B8"/>
+            </a:solidFill>
+            <a:prstDash val="dash"/>
+            <a:headEnd type="triangle"/>
+            <a:tailEnd type="oval"/>
+          </a:ln>
+        </p:spPr>
+      </p:cxnSp>
+    </p:spTree>
+  </p:cSld>
+  <p:clrMapOvr>
+    <a:masterClrMapping/>
+  </p:clrMapOvr>
+  <p:transition spd="fast">
+    <p:pull dir="r"/>
+  </p:transition>
+</p:sld>
+</file>
+
+<file path=ppt/slides/slide11.xml><?xml version="1.0" encoding="utf-8"?>
+<p:sld xmlns:a="http://schemas.openxmlformats.org/drawingml/2006/main" xmlns:r="http://schemas.openxmlformats.org/officeDocument/2006/relationships" xmlns:p="http://schemas.openxmlformats.org/presentationml/2006/main">
+  <p:cSld>
+    <p:bg>
+      <p:bgPr>
+        <a:solidFill>
           <a:srgbClr val="0F172A"/>
         </a:solidFill>
         <a:effectLst/>
@@ -4231,7 +5050,7 @@
 </p:sld>
 </file>
 
-<file path=ppt/slides/slide11.xml><?xml version="1.0" encoding="utf-8"?>
+<file path=ppt/slides/slide12.xml><?xml version="1.0" encoding="utf-8"?>
 <p:sld xmlns:a="http://schemas.openxmlformats.org/drawingml/2006/main" xmlns:r="http://schemas.openxmlformats.org/officeDocument/2006/relationships" xmlns:p="http://schemas.openxmlformats.org/presentationml/2006/main">
   <p:cSld>
     <p:bg>
@@ -4622,7 +5441,7 @@
 </p:sld>
 </file>
 
-<file path=ppt/slides/slide12.xml><?xml version="1.0" encoding="utf-8"?>
+<file path=ppt/slides/slide13.xml><?xml version="1.0" encoding="utf-8"?>
 <p:sld xmlns:a="http://schemas.openxmlformats.org/drawingml/2006/main" xmlns:r="http://schemas.openxmlformats.org/officeDocument/2006/relationships" xmlns:p="http://schemas.openxmlformats.org/presentationml/2006/main">
   <p:cSld>
     <p:bg>
@@ -5013,7 +5832,7 @@
 </p:sld>
 </file>
 
-<file path=ppt/slides/slide13.xml><?xml version="1.0" encoding="utf-8"?>
+<file path=ppt/slides/slide14.xml><?xml version="1.0" encoding="utf-8"?>
 <p:sld xmlns:a="http://schemas.openxmlformats.org/drawingml/2006/main" xmlns:r="http://schemas.openxmlformats.org/officeDocument/2006/relationships" xmlns:p="http://schemas.openxmlformats.org/presentationml/2006/main">
   <p:cSld>
     <p:bg>
@@ -5315,7 +6134,7 @@
       <p:sp>
         <p:nvSpPr>
           <p:cNvPr id="9" name="roundRect 8">
-            <a:hlinkClick r:id="rId4" tooltip="Jump directly to Slide 10" action="ppaction://hlinksldjump"/>
+            <a:hlinkClick r:id="rId4" tooltip="Jump directly to Slide 11" action="ppaction://hlinksldjump"/>
           </p:cNvPr>
           <p:cNvSpPr/>
           <p:nvPr/>
@@ -5349,7 +6168,7 @@
                 <a:latin typeface="+mn-lt"/>
                 <a:cs typeface="+mn-lt"/>
               </a:rPr>
-              <a:t>📈 Slide 10: OpenXML Charts &amp; Graphs ➔</a:t>
+              <a:t>📈 Slide 11: OpenXML Charts &amp; Graphs ➔</a:t>
             </a:r>
           </a:p>
           <a:p>
@@ -5369,7 +6188,7 @@
       <p:sp>
         <p:nvSpPr>
           <p:cNvPr id="10" name="roundRect 9">
-            <a:hlinkClick r:id="rId5" tooltip="Jump directly to Slide 15" action="ppaction://hlinksldjump"/>
+            <a:hlinkClick r:id="rId5" tooltip="Jump directly to Slide 16" action="ppaction://hlinksldjump"/>
           </p:cNvPr>
           <p:cNvSpPr/>
           <p:nvPr/>
@@ -5403,7 +6222,7 @@
                 <a:latin typeface="+mn-lt"/>
                 <a:cs typeface="+mn-lt"/>
               </a:rPr>
-              <a:t>⚡ Slide 15: Engine Benchmark Matrix ➔</a:t>
+              <a:t>⚡ Slide 16: Engine Benchmark Matrix ➔</a:t>
             </a:r>
           </a:p>
           <a:p>
@@ -5734,7 +6553,7 @@
       <p:sp>
         <p:nvSpPr>
           <p:cNvPr id="18" name="roundRect 17">
-            <a:hlinkClick tooltip="Jump to Slide 12" action="ppaction://hlinkshowjump?jump=previousslide"/>
+            <a:hlinkClick tooltip="Jump to Slide 13" action="ppaction://hlinkshowjump?jump=previousslide"/>
           </p:cNvPr>
           <p:cNvSpPr/>
           <p:nvPr/>
@@ -5772,7 +6591,7 @@
       <p:sp>
         <p:nvSpPr>
           <p:cNvPr id="19" name="roundRect 18">
-            <a:hlinkClick tooltip="Jump to Slide 14" action="ppaction://hlinkshowjump?jump=nextslide"/>
+            <a:hlinkClick tooltip="Jump to Slide 15" action="ppaction://hlinkshowjump?jump=nextslide"/>
           </p:cNvPr>
           <p:cNvSpPr/>
           <p:nvPr/>
@@ -5889,7 +6708,7 @@
 </p:sld>
 </file>
 
-<file path=ppt/slides/slide14.xml><?xml version="1.0" encoding="utf-8"?>
+<file path=ppt/slides/slide15.xml><?xml version="1.0" encoding="utf-8"?>
 <p:sld xmlns:a="http://schemas.openxmlformats.org/drawingml/2006/main" xmlns:r="http://schemas.openxmlformats.org/officeDocument/2006/relationships" xmlns:p="http://schemas.openxmlformats.org/presentationml/2006/main">
   <p:cSld>
     <p:bg>
@@ -5992,7 +6811,7 @@
       <p:sp>
         <p:nvSpPr>
           <p:cNvPr id="4" name="roundRect 3">
-            <a:hlinkClick r:id="rId2" tooltip="Return to Hyperlinks Hub (Slide 13)" action="ppaction://hlinksldjump"/>
+            <a:hlinkClick r:id="rId2" tooltip="Return to Hyperlinks Hub (Slide 14)" action="ppaction://hlinksldjump"/>
           </p:cNvPr>
           <p:cNvSpPr/>
           <p:nvPr/>
@@ -6042,7 +6861,7 @@
       <p:sp>
         <p:nvSpPr>
           <p:cNvPr id="5" name="roundRect 4">
-            <a:hlinkClick r:id="rId3" tooltip="Advance to Live Benchmarks (Slide 15)" action="ppaction://hlinksldjump"/>
+            <a:hlinkClick r:id="rId3" tooltip="Advance to Live Benchmarks (Slide 16)" action="ppaction://hlinksldjump"/>
           </p:cNvPr>
           <p:cNvSpPr/>
           <p:nvPr/>
@@ -6738,7 +7557,7 @@
 </p:sld>
 </file>
 
-<file path=ppt/slides/slide15.xml><?xml version="1.0" encoding="utf-8"?>
+<file path=ppt/slides/slide16.xml><?xml version="1.0" encoding="utf-8"?>
 <p:sld xmlns:a="http://schemas.openxmlformats.org/drawingml/2006/main" xmlns:r="http://schemas.openxmlformats.org/officeDocument/2006/relationships" xmlns:p="http://schemas.openxmlformats.org/presentationml/2006/main">
   <p:cSld>
     <p:bg>
@@ -6970,7 +7789,7 @@
       <p:sp>
         <p:nvSpPr>
           <p:cNvPr id="10" name="roundRect 9">
-            <a:hlinkClick r:id="rId3" tooltip="Return to Hyperlinks Hub (Slide 13)" action="ppaction://hlinksldjump"/>
+            <a:hlinkClick r:id="rId3" tooltip="Return to Hyperlinks Hub (Slide 14)" action="ppaction://hlinksldjump"/>
           </p:cNvPr>
           <p:cNvSpPr/>
           <p:nvPr/>
@@ -11446,9 +12265,7 @@
         <p:nvSpPr>
           <p:cNvPr id="4" name="placeholder:1"/>
           <p:cNvSpPr/>
-          <p:nvPr>
-            <p:ph idx="1"/>
-          </p:nvPr>
+          <p:nvPr/>
         </p:nvSpPr>
         <p:spPr>
           <a:xfrm>
@@ -11686,7 +12503,7 @@
     <p:bg>
       <p:bgPr>
         <a:solidFill>
-          <a:srgbClr val="F8FAFC"/>
+          <a:srgbClr val="0F172A"/>
         </a:solidFill>
         <a:effectLst/>
       </p:bgPr>
@@ -11714,7 +12531,7 @@
         <p:spPr>
           <a:xfrm>
             <a:off x="914400" y="731520"/>
-            <a:ext cx="10360152" cy="548640"/>
+            <a:ext cx="10360152" cy="731520"/>
           </a:xfrm>
           <a:prstGeom prst="rect">
             <a:avLst/>
@@ -11727,12 +12544,12 @@
             <a:r>
               <a:rPr b="1" sz="2400">
                 <a:solidFill>
-                  <a:srgbClr val="0F172A"/>
+                  <a:srgbClr val="38BDF8"/>
                 </a:solidFill>
                 <a:latin typeface="+mj-lt"/>
                 <a:cs typeface="+mj-lt"/>
               </a:rPr>
-              <a:t>Flow Connectors &amp; Composite Group Architecture</a:t>
+              <a:t>Hierarchical Block Indentation (bullet: false) &amp; Code Outlines</a:t>
             </a:r>
           </a:p>
         </p:txBody>
@@ -11745,7 +12562,7 @@
         </p:nvSpPr>
         <p:spPr>
           <a:xfrm>
-            <a:off x="914400" y="1280160"/>
+            <a:off x="914400" y="1371600"/>
             <a:ext cx="10360152" cy="365760"/>
           </a:xfrm>
           <a:prstGeom prst="rect">
@@ -11757,642 +12574,658 @@
           <a:lstStyle/>
           <a:p>
             <a:r>
-              <a:rPr sz="1400">
+              <a:rPr sz="1300">
+                <a:solidFill>
+                  <a:srgbClr val="94A3B8"/>
+                </a:solidFill>
+                <a:latin typeface="+mn-lt"/>
+                <a:cs typeface="+mn-lt"/>
+              </a:rPr>
+              <a:t>Demonstrating { level: N, bullet: false } (&lt;a:buNone/&gt;) — suppresses bullet glyphs while preserving precise margin indentation, soft breaks, and Tab / Shift+Tab cycling</a:t>
+            </a:r>
+          </a:p>
+        </p:txBody>
+      </p:sp>
+      <p:sp>
+        <p:nvSpPr>
+          <p:cNvPr id="4" name="roundRect 3"/>
+          <p:cNvSpPr/>
+          <p:nvPr/>
+        </p:nvSpPr>
+        <p:spPr>
+          <a:xfrm>
+            <a:off x="914400" y="1828800"/>
+            <a:ext cx="4937760" cy="4480560"/>
+          </a:xfrm>
+          <a:prstGeom prst="roundRect">
+            <a:avLst/>
+          </a:prstGeom>
+          <a:solidFill>
+            <a:srgbClr val="1E293B"/>
+          </a:solidFill>
+          <a:ln w="13716">
+            <a:solidFill>
+              <a:srgbClr val="38BDF8"/>
+            </a:solidFill>
+          </a:ln>
+          <a:effectLst>
+            <a:outerShdw blurRad="182880" dist="45720" dir="5400000">
+              <a:srgbClr val="000000">
+                <a:alpha val="40000"/>
+              </a:srgbClr>
+            </a:outerShdw>
+          </a:effectLst>
+        </p:spPr>
+        <p:txBody>
+          <a:bodyPr/>
+          <a:lstStyle/>
+          <a:p>
+            <a:endParaRPr/>
+          </a:p>
+        </p:txBody>
+      </p:sp>
+      <p:sp>
+        <p:nvSpPr>
+          <p:cNvPr id="5" name="Text Box 4"/>
+          <p:cNvSpPr txBox="1"/>
+          <p:nvPr/>
+        </p:nvSpPr>
+        <p:spPr>
+          <a:xfrm>
+            <a:off x="1097280" y="2011680"/>
+            <a:ext cx="4572000" cy="365760"/>
+          </a:xfrm>
+          <a:prstGeom prst="rect">
+            <a:avLst/>
+          </a:prstGeom>
+        </p:spPr>
+        <p:txBody>
+          <a:bodyPr/>
+          <a:lstStyle/>
+          <a:p>
+            <a:r>
+              <a:rPr b="1" sz="1400">
+                <a:solidFill>
+                  <a:srgbClr val="38BDF8"/>
+                </a:solidFill>
+                <a:latin typeface="+mn-lt"/>
+                <a:cs typeface="+mn-lt"/>
+              </a:rPr>
+              <a:t>📋 Architectural Block Outlining</a:t>
+            </a:r>
+          </a:p>
+        </p:txBody>
+      </p:sp>
+      <p:sp>
+        <p:nvSpPr>
+          <p:cNvPr id="6" name="Text Box 5"/>
+          <p:cNvSpPr txBox="1"/>
+          <p:nvPr/>
+        </p:nvSpPr>
+        <p:spPr>
+          <a:xfrm>
+            <a:off x="1097280" y="2423160"/>
+            <a:ext cx="4572000" cy="3749040"/>
+          </a:xfrm>
+          <a:prstGeom prst="rect">
+            <a:avLst/>
+          </a:prstGeom>
+        </p:spPr>
+        <p:txBody>
+          <a:bodyPr/>
+          <a:lstStyle/>
+          <a:p>
+            <a:pPr marL="285750" indent="-285750">
+              <a:buFont typeface="Arial" panose="020B0604020202020204" pitchFamily="34" charset="0"/>
+              <a:buChar char="•"/>
+            </a:pPr>
+            <a:r>
+              <a:rPr b="1" sz="1050">
+                <a:solidFill>
+                  <a:srgbClr val="E2E8F0"/>
+                </a:solidFill>
+                <a:latin typeface="+mn-lt"/>
+                <a:cs typeface="+mn-lt"/>
+              </a:rPr>
+              <a:t>1. Primary Storage Engine (Raft Consensus)</a:t>
+            </a:r>
+          </a:p>
+          <a:p>
+            <a:pPr lvl="1">
+              <a:buNone/>
+            </a:pPr>
+            <a:r>
+              <a:rPr sz="1050">
+                <a:solidFill>
+                  <a:srgbClr val="94A3B8"/>
+                </a:solidFill>
+                <a:latin typeface="+mn-lt"/>
+                <a:cs typeface="+mn-lt"/>
+              </a:rPr>
+              <a:t>↳ level: 1, bullet: false — Block explanation indented under Level 0</a:t>
+            </a:r>
+            <a:br>
+              <a:rPr sz="1050">
+                <a:solidFill>
+                  <a:srgbClr val="E2E8F0"/>
+                </a:solidFill>
+                <a:latin typeface="+mn-lt"/>
+                <a:cs typeface="+mn-lt"/>
+              </a:rPr>
+            </a:br>
+            <a:r>
+              <a:rPr sz="1050">
                 <a:solidFill>
                   <a:srgbClr val="64748B"/>
                 </a:solidFill>
                 <a:latin typeface="+mn-lt"/>
                 <a:cs typeface="+mn-lt"/>
               </a:rPr>
-              <a:t>Demonstrating vector connectors (solid, dashed), coordinates, and composite group containers (addGroup)</a:t>
-            </a:r>
-          </a:p>
-        </p:txBody>
-      </p:sp>
-      <p:sp>
-        <p:nvSpPr>
-          <p:cNvPr id="19" name="Text Box 18"/>
-          <p:cNvSpPr txBox="1"/>
-          <p:nvPr/>
-        </p:nvSpPr>
-        <p:spPr>
-          <a:xfrm>
-            <a:off x="914400" y="5806440"/>
-            <a:ext cx="10241280" cy="365760"/>
-          </a:xfrm>
-          <a:prstGeom prst="rect">
-            <a:avLst/>
-          </a:prstGeom>
-        </p:spPr>
-        <p:txBody>
-          <a:bodyPr/>
-          <a:lstStyle/>
-          <a:p>
-            <a:pPr algn="ctr"/>
-            <a:r>
-              <a:rPr sz="1100">
+              <a:t>Maintains strict linearizable consistency across all state machine nodes.</a:t>
+            </a:r>
+          </a:p>
+          <a:p>
+            <a:pPr lvl="2">
+              <a:buNone/>
+            </a:pPr>
+            <a:r>
+              <a:rPr sz="1050">
+                <a:solidFill>
+                  <a:srgbClr val="38BDF8"/>
+                </a:solidFill>
+                <a:latin typeface="+mn-lt"/>
+                <a:cs typeface="+mn-lt"/>
+              </a:rPr>
+              <a:t>• Technical SLA: </a:t>
+            </a:r>
+            <a:r>
+              <a:rPr sz="1050">
+                <a:solidFill>
+                  <a:srgbClr val="CBD5E1"/>
+                </a:solidFill>
+                <a:latin typeface="+mn-lt"/>
+                <a:cs typeface="+mn-lt"/>
+              </a:rPr>
+              <a:t>P99 commit latency &lt; 0.85ms over NVMe WAL</a:t>
+            </a:r>
+          </a:p>
+          <a:p>
+            <a:pPr marL="285750" indent="-285750">
+              <a:buFont typeface="Arial" panose="020B0604020202020204" pitchFamily="34" charset="0"/>
+              <a:buChar char="•"/>
+            </a:pPr>
+            <a:r>
+              <a:rPr b="1" sz="1050">
+                <a:solidFill>
+                  <a:srgbClr val="E2E8F0"/>
+                </a:solidFill>
+                <a:latin typeface="+mn-lt"/>
+                <a:cs typeface="+mn-lt"/>
+              </a:rPr>
+              <a:t>2. Multi-Region Active Replication</a:t>
+            </a:r>
+          </a:p>
+          <a:p>
+            <a:pPr lvl="1">
+              <a:buNone/>
+            </a:pPr>
+            <a:r>
+              <a:rPr sz="1050">
+                <a:solidFill>
+                  <a:srgbClr val="94A3B8"/>
+                </a:solidFill>
+                <a:latin typeface="+mn-lt"/>
+                <a:cs typeface="+mn-lt"/>
+              </a:rPr>
+              <a:t>↳ level: 1, bullet: false — Block commentary (no bullet glyph)</a:t>
+            </a:r>
+            <a:br>
+              <a:rPr sz="1050">
+                <a:solidFill>
+                  <a:srgbClr val="E2E8F0"/>
+                </a:solidFill>
+                <a:latin typeface="+mn-lt"/>
+                <a:cs typeface="+mn-lt"/>
+              </a:rPr>
+            </a:br>
+            <a:r>
+              <a:rPr sz="1050">
                 <a:solidFill>
                   <a:srgbClr val="64748B"/>
                 </a:solidFill>
                 <a:latin typeface="+mn-lt"/>
                 <a:cs typeface="+mn-lt"/>
               </a:rPr>
-              <a:t>Isomorphic Pipeline Feedback Loop: 100% Roundtrip Bit-Exact Precision</a:t>
-            </a:r>
-          </a:p>
-        </p:txBody>
-      </p:sp>
-      <p:sp>
-        <p:nvSpPr>
-          <p:cNvPr id="20" name="Text Box 19"/>
-          <p:cNvSpPr txBox="1"/>
-          <p:nvPr/>
-        </p:nvSpPr>
-        <p:spPr>
-          <a:xfrm>
-            <a:off x="731520" y="6510528"/>
-            <a:ext cx="10725912" cy="228600"/>
-          </a:xfrm>
-          <a:prstGeom prst="rect">
-            <a:avLst/>
-          </a:prstGeom>
-        </p:spPr>
-        <p:txBody>
-          <a:bodyPr/>
-          <a:lstStyle/>
-          <a:p>
-            <a:pPr algn="ctr"/>
-            <a:r>
-              <a:rPr i="1" sz="800">
-                <a:solidFill>
-                  <a:srgbClr val="94A3B8"/>
-                </a:solidFill>
-                <a:latin typeface="+mn-lt"/>
-                <a:cs typeface="+mn-lt"/>
-              </a:rPr>
-              <a:t>* Disclaimer: All benchmark metrics, performance figures, and simulated architectures in this deck are synthetic demonstration values generated solely to showcase the authoring, formatting, and rendering capabilities of @hokkyss/pptx.</a:t>
-            </a:r>
-          </a:p>
-        </p:txBody>
-      </p:sp>
-      <p:grpSp>
-        <p:nvGrpSpPr>
-          <p:cNvPr id="4" name="Stage 1 Ingress Container"/>
-          <p:cNvGrpSpPr/>
-          <p:nvPr/>
-        </p:nvGrpSpPr>
-        <p:grpSpPr>
-          <a:xfrm>
-            <a:off x="914400" y="2011680"/>
-            <a:ext cx="2926080" cy="3200400"/>
-            <a:chOff x="914400" y="2011680"/>
-            <a:chExt cx="2926080" cy="3200400"/>
-          </a:xfrm>
-        </p:grpSpPr>
-        <p:sp>
-          <p:nvSpPr>
-            <p:cNvPr id="5" name="Stage 1 Background"/>
-            <p:cNvSpPr/>
-            <p:nvPr/>
-          </p:nvSpPr>
-          <p:spPr>
-            <a:xfrm>
-              <a:off x="914400" y="2011680"/>
-              <a:ext cx="2926080" cy="3200400"/>
-            </a:xfrm>
-            <a:prstGeom prst="roundRect">
-              <a:avLst/>
-            </a:prstGeom>
-            <a:solidFill>
-              <a:srgbClr val="FFFFFF"/>
-            </a:solidFill>
-            <a:ln w="13716">
-              <a:solidFill>
-                <a:srgbClr val="0284C7"/>
-              </a:solidFill>
-            </a:ln>
-            <a:effectLst>
-              <a:outerShdw blurRad="109728" dist="38100" dir="5400000">
-                <a:srgbClr val="0F172A">
-                  <a:alpha val="10000"/>
-                </a:srgbClr>
-              </a:outerShdw>
-            </a:effectLst>
-          </p:spPr>
-          <p:txBody>
-            <a:bodyPr/>
-            <a:lstStyle/>
-            <a:p>
-              <a:endParaRPr/>
-            </a:p>
-          </p:txBody>
-        </p:sp>
-        <p:sp>
-          <p:nvSpPr>
-            <p:cNvPr id="6" name="roundRect 5"/>
-            <p:cNvSpPr/>
-            <p:nvPr/>
-          </p:nvSpPr>
-          <p:spPr>
-            <a:xfrm>
-              <a:off x="1188720" y="2286000"/>
-              <a:ext cx="2377440" cy="365760"/>
-            </a:xfrm>
-            <a:prstGeom prst="roundRect">
-              <a:avLst/>
-            </a:prstGeom>
-            <a:solidFill>
-              <a:srgbClr val="0284C7"/>
-            </a:solidFill>
-          </p:spPr>
-          <p:txBody>
-            <a:bodyPr/>
-            <a:lstStyle/>
-            <a:p>
-              <a:pPr algn="ctr"/>
-              <a:r>
-                <a:rPr b="1" sz="1000">
-                  <a:solidFill>
-                    <a:srgbClr val="FFFFFF"/>
-                  </a:solidFill>
-                  <a:latin typeface="+mn-lt"/>
-                  <a:cs typeface="+mn-lt"/>
-                </a:rPr>
-                <a:t>STEP 1: INGESTION</a:t>
-              </a:r>
-            </a:p>
-          </p:txBody>
-        </p:sp>
-        <p:sp>
-          <p:nvSpPr>
-            <p:cNvPr id="7" name="Text Box 6"/>
-            <p:cNvSpPr/>
-            <p:nvPr/>
-          </p:nvSpPr>
-          <p:spPr>
-            <a:xfrm>
-              <a:off x="1188720" y="2926080"/>
-              <a:ext cx="2377440" cy="1828800"/>
-            </a:xfrm>
-            <a:prstGeom prst="rect">
-              <a:avLst/>
-            </a:prstGeom>
-          </p:spPr>
-          <p:txBody>
-            <a:bodyPr/>
-            <a:lstStyle/>
-            <a:p>
-              <a:pPr marL="285750" indent="-285750">
-                <a:buFont typeface="Arial" panose="020B0604020202020204" pitchFamily="34" charset="0"/>
-                <a:buChar char="•"/>
-              </a:pPr>
-              <a:r>
-                <a:rPr sz="1100">
-                  <a:solidFill>
-                    <a:srgbClr val="475569"/>
-                  </a:solidFill>
-                  <a:latin typeface="+mn-lt"/>
-                  <a:cs typeface="+mn-lt"/>
-                </a:rPr>
-                <a:t>Streaming ZIP decompression</a:t>
-              </a:r>
-            </a:p>
-            <a:p>
-              <a:pPr marL="285750" indent="-285750">
-                <a:buFont typeface="Arial" panose="020B0604020202020204" pitchFamily="34" charset="0"/>
-                <a:buChar char="•"/>
-              </a:pPr>
-              <a:r>
-                <a:rPr sz="1100">
-                  <a:solidFill>
-                    <a:srgbClr val="475569"/>
-                  </a:solidFill>
-                  <a:latin typeface="+mn-lt"/>
-                  <a:cs typeface="+mn-lt"/>
-                </a:rPr>
-                <a:t>XML DOM part resolution</a:t>
-              </a:r>
-            </a:p>
-            <a:p>
-              <a:pPr marL="285750" indent="-285750">
-                <a:buFont typeface="Arial" panose="020B0604020202020204" pitchFamily="34" charset="0"/>
-                <a:buChar char="•"/>
-              </a:pPr>
-              <a:r>
-                <a:rPr sz="1100">
-                  <a:solidFill>
-                    <a:srgbClr val="475569"/>
-                  </a:solidFill>
-                  <a:latin typeface="+mn-lt"/>
-                  <a:cs typeface="+mn-lt"/>
-                </a:rPr>
-                <a:t>Extract relationships map</a:t>
-              </a:r>
-            </a:p>
-          </p:txBody>
-        </p:sp>
-      </p:grpSp>
-      <p:grpSp>
-        <p:nvGrpSpPr>
-          <p:cNvPr id="8" name="Stage 2 AST Container"/>
-          <p:cNvGrpSpPr/>
-          <p:nvPr/>
-        </p:nvGrpSpPr>
-        <p:grpSpPr>
-          <a:xfrm>
-            <a:off x="4572000" y="2011680"/>
-            <a:ext cx="2926080" cy="3200400"/>
-            <a:chOff x="4572000" y="2011680"/>
-            <a:chExt cx="2926080" cy="3200400"/>
-          </a:xfrm>
-        </p:grpSpPr>
-        <p:sp>
-          <p:nvSpPr>
-            <p:cNvPr id="9" name="Stage 2 Background"/>
-            <p:cNvSpPr/>
-            <p:nvPr/>
-          </p:nvSpPr>
-          <p:spPr>
-            <a:xfrm>
-              <a:off x="4572000" y="2011680"/>
-              <a:ext cx="2926080" cy="3200400"/>
-            </a:xfrm>
-            <a:prstGeom prst="roundRect">
-              <a:avLst/>
-            </a:prstGeom>
-            <a:solidFill>
-              <a:srgbClr val="FFFFFF"/>
-            </a:solidFill>
-            <a:ln w="13716">
-              <a:solidFill>
-                <a:srgbClr val="6366F1"/>
-              </a:solidFill>
-            </a:ln>
-            <a:effectLst>
-              <a:outerShdw blurRad="109728" dist="38100" dir="5400000">
-                <a:srgbClr val="0F172A">
-                  <a:alpha val="10000"/>
-                </a:srgbClr>
-              </a:outerShdw>
-            </a:effectLst>
-          </p:spPr>
-          <p:txBody>
-            <a:bodyPr/>
-            <a:lstStyle/>
-            <a:p>
-              <a:endParaRPr/>
-            </a:p>
-          </p:txBody>
-        </p:sp>
-        <p:sp>
-          <p:nvSpPr>
-            <p:cNvPr id="10" name="roundRect 9"/>
-            <p:cNvSpPr/>
-            <p:nvPr/>
-          </p:nvSpPr>
-          <p:spPr>
-            <a:xfrm>
-              <a:off x="4846320" y="2286000"/>
-              <a:ext cx="2377440" cy="365760"/>
-            </a:xfrm>
-            <a:prstGeom prst="roundRect">
-              <a:avLst/>
-            </a:prstGeom>
+              <a:t>Automatic failover orchestration with zero operational downtime.</a:t>
+            </a:r>
+          </a:p>
+          <a:p>
+            <a:pPr lvl="2">
+              <a:buNone/>
+            </a:pPr>
+            <a:r>
+              <a:rPr sz="1050">
+                <a:solidFill>
+                  <a:srgbClr val="10B981"/>
+                </a:solidFill>
+                <a:latin typeface="+mn-lt"/>
+                <a:cs typeface="+mn-lt"/>
+              </a:rPr>
+              <a:t>• Health Heartbeat: </a:t>
+            </a:r>
+            <a:r>
+              <a:rPr sz="1050">
+                <a:solidFill>
+                  <a:srgbClr val="CBD5E1"/>
+                </a:solidFill>
+                <a:latin typeface="+mn-lt"/>
+                <a:cs typeface="+mn-lt"/>
+              </a:rPr>
+              <a:t>Sub-50ms peer gossip discovery with eBPF probes</a:t>
+            </a:r>
+          </a:p>
+        </p:txBody>
+      </p:sp>
+      <p:sp>
+        <p:nvSpPr>
+          <p:cNvPr id="7" name="roundRect 6"/>
+          <p:cNvSpPr/>
+          <p:nvPr/>
+        </p:nvSpPr>
+        <p:spPr>
+          <a:xfrm>
+            <a:off x="6217920" y="1828800"/>
+            <a:ext cx="4937760" cy="4480560"/>
+          </a:xfrm>
+          <a:prstGeom prst="roundRect">
+            <a:avLst/>
+          </a:prstGeom>
+          <a:solidFill>
+            <a:srgbClr val="1E293B"/>
+          </a:solidFill>
+          <a:ln w="13716">
             <a:solidFill>
               <a:srgbClr val="6366F1"/>
             </a:solidFill>
-          </p:spPr>
-          <p:txBody>
-            <a:bodyPr/>
-            <a:lstStyle/>
-            <a:p>
-              <a:pPr algn="ctr"/>
-              <a:r>
-                <a:rPr b="1" sz="1000">
-                  <a:solidFill>
-                    <a:srgbClr val="FFFFFF"/>
-                  </a:solidFill>
-                  <a:latin typeface="+mn-lt"/>
-                  <a:cs typeface="+mn-lt"/>
-                </a:rPr>
-                <a:t>STEP 2: MODELING</a:t>
-              </a:r>
-            </a:p>
-          </p:txBody>
-        </p:sp>
-        <p:sp>
-          <p:nvSpPr>
-            <p:cNvPr id="11" name="Text Box 10"/>
-            <p:cNvSpPr/>
-            <p:nvPr/>
-          </p:nvSpPr>
-          <p:spPr>
-            <a:xfrm>
-              <a:off x="4846320" y="2926080"/>
-              <a:ext cx="2377440" cy="1828800"/>
-            </a:xfrm>
-            <a:prstGeom prst="rect">
-              <a:avLst/>
-            </a:prstGeom>
-          </p:spPr>
-          <p:txBody>
-            <a:bodyPr/>
-            <a:lstStyle/>
-            <a:p>
-              <a:pPr marL="285750" indent="-285750">
-                <a:buFont typeface="Arial" panose="020B0604020202020204" pitchFamily="34" charset="0"/>
-                <a:buChar char="•"/>
-              </a:pPr>
-              <a:r>
-                <a:rPr sz="1100">
-                  <a:solidFill>
-                    <a:srgbClr val="475569"/>
-                  </a:solidFill>
-                  <a:latin typeface="+mn-lt"/>
-                  <a:cs typeface="+mn-lt"/>
-                </a:rPr>
-                <a:t>Type-safe AST generation</a:t>
-              </a:r>
-            </a:p>
-            <a:p>
-              <a:pPr marL="285750" indent="-285750">
-                <a:buFont typeface="Arial" panose="020B0604020202020204" pitchFamily="34" charset="0"/>
-                <a:buChar char="•"/>
-              </a:pPr>
-              <a:r>
-                <a:rPr sz="1100">
-                  <a:solidFill>
-                    <a:srgbClr val="475569"/>
-                  </a:solidFill>
-                  <a:latin typeface="+mn-lt"/>
-                  <a:cs typeface="+mn-lt"/>
-                </a:rPr>
-                <a:t>Layer &amp; placeholder cascade</a:t>
-              </a:r>
-            </a:p>
-            <a:p>
-              <a:pPr marL="285750" indent="-285750">
-                <a:buFont typeface="Arial" panose="020B0604020202020204" pitchFamily="34" charset="0"/>
-                <a:buChar char="•"/>
-              </a:pPr>
-              <a:r>
-                <a:rPr sz="1100">
-                  <a:solidFill>
-                    <a:srgbClr val="475569"/>
-                  </a:solidFill>
-                  <a:latin typeface="+mn-lt"/>
-                  <a:cs typeface="+mn-lt"/>
-                </a:rPr>
-                <a:t>Fluent mutations &amp; styling</a:t>
-              </a:r>
-            </a:p>
-          </p:txBody>
-        </p:sp>
-      </p:grpSp>
-      <p:grpSp>
-        <p:nvGrpSpPr>
-          <p:cNvPr id="12" name="Stage 3 Packaging Container"/>
-          <p:cNvGrpSpPr/>
-          <p:nvPr/>
-        </p:nvGrpSpPr>
-        <p:grpSpPr>
-          <a:xfrm>
-            <a:off x="8229600" y="2011680"/>
-            <a:ext cx="2926080" cy="3200400"/>
-            <a:chOff x="8229600" y="2011680"/>
-            <a:chExt cx="2926080" cy="3200400"/>
-          </a:xfrm>
-        </p:grpSpPr>
-        <p:sp>
-          <p:nvSpPr>
-            <p:cNvPr id="13" name="Stage 3 Background"/>
-            <p:cNvSpPr/>
-            <p:nvPr/>
-          </p:nvSpPr>
-          <p:spPr>
-            <a:xfrm>
-              <a:off x="8229600" y="2011680"/>
-              <a:ext cx="2926080" cy="3200400"/>
-            </a:xfrm>
-            <a:prstGeom prst="roundRect">
-              <a:avLst/>
-            </a:prstGeom>
-            <a:solidFill>
-              <a:srgbClr val="FFFFFF"/>
-            </a:solidFill>
-            <a:ln w="13716">
-              <a:solidFill>
-                <a:srgbClr val="10B981"/>
-              </a:solidFill>
-            </a:ln>
-            <a:effectLst>
-              <a:outerShdw blurRad="109728" dist="38100" dir="5400000">
-                <a:srgbClr val="0F172A">
-                  <a:alpha val="10000"/>
-                </a:srgbClr>
-              </a:outerShdw>
-            </a:effectLst>
-          </p:spPr>
-          <p:txBody>
-            <a:bodyPr/>
-            <a:lstStyle/>
-            <a:p>
-              <a:endParaRPr/>
-            </a:p>
-          </p:txBody>
-        </p:sp>
-        <p:sp>
-          <p:nvSpPr>
-            <p:cNvPr id="14" name="roundRect 13"/>
-            <p:cNvSpPr/>
-            <p:nvPr/>
-          </p:nvSpPr>
-          <p:spPr>
-            <a:xfrm>
-              <a:off x="8503920" y="2286000"/>
-              <a:ext cx="2377440" cy="365760"/>
-            </a:xfrm>
-            <a:prstGeom prst="roundRect">
-              <a:avLst/>
-            </a:prstGeom>
-            <a:solidFill>
-              <a:srgbClr val="10B981"/>
-            </a:solidFill>
-          </p:spPr>
-          <p:txBody>
-            <a:bodyPr/>
-            <a:lstStyle/>
-            <a:p>
-              <a:pPr algn="ctr"/>
-              <a:r>
-                <a:rPr b="1" sz="1000">
-                  <a:solidFill>
-                    <a:srgbClr val="FFFFFF"/>
-                  </a:solidFill>
-                  <a:latin typeface="+mn-lt"/>
-                  <a:cs typeface="+mn-lt"/>
-                </a:rPr>
-                <a:t>STEP 3: COMPILATION</a:t>
-              </a:r>
-            </a:p>
-          </p:txBody>
-        </p:sp>
-        <p:sp>
-          <p:nvSpPr>
-            <p:cNvPr id="15" name="Text Box 14"/>
-            <p:cNvSpPr/>
-            <p:nvPr/>
-          </p:nvSpPr>
-          <p:spPr>
-            <a:xfrm>
-              <a:off x="8503920" y="2926080"/>
-              <a:ext cx="2377440" cy="1828800"/>
-            </a:xfrm>
-            <a:prstGeom prst="rect">
-              <a:avLst/>
-            </a:prstGeom>
-          </p:spPr>
-          <p:txBody>
-            <a:bodyPr/>
-            <a:lstStyle/>
-            <a:p>
-              <a:pPr marL="285750" indent="-285750">
-                <a:buFont typeface="Arial" panose="020B0604020202020204" pitchFamily="34" charset="0"/>
-                <a:buChar char="•"/>
-              </a:pPr>
-              <a:r>
-                <a:rPr sz="1100">
-                  <a:solidFill>
-                    <a:srgbClr val="475569"/>
-                  </a:solidFill>
-                  <a:latin typeface="+mn-lt"/>
-                  <a:cs typeface="+mn-lt"/>
-                </a:rPr>
-                <a:t>Deterministic XML emission</a:t>
-              </a:r>
-            </a:p>
-            <a:p>
-              <a:pPr marL="285750" indent="-285750">
-                <a:buFont typeface="Arial" panose="020B0604020202020204" pitchFamily="34" charset="0"/>
-                <a:buChar char="•"/>
-              </a:pPr>
-              <a:r>
-                <a:rPr sz="1100">
-                  <a:solidFill>
-                    <a:srgbClr val="475569"/>
-                  </a:solidFill>
-                  <a:latin typeface="+mn-lt"/>
-                  <a:cs typeface="+mn-lt"/>
-                </a:rPr>
-                <a:t>Zero-copy fflate compression</a:t>
-              </a:r>
-            </a:p>
-            <a:p>
-              <a:pPr marL="285750" indent="-285750">
-                <a:buFont typeface="Arial" panose="020B0604020202020204" pitchFamily="34" charset="0"/>
-                <a:buChar char="•"/>
-              </a:pPr>
-              <a:r>
-                <a:rPr sz="1100">
-                  <a:solidFill>
-                    <a:srgbClr val="475569"/>
-                  </a:solidFill>
-                  <a:latin typeface="+mn-lt"/>
-                  <a:cs typeface="+mn-lt"/>
-                </a:rPr>
-                <a:t>ECMA-376 compliant PPTX</a:t>
-              </a:r>
-            </a:p>
-          </p:txBody>
-        </p:sp>
-      </p:grpSp>
-      <p:cxnSp>
-        <p:nvCxnSpPr>
-          <p:cNvPr id="16" name="Connector 15"/>
-          <p:cNvCxnSpPr>
-            <a:cxnSpLocks/>
-            <a:stCxn id="5" idx="3"/>
-            <a:endCxn id="9" idx="1"/>
-          </p:cNvCxnSpPr>
-          <p:nvPr/>
-        </p:nvCxnSpPr>
-        <p:spPr>
-          <a:xfrm>
-            <a:off x="3840480" y="3611880"/>
-            <a:ext cx="731520" cy="0"/>
-          </a:xfrm>
-          <a:prstGeom prst="line">
-            <a:avLst/>
-          </a:prstGeom>
-          <a:ln w="27432">
-            <a:solidFill>
-              <a:srgbClr val="0284C7"/>
-            </a:solidFill>
-            <a:prstDash val="solid"/>
-            <a:headEnd type="triangle" w="lg" len="lg"/>
           </a:ln>
-        </p:spPr>
-      </p:cxnSp>
-      <p:cxnSp>
-        <p:nvCxnSpPr>
-          <p:cNvPr id="17" name="Connector 16"/>
-          <p:cNvCxnSpPr>
-            <a:cxnSpLocks/>
-            <a:stCxn id="9" idx="3"/>
-            <a:endCxn id="13" idx="1"/>
-          </p:cNvCxnSpPr>
-          <p:nvPr/>
-        </p:nvCxnSpPr>
-        <p:spPr>
-          <a:xfrm>
-            <a:off x="7498080" y="3611880"/>
-            <a:ext cx="731520" cy="0"/>
-          </a:xfrm>
-          <a:prstGeom prst="line">
-            <a:avLst/>
-          </a:prstGeom>
-          <a:ln w="27432">
-            <a:solidFill>
-              <a:srgbClr val="6366F1"/>
-            </a:solidFill>
-            <a:prstDash val="solid"/>
-            <a:headEnd type="stealth" w="lg" len="lg"/>
-          </a:ln>
-        </p:spPr>
-      </p:cxnSp>
-      <p:cxnSp>
-        <p:nvCxnSpPr>
-          <p:cNvPr id="18" name="Connector 17"/>
-          <p:cNvCxnSpPr>
-            <a:cxnSpLocks/>
-          </p:cNvCxnSpPr>
-          <p:nvPr/>
-        </p:nvCxnSpPr>
-        <p:spPr>
-          <a:xfrm>
-            <a:off x="914400" y="5669280"/>
-            <a:ext cx="10241280" cy="0"/>
-          </a:xfrm>
-          <a:prstGeom prst="line">
-            <a:avLst/>
-          </a:prstGeom>
-          <a:ln w="18288">
-            <a:solidFill>
-              <a:srgbClr val="94A3B8"/>
-            </a:solidFill>
-            <a:prstDash val="dash"/>
-            <a:headEnd type="triangle"/>
-            <a:tailEnd type="oval"/>
-          </a:ln>
-        </p:spPr>
-      </p:cxnSp>
+          <a:effectLst>
+            <a:outerShdw blurRad="182880" dist="45720" dir="5400000">
+              <a:srgbClr val="000000">
+                <a:alpha val="40000"/>
+              </a:srgbClr>
+            </a:outerShdw>
+          </a:effectLst>
+        </p:spPr>
+        <p:txBody>
+          <a:bodyPr/>
+          <a:lstStyle/>
+          <a:p>
+            <a:endParaRPr/>
+          </a:p>
+        </p:txBody>
+      </p:sp>
+      <p:sp>
+        <p:nvSpPr>
+          <p:cNvPr id="8" name="Text Box 7"/>
+          <p:cNvSpPr txBox="1"/>
+          <p:nvPr/>
+        </p:nvSpPr>
+        <p:spPr>
+          <a:xfrm>
+            <a:off x="6400800" y="2011680"/>
+            <a:ext cx="4572000" cy="365760"/>
+          </a:xfrm>
+          <a:prstGeom prst="rect">
+            <a:avLst/>
+          </a:prstGeom>
+        </p:spPr>
+        <p:txBody>
+          <a:bodyPr/>
+          <a:lstStyle/>
+          <a:p>
+            <a:r>
+              <a:rPr b="1" sz="1400">
+                <a:solidFill>
+                  <a:srgbClr val="818CF8"/>
+                </a:solidFill>
+                <a:latin typeface="+mn-lt"/>
+                <a:cs typeface="+mn-lt"/>
+              </a:rPr>
+              <a:t>💻 Code &amp; Config Indentation Simulation</a:t>
+            </a:r>
+          </a:p>
+        </p:txBody>
+      </p:sp>
+      <p:sp>
+        <p:nvSpPr>
+          <p:cNvPr id="9" name="Text Box 8"/>
+          <p:cNvSpPr txBox="1"/>
+          <p:nvPr/>
+        </p:nvSpPr>
+        <p:spPr>
+          <a:xfrm>
+            <a:off x="6400800" y="2423160"/>
+            <a:ext cx="4572000" cy="3749040"/>
+          </a:xfrm>
+          <a:prstGeom prst="rect">
+            <a:avLst/>
+          </a:prstGeom>
+        </p:spPr>
+        <p:txBody>
+          <a:bodyPr/>
+          <a:lstStyle/>
+          <a:p>
+            <a:pPr>
+              <a:buNone/>
+            </a:pPr>
+            <a:r>
+              <a:rPr sz="1100">
+                <a:solidFill>
+                  <a:srgbClr val="F43F5E"/>
+                </a:solidFill>
+                <a:latin typeface="Courier New"/>
+                <a:cs typeface="Courier New"/>
+              </a:rPr>
+              <a:t>export interface </a:t>
+            </a:r>
+            <a:r>
+              <a:rPr b="1" sz="1100">
+                <a:solidFill>
+                  <a:srgbClr val="38BDF8"/>
+                </a:solidFill>
+                <a:latin typeface="Courier New"/>
+                <a:cs typeface="Courier New"/>
+              </a:rPr>
+              <a:t>PresentationConfig </a:t>
+            </a:r>
+            <a:r>
+              <a:rPr sz="1100">
+                <a:solidFill>
+                  <a:srgbClr val="E2E8F0"/>
+                </a:solidFill>
+                <a:latin typeface="Courier New"/>
+                <a:cs typeface="Courier New"/>
+              </a:rPr>
+              <a:t>{</a:t>
+            </a:r>
+          </a:p>
+          <a:p>
+            <a:pPr lvl="1">
+              <a:buNone/>
+            </a:pPr>
+            <a:r>
+              <a:rPr sz="1100">
+                <a:solidFill>
+                  <a:srgbClr val="CBD5E1"/>
+                </a:solidFill>
+                <a:latin typeface="Courier New"/>
+                <a:cs typeface="Courier New"/>
+              </a:rPr>
+              <a:t>author: </a:t>
+            </a:r>
+            <a:r>
+              <a:rPr sz="1100">
+                <a:solidFill>
+                  <a:srgbClr val="10B981"/>
+                </a:solidFill>
+                <a:latin typeface="Courier New"/>
+                <a:cs typeface="Courier New"/>
+              </a:rPr>
+              <a:t>'Hokkyss Core Team'</a:t>
+            </a:r>
+            <a:r>
+              <a:rPr sz="1100">
+                <a:solidFill>
+                  <a:srgbClr val="E2E8F0"/>
+                </a:solidFill>
+                <a:latin typeface="Courier New"/>
+                <a:cs typeface="Courier New"/>
+              </a:rPr>
+              <a:t>;</a:t>
+            </a:r>
+          </a:p>
+          <a:p>
+            <a:pPr lvl="1">
+              <a:buNone/>
+            </a:pPr>
+            <a:r>
+              <a:rPr sz="1100">
+                <a:solidFill>
+                  <a:srgbClr val="CBD5E1"/>
+                </a:solidFill>
+                <a:latin typeface="Courier New"/>
+                <a:cs typeface="Courier New"/>
+              </a:rPr>
+              <a:t>dimensions: </a:t>
+            </a:r>
+            <a:r>
+              <a:rPr sz="1100">
+                <a:solidFill>
+                  <a:srgbClr val="E2E8F0"/>
+                </a:solidFill>
+                <a:latin typeface="Courier New"/>
+                <a:cs typeface="Courier New"/>
+              </a:rPr>
+              <a:t>{</a:t>
+            </a:r>
+          </a:p>
+          <a:p>
+            <a:pPr lvl="2">
+              <a:buNone/>
+            </a:pPr>
+            <a:r>
+              <a:rPr sz="1100">
+                <a:solidFill>
+                  <a:srgbClr val="CBD5E1"/>
+                </a:solidFill>
+                <a:latin typeface="Courier New"/>
+                <a:cs typeface="Courier New"/>
+              </a:rPr>
+              <a:t>width: </a:t>
+            </a:r>
+            <a:r>
+              <a:rPr sz="1100">
+                <a:solidFill>
+                  <a:srgbClr val="F59E0B"/>
+                </a:solidFill>
+                <a:latin typeface="Courier New"/>
+                <a:cs typeface="Courier New"/>
+              </a:rPr>
+              <a:t>inches(13.33)</a:t>
+            </a:r>
+            <a:r>
+              <a:rPr sz="1100">
+                <a:solidFill>
+                  <a:srgbClr val="E2E8F0"/>
+                </a:solidFill>
+                <a:latin typeface="Courier New"/>
+                <a:cs typeface="Courier New"/>
+              </a:rPr>
+              <a:t>;</a:t>
+            </a:r>
+          </a:p>
+          <a:p>
+            <a:pPr lvl="2">
+              <a:buNone/>
+            </a:pPr>
+            <a:r>
+              <a:rPr sz="1100">
+                <a:solidFill>
+                  <a:srgbClr val="CBD5E1"/>
+                </a:solidFill>
+                <a:latin typeface="Courier New"/>
+                <a:cs typeface="Courier New"/>
+              </a:rPr>
+              <a:t>height: </a:t>
+            </a:r>
+            <a:r>
+              <a:rPr sz="1100">
+                <a:solidFill>
+                  <a:srgbClr val="F59E0B"/>
+                </a:solidFill>
+                <a:latin typeface="Courier New"/>
+                <a:cs typeface="Courier New"/>
+              </a:rPr>
+              <a:t>inches(7.5)</a:t>
+            </a:r>
+            <a:r>
+              <a:rPr sz="1100">
+                <a:solidFill>
+                  <a:srgbClr val="E2E8F0"/>
+                </a:solidFill>
+                <a:latin typeface="Courier New"/>
+                <a:cs typeface="Courier New"/>
+              </a:rPr>
+              <a:t>;</a:t>
+            </a:r>
+          </a:p>
+          <a:p>
+            <a:pPr lvl="1">
+              <a:buNone/>
+            </a:pPr>
+            <a:r>
+              <a:rPr sz="1100">
+                <a:solidFill>
+                  <a:srgbClr val="E2E8F0"/>
+                </a:solidFill>
+                <a:latin typeface="Courier New"/>
+                <a:cs typeface="Courier New"/>
+              </a:rPr>
+              <a:t>};</a:t>
+            </a:r>
+          </a:p>
+          <a:p>
+            <a:pPr lvl="1">
+              <a:buNone/>
+            </a:pPr>
+            <a:r>
+              <a:rPr sz="1100">
+                <a:solidFill>
+                  <a:srgbClr val="CBD5E1"/>
+                </a:solidFill>
+                <a:latin typeface="Courier New"/>
+                <a:cs typeface="Courier New"/>
+              </a:rPr>
+              <a:t>bulletFormatting: </a:t>
+            </a:r>
+            <a:r>
+              <a:rPr sz="1100">
+                <a:solidFill>
+                  <a:srgbClr val="E2E8F0"/>
+                </a:solidFill>
+                <a:latin typeface="Courier New"/>
+                <a:cs typeface="Courier New"/>
+              </a:rPr>
+              <a:t>{</a:t>
+            </a:r>
+          </a:p>
+          <a:p>
+            <a:pPr lvl="2">
+              <a:buNone/>
+            </a:pPr>
+            <a:r>
+              <a:rPr sz="1100">
+                <a:solidFill>
+                  <a:srgbClr val="CBD5E1"/>
+                </a:solidFill>
+                <a:latin typeface="Courier New"/>
+                <a:cs typeface="Courier New"/>
+              </a:rPr>
+              <a:t>type: </a:t>
+            </a:r>
+            <a:r>
+              <a:rPr sz="1100">
+                <a:solidFill>
+                  <a:srgbClr val="10B981"/>
+                </a:solidFill>
+                <a:latin typeface="Courier New"/>
+                <a:cs typeface="Courier New"/>
+              </a:rPr>
+              <a:t>'none'</a:t>
+            </a:r>
+            <a:r>
+              <a:rPr i="1" sz="1100">
+                <a:solidFill>
+                  <a:srgbClr val="64748B"/>
+                </a:solidFill>
+                <a:latin typeface="Courier New"/>
+                <a:cs typeface="Courier New"/>
+              </a:rPr>
+              <a:t> // &lt;a:buNone/&gt; suppresses glyph</a:t>
+            </a:r>
+          </a:p>
+          <a:p>
+            <a:pPr lvl="1">
+              <a:buNone/>
+            </a:pPr>
+            <a:r>
+              <a:rPr sz="1100">
+                <a:solidFill>
+                  <a:srgbClr val="E2E8F0"/>
+                </a:solidFill>
+                <a:latin typeface="Courier New"/>
+                <a:cs typeface="Courier New"/>
+              </a:rPr>
+              <a:t>};</a:t>
+            </a:r>
+          </a:p>
+          <a:p>
+            <a:pPr>
+              <a:buNone/>
+            </a:pPr>
+            <a:r>
+              <a:rPr sz="1100">
+                <a:solidFill>
+                  <a:srgbClr val="E2E8F0"/>
+                </a:solidFill>
+                <a:latin typeface="Courier New"/>
+                <a:cs typeface="Courier New"/>
+              </a:rPr>
+              <a:t>}</a:t>
+            </a:r>
+          </a:p>
+        </p:txBody>
+      </p:sp>
+      <p:sp>
+        <p:nvSpPr>
+          <p:cNvPr id="10" name="Text Box 9"/>
+          <p:cNvSpPr txBox="1"/>
+          <p:nvPr/>
+        </p:nvSpPr>
+        <p:spPr>
+          <a:xfrm>
+            <a:off x="731520" y="6510528"/>
+            <a:ext cx="10725912" cy="228600"/>
+          </a:xfrm>
+          <a:prstGeom prst="rect">
+            <a:avLst/>
+          </a:prstGeom>
+        </p:spPr>
+        <p:txBody>
+          <a:bodyPr/>
+          <a:lstStyle/>
+          <a:p>
+            <a:pPr algn="ctr"/>
+            <a:r>
+              <a:rPr i="1" sz="800">
+                <a:solidFill>
+                  <a:srgbClr val="64748B"/>
+                </a:solidFill>
+                <a:latin typeface="+mn-lt"/>
+                <a:cs typeface="+mn-lt"/>
+              </a:rPr>
+              <a:t>* Disclaimer: All benchmark metrics, performance figures, and simulated architectures in this deck are synthetic demonstration values generated solely to showcase the authoring, formatting, and rendering capabilities of @hokkyss/pptx.</a:t>
+            </a:r>
+          </a:p>
+        </p:txBody>
+      </p:sp>
     </p:spTree>
   </p:cSld>
   <p:clrMapOvr>
     <a:masterClrMapping/>
   </p:clrMapOvr>
   <p:transition spd="fast">
-    <p:pull dir="r"/>
+    <p:wipe dir="r"/>
   </p:transition>
 </p:sld>
 </file>

</xml_diff>

<commit_message>
refactor(pptx): rely on slide master and defaultTextStyle for bullet margins and indents
</commit_message>
<xml_diff>
--- a/hokkyss_showcase_deck.pptx
+++ b/hokkyss_showcase_deck.pptx
@@ -1904,7 +1904,7 @@
             </a:r>
           </a:p>
           <a:p>
-            <a:pPr marL="285750" indent="-285750">
+            <a:pPr>
               <a:buFont typeface="Arial" panose="020B0604020202020204" pitchFamily="34" charset="0"/>
               <a:buChar char="•"/>
             </a:pPr>
@@ -1931,7 +1931,7 @@
             </a:r>
           </a:p>
           <a:p>
-            <a:pPr lvl="1" marL="742950" indent="-285750">
+            <a:pPr lvl="1">
               <a:buFont typeface="Arial" panose="020B0604020202020204" pitchFamily="34" charset="0"/>
               <a:buChar char="•"/>
             </a:pPr>
@@ -1944,7 +1944,7 @@
             </a:r>
           </a:p>
           <a:p>
-            <a:pPr lvl="1" marL="742950" indent="-285750">
+            <a:pPr lvl="1">
               <a:buFont typeface="Arial" panose="020B0604020202020204" pitchFamily="34" charset="0"/>
               <a:buChar char="•"/>
             </a:pPr>
@@ -1957,7 +1957,7 @@
             </a:r>
           </a:p>
           <a:p>
-            <a:pPr marL="285750" indent="-285750">
+            <a:pPr>
               <a:buFont typeface="Arial" panose="020B0604020202020204" pitchFamily="34" charset="0"/>
               <a:buChar char="•"/>
             </a:pPr>
@@ -1984,7 +1984,7 @@
             </a:r>
           </a:p>
           <a:p>
-            <a:pPr marL="342900" indent="-342900">
+            <a:pPr>
               <a:buAutoNum type="arabicPeriod"/>
             </a:pPr>
             <a:r>
@@ -1996,7 +1996,7 @@
             </a:r>
           </a:p>
           <a:p>
-            <a:pPr marL="342900" indent="-342900">
+            <a:pPr>
               <a:buAutoNum type="arabicPeriod"/>
             </a:pPr>
             <a:r>
@@ -2077,7 +2077,7 @@
             </a:r>
           </a:p>
           <a:p>
-            <a:pPr marL="285750" indent="-285750">
+            <a:pPr>
               <a:buFont typeface="Arial" panose="020B0604020202020204" pitchFamily="34" charset="0"/>
               <a:buChar char="•"/>
             </a:pPr>
@@ -2090,7 +2090,7 @@
             </a:r>
           </a:p>
           <a:p>
-            <a:pPr marL="285750" indent="-285750">
+            <a:pPr>
               <a:buFont typeface="Arial" panose="020B0604020202020204" pitchFamily="34" charset="0"/>
               <a:buChar char="•"/>
             </a:pPr>
@@ -2103,7 +2103,7 @@
             </a:r>
           </a:p>
           <a:p>
-            <a:pPr marL="285750" indent="-285750">
+            <a:pPr>
               <a:buFont typeface="Arial" panose="020B0604020202020204" pitchFamily="34" charset="0"/>
               <a:buChar char="•"/>
             </a:pPr>
@@ -2185,7 +2185,7 @@
             </a:r>
           </a:p>
           <a:p>
-            <a:pPr marL="285750" indent="-285750">
+            <a:pPr>
               <a:buFont typeface="Arial" panose="020B0604020202020204" pitchFamily="34" charset="0"/>
               <a:buChar char="•"/>
             </a:pPr>
@@ -2198,7 +2198,7 @@
             </a:r>
           </a:p>
           <a:p>
-            <a:pPr marL="285750" indent="-285750">
+            <a:pPr>
               <a:buFont typeface="Arial" panose="020B0604020202020204" pitchFamily="34" charset="0"/>
               <a:buChar char="•"/>
             </a:pPr>
@@ -2211,7 +2211,7 @@
             </a:r>
           </a:p>
           <a:p>
-            <a:pPr marL="285750" indent="-285750">
+            <a:pPr>
               <a:buFont typeface="Arial" panose="020B0604020202020204" pitchFamily="34" charset="0"/>
               <a:buChar char="•"/>
             </a:pPr>
@@ -2293,7 +2293,7 @@
             </a:r>
           </a:p>
           <a:p>
-            <a:pPr marL="285750" indent="-285750">
+            <a:pPr>
               <a:buFont typeface="Arial" panose="020B0604020202020204" pitchFamily="34" charset="0"/>
               <a:buChar char="•"/>
             </a:pPr>
@@ -2306,7 +2306,7 @@
             </a:r>
           </a:p>
           <a:p>
-            <a:pPr marL="285750" indent="-285750">
+            <a:pPr>
               <a:buFont typeface="Arial" panose="020B0604020202020204" pitchFamily="34" charset="0"/>
               <a:buChar char="•"/>
             </a:pPr>
@@ -2319,7 +2319,7 @@
             </a:r>
           </a:p>
           <a:p>
-            <a:pPr marL="285750" indent="-285750">
+            <a:pPr>
               <a:buFont typeface="Arial" panose="020B0604020202020204" pitchFamily="34" charset="0"/>
               <a:buChar char="•"/>
             </a:pPr>
@@ -2401,7 +2401,7 @@
             </a:r>
           </a:p>
           <a:p>
-            <a:pPr marL="285750" indent="-285750">
+            <a:pPr>
               <a:buFont typeface="Arial" panose="020B0604020202020204" pitchFamily="34" charset="0"/>
               <a:buChar char="•"/>
             </a:pPr>
@@ -2414,7 +2414,7 @@
             </a:r>
           </a:p>
           <a:p>
-            <a:pPr marL="285750" indent="-285750">
+            <a:pPr>
               <a:buFont typeface="Arial" panose="020B0604020202020204" pitchFamily="34" charset="0"/>
               <a:buChar char="•"/>
             </a:pPr>
@@ -2489,7 +2489,7 @@
             </a:r>
           </a:p>
           <a:p>
-            <a:pPr marL="285750" indent="-285750">
+            <a:pPr>
               <a:buFont typeface="Arial" panose="020B0604020202020204" pitchFamily="34" charset="0"/>
               <a:buChar char="•"/>
             </a:pPr>
@@ -2502,7 +2502,7 @@
             </a:r>
           </a:p>
           <a:p>
-            <a:pPr marL="285750" indent="-285750">
+            <a:pPr>
               <a:buFont typeface="Arial" panose="020B0604020202020204" pitchFamily="34" charset="0"/>
               <a:buChar char="•"/>
             </a:pPr>
@@ -2515,7 +2515,7 @@
             </a:r>
           </a:p>
           <a:p>
-            <a:pPr lvl="1" marL="742950" indent="-285750">
+            <a:pPr lvl="1">
               <a:buFont typeface="Arial" panose="020B0604020202020204" pitchFamily="34" charset="0"/>
               <a:buChar char="•"/>
             </a:pPr>
@@ -2528,7 +2528,7 @@
             </a:r>
           </a:p>
           <a:p>
-            <a:pPr lvl="1" marL="742950" indent="-285750">
+            <a:pPr lvl="1">
               <a:buFont typeface="Arial" panose="020B0604020202020204" pitchFamily="34" charset="0"/>
               <a:buChar char="•"/>
             </a:pPr>
@@ -2541,7 +2541,7 @@
             </a:r>
           </a:p>
           <a:p>
-            <a:pPr lvl="2" marL="1200150" indent="-285750">
+            <a:pPr lvl="2">
               <a:buFont typeface="Arial" panose="020B0604020202020204" pitchFamily="34" charset="0"/>
               <a:buChar char="•"/>
             </a:pPr>
@@ -2554,7 +2554,7 @@
             </a:r>
           </a:p>
           <a:p>
-            <a:pPr lvl="3" marL="1657350" indent="-285750">
+            <a:pPr lvl="3">
               <a:buFont typeface="Arial" panose="020B0604020202020204" pitchFamily="34" charset="0"/>
               <a:buChar char="•"/>
             </a:pPr>
@@ -2567,7 +2567,7 @@
             </a:r>
           </a:p>
           <a:p>
-            <a:pPr marL="342900" indent="-342900">
+            <a:pPr>
               <a:buAutoNum type="arabicPeriod"/>
             </a:pPr>
             <a:r>
@@ -2641,7 +2641,7 @@
             </a:r>
           </a:p>
           <a:p>
-            <a:pPr marL="285750" indent="-285750">
+            <a:pPr>
               <a:buFont typeface="Arial" panose="020B0604020202020204" pitchFamily="34" charset="0"/>
               <a:buChar char="•"/>
             </a:pPr>
@@ -2654,7 +2654,7 @@
             </a:r>
           </a:p>
           <a:p>
-            <a:pPr marL="285750" indent="-285750">
+            <a:pPr>
               <a:buFont typeface="Arial" panose="020B0604020202020204" pitchFamily="34" charset="0"/>
               <a:buChar char="•"/>
             </a:pPr>
@@ -2667,7 +2667,7 @@
             </a:r>
           </a:p>
           <a:p>
-            <a:pPr lvl="1" marL="742950" indent="-285750">
+            <a:pPr lvl="1">
               <a:buFont typeface="Arial" panose="020B0604020202020204" pitchFamily="34" charset="0"/>
               <a:buChar char="•"/>
             </a:pPr>
@@ -2680,7 +2680,7 @@
             </a:r>
           </a:p>
           <a:p>
-            <a:pPr lvl="1" marL="742950" indent="-285750">
+            <a:pPr lvl="1">
               <a:buFont typeface="Arial" panose="020B0604020202020204" pitchFamily="34" charset="0"/>
               <a:buChar char="•"/>
             </a:pPr>
@@ -2755,7 +2755,7 @@
             </a:r>
           </a:p>
           <a:p>
-            <a:pPr marL="285750" indent="-285750">
+            <a:pPr>
               <a:buFont typeface="Arial" panose="020B0604020202020204" pitchFamily="34" charset="0"/>
               <a:buChar char="•"/>
             </a:pPr>
@@ -2768,7 +2768,7 @@
             </a:r>
           </a:p>
           <a:p>
-            <a:pPr marL="285750" indent="-285750">
+            <a:pPr>
               <a:buFont typeface="Arial" panose="020B0604020202020204" pitchFamily="34" charset="0"/>
               <a:buChar char="•"/>
             </a:pPr>
@@ -2781,7 +2781,7 @@
             </a:r>
           </a:p>
           <a:p>
-            <a:pPr lvl="1" marL="742950" indent="-285750">
+            <a:pPr lvl="1">
               <a:buFont typeface="Arial" panose="020B0604020202020204" pitchFamily="34" charset="0"/>
               <a:buChar char="•"/>
             </a:pPr>
@@ -2863,7 +2863,7 @@
             </a:r>
           </a:p>
           <a:p>
-            <a:pPr marL="285750" indent="-285750">
+            <a:pPr>
               <a:buFont typeface="Arial" panose="020B0604020202020204" pitchFamily="34" charset="0"/>
               <a:buChar char="•"/>
             </a:pPr>
@@ -2876,7 +2876,7 @@
             </a:r>
           </a:p>
           <a:p>
-            <a:pPr marL="285750" indent="-285750">
+            <a:pPr>
               <a:buFont typeface="Arial" panose="020B0604020202020204" pitchFamily="34" charset="0"/>
               <a:buChar char="•"/>
             </a:pPr>
@@ -2958,7 +2958,7 @@
             </a:r>
           </a:p>
           <a:p>
-            <a:pPr marL="285750" indent="-285750">
+            <a:pPr>
               <a:buFont typeface="Arial" panose="020B0604020202020204" pitchFamily="34" charset="0"/>
               <a:buChar char="•"/>
             </a:pPr>
@@ -2971,7 +2971,7 @@
             </a:r>
           </a:p>
           <a:p>
-            <a:pPr marL="285750" indent="-285750">
+            <a:pPr>
               <a:buFont typeface="Arial" panose="020B0604020202020204" pitchFamily="34" charset="0"/>
               <a:buChar char="•"/>
             </a:pPr>
@@ -2984,7 +2984,7 @@
             </a:r>
           </a:p>
           <a:p>
-            <a:pPr marL="285750" indent="-285750">
+            <a:pPr>
               <a:buFont typeface="Arial" panose="020B0604020202020204" pitchFamily="34" charset="0"/>
               <a:buChar char="•"/>
             </a:pPr>
@@ -3066,7 +3066,7 @@
             </a:r>
           </a:p>
           <a:p>
-            <a:pPr marL="285750" indent="-285750">
+            <a:pPr>
               <a:buFont typeface="Arial" panose="020B0604020202020204" pitchFamily="34" charset="0"/>
               <a:buChar char="•"/>
             </a:pPr>
@@ -3079,7 +3079,7 @@
             </a:r>
           </a:p>
           <a:p>
-            <a:pPr marL="285750" indent="-285750">
+            <a:pPr>
               <a:buFont typeface="Arial" panose="020B0604020202020204" pitchFamily="34" charset="0"/>
               <a:buChar char="•"/>
             </a:pPr>
@@ -3092,7 +3092,7 @@
             </a:r>
           </a:p>
           <a:p>
-            <a:pPr marL="285750" indent="-285750">
+            <a:pPr>
               <a:buFont typeface="Arial" panose="020B0604020202020204" pitchFamily="34" charset="0"/>
               <a:buChar char="•"/>
             </a:pPr>
@@ -3174,7 +3174,7 @@
             </a:r>
           </a:p>
           <a:p>
-            <a:pPr marL="285750" indent="-285750">
+            <a:pPr>
               <a:buFont typeface="Arial" panose="020B0604020202020204" pitchFamily="34" charset="0"/>
               <a:buChar char="•"/>
             </a:pPr>
@@ -3187,7 +3187,7 @@
             </a:r>
           </a:p>
           <a:p>
-            <a:pPr marL="285750" indent="-285750">
+            <a:pPr>
               <a:buFont typeface="Arial" panose="020B0604020202020204" pitchFamily="34" charset="0"/>
               <a:buChar char="•"/>
             </a:pPr>
@@ -3200,7 +3200,7 @@
             </a:r>
           </a:p>
           <a:p>
-            <a:pPr marL="285750" indent="-285750">
+            <a:pPr>
               <a:buFont typeface="Arial" panose="020B0604020202020204" pitchFamily="34" charset="0"/>
               <a:buChar char="•"/>
             </a:pPr>
@@ -4192,7 +4192,7 @@
             <a:bodyPr/>
             <a:lstStyle/>
             <a:p>
-              <a:pPr marL="285750" indent="-285750">
+              <a:pPr>
                 <a:buFont typeface="Arial" panose="020B0604020202020204" pitchFamily="34" charset="0"/>
                 <a:buChar char="•"/>
               </a:pPr>
@@ -4208,7 +4208,7 @@
               </a:r>
             </a:p>
             <a:p>
-              <a:pPr marL="285750" indent="-285750">
+              <a:pPr>
                 <a:buFont typeface="Arial" panose="020B0604020202020204" pitchFamily="34" charset="0"/>
                 <a:buChar char="•"/>
               </a:pPr>
@@ -4224,7 +4224,7 @@
               </a:r>
             </a:p>
             <a:p>
-              <a:pPr marL="285750" indent="-285750">
+              <a:pPr>
                 <a:buFont typeface="Arial" panose="020B0604020202020204" pitchFamily="34" charset="0"/>
                 <a:buChar char="•"/>
               </a:pPr>
@@ -4349,7 +4349,7 @@
             <a:bodyPr/>
             <a:lstStyle/>
             <a:p>
-              <a:pPr marL="285750" indent="-285750">
+              <a:pPr>
                 <a:buFont typeface="Arial" panose="020B0604020202020204" pitchFamily="34" charset="0"/>
                 <a:buChar char="•"/>
               </a:pPr>
@@ -4365,7 +4365,7 @@
               </a:r>
             </a:p>
             <a:p>
-              <a:pPr marL="285750" indent="-285750">
+              <a:pPr>
                 <a:buFont typeface="Arial" panose="020B0604020202020204" pitchFamily="34" charset="0"/>
                 <a:buChar char="•"/>
               </a:pPr>
@@ -4381,7 +4381,7 @@
               </a:r>
             </a:p>
             <a:p>
-              <a:pPr marL="285750" indent="-285750">
+              <a:pPr>
                 <a:buFont typeface="Arial" panose="020B0604020202020204" pitchFamily="34" charset="0"/>
                 <a:buChar char="•"/>
               </a:pPr>
@@ -4506,7 +4506,7 @@
             <a:bodyPr/>
             <a:lstStyle/>
             <a:p>
-              <a:pPr marL="285750" indent="-285750">
+              <a:pPr>
                 <a:buFont typeface="Arial" panose="020B0604020202020204" pitchFamily="34" charset="0"/>
                 <a:buChar char="•"/>
               </a:pPr>
@@ -4522,7 +4522,7 @@
               </a:r>
             </a:p>
             <a:p>
-              <a:pPr marL="285750" indent="-285750">
+              <a:pPr>
                 <a:buFont typeface="Arial" panose="020B0604020202020204" pitchFamily="34" charset="0"/>
                 <a:buChar char="•"/>
               </a:pPr>
@@ -4538,7 +4538,7 @@
               </a:r>
             </a:p>
             <a:p>
-              <a:pPr marL="285750" indent="-285750">
+              <a:pPr>
                 <a:buFont typeface="Arial" panose="020B0604020202020204" pitchFamily="34" charset="0"/>
                 <a:buChar char="•"/>
               </a:pPr>
@@ -10085,7 +10085,7 @@
           <a:bodyPr/>
           <a:lstStyle/>
           <a:p>
-            <a:pPr marL="285750" indent="-285750">
+            <a:pPr>
               <a:buFont typeface="Arial" panose="020B0604020202020204" pitchFamily="34" charset="0"/>
               <a:buChar char="•"/>
             </a:pPr>
@@ -10101,7 +10101,7 @@
             </a:r>
           </a:p>
           <a:p>
-            <a:pPr lvl="1" marL="742950" indent="-285750">
+            <a:pPr lvl="1">
               <a:buFont typeface="Arial" panose="020B0604020202020204" pitchFamily="34" charset="0"/>
               <a:buChar char="•"/>
             </a:pPr>
@@ -10117,7 +10117,7 @@
             </a:r>
           </a:p>
           <a:p>
-            <a:pPr lvl="2" marL="1200150" indent="-285750">
+            <a:pPr lvl="2">
               <a:buFont typeface="Arial" panose="020B0604020202020204" pitchFamily="34" charset="0"/>
               <a:buChar char="•"/>
             </a:pPr>
@@ -10163,7 +10163,7 @@
             </a:r>
           </a:p>
           <a:p>
-            <a:pPr lvl="2" marL="1200150" indent="-285750">
+            <a:pPr lvl="2">
               <a:buFont typeface="Arial" panose="020B0604020202020204" pitchFamily="34" charset="0"/>
               <a:buChar char="•"/>
             </a:pPr>
@@ -10209,7 +10209,7 @@
             </a:r>
           </a:p>
           <a:p>
-            <a:pPr lvl="2" marL="1200150" indent="-285750">
+            <a:pPr lvl="2">
               <a:buFont typeface="Arial" panose="020B0604020202020204" pitchFamily="34" charset="0"/>
               <a:buChar char="•"/>
             </a:pPr>
@@ -10255,7 +10255,7 @@
             </a:r>
           </a:p>
           <a:p>
-            <a:pPr marL="285750" indent="-285750">
+            <a:pPr>
               <a:buFont typeface="Arial" panose="020B0604020202020204" pitchFamily="34" charset="0"/>
               <a:buChar char="•"/>
             </a:pPr>
@@ -10271,7 +10271,7 @@
             </a:r>
           </a:p>
           <a:p>
-            <a:pPr lvl="1" marL="742950" indent="-285750">
+            <a:pPr lvl="1">
               <a:buFont typeface="Arial" panose="020B0604020202020204" pitchFamily="34" charset="0"/>
               <a:buChar char="•"/>
             </a:pPr>
@@ -10287,7 +10287,7 @@
             </a:r>
           </a:p>
           <a:p>
-            <a:pPr lvl="2" marL="1200150" indent="-285750">
+            <a:pPr lvl="2">
               <a:buFont typeface="Arial" panose="020B0604020202020204" pitchFamily="34" charset="0"/>
               <a:buChar char="•"/>
             </a:pPr>
@@ -11378,7 +11378,7 @@
           <a:bodyPr/>
           <a:lstStyle/>
           <a:p>
-            <a:pPr marL="285750" indent="-285750">
+            <a:pPr>
               <a:buFont typeface="Arial" panose="020B0604020202020204" pitchFamily="34" charset="0"/>
               <a:buChar char="•"/>
             </a:pPr>
@@ -11394,7 +11394,7 @@
             </a:r>
           </a:p>
           <a:p>
-            <a:pPr marL="285750" indent="-285750">
+            <a:pPr>
               <a:buFont typeface="Arial" panose="020B0604020202020204" pitchFamily="34" charset="0"/>
               <a:buChar char="•"/>
             </a:pPr>
@@ -11410,7 +11410,7 @@
             </a:r>
           </a:p>
           <a:p>
-            <a:pPr marL="285750" indent="-285750">
+            <a:pPr>
               <a:buFont typeface="Arial" panose="020B0604020202020204" pitchFamily="34" charset="0"/>
               <a:buChar char="•"/>
             </a:pPr>
@@ -11426,7 +11426,7 @@
             </a:r>
           </a:p>
           <a:p>
-            <a:pPr marL="285750" indent="-285750">
+            <a:pPr>
               <a:buFont typeface="Arial" panose="020B0604020202020204" pitchFamily="34" charset="0"/>
               <a:buChar char="•"/>
             </a:pPr>
@@ -11713,7 +11713,7 @@
           <a:bodyPr/>
           <a:lstStyle/>
           <a:p>
-            <a:pPr marL="285750" indent="-285750">
+            <a:pPr>
               <a:buFont typeface="Arial" panose="020B0604020202020204" pitchFamily="34" charset="0"/>
               <a:buChar char="•"/>
             </a:pPr>
@@ -11748,7 +11748,7 @@
             </a:r>
           </a:p>
           <a:p>
-            <a:pPr lvl="1" marL="742950" indent="-285750">
+            <a:pPr lvl="1">
               <a:buFont typeface="Arial" panose="020B0604020202020204" pitchFamily="34" charset="0"/>
               <a:buChar char="•"/>
             </a:pPr>
@@ -11783,7 +11783,7 @@
             </a:r>
           </a:p>
           <a:p>
-            <a:pPr lvl="2" marL="1200150" indent="-285750">
+            <a:pPr lvl="2">
               <a:buFont typeface="Arial" panose="020B0604020202020204" pitchFamily="34" charset="0"/>
               <a:buChar char="•"/>
             </a:pPr>
@@ -11818,7 +11818,7 @@
             </a:r>
           </a:p>
           <a:p>
-            <a:pPr lvl="3" marL="1657350" indent="-285750">
+            <a:pPr lvl="3">
               <a:buFont typeface="Arial" panose="020B0604020202020204" pitchFamily="34" charset="0"/>
               <a:buChar char="•"/>
             </a:pPr>
@@ -11834,7 +11834,7 @@
             </a:r>
           </a:p>
           <a:p>
-            <a:pPr marL="285750" indent="-285750">
+            <a:pPr>
               <a:buFont typeface="Arial" panose="020B0604020202020204" pitchFamily="34" charset="0"/>
               <a:buChar char="•"/>
             </a:pPr>
@@ -11869,7 +11869,7 @@
             </a:r>
           </a:p>
           <a:p>
-            <a:pPr lvl="1" marL="742950" indent="-285750">
+            <a:pPr lvl="1">
               <a:buFont typeface="Arial" panose="020B0604020202020204" pitchFamily="34" charset="0"/>
               <a:buChar char="•"/>
             </a:pPr>
@@ -11975,7 +11975,7 @@
           <a:bodyPr/>
           <a:lstStyle/>
           <a:p>
-            <a:pPr marL="342900" indent="-342900">
+            <a:pPr>
               <a:buAutoNum type="arabicPeriod"/>
             </a:pPr>
             <a:r>
@@ -12009,7 +12009,7 @@
             </a:r>
           </a:p>
           <a:p>
-            <a:pPr lvl="1" marL="742950" indent="-285750">
+            <a:pPr lvl="1">
               <a:buFont typeface="Arial" panose="020B0604020202020204" pitchFamily="34" charset="0"/>
               <a:buChar char="•"/>
             </a:pPr>
@@ -12025,7 +12025,7 @@
             </a:r>
           </a:p>
           <a:p>
-            <a:pPr marL="342900" indent="-342900">
+            <a:pPr>
               <a:buAutoNum type="arabicPeriod"/>
             </a:pPr>
             <a:r>
@@ -12059,7 +12059,7 @@
             </a:r>
           </a:p>
           <a:p>
-            <a:pPr lvl="1" marL="742950" indent="-285750">
+            <a:pPr lvl="1">
               <a:buFont typeface="Arial" panose="020B0604020202020204" pitchFamily="34" charset="0"/>
               <a:buChar char="•"/>
             </a:pPr>
@@ -12075,7 +12075,7 @@
             </a:r>
           </a:p>
           <a:p>
-            <a:pPr marL="342900" indent="-342900">
+            <a:pPr>
               <a:buAutoNum type="arabicPeriod"/>
             </a:pPr>
             <a:r>
@@ -12109,7 +12109,7 @@
             </a:r>
           </a:p>
           <a:p>
-            <a:pPr lvl="1" marL="742950" indent="-285750">
+            <a:pPr lvl="1">
               <a:buFont typeface="Arial" panose="020B0604020202020204" pitchFamily="34" charset="0"/>
               <a:buChar char="•"/>
             </a:pPr>
@@ -12280,7 +12280,7 @@
           <a:bodyPr/>
           <a:lstStyle/>
           <a:p>
-            <a:pPr marL="285750" indent="-285750">
+            <a:pPr>
               <a:buFont typeface="Arial" panose="020B0604020202020204" pitchFamily="34" charset="0"/>
               <a:buChar char="•"/>
             </a:pPr>
@@ -12315,7 +12315,7 @@
             </a:r>
           </a:p>
           <a:p>
-            <a:pPr lvl="1" marL="742950" indent="-285750">
+            <a:pPr lvl="1">
               <a:buFont typeface="Arial" panose="020B0604020202020204" pitchFamily="34" charset="0"/>
               <a:buChar char="•"/>
             </a:pPr>
@@ -12350,7 +12350,7 @@
             </a:r>
           </a:p>
           <a:p>
-            <a:pPr lvl="2" marL="1200150" indent="-285750">
+            <a:pPr lvl="2">
               <a:buFont typeface="Arial" panose="020B0604020202020204" pitchFamily="34" charset="0"/>
               <a:buChar char="•"/>
             </a:pPr>
@@ -12385,7 +12385,7 @@
             </a:r>
           </a:p>
           <a:p>
-            <a:pPr lvl="3" marL="1657350" indent="-285750">
+            <a:pPr lvl="3">
               <a:buFont typeface="Arial" panose="020B0604020202020204" pitchFamily="34" charset="0"/>
               <a:buChar char="•"/>
             </a:pPr>
@@ -12401,7 +12401,7 @@
             </a:r>
           </a:p>
           <a:p>
-            <a:pPr marL="285750" indent="-285750">
+            <a:pPr>
               <a:buFont typeface="Arial" panose="020B0604020202020204" pitchFamily="34" charset="0"/>
               <a:buChar char="•"/>
             </a:pPr>
@@ -12436,7 +12436,7 @@
             </a:r>
           </a:p>
           <a:p>
-            <a:pPr lvl="1" marL="742950" indent="-285750">
+            <a:pPr lvl="1">
               <a:buFont typeface="Arial" panose="020B0604020202020204" pitchFamily="34" charset="0"/>
               <a:buChar char="•"/>
             </a:pPr>
@@ -12675,7 +12675,7 @@
           <a:bodyPr/>
           <a:lstStyle/>
           <a:p>
-            <a:pPr marL="285750" indent="-285750">
+            <a:pPr>
               <a:buFont typeface="Arial" panose="020B0604020202020204" pitchFamily="34" charset="0"/>
               <a:buChar char="•"/>
             </a:pPr>
@@ -12750,7 +12750,7 @@
             </a:r>
           </a:p>
           <a:p>
-            <a:pPr marL="285750" indent="-285750">
+            <a:pPr>
               <a:buFont typeface="Arial" panose="020B0604020202020204" pitchFamily="34" charset="0"/>
               <a:buChar char="•"/>
             </a:pPr>

</xml_diff>